<commit_message>
PS Economics slide: weekly KPIs with last week's change, clearer capacity bar
- Top boxes are now this week against last week (Sydney weeks, PS staff
  only): hours logged 51.0 -> 11.5h, billable utilisation 16.8% -> 3.7%,
  chargeable 12.5 -> 3.5h, non-chargeable 1.0 -> 1.0h. The Jan-Sep
  finance figures stay in the P&L chart.
- Capacity bar retitled "hours available, and how they were logged".
  "Billable, not flagged" becomes "Chargeable? left blank", with a note
  saying what the bar and that band mean.

Co-Authored-By: Claude Opus 5.5 <noreply@anthropic.com>
Claude-Session: https://claude.ai/code/session_01Lq5maWicgiSj2RkHzTdcCm
</commit_message>
<xml_diff>
--- a/exec-deck/output/H&L PS Economics - The Hidden Work - WC 19 Oct 2026.pptx
+++ b/exec-deck/output/H&L PS Economics - The Hidden Work - WC 19 Oct 2026.pptx
@@ -1857,7 +1857,7 @@
                 <a:ea typeface="Poppins" pitchFamily="34" charset="-122"/>
                 <a:cs typeface="Poppins" pitchFamily="34" charset="-120"/>
               </a:rPr>
-              <a:t>PS REVENUE · JAN–SEP</a:t>
+              <a:t>HOURS LOGGED · THIS WEEK</a:t>
             </a:r>
             <a:endParaRPr lang="en-US" sz="850" dirty="0"/>
           </a:p>
@@ -1896,7 +1896,7 @@
                 <a:ea typeface="Poppins" pitchFamily="34" charset="-122"/>
                 <a:cs typeface="Poppins" pitchFamily="34" charset="-120"/>
               </a:rPr>
-              <a:t>$293k</a:t>
+              <a:t>11.5 Hrs</a:t>
             </a:r>
             <a:endParaRPr lang="en-US" sz="2200" dirty="0"/>
           </a:p>
@@ -1927,15 +1927,15 @@
               <a:buNone/>
             </a:pPr>
             <a:r>
-              <a:rPr lang="en-US" sz="730" dirty="0">
-                <a:solidFill>
-                  <a:srgbClr val="8FA1AC"/>
-                </a:solidFill>
-                <a:latin typeface="Poppins" pitchFamily="34" charset="0"/>
-                <a:ea typeface="Poppins" pitchFamily="34" charset="-122"/>
-                <a:cs typeface="Poppins" pitchFamily="34" charset="-120"/>
-              </a:rPr>
-              <a:t>billed to customers</a:t>
+              <a:rPr lang="en-US" sz="730" b="1" dirty="0">
+                <a:solidFill>
+                  <a:srgbClr val="B4552D"/>
+                </a:solidFill>
+                <a:latin typeface="Poppins" pitchFamily="34" charset="0"/>
+                <a:ea typeface="Poppins" pitchFamily="34" charset="-122"/>
+                <a:cs typeface="Poppins" pitchFamily="34" charset="-120"/>
+              </a:rPr>
+              <a:t>▼ from 51.0 hrs last week</a:t>
             </a:r>
             <a:endParaRPr lang="en-US" sz="730" dirty="0"/>
           </a:p>
@@ -2023,7 +2023,7 @@
                 <a:ea typeface="Poppins" pitchFamily="34" charset="-122"/>
                 <a:cs typeface="Poppins" pitchFamily="34" charset="-120"/>
               </a:rPr>
-              <a:t>PS COST · JAN–SEP</a:t>
+              <a:t>BILLABLE UTILISATION</a:t>
             </a:r>
             <a:endParaRPr lang="en-US" sz="850" dirty="0"/>
           </a:p>
@@ -2062,7 +2062,7 @@
                 <a:ea typeface="Poppins" pitchFamily="34" charset="-122"/>
                 <a:cs typeface="Poppins" pitchFamily="34" charset="-120"/>
               </a:rPr>
-              <a:t>$562k</a:t>
+              <a:t>3.7%</a:t>
             </a:r>
             <a:endParaRPr lang="en-US" sz="2200" dirty="0"/>
           </a:p>
@@ -2093,15 +2093,15 @@
               <a:buNone/>
             </a:pPr>
             <a:r>
-              <a:rPr lang="en-US" sz="730" dirty="0">
-                <a:solidFill>
-                  <a:srgbClr val="8FA1AC"/>
-                </a:solidFill>
-                <a:latin typeface="Poppins" pitchFamily="34" charset="0"/>
-                <a:ea typeface="Poppins" pitchFamily="34" charset="-122"/>
-                <a:cs typeface="Poppins" pitchFamily="34" charset="-120"/>
-              </a:rPr>
-              <a:t>$501k staff · $61k non-staff</a:t>
+              <a:rPr lang="en-US" sz="730" b="1" dirty="0">
+                <a:solidFill>
+                  <a:srgbClr val="B4552D"/>
+                </a:solidFill>
+                <a:latin typeface="Poppins" pitchFamily="34" charset="0"/>
+                <a:ea typeface="Poppins" pitchFamily="34" charset="-122"/>
+                <a:cs typeface="Poppins" pitchFamily="34" charset="-120"/>
+              </a:rPr>
+              <a:t>▼ from 16.8% last week · target 50%</a:t>
             </a:r>
             <a:endParaRPr lang="en-US" sz="730" dirty="0"/>
           </a:p>
@@ -2189,7 +2189,7 @@
                 <a:ea typeface="Poppins" pitchFamily="34" charset="-122"/>
                 <a:cs typeface="Poppins" pitchFamily="34" charset="-120"/>
               </a:rPr>
-              <a:t>SHORTFALL</a:t>
+              <a:t>CHARGEABLE HOURS</a:t>
             </a:r>
             <a:endParaRPr lang="en-US" sz="850" dirty="0"/>
           </a:p>
@@ -2228,7 +2228,7 @@
                 <a:ea typeface="Poppins" pitchFamily="34" charset="-122"/>
                 <a:cs typeface="Poppins" pitchFamily="34" charset="-120"/>
               </a:rPr>
-              <a:t>−$268k</a:t>
+              <a:t>3.5 Hrs</a:t>
             </a:r>
             <a:endParaRPr lang="en-US" sz="2200" dirty="0"/>
           </a:p>
@@ -2267,7 +2267,7 @@
                 <a:ea typeface="Poppins" pitchFamily="34" charset="-122"/>
                 <a:cs typeface="Poppins" pitchFamily="34" charset="-120"/>
               </a:rPr>
-              <a:t>PS recovers 52% of its cost</a:t>
+              <a:t>▼ from 12.5 hrs last week</a:t>
             </a:r>
             <a:endParaRPr lang="en-US" sz="730" dirty="0"/>
           </a:p>
@@ -2355,7 +2355,7 @@
                 <a:ea typeface="Poppins" pitchFamily="34" charset="-122"/>
                 <a:cs typeface="Poppins" pitchFamily="34" charset="-120"/>
               </a:rPr>
-              <a:t>PARTNER COMMISSION · JAN–SEP</a:t>
+              <a:t>NON-CHARGEABLE (HIDDEN)</a:t>
             </a:r>
             <a:endParaRPr lang="en-US" sz="850" dirty="0"/>
           </a:p>
@@ -2394,7 +2394,7 @@
                 <a:ea typeface="Poppins" pitchFamily="34" charset="-122"/>
                 <a:cs typeface="Poppins" pitchFamily="34" charset="-120"/>
               </a:rPr>
-              <a:t>$1.29M</a:t>
+              <a:t>1.0 Hrs</a:t>
             </a:r>
             <a:endParaRPr lang="en-US" sz="2200" dirty="0"/>
           </a:p>
@@ -2427,13 +2427,13 @@
             <a:r>
               <a:rPr lang="en-US" sz="730" b="1" dirty="0">
                 <a:solidFill>
-                  <a:srgbClr val="3D8F5F"/>
-                </a:solidFill>
-                <a:latin typeface="Poppins" pitchFamily="34" charset="0"/>
-                <a:ea typeface="Poppins" pitchFamily="34" charset="-122"/>
-                <a:cs typeface="Poppins" pitchFamily="34" charset="-120"/>
-              </a:rPr>
-              <a:t>paid to H&amp;L by premium partners</a:t>
+                  <a:srgbClr val="5E7280"/>
+                </a:solidFill>
+                <a:latin typeface="Poppins" pitchFamily="34" charset="0"/>
+                <a:ea typeface="Poppins" pitchFamily="34" charset="-122"/>
+                <a:cs typeface="Poppins" pitchFamily="34" charset="-120"/>
+              </a:rPr>
+              <a:t>— same as last week · ≈ $42 of cost</a:t>
             </a:r>
             <a:endParaRPr lang="en-US" sz="730" dirty="0"/>
           </a:p>
@@ -2585,7 +2585,7 @@
                 <a:ea typeface="Poppins" pitchFamily="34" charset="-122"/>
                 <a:cs typeface="Poppins" pitchFamily="34" charset="-120"/>
               </a:rPr>
-              <a:t>WHERE Q4 PS CAPACITY WENT — 1–25 OCT</a:t>
+              <a:t>Q4 PS HOURS AVAILABLE — AND HOW THEY WERE LOGGED</a:t>
             </a:r>
             <a:endParaRPr lang="en-US" sz="1200" dirty="0"/>
           </a:p>
@@ -2876,7 +2876,7 @@
                 <a:ea typeface="Poppins" pitchFamily="34" charset="-122"/>
                 <a:cs typeface="Poppins" pitchFamily="34" charset="-120"/>
               </a:rPr>
-              <a:t>Billable, not flagged</a:t>
+              <a:t>Chargeable? left blank</a:t>
             </a:r>
             <a:endParaRPr lang="en-US" sz="650" dirty="0"/>
           </a:p>
@@ -2983,8 +2983,8 @@
         </p:nvSpPr>
         <p:spPr>
           <a:xfrm>
-            <a:off x="612648" y="6135624"/>
-            <a:ext cx="4718304" cy="164592"/>
+            <a:off x="612648" y="6080760"/>
+            <a:ext cx="4718304" cy="237744"/>
           </a:xfrm>
           <a:prstGeom prst="rect">
             <a:avLst/>
@@ -3000,7 +3000,7 @@
               <a:buNone/>
             </a:pPr>
             <a:r>
-              <a:rPr lang="en-US" sz="630" dirty="0">
+              <a:rPr lang="en-US" sz="600" dirty="0">
                 <a:solidFill>
                   <a:srgbClr val="8FA1AC"/>
                 </a:solidFill>
@@ -3008,9 +3008,9 @@
                 <a:ea typeface="Poppins" pitchFamily="34" charset="-122"/>
                 <a:cs typeface="Poppins" pitchFamily="34" charset="-120"/>
               </a:rPr>
-              <a:t>of 1,064h available · at ~$42/h, the unlogged hours alone are ≈ $40k of cost with no owner</a:t>
-            </a:r>
-            <a:endParaRPr lang="en-US" sz="630" dirty="0"/>
+              <a:t>Bar = the 1,064h PS staff were available 1–25 Oct. "Left blank" = logged as billable but Is Chargeable not filled in (new this week). Not logged ≈ $40k of cost at ~$42/h.</a:t>
+            </a:r>
+            <a:endParaRPr lang="en-US" sz="600" dirty="0"/>
           </a:p>
         </p:txBody>
       </p:sp>
@@ -5273,7 +5273,7 @@
                 <a:ea typeface="Poppins" pitchFamily="34" charset="-122"/>
                 <a:cs typeface="Poppins" pitchFamily="34" charset="-120"/>
               </a:rPr>
-              <a:t>16.9h in Q4 can be tied to a partner, from ticket subjects only, and none carry a non-chargeable reason. 6.3h went to Uber Eats, which pays no commission.</a:t>
+              <a:t>16.9h in Q4 can be tied to a partner, from ticket subjects only, and none carry a non-chargeable reason. This week's 11.5h will restate up as late logging lands.</a:t>
             </a:r>
             <a:endParaRPr lang="en-US" sz="900" dirty="0"/>
           </a:p>

</xml_diff>

<commit_message>
PS Economics slide: billable utilisation, Integration Level 3 partners
- Boxes: Total hours logged; Billable utilisation (all billable hours,
  chargeable and non-chargeable alike, against the 50% target);
  chargeable vs non-chargeable split on the Is Chargeable field.
- Partner hours now come from the ticket's Integration Level 3 field, not
  subject text. Adds NowBookIt (2.0h, no commission); H&L Pay is 2.0h,
  both flagged non-chargeable. Tyro has no tagged hours this quarter.
- Week-on-week rebuilt on the new method (billable, chargeable,
  non-chargeable, blank, utilisation, first reported) and made smaller so
  the P&L chart has more room. The chart's Jan-Sep total line and the
  table footnotes are removed.

Co-Authored-By: Claude Opus 5.5 <noreply@anthropic.com>
Claude-Session: https://claude.ai/code/session_01Lq5maWicgiSj2RkHzTdcCm
</commit_message>
<xml_diff>
--- a/exec-deck/output/H&L PS Economics - The Hidden Work - WC 19 Oct 2026.pptx
+++ b/exec-deck/output/H&L PS Economics - The Hidden Work - WC 19 Oct 2026.pptx
@@ -1857,7 +1857,7 @@
                 <a:ea typeface="Poppins" pitchFamily="34" charset="-122"/>
                 <a:cs typeface="Poppins" pitchFamily="34" charset="-120"/>
               </a:rPr>
-              <a:t>HOURS LOGGED</a:t>
+              <a:t>TOTAL HOURS LOGGED</a:t>
             </a:r>
             <a:endParaRPr lang="en-US" sz="700" dirty="0"/>
           </a:p>
@@ -2037,7 +2037,7 @@
                 <a:ea typeface="Poppins" pitchFamily="34" charset="-122"/>
                 <a:cs typeface="Poppins" pitchFamily="34" charset="-120"/>
               </a:rPr>
-              <a:t>UTILISATION</a:t>
+              <a:t>BILLABLE UTILISATION</a:t>
             </a:r>
             <a:endParaRPr lang="en-US" sz="700" dirty="0"/>
           </a:p>
@@ -2077,6 +2077,20 @@
                 <a:cs typeface="Poppins" pitchFamily="34" charset="-120"/>
               </a:rPr>
               <a:t>3.7%</a:t>
+            </a:r>
+            <a:pPr indent="0" marL="0">
+              <a:buNone/>
+            </a:pPr>
+            <a:r>
+              <a:rPr lang="en-US" sz="900" b="1" dirty="0">
+                <a:solidFill>
+                  <a:srgbClr val="5E7280"/>
+                </a:solidFill>
+                <a:latin typeface="Poppins" pitchFamily="34" charset="0"/>
+                <a:ea typeface="Poppins" pitchFamily="34" charset="-122"/>
+                <a:cs typeface="Poppins" pitchFamily="34" charset="-120"/>
+              </a:rPr>
+              <a:t>  target 50%</a:t>
             </a:r>
             <a:endParaRPr lang="en-US" sz="2000" dirty="0"/>
           </a:p>
@@ -2822,11 +2836,11 @@
         <p:spPr>
           <a:xfrm>
             <a:off x="411480" y="2011680"/>
-            <a:ext cx="5120640" cy="2240280"/>
+            <a:ext cx="5120640" cy="2880360"/>
           </a:xfrm>
           <a:prstGeom prst="roundRect">
             <a:avLst>
-              <a:gd name="adj" fmla="val 2857"/>
+              <a:gd name="adj" fmla="val 2222"/>
             </a:avLst>
           </a:prstGeom>
           <a:solidFill>
@@ -2881,54 +2895,15 @@
           </a:p>
         </p:txBody>
       </p:sp>
-      <p:sp>
-        <p:nvSpPr>
-          <p:cNvPr id="45" name="Text 43"/>
-          <p:cNvSpPr txBox="1"/>
-          <p:nvPr/>
-        </p:nvSpPr>
-        <p:spPr>
-          <a:xfrm>
-            <a:off x="2788920" y="2121408"/>
-            <a:ext cx="2560320" cy="274320"/>
-          </a:xfrm>
-          <a:prstGeom prst="rect">
-            <a:avLst/>
-          </a:prstGeom>
-          <a:noFill/>
-          <a:ln/>
-        </p:spPr>
-        <p:txBody>
-          <a:bodyPr wrap="square" lIns="0" tIns="0" rIns="0" bIns="0" rtlCol="0" anchor="ctr"/>
-          <a:lstStyle/>
-          <a:p>
-            <a:pPr algn="r" indent="0" marL="0">
-              <a:buNone/>
-            </a:pPr>
-            <a:r>
-              <a:rPr lang="en-US" sz="700" b="1" dirty="0">
-                <a:solidFill>
-                  <a:srgbClr val="B4552D"/>
-                </a:solidFill>
-                <a:latin typeface="Poppins" pitchFamily="34" charset="0"/>
-                <a:ea typeface="Poppins" pitchFamily="34" charset="-122"/>
-                <a:cs typeface="Poppins" pitchFamily="34" charset="-120"/>
-              </a:rPr>
-              <a:t>Jan–Sep: revenue $293k · cost $562k · −$268k</a:t>
-            </a:r>
-            <a:endParaRPr lang="en-US" sz="700" dirty="0"/>
-          </a:p>
-        </p:txBody>
-      </p:sp>
       <p:graphicFrame>
         <p:nvGraphicFramePr>
-          <p:cNvPr id="46" name="Chart 0" descr=""/>
+          <p:cNvPr id="45" name="Chart 0" descr=""/>
           <p:cNvGraphicFramePr/>
           <p:nvPr/>
         </p:nvGraphicFramePr>
         <p:xfrm>
           <a:off x="521208" y="2359152"/>
-          <a:ext cx="4901184" cy="1819656"/>
+          <a:ext cx="4901184" cy="2459736"/>
         </p:xfrm>
         <a:graphic xmlns:a="http://schemas.openxmlformats.org/drawingml/2006/main">
           <a:graphicData uri="http://schemas.openxmlformats.org/drawingml/2006/chart">
@@ -2938,18 +2913,18 @@
       </p:graphicFrame>
       <p:sp>
         <p:nvSpPr>
-          <p:cNvPr id="47" name="Shape 44"/>
+          <p:cNvPr id="46" name="Shape 43"/>
           <p:cNvSpPr/>
           <p:nvPr/>
         </p:nvSpPr>
         <p:spPr>
           <a:xfrm>
-            <a:off x="411480" y="4361688"/>
-            <a:ext cx="5120640" cy="2057400"/>
+            <a:off x="411480" y="5001768"/>
+            <a:ext cx="5120640" cy="1417320"/>
           </a:xfrm>
           <a:prstGeom prst="roundRect">
             <a:avLst>
-              <a:gd name="adj" fmla="val 3111"/>
+              <a:gd name="adj" fmla="val 4516"/>
             </a:avLst>
           </a:prstGeom>
           <a:solidFill>
@@ -2967,30 +2942,395 @@
       </p:sp>
       <p:sp>
         <p:nvSpPr>
+          <p:cNvPr id="47" name="Text 44"/>
+          <p:cNvSpPr txBox="1"/>
+          <p:nvPr/>
+        </p:nvSpPr>
+        <p:spPr>
+          <a:xfrm>
+            <a:off x="594360" y="5056632"/>
+            <a:ext cx="4754880" cy="219456"/>
+          </a:xfrm>
+          <a:prstGeom prst="rect">
+            <a:avLst/>
+          </a:prstGeom>
+          <a:noFill/>
+          <a:ln/>
+        </p:spPr>
+        <p:txBody>
+          <a:bodyPr wrap="square" lIns="0" tIns="0" rIns="0" bIns="0" rtlCol="0" anchor="ctr"/>
+          <a:lstStyle/>
+          <a:p>
+            <a:pPr indent="0" marL="0">
+              <a:buNone/>
+            </a:pPr>
+            <a:r>
+              <a:rPr lang="en-US" sz="1000" b="1" dirty="0">
+                <a:solidFill>
+                  <a:srgbClr val="2C8394"/>
+                </a:solidFill>
+                <a:latin typeface="Poppins" pitchFamily="34" charset="0"/>
+                <a:ea typeface="Poppins" pitchFamily="34" charset="-122"/>
+                <a:cs typeface="Poppins" pitchFamily="34" charset="-120"/>
+              </a:rPr>
+              <a:t>WEEK ON WEEK  </a:t>
+            </a:r>
+            <a:pPr indent="0" marL="0">
+              <a:buNone/>
+            </a:pPr>
+            <a:r>
+              <a:rPr lang="en-US" sz="650" dirty="0">
+                <a:solidFill>
+                  <a:srgbClr val="8FA1AC"/>
+                </a:solidFill>
+                <a:latin typeface="Poppins" pitchFamily="34" charset="0"/>
+                <a:ea typeface="Poppins" pitchFamily="34" charset="-122"/>
+                <a:cs typeface="Poppins" pitchFamily="34" charset="-120"/>
+              </a:rPr>
+              <a:t>billable hours as the weeks stand today</a:t>
+            </a:r>
+            <a:endParaRPr lang="en-US" sz="1000" dirty="0"/>
+          </a:p>
+        </p:txBody>
+      </p:sp>
+      <p:sp>
+        <p:nvSpPr>
           <p:cNvPr id="48" name="Text 45"/>
           <p:cNvSpPr txBox="1"/>
           <p:nvPr/>
         </p:nvSpPr>
         <p:spPr>
           <a:xfrm>
-            <a:off x="612648" y="4434840"/>
-            <a:ext cx="4718304" cy="237744"/>
-          </a:xfrm>
-          <a:prstGeom prst="rect">
-            <a:avLst/>
-          </a:prstGeom>
-          <a:noFill/>
-          <a:ln/>
-        </p:spPr>
-        <p:txBody>
-          <a:bodyPr wrap="square" lIns="0" tIns="0" rIns="0" bIns="0" rtlCol="0" anchor="ctr"/>
-          <a:lstStyle/>
-          <a:p>
-            <a:pPr indent="0" marL="0">
-              <a:buNone/>
-            </a:pPr>
-            <a:r>
-              <a:rPr lang="en-US" sz="1100" b="1" dirty="0">
+            <a:off x="594360" y="5294376"/>
+            <a:ext cx="777240" cy="146304"/>
+          </a:xfrm>
+          <a:prstGeom prst="rect">
+            <a:avLst/>
+          </a:prstGeom>
+          <a:noFill/>
+          <a:ln/>
+        </p:spPr>
+        <p:txBody>
+          <a:bodyPr wrap="square" lIns="0" tIns="0" rIns="0" bIns="0" rtlCol="0" anchor="ctr"/>
+          <a:lstStyle/>
+          <a:p>
+            <a:pPr algn="l" indent="0" marL="0">
+              <a:buNone/>
+            </a:pPr>
+            <a:r>
+              <a:rPr lang="en-US" sz="580" b="1" dirty="0">
+                <a:solidFill>
+                  <a:srgbClr val="8FA1AC"/>
+                </a:solidFill>
+                <a:latin typeface="Poppins" pitchFamily="34" charset="0"/>
+                <a:ea typeface="Poppins" pitchFamily="34" charset="-122"/>
+                <a:cs typeface="Poppins" pitchFamily="34" charset="-120"/>
+              </a:rPr>
+              <a:t>WEEK</a:t>
+            </a:r>
+            <a:endParaRPr lang="en-US" sz="580" dirty="0"/>
+          </a:p>
+        </p:txBody>
+      </p:sp>
+      <p:sp>
+        <p:nvSpPr>
+          <p:cNvPr id="49" name="Text 46"/>
+          <p:cNvSpPr txBox="1"/>
+          <p:nvPr/>
+        </p:nvSpPr>
+        <p:spPr>
+          <a:xfrm>
+            <a:off x="1371600" y="5294376"/>
+            <a:ext cx="594360" cy="146304"/>
+          </a:xfrm>
+          <a:prstGeom prst="rect">
+            <a:avLst/>
+          </a:prstGeom>
+          <a:noFill/>
+          <a:ln/>
+        </p:spPr>
+        <p:txBody>
+          <a:bodyPr wrap="square" lIns="0" tIns="0" rIns="0" bIns="0" rtlCol="0" anchor="ctr"/>
+          <a:lstStyle/>
+          <a:p>
+            <a:pPr algn="r" indent="0" marL="0">
+              <a:buNone/>
+            </a:pPr>
+            <a:r>
+              <a:rPr lang="en-US" sz="580" b="1" dirty="0">
+                <a:solidFill>
+                  <a:srgbClr val="8FA1AC"/>
+                </a:solidFill>
+                <a:latin typeface="Poppins" pitchFamily="34" charset="0"/>
+                <a:ea typeface="Poppins" pitchFamily="34" charset="-122"/>
+                <a:cs typeface="Poppins" pitchFamily="34" charset="-120"/>
+              </a:rPr>
+              <a:t>BILLABLE</a:t>
+            </a:r>
+            <a:endParaRPr lang="en-US" sz="580" dirty="0"/>
+          </a:p>
+        </p:txBody>
+      </p:sp>
+      <p:sp>
+        <p:nvSpPr>
+          <p:cNvPr id="50" name="Text 47"/>
+          <p:cNvSpPr txBox="1"/>
+          <p:nvPr/>
+        </p:nvSpPr>
+        <p:spPr>
+          <a:xfrm>
+            <a:off x="2011680" y="5294376"/>
+            <a:ext cx="685800" cy="146304"/>
+          </a:xfrm>
+          <a:prstGeom prst="rect">
+            <a:avLst/>
+          </a:prstGeom>
+          <a:noFill/>
+          <a:ln/>
+        </p:spPr>
+        <p:txBody>
+          <a:bodyPr wrap="square" lIns="0" tIns="0" rIns="0" bIns="0" rtlCol="0" anchor="ctr"/>
+          <a:lstStyle/>
+          <a:p>
+            <a:pPr algn="r" indent="0" marL="0">
+              <a:buNone/>
+            </a:pPr>
+            <a:r>
+              <a:rPr lang="en-US" sz="580" b="1" dirty="0">
+                <a:solidFill>
+                  <a:srgbClr val="8FA1AC"/>
+                </a:solidFill>
+                <a:latin typeface="Poppins" pitchFamily="34" charset="0"/>
+                <a:ea typeface="Poppins" pitchFamily="34" charset="-122"/>
+                <a:cs typeface="Poppins" pitchFamily="34" charset="-120"/>
+              </a:rPr>
+              <a:t>CHARGEABLE</a:t>
+            </a:r>
+            <a:endParaRPr lang="en-US" sz="580" dirty="0"/>
+          </a:p>
+        </p:txBody>
+      </p:sp>
+      <p:sp>
+        <p:nvSpPr>
+          <p:cNvPr id="51" name="Text 48"/>
+          <p:cNvSpPr txBox="1"/>
+          <p:nvPr/>
+        </p:nvSpPr>
+        <p:spPr>
+          <a:xfrm>
+            <a:off x="2743200" y="5294376"/>
+            <a:ext cx="640080" cy="146304"/>
+          </a:xfrm>
+          <a:prstGeom prst="rect">
+            <a:avLst/>
+          </a:prstGeom>
+          <a:noFill/>
+          <a:ln/>
+        </p:spPr>
+        <p:txBody>
+          <a:bodyPr wrap="square" lIns="0" tIns="0" rIns="0" bIns="0" rtlCol="0" anchor="ctr"/>
+          <a:lstStyle/>
+          <a:p>
+            <a:pPr algn="r" indent="0" marL="0">
+              <a:buNone/>
+            </a:pPr>
+            <a:r>
+              <a:rPr lang="en-US" sz="580" b="1" dirty="0">
+                <a:solidFill>
+                  <a:srgbClr val="8FA1AC"/>
+                </a:solidFill>
+                <a:latin typeface="Poppins" pitchFamily="34" charset="0"/>
+                <a:ea typeface="Poppins" pitchFamily="34" charset="-122"/>
+                <a:cs typeface="Poppins" pitchFamily="34" charset="-120"/>
+              </a:rPr>
+              <a:t>NON-CHARG.</a:t>
+            </a:r>
+            <a:endParaRPr lang="en-US" sz="580" dirty="0"/>
+          </a:p>
+        </p:txBody>
+      </p:sp>
+      <p:sp>
+        <p:nvSpPr>
+          <p:cNvPr id="52" name="Text 49"/>
+          <p:cNvSpPr txBox="1"/>
+          <p:nvPr/>
+        </p:nvSpPr>
+        <p:spPr>
+          <a:xfrm>
+            <a:off x="3429000" y="5294376"/>
+            <a:ext cx="457200" cy="146304"/>
+          </a:xfrm>
+          <a:prstGeom prst="rect">
+            <a:avLst/>
+          </a:prstGeom>
+          <a:noFill/>
+          <a:ln/>
+        </p:spPr>
+        <p:txBody>
+          <a:bodyPr wrap="square" lIns="0" tIns="0" rIns="0" bIns="0" rtlCol="0" anchor="ctr"/>
+          <a:lstStyle/>
+          <a:p>
+            <a:pPr algn="r" indent="0" marL="0">
+              <a:buNone/>
+            </a:pPr>
+            <a:r>
+              <a:rPr lang="en-US" sz="580" b="1" dirty="0">
+                <a:solidFill>
+                  <a:srgbClr val="8FA1AC"/>
+                </a:solidFill>
+                <a:latin typeface="Poppins" pitchFamily="34" charset="0"/>
+                <a:ea typeface="Poppins" pitchFamily="34" charset="-122"/>
+                <a:cs typeface="Poppins" pitchFamily="34" charset="-120"/>
+              </a:rPr>
+              <a:t>BLANK</a:t>
+            </a:r>
+            <a:endParaRPr lang="en-US" sz="580" dirty="0"/>
+          </a:p>
+        </p:txBody>
+      </p:sp>
+      <p:sp>
+        <p:nvSpPr>
+          <p:cNvPr id="53" name="Text 50"/>
+          <p:cNvSpPr txBox="1"/>
+          <p:nvPr/>
+        </p:nvSpPr>
+        <p:spPr>
+          <a:xfrm>
+            <a:off x="3931920" y="5294376"/>
+            <a:ext cx="457200" cy="146304"/>
+          </a:xfrm>
+          <a:prstGeom prst="rect">
+            <a:avLst/>
+          </a:prstGeom>
+          <a:noFill/>
+          <a:ln/>
+        </p:spPr>
+        <p:txBody>
+          <a:bodyPr wrap="square" lIns="0" tIns="0" rIns="0" bIns="0" rtlCol="0" anchor="ctr"/>
+          <a:lstStyle/>
+          <a:p>
+            <a:pPr algn="r" indent="0" marL="0">
+              <a:buNone/>
+            </a:pPr>
+            <a:r>
+              <a:rPr lang="en-US" sz="580" b="1" dirty="0">
+                <a:solidFill>
+                  <a:srgbClr val="8FA1AC"/>
+                </a:solidFill>
+                <a:latin typeface="Poppins" pitchFamily="34" charset="0"/>
+                <a:ea typeface="Poppins" pitchFamily="34" charset="-122"/>
+                <a:cs typeface="Poppins" pitchFamily="34" charset="-120"/>
+              </a:rPr>
+              <a:t>UTIL</a:t>
+            </a:r>
+            <a:endParaRPr lang="en-US" sz="580" dirty="0"/>
+          </a:p>
+        </p:txBody>
+      </p:sp>
+      <p:sp>
+        <p:nvSpPr>
+          <p:cNvPr id="54" name="Text 51"/>
+          <p:cNvSpPr txBox="1"/>
+          <p:nvPr/>
+        </p:nvSpPr>
+        <p:spPr>
+          <a:xfrm>
+            <a:off x="4434840" y="5294376"/>
+            <a:ext cx="914400" cy="146304"/>
+          </a:xfrm>
+          <a:prstGeom prst="rect">
+            <a:avLst/>
+          </a:prstGeom>
+          <a:noFill/>
+          <a:ln/>
+        </p:spPr>
+        <p:txBody>
+          <a:bodyPr wrap="square" lIns="0" tIns="0" rIns="0" bIns="0" rtlCol="0" anchor="ctr"/>
+          <a:lstStyle/>
+          <a:p>
+            <a:pPr algn="r" indent="0" marL="0">
+              <a:buNone/>
+            </a:pPr>
+            <a:r>
+              <a:rPr lang="en-US" sz="580" b="1" dirty="0">
+                <a:solidFill>
+                  <a:srgbClr val="8FA1AC"/>
+                </a:solidFill>
+                <a:latin typeface="Poppins" pitchFamily="34" charset="0"/>
+                <a:ea typeface="Poppins" pitchFamily="34" charset="-122"/>
+                <a:cs typeface="Poppins" pitchFamily="34" charset="-120"/>
+              </a:rPr>
+              <a:t>FIRST REPORTED</a:t>
+            </a:r>
+            <a:endParaRPr lang="en-US" sz="580" dirty="0"/>
+          </a:p>
+        </p:txBody>
+      </p:sp>
+      <p:sp>
+        <p:nvSpPr>
+          <p:cNvPr id="55" name="Text 52"/>
+          <p:cNvSpPr txBox="1"/>
+          <p:nvPr/>
+        </p:nvSpPr>
+        <p:spPr>
+          <a:xfrm>
+            <a:off x="594360" y="5458968"/>
+            <a:ext cx="777240" cy="237744"/>
+          </a:xfrm>
+          <a:prstGeom prst="rect">
+            <a:avLst/>
+          </a:prstGeom>
+          <a:noFill/>
+          <a:ln/>
+        </p:spPr>
+        <p:txBody>
+          <a:bodyPr wrap="square" lIns="0" tIns="0" rIns="0" bIns="0" rtlCol="0" anchor="ctr"/>
+          <a:lstStyle/>
+          <a:p>
+            <a:pPr algn="l" indent="0" marL="0">
+              <a:buNone/>
+            </a:pPr>
+            <a:r>
+              <a:rPr lang="en-US" sz="780" b="1" dirty="0">
+                <a:solidFill>
+                  <a:srgbClr val="12293A"/>
+                </a:solidFill>
+                <a:latin typeface="Poppins" pitchFamily="34" charset="0"/>
+                <a:ea typeface="Poppins" pitchFamily="34" charset="-122"/>
+                <a:cs typeface="Poppins" pitchFamily="34" charset="-120"/>
+              </a:rPr>
+              <a:t>5–11 Oct</a:t>
+            </a:r>
+            <a:endParaRPr lang="en-US" sz="780" dirty="0"/>
+          </a:p>
+        </p:txBody>
+      </p:sp>
+      <p:sp>
+        <p:nvSpPr>
+          <p:cNvPr id="56" name="Text 53"/>
+          <p:cNvSpPr txBox="1"/>
+          <p:nvPr/>
+        </p:nvSpPr>
+        <p:spPr>
+          <a:xfrm>
+            <a:off x="1371600" y="5458968"/>
+            <a:ext cx="594360" cy="237744"/>
+          </a:xfrm>
+          <a:prstGeom prst="rect">
+            <a:avLst/>
+          </a:prstGeom>
+          <a:noFill/>
+          <a:ln/>
+        </p:spPr>
+        <p:txBody>
+          <a:bodyPr wrap="square" lIns="0" tIns="0" rIns="0" bIns="0" rtlCol="0" anchor="ctr"/>
+          <a:lstStyle/>
+          <a:p>
+            <a:pPr algn="r" indent="0" marL="0">
+              <a:buNone/>
+            </a:pPr>
+            <a:r>
+              <a:rPr lang="en-US" sz="780" b="1" dirty="0">
                 <a:solidFill>
                   <a:srgbClr val="2C8394"/>
                 </a:solidFill>
@@ -2998,13 +3338,77 @@
                 <a:ea typeface="Poppins" pitchFamily="34" charset="-122"/>
                 <a:cs typeface="Poppins" pitchFamily="34" charset="-120"/>
               </a:rPr>
-              <a:t>WEEK ON WEEK  </a:t>
-            </a:r>
-            <a:pPr indent="0" marL="0">
-              <a:buNone/>
-            </a:pPr>
-            <a:r>
-              <a:rPr lang="en-US" sz="650" dirty="0">
+              <a:t>35.3h</a:t>
+            </a:r>
+            <a:endParaRPr lang="en-US" sz="780" dirty="0"/>
+          </a:p>
+        </p:txBody>
+      </p:sp>
+      <p:sp>
+        <p:nvSpPr>
+          <p:cNvPr id="57" name="Text 54"/>
+          <p:cNvSpPr txBox="1"/>
+          <p:nvPr/>
+        </p:nvSpPr>
+        <p:spPr>
+          <a:xfrm>
+            <a:off x="2011680" y="5458968"/>
+            <a:ext cx="685800" cy="237744"/>
+          </a:xfrm>
+          <a:prstGeom prst="rect">
+            <a:avLst/>
+          </a:prstGeom>
+          <a:noFill/>
+          <a:ln/>
+        </p:spPr>
+        <p:txBody>
+          <a:bodyPr wrap="square" lIns="0" tIns="0" rIns="0" bIns="0" rtlCol="0" anchor="ctr"/>
+          <a:lstStyle/>
+          <a:p>
+            <a:pPr algn="r" indent="0" marL="0">
+              <a:buNone/>
+            </a:pPr>
+            <a:r>
+              <a:rPr lang="en-US" sz="780" dirty="0">
+                <a:solidFill>
+                  <a:srgbClr val="12293A"/>
+                </a:solidFill>
+                <a:latin typeface="Poppins" pitchFamily="34" charset="0"/>
+                <a:ea typeface="Poppins" pitchFamily="34" charset="-122"/>
+                <a:cs typeface="Poppins" pitchFamily="34" charset="-120"/>
+              </a:rPr>
+              <a:t>19.0h</a:t>
+            </a:r>
+            <a:endParaRPr lang="en-US" sz="780" dirty="0"/>
+          </a:p>
+        </p:txBody>
+      </p:sp>
+      <p:sp>
+        <p:nvSpPr>
+          <p:cNvPr id="58" name="Text 55"/>
+          <p:cNvSpPr txBox="1"/>
+          <p:nvPr/>
+        </p:nvSpPr>
+        <p:spPr>
+          <a:xfrm>
+            <a:off x="2743200" y="5458968"/>
+            <a:ext cx="640080" cy="237744"/>
+          </a:xfrm>
+          <a:prstGeom prst="rect">
+            <a:avLst/>
+          </a:prstGeom>
+          <a:noFill/>
+          <a:ln/>
+        </p:spPr>
+        <p:txBody>
+          <a:bodyPr wrap="square" lIns="0" tIns="0" rIns="0" bIns="0" rtlCol="0" anchor="ctr"/>
+          <a:lstStyle/>
+          <a:p>
+            <a:pPr algn="r" indent="0" marL="0">
+              <a:buNone/>
+            </a:pPr>
+            <a:r>
+              <a:rPr lang="en-US" sz="780" dirty="0">
                 <a:solidFill>
                   <a:srgbClr val="8FA1AC"/>
                 </a:solidFill>
@@ -3012,217 +3416,139 @@
                 <a:ea typeface="Poppins" pitchFamily="34" charset="-122"/>
                 <a:cs typeface="Poppins" pitchFamily="34" charset="-120"/>
               </a:rPr>
-              <a:t>as the weeks stand today</a:t>
-            </a:r>
-            <a:endParaRPr lang="en-US" sz="1100" dirty="0"/>
-          </a:p>
-        </p:txBody>
-      </p:sp>
-      <p:sp>
-        <p:nvSpPr>
-          <p:cNvPr id="49" name="Text 46"/>
-          <p:cNvSpPr txBox="1"/>
-          <p:nvPr/>
-        </p:nvSpPr>
-        <p:spPr>
-          <a:xfrm>
-            <a:off x="612648" y="4709160"/>
-            <a:ext cx="1097280" cy="164592"/>
-          </a:xfrm>
-          <a:prstGeom prst="rect">
-            <a:avLst/>
-          </a:prstGeom>
-          <a:noFill/>
-          <a:ln/>
-        </p:spPr>
-        <p:txBody>
-          <a:bodyPr wrap="square" lIns="0" tIns="0" rIns="0" bIns="0" rtlCol="0" anchor="ctr"/>
-          <a:lstStyle/>
-          <a:p>
-            <a:pPr algn="l" indent="0" marL="0">
-              <a:buNone/>
-            </a:pPr>
-            <a:r>
-              <a:rPr lang="en-US" sz="630" b="1" dirty="0">
-                <a:solidFill>
-                  <a:srgbClr val="8FA1AC"/>
-                </a:solidFill>
-                <a:latin typeface="Poppins" pitchFamily="34" charset="0"/>
-                <a:ea typeface="Poppins" pitchFamily="34" charset="-122"/>
-                <a:cs typeface="Poppins" pitchFamily="34" charset="-120"/>
-              </a:rPr>
-              <a:t>WEEK</a:t>
-            </a:r>
-            <a:endParaRPr lang="en-US" sz="630" dirty="0"/>
-          </a:p>
-        </p:txBody>
-      </p:sp>
-      <p:sp>
-        <p:nvSpPr>
-          <p:cNvPr id="50" name="Text 47"/>
-          <p:cNvSpPr txBox="1"/>
-          <p:nvPr/>
-        </p:nvSpPr>
-        <p:spPr>
-          <a:xfrm>
-            <a:off x="1737360" y="4709160"/>
-            <a:ext cx="457200" cy="164592"/>
-          </a:xfrm>
-          <a:prstGeom prst="rect">
-            <a:avLst/>
-          </a:prstGeom>
-          <a:noFill/>
-          <a:ln/>
-        </p:spPr>
-        <p:txBody>
-          <a:bodyPr wrap="square" lIns="0" tIns="0" rIns="0" bIns="0" rtlCol="0" anchor="ctr"/>
-          <a:lstStyle/>
-          <a:p>
-            <a:pPr algn="r" indent="0" marL="0">
-              <a:buNone/>
-            </a:pPr>
-            <a:r>
-              <a:rPr lang="en-US" sz="630" b="1" dirty="0">
-                <a:solidFill>
-                  <a:srgbClr val="8FA1AC"/>
-                </a:solidFill>
-                <a:latin typeface="Poppins" pitchFamily="34" charset="0"/>
-                <a:ea typeface="Poppins" pitchFamily="34" charset="-122"/>
-                <a:cs typeface="Poppins" pitchFamily="34" charset="-120"/>
-              </a:rPr>
-              <a:t>ITEMS</a:t>
-            </a:r>
-            <a:endParaRPr lang="en-US" sz="630" dirty="0"/>
-          </a:p>
-        </p:txBody>
-      </p:sp>
-      <p:sp>
-        <p:nvSpPr>
-          <p:cNvPr id="51" name="Text 48"/>
-          <p:cNvSpPr txBox="1"/>
-          <p:nvPr/>
-        </p:nvSpPr>
-        <p:spPr>
-          <a:xfrm>
-            <a:off x="2240280" y="4709160"/>
-            <a:ext cx="777240" cy="164592"/>
-          </a:xfrm>
-          <a:prstGeom prst="rect">
-            <a:avLst/>
-          </a:prstGeom>
-          <a:noFill/>
-          <a:ln/>
-        </p:spPr>
-        <p:txBody>
-          <a:bodyPr wrap="square" lIns="0" tIns="0" rIns="0" bIns="0" rtlCol="0" anchor="ctr"/>
-          <a:lstStyle/>
-          <a:p>
-            <a:pPr algn="r" indent="0" marL="0">
-              <a:buNone/>
-            </a:pPr>
-            <a:r>
-              <a:rPr lang="en-US" sz="630" b="1" dirty="0">
-                <a:solidFill>
-                  <a:srgbClr val="8FA1AC"/>
-                </a:solidFill>
-                <a:latin typeface="Poppins" pitchFamily="34" charset="0"/>
-                <a:ea typeface="Poppins" pitchFamily="34" charset="-122"/>
-                <a:cs typeface="Poppins" pitchFamily="34" charset="-120"/>
-              </a:rPr>
-              <a:t>HOURS NOW</a:t>
-            </a:r>
-            <a:endParaRPr lang="en-US" sz="630" dirty="0"/>
-          </a:p>
-        </p:txBody>
-      </p:sp>
-      <p:sp>
-        <p:nvSpPr>
-          <p:cNvPr id="52" name="Text 49"/>
-          <p:cNvSpPr txBox="1"/>
-          <p:nvPr/>
-        </p:nvSpPr>
-        <p:spPr>
-          <a:xfrm>
-            <a:off x="3063240" y="4709160"/>
-            <a:ext cx="502920" cy="164592"/>
-          </a:xfrm>
-          <a:prstGeom prst="rect">
-            <a:avLst/>
-          </a:prstGeom>
-          <a:noFill/>
-          <a:ln/>
-        </p:spPr>
-        <p:txBody>
-          <a:bodyPr wrap="square" lIns="0" tIns="0" rIns="0" bIns="0" rtlCol="0" anchor="ctr"/>
-          <a:lstStyle/>
-          <a:p>
-            <a:pPr algn="r" indent="0" marL="0">
-              <a:buNone/>
-            </a:pPr>
-            <a:r>
-              <a:rPr lang="en-US" sz="630" b="1" dirty="0">
-                <a:solidFill>
-                  <a:srgbClr val="8FA1AC"/>
-                </a:solidFill>
-                <a:latin typeface="Poppins" pitchFamily="34" charset="0"/>
-                <a:ea typeface="Poppins" pitchFamily="34" charset="-122"/>
-                <a:cs typeface="Poppins" pitchFamily="34" charset="-120"/>
-              </a:rPr>
-              <a:t>UTIL</a:t>
-            </a:r>
-            <a:endParaRPr lang="en-US" sz="630" dirty="0"/>
-          </a:p>
-        </p:txBody>
-      </p:sp>
-      <p:sp>
-        <p:nvSpPr>
-          <p:cNvPr id="53" name="Text 50"/>
-          <p:cNvSpPr txBox="1"/>
-          <p:nvPr/>
-        </p:nvSpPr>
-        <p:spPr>
-          <a:xfrm>
-            <a:off x="3611880" y="4709160"/>
-            <a:ext cx="1737360" cy="164592"/>
-          </a:xfrm>
-          <a:prstGeom prst="rect">
-            <a:avLst/>
-          </a:prstGeom>
-          <a:noFill/>
-          <a:ln/>
-        </p:spPr>
-        <p:txBody>
-          <a:bodyPr wrap="square" lIns="0" tIns="0" rIns="0" bIns="0" rtlCol="0" anchor="ctr"/>
-          <a:lstStyle/>
-          <a:p>
-            <a:pPr algn="r" indent="0" marL="0">
-              <a:buNone/>
-            </a:pPr>
-            <a:r>
-              <a:rPr lang="en-US" sz="630" b="1" dirty="0">
-                <a:solidFill>
-                  <a:srgbClr val="8FA1AC"/>
-                </a:solidFill>
-                <a:latin typeface="Poppins" pitchFamily="34" charset="0"/>
-                <a:ea typeface="Poppins" pitchFamily="34" charset="-122"/>
-                <a:cs typeface="Poppins" pitchFamily="34" charset="-120"/>
-              </a:rPr>
-              <a:t>AS FIRST REPORTED</a:t>
-            </a:r>
-            <a:endParaRPr lang="en-US" sz="630" dirty="0"/>
-          </a:p>
-        </p:txBody>
-      </p:sp>
-      <p:sp>
-        <p:nvSpPr>
-          <p:cNvPr id="54" name="Shape 51"/>
+              <a:t>—</a:t>
+            </a:r>
+            <a:endParaRPr lang="en-US" sz="780" dirty="0"/>
+          </a:p>
+        </p:txBody>
+      </p:sp>
+      <p:sp>
+        <p:nvSpPr>
+          <p:cNvPr id="59" name="Text 56"/>
+          <p:cNvSpPr txBox="1"/>
+          <p:nvPr/>
+        </p:nvSpPr>
+        <p:spPr>
+          <a:xfrm>
+            <a:off x="3429000" y="5458968"/>
+            <a:ext cx="457200" cy="237744"/>
+          </a:xfrm>
+          <a:prstGeom prst="rect">
+            <a:avLst/>
+          </a:prstGeom>
+          <a:noFill/>
+          <a:ln/>
+        </p:spPr>
+        <p:txBody>
+          <a:bodyPr wrap="square" lIns="0" tIns="0" rIns="0" bIns="0" rtlCol="0" anchor="ctr"/>
+          <a:lstStyle/>
+          <a:p>
+            <a:pPr algn="r" indent="0" marL="0">
+              <a:buNone/>
+            </a:pPr>
+            <a:r>
+              <a:rPr lang="en-US" sz="780" dirty="0">
+                <a:solidFill>
+                  <a:srgbClr val="C88A2E"/>
+                </a:solidFill>
+                <a:latin typeface="Poppins" pitchFamily="34" charset="0"/>
+                <a:ea typeface="Poppins" pitchFamily="34" charset="-122"/>
+                <a:cs typeface="Poppins" pitchFamily="34" charset="-120"/>
+              </a:rPr>
+              <a:t>16.3h</a:t>
+            </a:r>
+            <a:endParaRPr lang="en-US" sz="780" dirty="0"/>
+          </a:p>
+        </p:txBody>
+      </p:sp>
+      <p:sp>
+        <p:nvSpPr>
+          <p:cNvPr id="60" name="Text 57"/>
+          <p:cNvSpPr txBox="1"/>
+          <p:nvPr/>
+        </p:nvSpPr>
+        <p:spPr>
+          <a:xfrm>
+            <a:off x="3931920" y="5458968"/>
+            <a:ext cx="457200" cy="237744"/>
+          </a:xfrm>
+          <a:prstGeom prst="rect">
+            <a:avLst/>
+          </a:prstGeom>
+          <a:noFill/>
+          <a:ln/>
+        </p:spPr>
+        <p:txBody>
+          <a:bodyPr wrap="square" lIns="0" tIns="0" rIns="0" bIns="0" rtlCol="0" anchor="ctr"/>
+          <a:lstStyle/>
+          <a:p>
+            <a:pPr algn="r" indent="0" marL="0">
+              <a:buNone/>
+            </a:pPr>
+            <a:r>
+              <a:rPr lang="en-US" sz="780" b="1" dirty="0">
+                <a:solidFill>
+                  <a:srgbClr val="C88A2E"/>
+                </a:solidFill>
+                <a:latin typeface="Poppins" pitchFamily="34" charset="0"/>
+                <a:ea typeface="Poppins" pitchFamily="34" charset="-122"/>
+                <a:cs typeface="Poppins" pitchFamily="34" charset="-120"/>
+              </a:rPr>
+              <a:t>10.3%</a:t>
+            </a:r>
+            <a:endParaRPr lang="en-US" sz="780" dirty="0"/>
+          </a:p>
+        </p:txBody>
+      </p:sp>
+      <p:sp>
+        <p:nvSpPr>
+          <p:cNvPr id="61" name="Text 58"/>
+          <p:cNvSpPr txBox="1"/>
+          <p:nvPr/>
+        </p:nvSpPr>
+        <p:spPr>
+          <a:xfrm>
+            <a:off x="4434840" y="5458968"/>
+            <a:ext cx="914400" cy="237744"/>
+          </a:xfrm>
+          <a:prstGeom prst="rect">
+            <a:avLst/>
+          </a:prstGeom>
+          <a:noFill/>
+          <a:ln/>
+        </p:spPr>
+        <p:txBody>
+          <a:bodyPr wrap="square" lIns="0" tIns="0" rIns="0" bIns="0" rtlCol="0" anchor="ctr"/>
+          <a:lstStyle/>
+          <a:p>
+            <a:pPr algn="r" indent="0" marL="0">
+              <a:buNone/>
+            </a:pPr>
+            <a:r>
+              <a:rPr lang="en-US" sz="680" b="1" dirty="0">
+                <a:solidFill>
+                  <a:srgbClr val="B4552D"/>
+                </a:solidFill>
+                <a:latin typeface="Poppins" pitchFamily="34" charset="0"/>
+                <a:ea typeface="Poppins" pitchFamily="34" charset="-122"/>
+                <a:cs typeface="Poppins" pitchFamily="34" charset="-120"/>
+              </a:rPr>
+              <a:t>21.3h  ▲ +14.0h</a:t>
+            </a:r>
+            <a:endParaRPr lang="en-US" sz="680" dirty="0"/>
+          </a:p>
+        </p:txBody>
+      </p:sp>
+      <p:sp>
+        <p:nvSpPr>
+          <p:cNvPr id="62" name="Shape 59"/>
           <p:cNvSpPr/>
           <p:nvPr/>
         </p:nvSpPr>
         <p:spPr>
           <a:xfrm>
-            <a:off x="612648" y="5148072"/>
-            <a:ext cx="4718304" cy="5486"/>
+            <a:off x="594360" y="5696712"/>
+            <a:ext cx="4754880" cy="5486"/>
           </a:xfrm>
           <a:prstGeom prst="rect">
             <a:avLst/>
@@ -3235,30 +3561,30 @@
       </p:sp>
       <p:sp>
         <p:nvSpPr>
-          <p:cNvPr id="55" name="Text 52"/>
-          <p:cNvSpPr txBox="1"/>
-          <p:nvPr/>
-        </p:nvSpPr>
-        <p:spPr>
-          <a:xfrm>
-            <a:off x="612648" y="4910328"/>
-            <a:ext cx="1097280" cy="246888"/>
-          </a:xfrm>
-          <a:prstGeom prst="rect">
-            <a:avLst/>
-          </a:prstGeom>
-          <a:noFill/>
-          <a:ln/>
-        </p:spPr>
-        <p:txBody>
-          <a:bodyPr wrap="square" lIns="0" tIns="0" rIns="0" bIns="0" rtlCol="0" anchor="ctr"/>
-          <a:lstStyle/>
-          <a:p>
-            <a:pPr indent="0" marL="0">
-              <a:buNone/>
-            </a:pPr>
-            <a:r>
-              <a:rPr lang="en-US" sz="800" b="1" dirty="0">
+          <p:cNvPr id="63" name="Text 60"/>
+          <p:cNvSpPr txBox="1"/>
+          <p:nvPr/>
+        </p:nvSpPr>
+        <p:spPr>
+          <a:xfrm>
+            <a:off x="594360" y="5696712"/>
+            <a:ext cx="777240" cy="237744"/>
+          </a:xfrm>
+          <a:prstGeom prst="rect">
+            <a:avLst/>
+          </a:prstGeom>
+          <a:noFill/>
+          <a:ln/>
+        </p:spPr>
+        <p:txBody>
+          <a:bodyPr wrap="square" lIns="0" tIns="0" rIns="0" bIns="0" rtlCol="0" anchor="ctr"/>
+          <a:lstStyle/>
+          <a:p>
+            <a:pPr algn="l" indent="0" marL="0">
+              <a:buNone/>
+            </a:pPr>
+            <a:r>
+              <a:rPr lang="en-US" sz="780" b="1" dirty="0">
                 <a:solidFill>
                   <a:srgbClr val="12293A"/>
                 </a:solidFill>
@@ -3266,77 +3592,38 @@
                 <a:ea typeface="Poppins" pitchFamily="34" charset="-122"/>
                 <a:cs typeface="Poppins" pitchFamily="34" charset="-120"/>
               </a:rPr>
-              <a:t>28 Sep–4 Oct</a:t>
-            </a:r>
-            <a:endParaRPr lang="en-US" sz="800" dirty="0"/>
-          </a:p>
-        </p:txBody>
-      </p:sp>
-      <p:sp>
-        <p:nvSpPr>
-          <p:cNvPr id="56" name="Text 53"/>
-          <p:cNvSpPr txBox="1"/>
-          <p:nvPr/>
-        </p:nvSpPr>
-        <p:spPr>
-          <a:xfrm>
-            <a:off x="1737360" y="4910328"/>
-            <a:ext cx="457200" cy="246888"/>
-          </a:xfrm>
-          <a:prstGeom prst="rect">
-            <a:avLst/>
-          </a:prstGeom>
-          <a:noFill/>
-          <a:ln/>
-        </p:spPr>
-        <p:txBody>
-          <a:bodyPr wrap="square" lIns="0" tIns="0" rIns="0" bIns="0" rtlCol="0" anchor="ctr"/>
-          <a:lstStyle/>
-          <a:p>
-            <a:pPr algn="r" indent="0" marL="0">
-              <a:buNone/>
-            </a:pPr>
-            <a:r>
-              <a:rPr lang="en-US" sz="800" dirty="0">
-                <a:solidFill>
-                  <a:srgbClr val="5E7280"/>
-                </a:solidFill>
-                <a:latin typeface="Poppins" pitchFamily="34" charset="0"/>
-                <a:ea typeface="Poppins" pitchFamily="34" charset="-122"/>
-                <a:cs typeface="Poppins" pitchFamily="34" charset="-120"/>
-              </a:rPr>
-              <a:t>32</a:t>
-            </a:r>
-            <a:endParaRPr lang="en-US" sz="800" dirty="0"/>
-          </a:p>
-        </p:txBody>
-      </p:sp>
-      <p:sp>
-        <p:nvSpPr>
-          <p:cNvPr id="57" name="Text 54"/>
-          <p:cNvSpPr txBox="1"/>
-          <p:nvPr/>
-        </p:nvSpPr>
-        <p:spPr>
-          <a:xfrm>
-            <a:off x="2240280" y="4910328"/>
-            <a:ext cx="777240" cy="246888"/>
-          </a:xfrm>
-          <a:prstGeom prst="rect">
-            <a:avLst/>
-          </a:prstGeom>
-          <a:noFill/>
-          <a:ln/>
-        </p:spPr>
-        <p:txBody>
-          <a:bodyPr wrap="square" lIns="0" tIns="0" rIns="0" bIns="0" rtlCol="0" anchor="ctr"/>
-          <a:lstStyle/>
-          <a:p>
-            <a:pPr algn="r" indent="0" marL="0">
-              <a:buNone/>
-            </a:pPr>
-            <a:r>
-              <a:rPr lang="en-US" sz="850" b="1" dirty="0">
+              <a:t>12–18 Oct</a:t>
+            </a:r>
+            <a:endParaRPr lang="en-US" sz="780" dirty="0"/>
+          </a:p>
+        </p:txBody>
+      </p:sp>
+      <p:sp>
+        <p:nvSpPr>
+          <p:cNvPr id="64" name="Text 61"/>
+          <p:cNvSpPr txBox="1"/>
+          <p:nvPr/>
+        </p:nvSpPr>
+        <p:spPr>
+          <a:xfrm>
+            <a:off x="1371600" y="5696712"/>
+            <a:ext cx="594360" cy="237744"/>
+          </a:xfrm>
+          <a:prstGeom prst="rect">
+            <a:avLst/>
+          </a:prstGeom>
+          <a:noFill/>
+          <a:ln/>
+        </p:spPr>
+        <p:txBody>
+          <a:bodyPr wrap="square" lIns="0" tIns="0" rIns="0" bIns="0" rtlCol="0" anchor="ctr"/>
+          <a:lstStyle/>
+          <a:p>
+            <a:pPr algn="r" indent="0" marL="0">
+              <a:buNone/>
+            </a:pPr>
+            <a:r>
+              <a:rPr lang="en-US" sz="780" b="1" dirty="0">
                 <a:solidFill>
                   <a:srgbClr val="2C8394"/>
                 </a:solidFill>
@@ -3344,38 +3631,116 @@
                 <a:ea typeface="Poppins" pitchFamily="34" charset="-122"/>
                 <a:cs typeface="Poppins" pitchFamily="34" charset="-120"/>
               </a:rPr>
-              <a:t>83.46h</a:t>
-            </a:r>
-            <a:endParaRPr lang="en-US" sz="850" dirty="0"/>
-          </a:p>
-        </p:txBody>
-      </p:sp>
-      <p:sp>
-        <p:nvSpPr>
-          <p:cNvPr id="58" name="Text 55"/>
-          <p:cNvSpPr txBox="1"/>
-          <p:nvPr/>
-        </p:nvSpPr>
-        <p:spPr>
-          <a:xfrm>
-            <a:off x="3063240" y="4910328"/>
-            <a:ext cx="502920" cy="246888"/>
-          </a:xfrm>
-          <a:prstGeom prst="rect">
-            <a:avLst/>
-          </a:prstGeom>
-          <a:noFill/>
-          <a:ln/>
-        </p:spPr>
-        <p:txBody>
-          <a:bodyPr wrap="square" lIns="0" tIns="0" rIns="0" bIns="0" rtlCol="0" anchor="ctr"/>
-          <a:lstStyle/>
-          <a:p>
-            <a:pPr algn="r" indent="0" marL="0">
-              <a:buNone/>
-            </a:pPr>
-            <a:r>
-              <a:rPr lang="en-US" sz="850" b="1" dirty="0">
+              <a:t>51.0h</a:t>
+            </a:r>
+            <a:endParaRPr lang="en-US" sz="780" dirty="0"/>
+          </a:p>
+        </p:txBody>
+      </p:sp>
+      <p:sp>
+        <p:nvSpPr>
+          <p:cNvPr id="65" name="Text 62"/>
+          <p:cNvSpPr txBox="1"/>
+          <p:nvPr/>
+        </p:nvSpPr>
+        <p:spPr>
+          <a:xfrm>
+            <a:off x="2011680" y="5696712"/>
+            <a:ext cx="685800" cy="237744"/>
+          </a:xfrm>
+          <a:prstGeom prst="rect">
+            <a:avLst/>
+          </a:prstGeom>
+          <a:noFill/>
+          <a:ln/>
+        </p:spPr>
+        <p:txBody>
+          <a:bodyPr wrap="square" lIns="0" tIns="0" rIns="0" bIns="0" rtlCol="0" anchor="ctr"/>
+          <a:lstStyle/>
+          <a:p>
+            <a:pPr algn="r" indent="0" marL="0">
+              <a:buNone/>
+            </a:pPr>
+            <a:r>
+              <a:rPr lang="en-US" sz="780" dirty="0">
+                <a:solidFill>
+                  <a:srgbClr val="12293A"/>
+                </a:solidFill>
+                <a:latin typeface="Poppins" pitchFamily="34" charset="0"/>
+                <a:ea typeface="Poppins" pitchFamily="34" charset="-122"/>
+                <a:cs typeface="Poppins" pitchFamily="34" charset="-120"/>
+              </a:rPr>
+              <a:t>12.5h</a:t>
+            </a:r>
+            <a:endParaRPr lang="en-US" sz="780" dirty="0"/>
+          </a:p>
+        </p:txBody>
+      </p:sp>
+      <p:sp>
+        <p:nvSpPr>
+          <p:cNvPr id="66" name="Text 63"/>
+          <p:cNvSpPr txBox="1"/>
+          <p:nvPr/>
+        </p:nvSpPr>
+        <p:spPr>
+          <a:xfrm>
+            <a:off x="2743200" y="5696712"/>
+            <a:ext cx="640080" cy="237744"/>
+          </a:xfrm>
+          <a:prstGeom prst="rect">
+            <a:avLst/>
+          </a:prstGeom>
+          <a:noFill/>
+          <a:ln/>
+        </p:spPr>
+        <p:txBody>
+          <a:bodyPr wrap="square" lIns="0" tIns="0" rIns="0" bIns="0" rtlCol="0" anchor="ctr"/>
+          <a:lstStyle/>
+          <a:p>
+            <a:pPr algn="r" indent="0" marL="0">
+              <a:buNone/>
+            </a:pPr>
+            <a:r>
+              <a:rPr lang="en-US" sz="780" dirty="0">
+                <a:solidFill>
+                  <a:srgbClr val="12293A"/>
+                </a:solidFill>
+                <a:latin typeface="Poppins" pitchFamily="34" charset="0"/>
+                <a:ea typeface="Poppins" pitchFamily="34" charset="-122"/>
+                <a:cs typeface="Poppins" pitchFamily="34" charset="-120"/>
+              </a:rPr>
+              <a:t>1.0h</a:t>
+            </a:r>
+            <a:endParaRPr lang="en-US" sz="780" dirty="0"/>
+          </a:p>
+        </p:txBody>
+      </p:sp>
+      <p:sp>
+        <p:nvSpPr>
+          <p:cNvPr id="67" name="Text 64"/>
+          <p:cNvSpPr txBox="1"/>
+          <p:nvPr/>
+        </p:nvSpPr>
+        <p:spPr>
+          <a:xfrm>
+            <a:off x="3429000" y="5696712"/>
+            <a:ext cx="457200" cy="237744"/>
+          </a:xfrm>
+          <a:prstGeom prst="rect">
+            <a:avLst/>
+          </a:prstGeom>
+          <a:noFill/>
+          <a:ln/>
+        </p:spPr>
+        <p:txBody>
+          <a:bodyPr wrap="square" lIns="0" tIns="0" rIns="0" bIns="0" rtlCol="0" anchor="ctr"/>
+          <a:lstStyle/>
+          <a:p>
+            <a:pPr algn="r" indent="0" marL="0">
+              <a:buNone/>
+            </a:pPr>
+            <a:r>
+              <a:rPr lang="en-US" sz="780" dirty="0">
                 <a:solidFill>
                   <a:srgbClr val="C88A2E"/>
                 </a:solidFill>
@@ -3383,38 +3748,38 @@
                 <a:ea typeface="Poppins" pitchFamily="34" charset="-122"/>
                 <a:cs typeface="Poppins" pitchFamily="34" charset="-120"/>
               </a:rPr>
-              <a:t>31.4%</a:t>
-            </a:r>
-            <a:endParaRPr lang="en-US" sz="850" dirty="0"/>
-          </a:p>
-        </p:txBody>
-      </p:sp>
-      <p:sp>
-        <p:nvSpPr>
-          <p:cNvPr id="59" name="Text 56"/>
-          <p:cNvSpPr txBox="1"/>
-          <p:nvPr/>
-        </p:nvSpPr>
-        <p:spPr>
-          <a:xfrm>
-            <a:off x="3611880" y="4910328"/>
-            <a:ext cx="1737360" cy="246888"/>
-          </a:xfrm>
-          <a:prstGeom prst="rect">
-            <a:avLst/>
-          </a:prstGeom>
-          <a:noFill/>
-          <a:ln/>
-        </p:spPr>
-        <p:txBody>
-          <a:bodyPr wrap="square" lIns="0" tIns="0" rIns="0" bIns="0" rtlCol="0" anchor="ctr"/>
-          <a:lstStyle/>
-          <a:p>
-            <a:pPr algn="r" indent="0" marL="0">
-              <a:buNone/>
-            </a:pPr>
-            <a:r>
-              <a:rPr lang="en-US" sz="700" b="1" dirty="0">
+              <a:t>37.5h</a:t>
+            </a:r>
+            <a:endParaRPr lang="en-US" sz="780" dirty="0"/>
+          </a:p>
+        </p:txBody>
+      </p:sp>
+      <p:sp>
+        <p:nvSpPr>
+          <p:cNvPr id="68" name="Text 65"/>
+          <p:cNvSpPr txBox="1"/>
+          <p:nvPr/>
+        </p:nvSpPr>
+        <p:spPr>
+          <a:xfrm>
+            <a:off x="3931920" y="5696712"/>
+            <a:ext cx="457200" cy="237744"/>
+          </a:xfrm>
+          <a:prstGeom prst="rect">
+            <a:avLst/>
+          </a:prstGeom>
+          <a:noFill/>
+          <a:ln/>
+        </p:spPr>
+        <p:txBody>
+          <a:bodyPr wrap="square" lIns="0" tIns="0" rIns="0" bIns="0" rtlCol="0" anchor="ctr"/>
+          <a:lstStyle/>
+          <a:p>
+            <a:pPr algn="r" indent="0" marL="0">
+              <a:buNone/>
+            </a:pPr>
+            <a:r>
+              <a:rPr lang="en-US" sz="780" b="1" dirty="0">
                 <a:solidFill>
                   <a:srgbClr val="C88A2E"/>
                 </a:solidFill>
@@ -3422,22 +3787,61 @@
                 <a:ea typeface="Poppins" pitchFamily="34" charset="-122"/>
                 <a:cs typeface="Poppins" pitchFamily="34" charset="-120"/>
               </a:rPr>
-              <a:t>88.87h · 33.4%   ▼ −5.41h</a:t>
-            </a:r>
-            <a:endParaRPr lang="en-US" sz="700" dirty="0"/>
-          </a:p>
-        </p:txBody>
-      </p:sp>
-      <p:sp>
-        <p:nvSpPr>
-          <p:cNvPr id="60" name="Shape 57"/>
+              <a:t>16.8%</a:t>
+            </a:r>
+            <a:endParaRPr lang="en-US" sz="780" dirty="0"/>
+          </a:p>
+        </p:txBody>
+      </p:sp>
+      <p:sp>
+        <p:nvSpPr>
+          <p:cNvPr id="69" name="Text 66"/>
+          <p:cNvSpPr txBox="1"/>
+          <p:nvPr/>
+        </p:nvSpPr>
+        <p:spPr>
+          <a:xfrm>
+            <a:off x="4434840" y="5696712"/>
+            <a:ext cx="914400" cy="237744"/>
+          </a:xfrm>
+          <a:prstGeom prst="rect">
+            <a:avLst/>
+          </a:prstGeom>
+          <a:noFill/>
+          <a:ln/>
+        </p:spPr>
+        <p:txBody>
+          <a:bodyPr wrap="square" lIns="0" tIns="0" rIns="0" bIns="0" rtlCol="0" anchor="ctr"/>
+          <a:lstStyle/>
+          <a:p>
+            <a:pPr algn="r" indent="0" marL="0">
+              <a:buNone/>
+            </a:pPr>
+            <a:r>
+              <a:rPr lang="en-US" sz="680" b="1" dirty="0">
+                <a:solidFill>
+                  <a:srgbClr val="B4552D"/>
+                </a:solidFill>
+                <a:latin typeface="Poppins" pitchFamily="34" charset="0"/>
+                <a:ea typeface="Poppins" pitchFamily="34" charset="-122"/>
+                <a:cs typeface="Poppins" pitchFamily="34" charset="-120"/>
+              </a:rPr>
+              <a:t>39.5h  ▲ +11.6h</a:t>
+            </a:r>
+            <a:endParaRPr lang="en-US" sz="680" dirty="0"/>
+          </a:p>
+        </p:txBody>
+      </p:sp>
+      <p:sp>
+        <p:nvSpPr>
+          <p:cNvPr id="70" name="Shape 67"/>
           <p:cNvSpPr/>
           <p:nvPr/>
         </p:nvSpPr>
         <p:spPr>
           <a:xfrm>
-            <a:off x="612648" y="5394960"/>
-            <a:ext cx="4718304" cy="5486"/>
+            <a:off x="594360" y="5934456"/>
+            <a:ext cx="4754880" cy="5486"/>
           </a:xfrm>
           <a:prstGeom prst="rect">
             <a:avLst/>
@@ -3450,30 +3854,108 @@
       </p:sp>
       <p:sp>
         <p:nvSpPr>
-          <p:cNvPr id="61" name="Text 58"/>
-          <p:cNvSpPr txBox="1"/>
-          <p:nvPr/>
-        </p:nvSpPr>
-        <p:spPr>
-          <a:xfrm>
-            <a:off x="612648" y="5157216"/>
-            <a:ext cx="1097280" cy="246888"/>
-          </a:xfrm>
-          <a:prstGeom prst="rect">
-            <a:avLst/>
-          </a:prstGeom>
-          <a:noFill/>
-          <a:ln/>
-        </p:spPr>
-        <p:txBody>
-          <a:bodyPr wrap="square" lIns="0" tIns="0" rIns="0" bIns="0" rtlCol="0" anchor="ctr"/>
-          <a:lstStyle/>
-          <a:p>
-            <a:pPr indent="0" marL="0">
-              <a:buNone/>
-            </a:pPr>
-            <a:r>
-              <a:rPr lang="en-US" sz="800" b="1" dirty="0">
+          <p:cNvPr id="71" name="Text 68"/>
+          <p:cNvSpPr txBox="1"/>
+          <p:nvPr/>
+        </p:nvSpPr>
+        <p:spPr>
+          <a:xfrm>
+            <a:off x="594360" y="5934456"/>
+            <a:ext cx="777240" cy="237744"/>
+          </a:xfrm>
+          <a:prstGeom prst="rect">
+            <a:avLst/>
+          </a:prstGeom>
+          <a:noFill/>
+          <a:ln/>
+        </p:spPr>
+        <p:txBody>
+          <a:bodyPr wrap="square" lIns="0" tIns="0" rIns="0" bIns="0" rtlCol="0" anchor="ctr"/>
+          <a:lstStyle/>
+          <a:p>
+            <a:pPr algn="l" indent="0" marL="0">
+              <a:buNone/>
+            </a:pPr>
+            <a:r>
+              <a:rPr lang="en-US" sz="780" b="1" dirty="0">
+                <a:solidFill>
+                  <a:srgbClr val="2C8394"/>
+                </a:solidFill>
+                <a:latin typeface="Poppins" pitchFamily="34" charset="0"/>
+                <a:ea typeface="Poppins" pitchFamily="34" charset="-122"/>
+                <a:cs typeface="Poppins" pitchFamily="34" charset="-120"/>
+              </a:rPr>
+              <a:t>19–25 Oct ●</a:t>
+            </a:r>
+            <a:endParaRPr lang="en-US" sz="780" dirty="0"/>
+          </a:p>
+        </p:txBody>
+      </p:sp>
+      <p:sp>
+        <p:nvSpPr>
+          <p:cNvPr id="72" name="Text 69"/>
+          <p:cNvSpPr txBox="1"/>
+          <p:nvPr/>
+        </p:nvSpPr>
+        <p:spPr>
+          <a:xfrm>
+            <a:off x="1371600" y="5934456"/>
+            <a:ext cx="594360" cy="237744"/>
+          </a:xfrm>
+          <a:prstGeom prst="rect">
+            <a:avLst/>
+          </a:prstGeom>
+          <a:noFill/>
+          <a:ln/>
+        </p:spPr>
+        <p:txBody>
+          <a:bodyPr wrap="square" lIns="0" tIns="0" rIns="0" bIns="0" rtlCol="0" anchor="ctr"/>
+          <a:lstStyle/>
+          <a:p>
+            <a:pPr algn="r" indent="0" marL="0">
+              <a:buNone/>
+            </a:pPr>
+            <a:r>
+              <a:rPr lang="en-US" sz="780" b="1" dirty="0">
+                <a:solidFill>
+                  <a:srgbClr val="2C8394"/>
+                </a:solidFill>
+                <a:latin typeface="Poppins" pitchFamily="34" charset="0"/>
+                <a:ea typeface="Poppins" pitchFamily="34" charset="-122"/>
+                <a:cs typeface="Poppins" pitchFamily="34" charset="-120"/>
+              </a:rPr>
+              <a:t>11.5h</a:t>
+            </a:r>
+            <a:endParaRPr lang="en-US" sz="780" dirty="0"/>
+          </a:p>
+        </p:txBody>
+      </p:sp>
+      <p:sp>
+        <p:nvSpPr>
+          <p:cNvPr id="73" name="Text 70"/>
+          <p:cNvSpPr txBox="1"/>
+          <p:nvPr/>
+        </p:nvSpPr>
+        <p:spPr>
+          <a:xfrm>
+            <a:off x="2011680" y="5934456"/>
+            <a:ext cx="685800" cy="237744"/>
+          </a:xfrm>
+          <a:prstGeom prst="rect">
+            <a:avLst/>
+          </a:prstGeom>
+          <a:noFill/>
+          <a:ln/>
+        </p:spPr>
+        <p:txBody>
+          <a:bodyPr wrap="square" lIns="0" tIns="0" rIns="0" bIns="0" rtlCol="0" anchor="ctr"/>
+          <a:lstStyle/>
+          <a:p>
+            <a:pPr algn="r" indent="0" marL="0">
+              <a:buNone/>
+            </a:pPr>
+            <a:r>
+              <a:rPr lang="en-US" sz="780" dirty="0">
                 <a:solidFill>
                   <a:srgbClr val="12293A"/>
                 </a:solidFill>
@@ -3481,116 +3963,77 @@
                 <a:ea typeface="Poppins" pitchFamily="34" charset="-122"/>
                 <a:cs typeface="Poppins" pitchFamily="34" charset="-120"/>
               </a:rPr>
-              <a:t>5–11 Oct</a:t>
-            </a:r>
-            <a:endParaRPr lang="en-US" sz="800" dirty="0"/>
-          </a:p>
-        </p:txBody>
-      </p:sp>
-      <p:sp>
-        <p:nvSpPr>
-          <p:cNvPr id="62" name="Text 59"/>
-          <p:cNvSpPr txBox="1"/>
-          <p:nvPr/>
-        </p:nvSpPr>
-        <p:spPr>
-          <a:xfrm>
-            <a:off x="1737360" y="5157216"/>
-            <a:ext cx="457200" cy="246888"/>
-          </a:xfrm>
-          <a:prstGeom prst="rect">
-            <a:avLst/>
-          </a:prstGeom>
-          <a:noFill/>
-          <a:ln/>
-        </p:spPr>
-        <p:txBody>
-          <a:bodyPr wrap="square" lIns="0" tIns="0" rIns="0" bIns="0" rtlCol="0" anchor="ctr"/>
-          <a:lstStyle/>
-          <a:p>
-            <a:pPr algn="r" indent="0" marL="0">
-              <a:buNone/>
-            </a:pPr>
-            <a:r>
-              <a:rPr lang="en-US" sz="800" dirty="0">
-                <a:solidFill>
-                  <a:srgbClr val="5E7280"/>
-                </a:solidFill>
-                <a:latin typeface="Poppins" pitchFamily="34" charset="0"/>
-                <a:ea typeface="Poppins" pitchFamily="34" charset="-122"/>
-                <a:cs typeface="Poppins" pitchFamily="34" charset="-120"/>
-              </a:rPr>
-              <a:t>21</a:t>
-            </a:r>
-            <a:endParaRPr lang="en-US" sz="800" dirty="0"/>
-          </a:p>
-        </p:txBody>
-      </p:sp>
-      <p:sp>
-        <p:nvSpPr>
-          <p:cNvPr id="63" name="Text 60"/>
-          <p:cNvSpPr txBox="1"/>
-          <p:nvPr/>
-        </p:nvSpPr>
-        <p:spPr>
-          <a:xfrm>
-            <a:off x="2240280" y="5157216"/>
-            <a:ext cx="777240" cy="246888"/>
-          </a:xfrm>
-          <a:prstGeom prst="rect">
-            <a:avLst/>
-          </a:prstGeom>
-          <a:noFill/>
-          <a:ln/>
-        </p:spPr>
-        <p:txBody>
-          <a:bodyPr wrap="square" lIns="0" tIns="0" rIns="0" bIns="0" rtlCol="0" anchor="ctr"/>
-          <a:lstStyle/>
-          <a:p>
-            <a:pPr algn="r" indent="0" marL="0">
-              <a:buNone/>
-            </a:pPr>
-            <a:r>
-              <a:rPr lang="en-US" sz="850" b="1" dirty="0">
-                <a:solidFill>
-                  <a:srgbClr val="2C8394"/>
-                </a:solidFill>
-                <a:latin typeface="Poppins" pitchFamily="34" charset="0"/>
-                <a:ea typeface="Poppins" pitchFamily="34" charset="-122"/>
-                <a:cs typeface="Poppins" pitchFamily="34" charset="-120"/>
-              </a:rPr>
-              <a:t>35.25h</a:t>
-            </a:r>
-            <a:endParaRPr lang="en-US" sz="850" dirty="0"/>
-          </a:p>
-        </p:txBody>
-      </p:sp>
-      <p:sp>
-        <p:nvSpPr>
-          <p:cNvPr id="64" name="Text 61"/>
-          <p:cNvSpPr txBox="1"/>
-          <p:nvPr/>
-        </p:nvSpPr>
-        <p:spPr>
-          <a:xfrm>
-            <a:off x="3063240" y="5157216"/>
-            <a:ext cx="502920" cy="246888"/>
-          </a:xfrm>
-          <a:prstGeom prst="rect">
-            <a:avLst/>
-          </a:prstGeom>
-          <a:noFill/>
-          <a:ln/>
-        </p:spPr>
-        <p:txBody>
-          <a:bodyPr wrap="square" lIns="0" tIns="0" rIns="0" bIns="0" rtlCol="0" anchor="ctr"/>
-          <a:lstStyle/>
-          <a:p>
-            <a:pPr algn="r" indent="0" marL="0">
-              <a:buNone/>
-            </a:pPr>
-            <a:r>
-              <a:rPr lang="en-US" sz="850" b="1" dirty="0">
+              <a:t>3.5h</a:t>
+            </a:r>
+            <a:endParaRPr lang="en-US" sz="780" dirty="0"/>
+          </a:p>
+        </p:txBody>
+      </p:sp>
+      <p:sp>
+        <p:nvSpPr>
+          <p:cNvPr id="74" name="Text 71"/>
+          <p:cNvSpPr txBox="1"/>
+          <p:nvPr/>
+        </p:nvSpPr>
+        <p:spPr>
+          <a:xfrm>
+            <a:off x="2743200" y="5934456"/>
+            <a:ext cx="640080" cy="237744"/>
+          </a:xfrm>
+          <a:prstGeom prst="rect">
+            <a:avLst/>
+          </a:prstGeom>
+          <a:noFill/>
+          <a:ln/>
+        </p:spPr>
+        <p:txBody>
+          <a:bodyPr wrap="square" lIns="0" tIns="0" rIns="0" bIns="0" rtlCol="0" anchor="ctr"/>
+          <a:lstStyle/>
+          <a:p>
+            <a:pPr algn="r" indent="0" marL="0">
+              <a:buNone/>
+            </a:pPr>
+            <a:r>
+              <a:rPr lang="en-US" sz="780" dirty="0">
+                <a:solidFill>
+                  <a:srgbClr val="12293A"/>
+                </a:solidFill>
+                <a:latin typeface="Poppins" pitchFamily="34" charset="0"/>
+                <a:ea typeface="Poppins" pitchFamily="34" charset="-122"/>
+                <a:cs typeface="Poppins" pitchFamily="34" charset="-120"/>
+              </a:rPr>
+              <a:t>1.0h</a:t>
+            </a:r>
+            <a:endParaRPr lang="en-US" sz="780" dirty="0"/>
+          </a:p>
+        </p:txBody>
+      </p:sp>
+      <p:sp>
+        <p:nvSpPr>
+          <p:cNvPr id="75" name="Text 72"/>
+          <p:cNvSpPr txBox="1"/>
+          <p:nvPr/>
+        </p:nvSpPr>
+        <p:spPr>
+          <a:xfrm>
+            <a:off x="3429000" y="5934456"/>
+            <a:ext cx="457200" cy="237744"/>
+          </a:xfrm>
+          <a:prstGeom prst="rect">
+            <a:avLst/>
+          </a:prstGeom>
+          <a:noFill/>
+          <a:ln/>
+        </p:spPr>
+        <p:txBody>
+          <a:bodyPr wrap="square" lIns="0" tIns="0" rIns="0" bIns="0" rtlCol="0" anchor="ctr"/>
+          <a:lstStyle/>
+          <a:p>
+            <a:pPr algn="r" indent="0" marL="0">
+              <a:buNone/>
+            </a:pPr>
+            <a:r>
+              <a:rPr lang="en-US" sz="780" dirty="0">
                 <a:solidFill>
                   <a:srgbClr val="C88A2E"/>
                 </a:solidFill>
@@ -3598,214 +4041,38 @@
                 <a:ea typeface="Poppins" pitchFamily="34" charset="-122"/>
                 <a:cs typeface="Poppins" pitchFamily="34" charset="-120"/>
               </a:rPr>
-              <a:t>10.3%</a:t>
-            </a:r>
-            <a:endParaRPr lang="en-US" sz="850" dirty="0"/>
-          </a:p>
-        </p:txBody>
-      </p:sp>
-      <p:sp>
-        <p:nvSpPr>
-          <p:cNvPr id="65" name="Text 62"/>
-          <p:cNvSpPr txBox="1"/>
-          <p:nvPr/>
-        </p:nvSpPr>
-        <p:spPr>
-          <a:xfrm>
-            <a:off x="3611880" y="5157216"/>
-            <a:ext cx="1737360" cy="246888"/>
-          </a:xfrm>
-          <a:prstGeom prst="rect">
-            <a:avLst/>
-          </a:prstGeom>
-          <a:noFill/>
-          <a:ln/>
-        </p:spPr>
-        <p:txBody>
-          <a:bodyPr wrap="square" lIns="0" tIns="0" rIns="0" bIns="0" rtlCol="0" anchor="ctr"/>
-          <a:lstStyle/>
-          <a:p>
-            <a:pPr algn="r" indent="0" marL="0">
-              <a:buNone/>
-            </a:pPr>
-            <a:r>
-              <a:rPr lang="en-US" sz="700" b="1" dirty="0">
-                <a:solidFill>
-                  <a:srgbClr val="B4552D"/>
-                </a:solidFill>
-                <a:latin typeface="Poppins" pitchFamily="34" charset="0"/>
-                <a:ea typeface="Poppins" pitchFamily="34" charset="-122"/>
-                <a:cs typeface="Poppins" pitchFamily="34" charset="-120"/>
-              </a:rPr>
-              <a:t>21.25h · 6.2%   ▲ +14.00h</a:t>
-            </a:r>
-            <a:endParaRPr lang="en-US" sz="700" dirty="0"/>
-          </a:p>
-        </p:txBody>
-      </p:sp>
-      <p:sp>
-        <p:nvSpPr>
-          <p:cNvPr id="66" name="Shape 63"/>
-          <p:cNvSpPr/>
-          <p:nvPr/>
-        </p:nvSpPr>
-        <p:spPr>
-          <a:xfrm>
-            <a:off x="612648" y="5641848"/>
-            <a:ext cx="4718304" cy="5486"/>
-          </a:xfrm>
-          <a:prstGeom prst="rect">
-            <a:avLst/>
-          </a:prstGeom>
-          <a:solidFill>
-            <a:srgbClr val="E2EAEE"/>
-          </a:solidFill>
-          <a:ln/>
-        </p:spPr>
-      </p:sp>
-      <p:sp>
-        <p:nvSpPr>
-          <p:cNvPr id="67" name="Text 64"/>
-          <p:cNvSpPr txBox="1"/>
-          <p:nvPr/>
-        </p:nvSpPr>
-        <p:spPr>
-          <a:xfrm>
-            <a:off x="612648" y="5404104"/>
-            <a:ext cx="1097280" cy="246888"/>
-          </a:xfrm>
-          <a:prstGeom prst="rect">
-            <a:avLst/>
-          </a:prstGeom>
-          <a:noFill/>
-          <a:ln/>
-        </p:spPr>
-        <p:txBody>
-          <a:bodyPr wrap="square" lIns="0" tIns="0" rIns="0" bIns="0" rtlCol="0" anchor="ctr"/>
-          <a:lstStyle/>
-          <a:p>
-            <a:pPr indent="0" marL="0">
-              <a:buNone/>
-            </a:pPr>
-            <a:r>
-              <a:rPr lang="en-US" sz="800" b="1" dirty="0">
-                <a:solidFill>
-                  <a:srgbClr val="12293A"/>
-                </a:solidFill>
-                <a:latin typeface="Poppins" pitchFamily="34" charset="0"/>
-                <a:ea typeface="Poppins" pitchFamily="34" charset="-122"/>
-                <a:cs typeface="Poppins" pitchFamily="34" charset="-120"/>
-              </a:rPr>
-              <a:t>12–18 Oct</a:t>
-            </a:r>
-            <a:endParaRPr lang="en-US" sz="800" dirty="0"/>
-          </a:p>
-        </p:txBody>
-      </p:sp>
-      <p:sp>
-        <p:nvSpPr>
-          <p:cNvPr id="68" name="Text 65"/>
-          <p:cNvSpPr txBox="1"/>
-          <p:nvPr/>
-        </p:nvSpPr>
-        <p:spPr>
-          <a:xfrm>
-            <a:off x="1737360" y="5404104"/>
-            <a:ext cx="457200" cy="246888"/>
-          </a:xfrm>
-          <a:prstGeom prst="rect">
-            <a:avLst/>
-          </a:prstGeom>
-          <a:noFill/>
-          <a:ln/>
-        </p:spPr>
-        <p:txBody>
-          <a:bodyPr wrap="square" lIns="0" tIns="0" rIns="0" bIns="0" rtlCol="0" anchor="ctr"/>
-          <a:lstStyle/>
-          <a:p>
-            <a:pPr algn="r" indent="0" marL="0">
-              <a:buNone/>
-            </a:pPr>
-            <a:r>
-              <a:rPr lang="en-US" sz="800" dirty="0">
-                <a:solidFill>
-                  <a:srgbClr val="5E7280"/>
-                </a:solidFill>
-                <a:latin typeface="Poppins" pitchFamily="34" charset="0"/>
-                <a:ea typeface="Poppins" pitchFamily="34" charset="-122"/>
-                <a:cs typeface="Poppins" pitchFamily="34" charset="-120"/>
-              </a:rPr>
-              <a:t>36</a:t>
-            </a:r>
-            <a:endParaRPr lang="en-US" sz="800" dirty="0"/>
-          </a:p>
-        </p:txBody>
-      </p:sp>
-      <p:sp>
-        <p:nvSpPr>
-          <p:cNvPr id="69" name="Text 66"/>
-          <p:cNvSpPr txBox="1"/>
-          <p:nvPr/>
-        </p:nvSpPr>
-        <p:spPr>
-          <a:xfrm>
-            <a:off x="2240280" y="5404104"/>
-            <a:ext cx="777240" cy="246888"/>
-          </a:xfrm>
-          <a:prstGeom prst="rect">
-            <a:avLst/>
-          </a:prstGeom>
-          <a:noFill/>
-          <a:ln/>
-        </p:spPr>
-        <p:txBody>
-          <a:bodyPr wrap="square" lIns="0" tIns="0" rIns="0" bIns="0" rtlCol="0" anchor="ctr"/>
-          <a:lstStyle/>
-          <a:p>
-            <a:pPr algn="r" indent="0" marL="0">
-              <a:buNone/>
-            </a:pPr>
-            <a:r>
-              <a:rPr lang="en-US" sz="850" b="1" dirty="0">
-                <a:solidFill>
-                  <a:srgbClr val="2C8394"/>
-                </a:solidFill>
-                <a:latin typeface="Poppins" pitchFamily="34" charset="0"/>
-                <a:ea typeface="Poppins" pitchFamily="34" charset="-122"/>
-                <a:cs typeface="Poppins" pitchFamily="34" charset="-120"/>
-              </a:rPr>
-              <a:t>51.02h</a:t>
-            </a:r>
-            <a:endParaRPr lang="en-US" sz="850" dirty="0"/>
-          </a:p>
-        </p:txBody>
-      </p:sp>
-      <p:sp>
-        <p:nvSpPr>
-          <p:cNvPr id="70" name="Text 67"/>
-          <p:cNvSpPr txBox="1"/>
-          <p:nvPr/>
-        </p:nvSpPr>
-        <p:spPr>
-          <a:xfrm>
-            <a:off x="3063240" y="5404104"/>
-            <a:ext cx="502920" cy="246888"/>
-          </a:xfrm>
-          <a:prstGeom prst="rect">
-            <a:avLst/>
-          </a:prstGeom>
-          <a:noFill/>
-          <a:ln/>
-        </p:spPr>
-        <p:txBody>
-          <a:bodyPr wrap="square" lIns="0" tIns="0" rIns="0" bIns="0" rtlCol="0" anchor="ctr"/>
-          <a:lstStyle/>
-          <a:p>
-            <a:pPr algn="r" indent="0" marL="0">
-              <a:buNone/>
-            </a:pPr>
-            <a:r>
-              <a:rPr lang="en-US" sz="850" b="1" dirty="0">
+              <a:t>7.0h</a:t>
+            </a:r>
+            <a:endParaRPr lang="en-US" sz="780" dirty="0"/>
+          </a:p>
+        </p:txBody>
+      </p:sp>
+      <p:sp>
+        <p:nvSpPr>
+          <p:cNvPr id="76" name="Text 73"/>
+          <p:cNvSpPr txBox="1"/>
+          <p:nvPr/>
+        </p:nvSpPr>
+        <p:spPr>
+          <a:xfrm>
+            <a:off x="3931920" y="5934456"/>
+            <a:ext cx="457200" cy="237744"/>
+          </a:xfrm>
+          <a:prstGeom prst="rect">
+            <a:avLst/>
+          </a:prstGeom>
+          <a:noFill/>
+          <a:ln/>
+        </p:spPr>
+        <p:txBody>
+          <a:bodyPr wrap="square" lIns="0" tIns="0" rIns="0" bIns="0" rtlCol="0" anchor="ctr"/>
+          <a:lstStyle/>
+          <a:p>
+            <a:pPr algn="r" indent="0" marL="0">
+              <a:buNone/>
+            </a:pPr>
+            <a:r>
+              <a:rPr lang="en-US" sz="780" b="1" dirty="0">
                 <a:solidFill>
                   <a:srgbClr val="C88A2E"/>
                 </a:solidFill>
@@ -3813,224 +4080,9 @@
                 <a:ea typeface="Poppins" pitchFamily="34" charset="-122"/>
                 <a:cs typeface="Poppins" pitchFamily="34" charset="-120"/>
               </a:rPr>
-              <a:t>16.8%</a:t>
-            </a:r>
-            <a:endParaRPr lang="en-US" sz="850" dirty="0"/>
-          </a:p>
-        </p:txBody>
-      </p:sp>
-      <p:sp>
-        <p:nvSpPr>
-          <p:cNvPr id="71" name="Text 68"/>
-          <p:cNvSpPr txBox="1"/>
-          <p:nvPr/>
-        </p:nvSpPr>
-        <p:spPr>
-          <a:xfrm>
-            <a:off x="3611880" y="5404104"/>
-            <a:ext cx="1737360" cy="246888"/>
-          </a:xfrm>
-          <a:prstGeom prst="rect">
-            <a:avLst/>
-          </a:prstGeom>
-          <a:noFill/>
-          <a:ln/>
-        </p:spPr>
-        <p:txBody>
-          <a:bodyPr wrap="square" lIns="0" tIns="0" rIns="0" bIns="0" rtlCol="0" anchor="ctr"/>
-          <a:lstStyle/>
-          <a:p>
-            <a:pPr algn="r" indent="0" marL="0">
-              <a:buNone/>
-            </a:pPr>
-            <a:r>
-              <a:rPr lang="en-US" sz="700" b="1" dirty="0">
-                <a:solidFill>
-                  <a:srgbClr val="B4552D"/>
-                </a:solidFill>
-                <a:latin typeface="Poppins" pitchFamily="34" charset="0"/>
-                <a:ea typeface="Poppins" pitchFamily="34" charset="-122"/>
-                <a:cs typeface="Poppins" pitchFamily="34" charset="-120"/>
-              </a:rPr>
-              <a:t>39.45h · 13.0%   ▲ +11.57h</a:t>
-            </a:r>
-            <a:endParaRPr lang="en-US" sz="700" dirty="0"/>
-          </a:p>
-        </p:txBody>
-      </p:sp>
-      <p:sp>
-        <p:nvSpPr>
-          <p:cNvPr id="72" name="Shape 69"/>
-          <p:cNvSpPr/>
-          <p:nvPr/>
-        </p:nvSpPr>
-        <p:spPr>
-          <a:xfrm>
-            <a:off x="612648" y="5888736"/>
-            <a:ext cx="4718304" cy="5486"/>
-          </a:xfrm>
-          <a:prstGeom prst="rect">
-            <a:avLst/>
-          </a:prstGeom>
-          <a:solidFill>
-            <a:srgbClr val="E2EAEE"/>
-          </a:solidFill>
-          <a:ln/>
-        </p:spPr>
-      </p:sp>
-      <p:sp>
-        <p:nvSpPr>
-          <p:cNvPr id="73" name="Text 70"/>
-          <p:cNvSpPr txBox="1"/>
-          <p:nvPr/>
-        </p:nvSpPr>
-        <p:spPr>
-          <a:xfrm>
-            <a:off x="612648" y="5650992"/>
-            <a:ext cx="1097280" cy="246888"/>
-          </a:xfrm>
-          <a:prstGeom prst="rect">
-            <a:avLst/>
-          </a:prstGeom>
-          <a:noFill/>
-          <a:ln/>
-        </p:spPr>
-        <p:txBody>
-          <a:bodyPr wrap="square" lIns="0" tIns="0" rIns="0" bIns="0" rtlCol="0" anchor="ctr"/>
-          <a:lstStyle/>
-          <a:p>
-            <a:pPr indent="0" marL="0">
-              <a:buNone/>
-            </a:pPr>
-            <a:r>
-              <a:rPr lang="en-US" sz="800" b="1" dirty="0">
-                <a:solidFill>
-                  <a:srgbClr val="2C8394"/>
-                </a:solidFill>
-                <a:latin typeface="Poppins" pitchFamily="34" charset="0"/>
-                <a:ea typeface="Poppins" pitchFamily="34" charset="-122"/>
-                <a:cs typeface="Poppins" pitchFamily="34" charset="-120"/>
-              </a:rPr>
-              <a:t>19–25 Oct  ●</a:t>
-            </a:r>
-            <a:endParaRPr lang="en-US" sz="800" dirty="0"/>
-          </a:p>
-        </p:txBody>
-      </p:sp>
-      <p:sp>
-        <p:nvSpPr>
-          <p:cNvPr id="74" name="Text 71"/>
-          <p:cNvSpPr txBox="1"/>
-          <p:nvPr/>
-        </p:nvSpPr>
-        <p:spPr>
-          <a:xfrm>
-            <a:off x="1737360" y="5650992"/>
-            <a:ext cx="457200" cy="246888"/>
-          </a:xfrm>
-          <a:prstGeom prst="rect">
-            <a:avLst/>
-          </a:prstGeom>
-          <a:noFill/>
-          <a:ln/>
-        </p:spPr>
-        <p:txBody>
-          <a:bodyPr wrap="square" lIns="0" tIns="0" rIns="0" bIns="0" rtlCol="0" anchor="ctr"/>
-          <a:lstStyle/>
-          <a:p>
-            <a:pPr algn="r" indent="0" marL="0">
-              <a:buNone/>
-            </a:pPr>
-            <a:r>
-              <a:rPr lang="en-US" sz="800" dirty="0">
-                <a:solidFill>
-                  <a:srgbClr val="5E7280"/>
-                </a:solidFill>
-                <a:latin typeface="Poppins" pitchFamily="34" charset="0"/>
-                <a:ea typeface="Poppins" pitchFamily="34" charset="-122"/>
-                <a:cs typeface="Poppins" pitchFamily="34" charset="-120"/>
-              </a:rPr>
-              <a:t>13</a:t>
-            </a:r>
-            <a:endParaRPr lang="en-US" sz="800" dirty="0"/>
-          </a:p>
-        </p:txBody>
-      </p:sp>
-      <p:sp>
-        <p:nvSpPr>
-          <p:cNvPr id="75" name="Text 72"/>
-          <p:cNvSpPr txBox="1"/>
-          <p:nvPr/>
-        </p:nvSpPr>
-        <p:spPr>
-          <a:xfrm>
-            <a:off x="2240280" y="5650992"/>
-            <a:ext cx="777240" cy="246888"/>
-          </a:xfrm>
-          <a:prstGeom prst="rect">
-            <a:avLst/>
-          </a:prstGeom>
-          <a:noFill/>
-          <a:ln/>
-        </p:spPr>
-        <p:txBody>
-          <a:bodyPr wrap="square" lIns="0" tIns="0" rIns="0" bIns="0" rtlCol="0" anchor="ctr"/>
-          <a:lstStyle/>
-          <a:p>
-            <a:pPr algn="r" indent="0" marL="0">
-              <a:buNone/>
-            </a:pPr>
-            <a:r>
-              <a:rPr lang="en-US" sz="850" b="1" dirty="0">
-                <a:solidFill>
-                  <a:srgbClr val="2C8394"/>
-                </a:solidFill>
-                <a:latin typeface="Poppins" pitchFamily="34" charset="0"/>
-                <a:ea typeface="Poppins" pitchFamily="34" charset="-122"/>
-                <a:cs typeface="Poppins" pitchFamily="34" charset="-120"/>
-              </a:rPr>
-              <a:t>11.50h</a:t>
-            </a:r>
-            <a:endParaRPr lang="en-US" sz="850" dirty="0"/>
-          </a:p>
-        </p:txBody>
-      </p:sp>
-      <p:sp>
-        <p:nvSpPr>
-          <p:cNvPr id="76" name="Text 73"/>
-          <p:cNvSpPr txBox="1"/>
-          <p:nvPr/>
-        </p:nvSpPr>
-        <p:spPr>
-          <a:xfrm>
-            <a:off x="3063240" y="5650992"/>
-            <a:ext cx="502920" cy="246888"/>
-          </a:xfrm>
-          <a:prstGeom prst="rect">
-            <a:avLst/>
-          </a:prstGeom>
-          <a:noFill/>
-          <a:ln/>
-        </p:spPr>
-        <p:txBody>
-          <a:bodyPr wrap="square" lIns="0" tIns="0" rIns="0" bIns="0" rtlCol="0" anchor="ctr"/>
-          <a:lstStyle/>
-          <a:p>
-            <a:pPr algn="r" indent="0" marL="0">
-              <a:buNone/>
-            </a:pPr>
-            <a:r>
-              <a:rPr lang="en-US" sz="850" b="1" dirty="0">
-                <a:solidFill>
-                  <a:srgbClr val="C88A2E"/>
-                </a:solidFill>
-                <a:latin typeface="Poppins" pitchFamily="34" charset="0"/>
-                <a:ea typeface="Poppins" pitchFamily="34" charset="-122"/>
-                <a:cs typeface="Poppins" pitchFamily="34" charset="-120"/>
-              </a:rPr>
               <a:t>3.7%</a:t>
             </a:r>
-            <a:endParaRPr lang="en-US" sz="850" dirty="0"/>
+            <a:endParaRPr lang="en-US" sz="780" dirty="0"/>
           </a:p>
         </p:txBody>
       </p:sp>
@@ -4042,24 +4094,24 @@
         </p:nvSpPr>
         <p:spPr>
           <a:xfrm>
-            <a:off x="3611880" y="5650992"/>
-            <a:ext cx="1737360" cy="246888"/>
-          </a:xfrm>
-          <a:prstGeom prst="rect">
-            <a:avLst/>
-          </a:prstGeom>
-          <a:noFill/>
-          <a:ln/>
-        </p:spPr>
-        <p:txBody>
-          <a:bodyPr wrap="square" lIns="0" tIns="0" rIns="0" bIns="0" rtlCol="0" anchor="ctr"/>
-          <a:lstStyle/>
-          <a:p>
-            <a:pPr algn="r" indent="0" marL="0">
-              <a:buNone/>
-            </a:pPr>
-            <a:r>
-              <a:rPr lang="en-US" sz="730" dirty="0">
+            <a:off x="4434840" y="5934456"/>
+            <a:ext cx="914400" cy="237744"/>
+          </a:xfrm>
+          <a:prstGeom prst="rect">
+            <a:avLst/>
+          </a:prstGeom>
+          <a:noFill/>
+          <a:ln/>
+        </p:spPr>
+        <p:txBody>
+          <a:bodyPr wrap="square" lIns="0" tIns="0" rIns="0" bIns="0" rtlCol="0" anchor="ctr"/>
+          <a:lstStyle/>
+          <a:p>
+            <a:pPr algn="r" indent="0" marL="0">
+              <a:buNone/>
+            </a:pPr>
+            <a:r>
+              <a:rPr lang="en-US" sz="680" dirty="0">
                 <a:solidFill>
                   <a:srgbClr val="8FA1AC"/>
                 </a:solidFill>
@@ -4069,52 +4121,13 @@
               </a:rPr>
               <a:t>first report</a:t>
             </a:r>
-            <a:endParaRPr lang="en-US" sz="730" dirty="0"/>
-          </a:p>
-        </p:txBody>
-      </p:sp>
-      <p:sp>
-        <p:nvSpPr>
-          <p:cNvPr id="78" name="Text 75"/>
-          <p:cNvSpPr txBox="1"/>
-          <p:nvPr/>
-        </p:nvSpPr>
-        <p:spPr>
-          <a:xfrm>
-            <a:off x="612648" y="6089904"/>
-            <a:ext cx="4718304" cy="292608"/>
-          </a:xfrm>
-          <a:prstGeom prst="rect">
-            <a:avLst/>
-          </a:prstGeom>
-          <a:noFill/>
-          <a:ln/>
-        </p:spPr>
-        <p:txBody>
-          <a:bodyPr wrap="square" lIns="0" tIns="0" rIns="0" bIns="0" rtlCol="0" anchor="t"/>
-          <a:lstStyle/>
-          <a:p>
-            <a:pPr indent="0" marL="0">
-              <a:buNone/>
-            </a:pPr>
-            <a:r>
-              <a:rPr lang="en-US" sz="580" dirty="0">
-                <a:solidFill>
-                  <a:srgbClr val="8FA1AC"/>
-                </a:solidFill>
-                <a:latin typeface="Poppins" pitchFamily="34" charset="0"/>
-                <a:ea typeface="Poppins" pitchFamily="34" charset="-122"/>
-                <a:cs typeface="Poppins" pitchFamily="34" charset="-120"/>
-              </a:rPr>
-              <a:t>Base is available staff × 38h: 7 for 28 Sep–4 Oct (Rhys and Rodney on leave), 9 for 5–11 Oct, 8 for 12–18 Oct (Isayah on leave) and 9 this week less two days each for Argenis and Karim. PS-pipeline tickets by Sydney week, re-pulled 24 Oct.</a:t>
-            </a:r>
-            <a:endParaRPr lang="en-US" sz="580" dirty="0"/>
-          </a:p>
-        </p:txBody>
-      </p:sp>
-      <p:sp>
-        <p:nvSpPr>
-          <p:cNvPr id="79" name="Shape 76"/>
+            <a:endParaRPr lang="en-US" sz="680" dirty="0"/>
+          </a:p>
+        </p:txBody>
+      </p:sp>
+      <p:sp>
+        <p:nvSpPr>
+          <p:cNvPr id="78" name="Shape 75"/>
           <p:cNvSpPr/>
           <p:nvPr/>
         </p:nvSpPr>
@@ -4143,7 +4156,7 @@
       </p:sp>
       <p:sp>
         <p:nvSpPr>
-          <p:cNvPr id="80" name="Text 77"/>
+          <p:cNvPr id="79" name="Text 76"/>
           <p:cNvSpPr txBox="1"/>
           <p:nvPr/>
         </p:nvSpPr>
@@ -4182,7 +4195,7 @@
       </p:sp>
       <p:sp>
         <p:nvSpPr>
-          <p:cNvPr id="81" name="Text 78"/>
+          <p:cNvPr id="80" name="Text 77"/>
           <p:cNvSpPr txBox="1"/>
           <p:nvPr/>
         </p:nvSpPr>
@@ -4221,7 +4234,7 @@
       </p:sp>
       <p:sp>
         <p:nvSpPr>
-          <p:cNvPr id="82" name="Text 79"/>
+          <p:cNvPr id="81" name="Text 78"/>
           <p:cNvSpPr txBox="1"/>
           <p:nvPr/>
         </p:nvSpPr>
@@ -4260,7 +4273,7 @@
       </p:sp>
       <p:sp>
         <p:nvSpPr>
-          <p:cNvPr id="83" name="Text 80"/>
+          <p:cNvPr id="82" name="Text 79"/>
           <p:cNvSpPr txBox="1"/>
           <p:nvPr/>
         </p:nvSpPr>
@@ -4299,7 +4312,7 @@
       </p:sp>
       <p:sp>
         <p:nvSpPr>
-          <p:cNvPr id="84" name="Text 81"/>
+          <p:cNvPr id="83" name="Text 80"/>
           <p:cNvSpPr txBox="1"/>
           <p:nvPr/>
         </p:nvSpPr>
@@ -4338,7 +4351,7 @@
       </p:sp>
       <p:sp>
         <p:nvSpPr>
-          <p:cNvPr id="85" name="Text 82"/>
+          <p:cNvPr id="84" name="Text 81"/>
           <p:cNvSpPr txBox="1"/>
           <p:nvPr/>
         </p:nvSpPr>
@@ -4377,7 +4390,7 @@
       </p:sp>
       <p:sp>
         <p:nvSpPr>
-          <p:cNvPr id="86" name="Text 83"/>
+          <p:cNvPr id="85" name="Text 82"/>
           <p:cNvSpPr txBox="1"/>
           <p:nvPr/>
         </p:nvSpPr>
@@ -4416,7 +4429,7 @@
       </p:sp>
       <p:sp>
         <p:nvSpPr>
-          <p:cNvPr id="87" name="Text 84"/>
+          <p:cNvPr id="86" name="Text 83"/>
           <p:cNvSpPr txBox="1"/>
           <p:nvPr/>
         </p:nvSpPr>
@@ -4455,7 +4468,7 @@
       </p:sp>
       <p:sp>
         <p:nvSpPr>
-          <p:cNvPr id="88" name="Text 85"/>
+          <p:cNvPr id="87" name="Text 84"/>
           <p:cNvSpPr txBox="1"/>
           <p:nvPr/>
         </p:nvSpPr>
@@ -4494,7 +4507,7 @@
       </p:sp>
       <p:sp>
         <p:nvSpPr>
-          <p:cNvPr id="89" name="Shape 86"/>
+          <p:cNvPr id="88" name="Shape 85"/>
           <p:cNvSpPr/>
           <p:nvPr/>
         </p:nvSpPr>
@@ -4514,7 +4527,7 @@
       </p:sp>
       <p:sp>
         <p:nvSpPr>
-          <p:cNvPr id="90" name="Text 87"/>
+          <p:cNvPr id="89" name="Text 86"/>
           <p:cNvSpPr txBox="1"/>
           <p:nvPr/>
         </p:nvSpPr>
@@ -4553,7 +4566,7 @@
       </p:sp>
       <p:sp>
         <p:nvSpPr>
-          <p:cNvPr id="91" name="Text 88"/>
+          <p:cNvPr id="90" name="Text 87"/>
           <p:cNvSpPr txBox="1"/>
           <p:nvPr/>
         </p:nvSpPr>
@@ -4592,7 +4605,7 @@
       </p:sp>
       <p:sp>
         <p:nvSpPr>
-          <p:cNvPr id="92" name="Text 89"/>
+          <p:cNvPr id="91" name="Text 88"/>
           <p:cNvSpPr txBox="1"/>
           <p:nvPr/>
         </p:nvSpPr>
@@ -4617,21 +4630,21 @@
             <a:r>
               <a:rPr lang="en-US" sz="680" dirty="0">
                 <a:solidFill>
-                  <a:srgbClr val="12293A"/>
-                </a:solidFill>
-                <a:latin typeface="Poppins" pitchFamily="34" charset="0"/>
-                <a:ea typeface="Poppins" pitchFamily="34" charset="-122"/>
-                <a:cs typeface="Poppins" pitchFamily="34" charset="-120"/>
-              </a:rPr>
-              <a:t>1.0h</a:t>
-            </a:r>
-            <a:endParaRPr lang="en-US" sz="680" dirty="0"/>
-          </a:p>
-        </p:txBody>
-      </p:sp>
-      <p:sp>
-        <p:nvSpPr>
-          <p:cNvPr id="93" name="Text 90"/>
+                  <a:srgbClr val="8FA1AC"/>
+                </a:solidFill>
+                <a:latin typeface="Poppins" pitchFamily="34" charset="0"/>
+                <a:ea typeface="Poppins" pitchFamily="34" charset="-122"/>
+                <a:cs typeface="Poppins" pitchFamily="34" charset="-120"/>
+              </a:rPr>
+              <a:t>—</a:t>
+            </a:r>
+            <a:endParaRPr lang="en-US" sz="680" dirty="0"/>
+          </a:p>
+        </p:txBody>
+      </p:sp>
+      <p:sp>
+        <p:nvSpPr>
+          <p:cNvPr id="92" name="Text 89"/>
           <p:cNvSpPr txBox="1"/>
           <p:nvPr/>
         </p:nvSpPr>
@@ -4656,21 +4669,21 @@
             <a:r>
               <a:rPr lang="en-US" sz="680" dirty="0">
                 <a:solidFill>
-                  <a:srgbClr val="5E7280"/>
-                </a:solidFill>
-                <a:latin typeface="Poppins" pitchFamily="34" charset="0"/>
-                <a:ea typeface="Poppins" pitchFamily="34" charset="-122"/>
-                <a:cs typeface="Poppins" pitchFamily="34" charset="-120"/>
-              </a:rPr>
-              <a:t>$42</a:t>
-            </a:r>
-            <a:endParaRPr lang="en-US" sz="680" dirty="0"/>
-          </a:p>
-        </p:txBody>
-      </p:sp>
-      <p:sp>
-        <p:nvSpPr>
-          <p:cNvPr id="94" name="Text 91"/>
+                  <a:srgbClr val="8FA1AC"/>
+                </a:solidFill>
+                <a:latin typeface="Poppins" pitchFamily="34" charset="0"/>
+                <a:ea typeface="Poppins" pitchFamily="34" charset="-122"/>
+                <a:cs typeface="Poppins" pitchFamily="34" charset="-120"/>
+              </a:rPr>
+              <a:t>—</a:t>
+            </a:r>
+            <a:endParaRPr lang="en-US" sz="680" dirty="0"/>
+          </a:p>
+        </p:txBody>
+      </p:sp>
+      <p:sp>
+        <p:nvSpPr>
+          <p:cNvPr id="93" name="Text 90"/>
           <p:cNvSpPr txBox="1"/>
           <p:nvPr/>
         </p:nvSpPr>
@@ -4709,7 +4722,7 @@
       </p:sp>
       <p:sp>
         <p:nvSpPr>
-          <p:cNvPr id="95" name="Text 92"/>
+          <p:cNvPr id="94" name="Text 91"/>
           <p:cNvSpPr txBox="1"/>
           <p:nvPr/>
         </p:nvSpPr>
@@ -4748,7 +4761,7 @@
       </p:sp>
       <p:sp>
         <p:nvSpPr>
-          <p:cNvPr id="96" name="Text 93"/>
+          <p:cNvPr id="95" name="Text 92"/>
           <p:cNvSpPr txBox="1"/>
           <p:nvPr/>
         </p:nvSpPr>
@@ -4787,7 +4800,7 @@
       </p:sp>
       <p:sp>
         <p:nvSpPr>
-          <p:cNvPr id="97" name="Text 94"/>
+          <p:cNvPr id="96" name="Text 93"/>
           <p:cNvSpPr txBox="1"/>
           <p:nvPr/>
         </p:nvSpPr>
@@ -4826,7 +4839,7 @@
       </p:sp>
       <p:sp>
         <p:nvSpPr>
-          <p:cNvPr id="98" name="Shape 95"/>
+          <p:cNvPr id="97" name="Shape 94"/>
           <p:cNvSpPr/>
           <p:nvPr/>
         </p:nvSpPr>
@@ -4846,7 +4859,7 @@
       </p:sp>
       <p:sp>
         <p:nvSpPr>
-          <p:cNvPr id="99" name="Text 96"/>
+          <p:cNvPr id="98" name="Text 95"/>
           <p:cNvSpPr txBox="1"/>
           <p:nvPr/>
         </p:nvSpPr>
@@ -4885,7 +4898,7 @@
       </p:sp>
       <p:sp>
         <p:nvSpPr>
-          <p:cNvPr id="100" name="Text 97"/>
+          <p:cNvPr id="99" name="Text 96"/>
           <p:cNvSpPr txBox="1"/>
           <p:nvPr/>
         </p:nvSpPr>
@@ -4924,7 +4937,7 @@
       </p:sp>
       <p:sp>
         <p:nvSpPr>
-          <p:cNvPr id="101" name="Text 98"/>
+          <p:cNvPr id="100" name="Text 97"/>
           <p:cNvSpPr txBox="1"/>
           <p:nvPr/>
         </p:nvSpPr>
@@ -4955,15 +4968,15 @@
                 <a:ea typeface="Poppins" pitchFamily="34" charset="-122"/>
                 <a:cs typeface="Poppins" pitchFamily="34" charset="-120"/>
               </a:rPr>
-              <a:t>2.0h</a:t>
-            </a:r>
-            <a:endParaRPr lang="en-US" sz="680" dirty="0"/>
-          </a:p>
-        </p:txBody>
-      </p:sp>
-      <p:sp>
-        <p:nvSpPr>
-          <p:cNvPr id="102" name="Text 99"/>
+              <a:t>1.0h</a:t>
+            </a:r>
+            <a:endParaRPr lang="en-US" sz="680" dirty="0"/>
+          </a:p>
+        </p:txBody>
+      </p:sp>
+      <p:sp>
+        <p:nvSpPr>
+          <p:cNvPr id="101" name="Text 98"/>
           <p:cNvSpPr txBox="1"/>
           <p:nvPr/>
         </p:nvSpPr>
@@ -4994,15 +5007,15 @@
                 <a:ea typeface="Poppins" pitchFamily="34" charset="-122"/>
                 <a:cs typeface="Poppins" pitchFamily="34" charset="-120"/>
               </a:rPr>
-              <a:t>$84</a:t>
-            </a:r>
-            <a:endParaRPr lang="en-US" sz="680" dirty="0"/>
-          </a:p>
-        </p:txBody>
-      </p:sp>
-      <p:sp>
-        <p:nvSpPr>
-          <p:cNvPr id="103" name="Text 100"/>
+              <a:t>$42</a:t>
+            </a:r>
+            <a:endParaRPr lang="en-US" sz="680" dirty="0"/>
+          </a:p>
+        </p:txBody>
+      </p:sp>
+      <p:sp>
+        <p:nvSpPr>
+          <p:cNvPr id="102" name="Text 99"/>
           <p:cNvSpPr txBox="1"/>
           <p:nvPr/>
         </p:nvSpPr>
@@ -5041,7 +5054,7 @@
       </p:sp>
       <p:sp>
         <p:nvSpPr>
-          <p:cNvPr id="104" name="Text 101"/>
+          <p:cNvPr id="103" name="Text 100"/>
           <p:cNvSpPr txBox="1"/>
           <p:nvPr/>
         </p:nvSpPr>
@@ -5080,7 +5093,7 @@
       </p:sp>
       <p:sp>
         <p:nvSpPr>
-          <p:cNvPr id="105" name="Text 102"/>
+          <p:cNvPr id="104" name="Text 101"/>
           <p:cNvSpPr txBox="1"/>
           <p:nvPr/>
         </p:nvSpPr>
@@ -5119,7 +5132,7 @@
       </p:sp>
       <p:sp>
         <p:nvSpPr>
-          <p:cNvPr id="106" name="Text 103"/>
+          <p:cNvPr id="105" name="Text 102"/>
           <p:cNvSpPr txBox="1"/>
           <p:nvPr/>
         </p:nvSpPr>
@@ -5158,7 +5171,7 @@
       </p:sp>
       <p:sp>
         <p:nvSpPr>
-          <p:cNvPr id="107" name="Shape 104"/>
+          <p:cNvPr id="106" name="Shape 103"/>
           <p:cNvSpPr/>
           <p:nvPr/>
         </p:nvSpPr>
@@ -5178,7 +5191,7 @@
       </p:sp>
       <p:sp>
         <p:nvSpPr>
-          <p:cNvPr id="108" name="Text 105"/>
+          <p:cNvPr id="107" name="Text 104"/>
           <p:cNvSpPr txBox="1"/>
           <p:nvPr/>
         </p:nvSpPr>
@@ -5217,7 +5230,7 @@
       </p:sp>
       <p:sp>
         <p:nvSpPr>
-          <p:cNvPr id="109" name="Text 106"/>
+          <p:cNvPr id="108" name="Text 105"/>
           <p:cNvSpPr txBox="1"/>
           <p:nvPr/>
         </p:nvSpPr>
@@ -5256,7 +5269,7 @@
       </p:sp>
       <p:sp>
         <p:nvSpPr>
-          <p:cNvPr id="110" name="Text 107"/>
+          <p:cNvPr id="109" name="Text 106"/>
           <p:cNvSpPr txBox="1"/>
           <p:nvPr/>
         </p:nvSpPr>
@@ -5295,7 +5308,7 @@
       </p:sp>
       <p:sp>
         <p:nvSpPr>
-          <p:cNvPr id="111" name="Text 108"/>
+          <p:cNvPr id="110" name="Text 107"/>
           <p:cNvSpPr txBox="1"/>
           <p:nvPr/>
         </p:nvSpPr>
@@ -5334,7 +5347,7 @@
       </p:sp>
       <p:sp>
         <p:nvSpPr>
-          <p:cNvPr id="112" name="Text 109"/>
+          <p:cNvPr id="111" name="Text 108"/>
           <p:cNvSpPr txBox="1"/>
           <p:nvPr/>
         </p:nvSpPr>
@@ -5373,7 +5386,7 @@
       </p:sp>
       <p:sp>
         <p:nvSpPr>
-          <p:cNvPr id="113" name="Text 110"/>
+          <p:cNvPr id="112" name="Text 109"/>
           <p:cNvSpPr txBox="1"/>
           <p:nvPr/>
         </p:nvSpPr>
@@ -5412,7 +5425,7 @@
       </p:sp>
       <p:sp>
         <p:nvSpPr>
-          <p:cNvPr id="114" name="Text 111"/>
+          <p:cNvPr id="113" name="Text 110"/>
           <p:cNvSpPr txBox="1"/>
           <p:nvPr/>
         </p:nvSpPr>
@@ -5451,7 +5464,7 @@
       </p:sp>
       <p:sp>
         <p:nvSpPr>
-          <p:cNvPr id="115" name="Text 112"/>
+          <p:cNvPr id="114" name="Text 111"/>
           <p:cNvSpPr txBox="1"/>
           <p:nvPr/>
         </p:nvSpPr>
@@ -5490,7 +5503,7 @@
       </p:sp>
       <p:sp>
         <p:nvSpPr>
-          <p:cNvPr id="116" name="Shape 113"/>
+          <p:cNvPr id="115" name="Shape 112"/>
           <p:cNvSpPr/>
           <p:nvPr/>
         </p:nvSpPr>
@@ -5510,7 +5523,7 @@
       </p:sp>
       <p:sp>
         <p:nvSpPr>
-          <p:cNvPr id="117" name="Text 114"/>
+          <p:cNvPr id="116" name="Text 113"/>
           <p:cNvSpPr txBox="1"/>
           <p:nvPr/>
         </p:nvSpPr>
@@ -5549,7 +5562,7 @@
       </p:sp>
       <p:sp>
         <p:nvSpPr>
-          <p:cNvPr id="118" name="Text 115"/>
+          <p:cNvPr id="117" name="Text 114"/>
           <p:cNvSpPr txBox="1"/>
           <p:nvPr/>
         </p:nvSpPr>
@@ -5588,7 +5601,7 @@
       </p:sp>
       <p:sp>
         <p:nvSpPr>
-          <p:cNvPr id="119" name="Text 116"/>
+          <p:cNvPr id="118" name="Text 115"/>
           <p:cNvSpPr txBox="1"/>
           <p:nvPr/>
         </p:nvSpPr>
@@ -5627,7 +5640,7 @@
       </p:sp>
       <p:sp>
         <p:nvSpPr>
-          <p:cNvPr id="120" name="Text 117"/>
+          <p:cNvPr id="119" name="Text 116"/>
           <p:cNvSpPr txBox="1"/>
           <p:nvPr/>
         </p:nvSpPr>
@@ -5666,7 +5679,7 @@
       </p:sp>
       <p:sp>
         <p:nvSpPr>
-          <p:cNvPr id="121" name="Text 118"/>
+          <p:cNvPr id="120" name="Text 117"/>
           <p:cNvSpPr txBox="1"/>
           <p:nvPr/>
         </p:nvSpPr>
@@ -5705,7 +5718,7 @@
       </p:sp>
       <p:sp>
         <p:nvSpPr>
-          <p:cNvPr id="122" name="Text 119"/>
+          <p:cNvPr id="121" name="Text 118"/>
           <p:cNvSpPr txBox="1"/>
           <p:nvPr/>
         </p:nvSpPr>
@@ -5744,7 +5757,7 @@
       </p:sp>
       <p:sp>
         <p:nvSpPr>
-          <p:cNvPr id="123" name="Text 120"/>
+          <p:cNvPr id="122" name="Text 119"/>
           <p:cNvSpPr txBox="1"/>
           <p:nvPr/>
         </p:nvSpPr>
@@ -5783,7 +5796,7 @@
       </p:sp>
       <p:sp>
         <p:nvSpPr>
-          <p:cNvPr id="124" name="Text 121"/>
+          <p:cNvPr id="123" name="Text 120"/>
           <p:cNvSpPr txBox="1"/>
           <p:nvPr/>
         </p:nvSpPr>
@@ -5822,7 +5835,7 @@
       </p:sp>
       <p:sp>
         <p:nvSpPr>
-          <p:cNvPr id="125" name="Shape 122"/>
+          <p:cNvPr id="124" name="Shape 121"/>
           <p:cNvSpPr/>
           <p:nvPr/>
         </p:nvSpPr>
@@ -5842,7 +5855,7 @@
       </p:sp>
       <p:sp>
         <p:nvSpPr>
-          <p:cNvPr id="126" name="Text 123"/>
+          <p:cNvPr id="125" name="Text 122"/>
           <p:cNvSpPr txBox="1"/>
           <p:nvPr/>
         </p:nvSpPr>
@@ -5873,15 +5886,15 @@
                 <a:ea typeface="Poppins" pitchFamily="34" charset="-122"/>
                 <a:cs typeface="Poppins" pitchFamily="34" charset="-120"/>
               </a:rPr>
-              <a:t>H&amp;L Pay (ValPay share)</a:t>
-            </a:r>
-            <a:endParaRPr lang="en-US" sz="680" dirty="0"/>
-          </a:p>
-        </p:txBody>
-      </p:sp>
-      <p:sp>
-        <p:nvSpPr>
-          <p:cNvPr id="127" name="Text 124"/>
+              <a:t>H&amp;L Pay</a:t>
+            </a:r>
+            <a:endParaRPr lang="en-US" sz="680" dirty="0"/>
+          </a:p>
+        </p:txBody>
+      </p:sp>
+      <p:sp>
+        <p:nvSpPr>
+          <p:cNvPr id="126" name="Text 123"/>
           <p:cNvSpPr txBox="1"/>
           <p:nvPr/>
         </p:nvSpPr>
@@ -5920,7 +5933,7 @@
       </p:sp>
       <p:sp>
         <p:nvSpPr>
-          <p:cNvPr id="128" name="Text 125"/>
+          <p:cNvPr id="127" name="Text 124"/>
           <p:cNvSpPr txBox="1"/>
           <p:nvPr/>
         </p:nvSpPr>
@@ -5951,15 +5964,15 @@
                 <a:ea typeface="Poppins" pitchFamily="34" charset="-122"/>
                 <a:cs typeface="Poppins" pitchFamily="34" charset="-120"/>
               </a:rPr>
-              <a:t>4.0h</a:t>
-            </a:r>
-            <a:endParaRPr lang="en-US" sz="680" dirty="0"/>
-          </a:p>
-        </p:txBody>
-      </p:sp>
-      <p:sp>
-        <p:nvSpPr>
-          <p:cNvPr id="129" name="Text 126"/>
+              <a:t>2.0h</a:t>
+            </a:r>
+            <a:endParaRPr lang="en-US" sz="680" dirty="0"/>
+          </a:p>
+        </p:txBody>
+      </p:sp>
+      <p:sp>
+        <p:nvSpPr>
+          <p:cNvPr id="128" name="Text 125"/>
           <p:cNvSpPr txBox="1"/>
           <p:nvPr/>
         </p:nvSpPr>
@@ -5990,15 +6003,15 @@
                 <a:ea typeface="Poppins" pitchFamily="34" charset="-122"/>
                 <a:cs typeface="Poppins" pitchFamily="34" charset="-120"/>
               </a:rPr>
-              <a:t>$168</a:t>
-            </a:r>
-            <a:endParaRPr lang="en-US" sz="680" dirty="0"/>
-          </a:p>
-        </p:txBody>
-      </p:sp>
-      <p:sp>
-        <p:nvSpPr>
-          <p:cNvPr id="130" name="Text 127"/>
+              <a:t>$84</a:t>
+            </a:r>
+            <a:endParaRPr lang="en-US" sz="680" dirty="0"/>
+          </a:p>
+        </p:txBody>
+      </p:sp>
+      <p:sp>
+        <p:nvSpPr>
+          <p:cNvPr id="129" name="Text 126"/>
           <p:cNvSpPr txBox="1"/>
           <p:nvPr/>
         </p:nvSpPr>
@@ -6029,15 +6042,15 @@
                 <a:ea typeface="Poppins" pitchFamily="34" charset="-122"/>
                 <a:cs typeface="Poppins" pitchFamily="34" charset="-120"/>
               </a:rPr>
-              <a:t>Uber Eats</a:t>
-            </a:r>
-            <a:endParaRPr lang="en-US" sz="680" dirty="0"/>
-          </a:p>
-        </p:txBody>
-      </p:sp>
-      <p:sp>
-        <p:nvSpPr>
-          <p:cNvPr id="131" name="Text 128"/>
+              <a:t>NowBookIt</a:t>
+            </a:r>
+            <a:endParaRPr lang="en-US" sz="680" dirty="0"/>
+          </a:p>
+        </p:txBody>
+      </p:sp>
+      <p:sp>
+        <p:nvSpPr>
+          <p:cNvPr id="130" name="Text 127"/>
           <p:cNvSpPr txBox="1"/>
           <p:nvPr/>
         </p:nvSpPr>
@@ -6076,7 +6089,7 @@
       </p:sp>
       <p:sp>
         <p:nvSpPr>
-          <p:cNvPr id="132" name="Text 129"/>
+          <p:cNvPr id="131" name="Text 128"/>
           <p:cNvSpPr txBox="1"/>
           <p:nvPr/>
         </p:nvSpPr>
@@ -6107,15 +6120,15 @@
                 <a:ea typeface="Poppins" pitchFamily="34" charset="-122"/>
                 <a:cs typeface="Poppins" pitchFamily="34" charset="-120"/>
               </a:rPr>
-              <a:t>6.3h</a:t>
-            </a:r>
-            <a:endParaRPr lang="en-US" sz="680" dirty="0"/>
-          </a:p>
-        </p:txBody>
-      </p:sp>
-      <p:sp>
-        <p:nvSpPr>
-          <p:cNvPr id="133" name="Text 130"/>
+              <a:t>2.0h</a:t>
+            </a:r>
+            <a:endParaRPr lang="en-US" sz="680" dirty="0"/>
+          </a:p>
+        </p:txBody>
+      </p:sp>
+      <p:sp>
+        <p:nvSpPr>
+          <p:cNvPr id="132" name="Text 129"/>
           <p:cNvSpPr txBox="1"/>
           <p:nvPr/>
         </p:nvSpPr>
@@ -6146,6 +6159,182 @@
                 <a:ea typeface="Poppins" pitchFamily="34" charset="-122"/>
                 <a:cs typeface="Poppins" pitchFamily="34" charset="-120"/>
               </a:rPr>
+              <a:t>$84</a:t>
+            </a:r>
+            <a:endParaRPr lang="en-US" sz="680" dirty="0"/>
+          </a:p>
+        </p:txBody>
+      </p:sp>
+      <p:sp>
+        <p:nvSpPr>
+          <p:cNvPr id="133" name="Shape 130"/>
+          <p:cNvSpPr/>
+          <p:nvPr/>
+        </p:nvSpPr>
+        <p:spPr>
+          <a:xfrm>
+            <a:off x="5806440" y="4219956"/>
+            <a:ext cx="2793492" cy="150876"/>
+          </a:xfrm>
+          <a:prstGeom prst="rect">
+            <a:avLst/>
+          </a:prstGeom>
+          <a:solidFill>
+            <a:srgbClr val="F2F6F8"/>
+          </a:solidFill>
+          <a:ln/>
+        </p:spPr>
+      </p:sp>
+      <p:sp>
+        <p:nvSpPr>
+          <p:cNvPr id="134" name="Text 131"/>
+          <p:cNvSpPr txBox="1"/>
+          <p:nvPr/>
+        </p:nvSpPr>
+        <p:spPr>
+          <a:xfrm>
+            <a:off x="5879592" y="4219956"/>
+            <a:ext cx="1097280" cy="150876"/>
+          </a:xfrm>
+          <a:prstGeom prst="rect">
+            <a:avLst/>
+          </a:prstGeom>
+          <a:noFill/>
+          <a:ln/>
+        </p:spPr>
+        <p:txBody>
+          <a:bodyPr wrap="square" lIns="0" tIns="0" rIns="0" bIns="0" rtlCol="0" anchor="ctr"/>
+          <a:lstStyle/>
+          <a:p>
+            <a:pPr algn="l" indent="0" marL="0">
+              <a:buNone/>
+            </a:pPr>
+            <a:r>
+              <a:rPr lang="en-US" sz="680" b="1" dirty="0">
+                <a:solidFill>
+                  <a:srgbClr val="B4552D"/>
+                </a:solidFill>
+                <a:latin typeface="Poppins" pitchFamily="34" charset="0"/>
+                <a:ea typeface="Poppins" pitchFamily="34" charset="-122"/>
+                <a:cs typeface="Poppins" pitchFamily="34" charset="-120"/>
+              </a:rPr>
+              <a:t>Uber Eats</a:t>
+            </a:r>
+            <a:endParaRPr lang="en-US" sz="680" dirty="0"/>
+          </a:p>
+        </p:txBody>
+      </p:sp>
+      <p:sp>
+        <p:nvSpPr>
+          <p:cNvPr id="135" name="Text 132"/>
+          <p:cNvSpPr txBox="1"/>
+          <p:nvPr/>
+        </p:nvSpPr>
+        <p:spPr>
+          <a:xfrm>
+            <a:off x="6903720" y="4219956"/>
+            <a:ext cx="731520" cy="150876"/>
+          </a:xfrm>
+          <a:prstGeom prst="rect">
+            <a:avLst/>
+          </a:prstGeom>
+          <a:noFill/>
+          <a:ln/>
+        </p:spPr>
+        <p:txBody>
+          <a:bodyPr wrap="square" lIns="0" tIns="0" rIns="0" bIns="0" rtlCol="0" anchor="ctr"/>
+          <a:lstStyle/>
+          <a:p>
+            <a:pPr algn="r" indent="0" marL="0">
+              <a:buNone/>
+            </a:pPr>
+            <a:r>
+              <a:rPr lang="en-US" sz="680" b="1" dirty="0">
+                <a:solidFill>
+                  <a:srgbClr val="12293A"/>
+                </a:solidFill>
+                <a:latin typeface="Poppins" pitchFamily="34" charset="0"/>
+                <a:ea typeface="Poppins" pitchFamily="34" charset="-122"/>
+                <a:cs typeface="Poppins" pitchFamily="34" charset="-120"/>
+              </a:rPr>
+              <a:t>$0</a:t>
+            </a:r>
+            <a:endParaRPr lang="en-US" sz="680" dirty="0"/>
+          </a:p>
+        </p:txBody>
+      </p:sp>
+      <p:sp>
+        <p:nvSpPr>
+          <p:cNvPr id="136" name="Text 133"/>
+          <p:cNvSpPr txBox="1"/>
+          <p:nvPr/>
+        </p:nvSpPr>
+        <p:spPr>
+          <a:xfrm>
+            <a:off x="7680960" y="4219956"/>
+            <a:ext cx="411480" cy="150876"/>
+          </a:xfrm>
+          <a:prstGeom prst="rect">
+            <a:avLst/>
+          </a:prstGeom>
+          <a:noFill/>
+          <a:ln/>
+        </p:spPr>
+        <p:txBody>
+          <a:bodyPr wrap="square" lIns="0" tIns="0" rIns="0" bIns="0" rtlCol="0" anchor="ctr"/>
+          <a:lstStyle/>
+          <a:p>
+            <a:pPr algn="r" indent="0" marL="0">
+              <a:buNone/>
+            </a:pPr>
+            <a:r>
+              <a:rPr lang="en-US" sz="680" dirty="0">
+                <a:solidFill>
+                  <a:srgbClr val="12293A"/>
+                </a:solidFill>
+                <a:latin typeface="Poppins" pitchFamily="34" charset="0"/>
+                <a:ea typeface="Poppins" pitchFamily="34" charset="-122"/>
+                <a:cs typeface="Poppins" pitchFamily="34" charset="-120"/>
+              </a:rPr>
+              <a:t>6.3h</a:t>
+            </a:r>
+            <a:endParaRPr lang="en-US" sz="680" dirty="0"/>
+          </a:p>
+        </p:txBody>
+      </p:sp>
+      <p:sp>
+        <p:nvSpPr>
+          <p:cNvPr id="137" name="Text 134"/>
+          <p:cNvSpPr txBox="1"/>
+          <p:nvPr/>
+        </p:nvSpPr>
+        <p:spPr>
+          <a:xfrm>
+            <a:off x="8092440" y="4219956"/>
+            <a:ext cx="502920" cy="150876"/>
+          </a:xfrm>
+          <a:prstGeom prst="rect">
+            <a:avLst/>
+          </a:prstGeom>
+          <a:noFill/>
+          <a:ln/>
+        </p:spPr>
+        <p:txBody>
+          <a:bodyPr wrap="square" lIns="0" tIns="0" rIns="0" bIns="0" rtlCol="0" anchor="ctr"/>
+          <a:lstStyle/>
+          <a:p>
+            <a:pPr algn="r" indent="0" marL="0">
+              <a:buNone/>
+            </a:pPr>
+            <a:r>
+              <a:rPr lang="en-US" sz="680" dirty="0">
+                <a:solidFill>
+                  <a:srgbClr val="5E7280"/>
+                </a:solidFill>
+                <a:latin typeface="Poppins" pitchFamily="34" charset="0"/>
+                <a:ea typeface="Poppins" pitchFamily="34" charset="-122"/>
+                <a:cs typeface="Poppins" pitchFamily="34" charset="-120"/>
+              </a:rPr>
               <a:t>$265</a:t>
             </a:r>
             <a:endParaRPr lang="en-US" sz="680" dirty="0"/>
@@ -6154,46 +6343,7 @@
       </p:sp>
       <p:sp>
         <p:nvSpPr>
-          <p:cNvPr id="134" name="Text 131"/>
-          <p:cNvSpPr txBox="1"/>
-          <p:nvPr/>
-        </p:nvSpPr>
-        <p:spPr>
-          <a:xfrm>
-            <a:off x="5879592" y="4233672"/>
-            <a:ext cx="2647188" cy="347472"/>
-          </a:xfrm>
-          <a:prstGeom prst="rect">
-            <a:avLst/>
-          </a:prstGeom>
-          <a:noFill/>
-          <a:ln/>
-        </p:spPr>
-        <p:txBody>
-          <a:bodyPr wrap="square" lIns="0" tIns="0" rIns="0" bIns="0" rtlCol="0" anchor="t"/>
-          <a:lstStyle/>
-          <a:p>
-            <a:pPr indent="0" marL="0">
-              <a:buNone/>
-            </a:pPr>
-            <a:r>
-              <a:rPr lang="en-US" sz="540" dirty="0">
-                <a:solidFill>
-                  <a:srgbClr val="8FA1AC"/>
-                </a:solidFill>
-                <a:latin typeface="Poppins" pitchFamily="34" charset="0"/>
-                <a:ea typeface="Poppins" pitchFamily="34" charset="-122"/>
-                <a:cs typeface="Poppins" pitchFamily="34" charset="-120"/>
-              </a:rPr>
-              <a:t>Q4 hours are matched on partner names in ticket subjects (estimate) — none carry a partner or non-chargeable reason yet. All are logged billable.</a:t>
-            </a:r>
-            <a:endParaRPr lang="en-US" sz="540" dirty="0"/>
-          </a:p>
-        </p:txBody>
-      </p:sp>
-      <p:sp>
-        <p:nvSpPr>
-          <p:cNvPr id="135" name="Shape 132"/>
+          <p:cNvPr id="138" name="Shape 135"/>
           <p:cNvSpPr/>
           <p:nvPr/>
         </p:nvSpPr>
@@ -6222,7 +6372,7 @@
       </p:sp>
       <p:sp>
         <p:nvSpPr>
-          <p:cNvPr id="136" name="Text 133"/>
+          <p:cNvPr id="139" name="Text 136"/>
           <p:cNvSpPr txBox="1"/>
           <p:nvPr/>
         </p:nvSpPr>
@@ -6261,7 +6411,7 @@
       </p:sp>
       <p:sp>
         <p:nvSpPr>
-          <p:cNvPr id="137" name="Text 134"/>
+          <p:cNvPr id="140" name="Text 137"/>
           <p:cNvSpPr txBox="1"/>
           <p:nvPr/>
         </p:nvSpPr>
@@ -6300,7 +6450,7 @@
       </p:sp>
       <p:sp>
         <p:nvSpPr>
-          <p:cNvPr id="138" name="Text 135"/>
+          <p:cNvPr id="141" name="Text 138"/>
           <p:cNvSpPr txBox="1"/>
           <p:nvPr/>
         </p:nvSpPr>
@@ -6339,7 +6489,7 @@
       </p:sp>
       <p:sp>
         <p:nvSpPr>
-          <p:cNvPr id="139" name="Text 136"/>
+          <p:cNvPr id="142" name="Text 139"/>
           <p:cNvSpPr txBox="1"/>
           <p:nvPr/>
         </p:nvSpPr>
@@ -6378,7 +6528,7 @@
       </p:sp>
       <p:sp>
         <p:nvSpPr>
-          <p:cNvPr id="140" name="Text 137"/>
+          <p:cNvPr id="143" name="Text 140"/>
           <p:cNvSpPr txBox="1"/>
           <p:nvPr/>
         </p:nvSpPr>
@@ -6417,7 +6567,7 @@
       </p:sp>
       <p:sp>
         <p:nvSpPr>
-          <p:cNvPr id="141" name="Text 138"/>
+          <p:cNvPr id="144" name="Text 141"/>
           <p:cNvSpPr txBox="1"/>
           <p:nvPr/>
         </p:nvSpPr>
@@ -6456,7 +6606,7 @@
       </p:sp>
       <p:sp>
         <p:nvSpPr>
-          <p:cNvPr id="142" name="Text 139"/>
+          <p:cNvPr id="145" name="Text 142"/>
           <p:cNvSpPr txBox="1"/>
           <p:nvPr/>
         </p:nvSpPr>
@@ -6495,7 +6645,7 @@
       </p:sp>
       <p:sp>
         <p:nvSpPr>
-          <p:cNvPr id="143" name="Text 140"/>
+          <p:cNvPr id="146" name="Text 143"/>
           <p:cNvSpPr txBox="1"/>
           <p:nvPr/>
         </p:nvSpPr>
@@ -6534,7 +6684,7 @@
       </p:sp>
       <p:sp>
         <p:nvSpPr>
-          <p:cNvPr id="144" name="Text 141"/>
+          <p:cNvPr id="147" name="Text 144"/>
           <p:cNvSpPr txBox="1"/>
           <p:nvPr/>
         </p:nvSpPr>
@@ -6573,7 +6723,7 @@
       </p:sp>
       <p:sp>
         <p:nvSpPr>
-          <p:cNvPr id="145" name="Text 142"/>
+          <p:cNvPr id="148" name="Text 145"/>
           <p:cNvSpPr txBox="1"/>
           <p:nvPr/>
         </p:nvSpPr>
@@ -6612,7 +6762,7 @@
       </p:sp>
       <p:sp>
         <p:nvSpPr>
-          <p:cNvPr id="146" name="Text 143"/>
+          <p:cNvPr id="149" name="Text 146"/>
           <p:cNvSpPr txBox="1"/>
           <p:nvPr/>
         </p:nvSpPr>
@@ -6651,7 +6801,7 @@
       </p:sp>
       <p:sp>
         <p:nvSpPr>
-          <p:cNvPr id="147" name="Shape 144"/>
+          <p:cNvPr id="150" name="Shape 147"/>
           <p:cNvSpPr/>
           <p:nvPr/>
         </p:nvSpPr>
@@ -6671,7 +6821,7 @@
       </p:sp>
       <p:sp>
         <p:nvSpPr>
-          <p:cNvPr id="148" name="Text 145"/>
+          <p:cNvPr id="151" name="Text 148"/>
           <p:cNvSpPr txBox="1"/>
           <p:nvPr/>
         </p:nvSpPr>
@@ -6710,7 +6860,7 @@
       </p:sp>
       <p:sp>
         <p:nvSpPr>
-          <p:cNvPr id="149" name="Text 146"/>
+          <p:cNvPr id="152" name="Text 149"/>
           <p:cNvSpPr txBox="1"/>
           <p:nvPr/>
         </p:nvSpPr>
@@ -6749,7 +6899,7 @@
       </p:sp>
       <p:sp>
         <p:nvSpPr>
-          <p:cNvPr id="150" name="Text 147"/>
+          <p:cNvPr id="153" name="Text 150"/>
           <p:cNvSpPr txBox="1"/>
           <p:nvPr/>
         </p:nvSpPr>
@@ -6788,7 +6938,7 @@
       </p:sp>
       <p:sp>
         <p:nvSpPr>
-          <p:cNvPr id="151" name="Text 148"/>
+          <p:cNvPr id="154" name="Text 151"/>
           <p:cNvSpPr txBox="1"/>
           <p:nvPr/>
         </p:nvSpPr>
@@ -6827,7 +6977,7 @@
       </p:sp>
       <p:sp>
         <p:nvSpPr>
-          <p:cNvPr id="152" name="Text 149"/>
+          <p:cNvPr id="155" name="Text 152"/>
           <p:cNvSpPr txBox="1"/>
           <p:nvPr/>
         </p:nvSpPr>
@@ -6866,7 +7016,7 @@
       </p:sp>
       <p:sp>
         <p:nvSpPr>
-          <p:cNvPr id="153" name="Text 150"/>
+          <p:cNvPr id="156" name="Text 153"/>
           <p:cNvSpPr txBox="1"/>
           <p:nvPr/>
         </p:nvSpPr>
@@ -6905,7 +7055,7 @@
       </p:sp>
       <p:sp>
         <p:nvSpPr>
-          <p:cNvPr id="154" name="Text 151"/>
+          <p:cNvPr id="157" name="Text 154"/>
           <p:cNvSpPr txBox="1"/>
           <p:nvPr/>
         </p:nvSpPr>
@@ -6944,7 +7094,7 @@
       </p:sp>
       <p:sp>
         <p:nvSpPr>
-          <p:cNvPr id="155" name="Text 152"/>
+          <p:cNvPr id="158" name="Text 155"/>
           <p:cNvSpPr txBox="1"/>
           <p:nvPr/>
         </p:nvSpPr>
@@ -6983,7 +7133,7 @@
       </p:sp>
       <p:sp>
         <p:nvSpPr>
-          <p:cNvPr id="156" name="Text 153"/>
+          <p:cNvPr id="159" name="Text 156"/>
           <p:cNvSpPr txBox="1"/>
           <p:nvPr/>
         </p:nvSpPr>
@@ -7022,7 +7172,7 @@
       </p:sp>
       <p:sp>
         <p:nvSpPr>
-          <p:cNvPr id="157" name="Text 154"/>
+          <p:cNvPr id="160" name="Text 157"/>
           <p:cNvSpPr txBox="1"/>
           <p:nvPr/>
         </p:nvSpPr>
@@ -7061,7 +7211,7 @@
       </p:sp>
       <p:sp>
         <p:nvSpPr>
-          <p:cNvPr id="158" name="Shape 155"/>
+          <p:cNvPr id="161" name="Shape 158"/>
           <p:cNvSpPr/>
           <p:nvPr/>
         </p:nvSpPr>
@@ -7081,7 +7231,7 @@
       </p:sp>
       <p:sp>
         <p:nvSpPr>
-          <p:cNvPr id="159" name="Text 156"/>
+          <p:cNvPr id="162" name="Text 159"/>
           <p:cNvSpPr txBox="1"/>
           <p:nvPr/>
         </p:nvSpPr>
@@ -7120,7 +7270,7 @@
       </p:sp>
       <p:sp>
         <p:nvSpPr>
-          <p:cNvPr id="160" name="Text 157"/>
+          <p:cNvPr id="163" name="Text 160"/>
           <p:cNvSpPr txBox="1"/>
           <p:nvPr/>
         </p:nvSpPr>
@@ -7159,7 +7309,7 @@
       </p:sp>
       <p:sp>
         <p:nvSpPr>
-          <p:cNvPr id="161" name="Text 158"/>
+          <p:cNvPr id="164" name="Text 161"/>
           <p:cNvSpPr txBox="1"/>
           <p:nvPr/>
         </p:nvSpPr>
@@ -7198,7 +7348,7 @@
       </p:sp>
       <p:sp>
         <p:nvSpPr>
-          <p:cNvPr id="162" name="Text 159"/>
+          <p:cNvPr id="165" name="Text 162"/>
           <p:cNvSpPr txBox="1"/>
           <p:nvPr/>
         </p:nvSpPr>
@@ -7237,7 +7387,7 @@
       </p:sp>
       <p:sp>
         <p:nvSpPr>
-          <p:cNvPr id="163" name="Text 160"/>
+          <p:cNvPr id="166" name="Text 163"/>
           <p:cNvSpPr txBox="1"/>
           <p:nvPr/>
         </p:nvSpPr>
@@ -7276,7 +7426,7 @@
       </p:sp>
       <p:sp>
         <p:nvSpPr>
-          <p:cNvPr id="164" name="Text 161"/>
+          <p:cNvPr id="167" name="Text 164"/>
           <p:cNvSpPr txBox="1"/>
           <p:nvPr/>
         </p:nvSpPr>
@@ -7315,7 +7465,7 @@
       </p:sp>
       <p:sp>
         <p:nvSpPr>
-          <p:cNvPr id="165" name="Text 162"/>
+          <p:cNvPr id="168" name="Text 165"/>
           <p:cNvSpPr txBox="1"/>
           <p:nvPr/>
         </p:nvSpPr>
@@ -7354,7 +7504,7 @@
       </p:sp>
       <p:sp>
         <p:nvSpPr>
-          <p:cNvPr id="166" name="Text 163"/>
+          <p:cNvPr id="169" name="Text 166"/>
           <p:cNvSpPr txBox="1"/>
           <p:nvPr/>
         </p:nvSpPr>
@@ -7393,7 +7543,7 @@
       </p:sp>
       <p:sp>
         <p:nvSpPr>
-          <p:cNvPr id="167" name="Text 164"/>
+          <p:cNvPr id="170" name="Text 167"/>
           <p:cNvSpPr txBox="1"/>
           <p:nvPr/>
         </p:nvSpPr>
@@ -7432,7 +7582,7 @@
       </p:sp>
       <p:sp>
         <p:nvSpPr>
-          <p:cNvPr id="168" name="Text 165"/>
+          <p:cNvPr id="171" name="Text 168"/>
           <p:cNvSpPr txBox="1"/>
           <p:nvPr/>
         </p:nvSpPr>
@@ -7471,7 +7621,7 @@
       </p:sp>
       <p:sp>
         <p:nvSpPr>
-          <p:cNvPr id="169" name="Shape 166"/>
+          <p:cNvPr id="172" name="Shape 169"/>
           <p:cNvSpPr/>
           <p:nvPr/>
         </p:nvSpPr>
@@ -7491,7 +7641,7 @@
       </p:sp>
       <p:sp>
         <p:nvSpPr>
-          <p:cNvPr id="170" name="Text 167"/>
+          <p:cNvPr id="173" name="Text 170"/>
           <p:cNvSpPr txBox="1"/>
           <p:nvPr/>
         </p:nvSpPr>
@@ -7530,7 +7680,7 @@
       </p:sp>
       <p:sp>
         <p:nvSpPr>
-          <p:cNvPr id="171" name="Text 168"/>
+          <p:cNvPr id="174" name="Text 171"/>
           <p:cNvSpPr txBox="1"/>
           <p:nvPr/>
         </p:nvSpPr>
@@ -7569,7 +7719,7 @@
       </p:sp>
       <p:sp>
         <p:nvSpPr>
-          <p:cNvPr id="172" name="Text 169"/>
+          <p:cNvPr id="175" name="Text 172"/>
           <p:cNvSpPr txBox="1"/>
           <p:nvPr/>
         </p:nvSpPr>
@@ -7608,7 +7758,7 @@
       </p:sp>
       <p:sp>
         <p:nvSpPr>
-          <p:cNvPr id="173" name="Text 170"/>
+          <p:cNvPr id="176" name="Text 173"/>
           <p:cNvSpPr txBox="1"/>
           <p:nvPr/>
         </p:nvSpPr>
@@ -7647,7 +7797,7 @@
       </p:sp>
       <p:sp>
         <p:nvSpPr>
-          <p:cNvPr id="174" name="Text 171"/>
+          <p:cNvPr id="177" name="Text 174"/>
           <p:cNvSpPr txBox="1"/>
           <p:nvPr/>
         </p:nvSpPr>
@@ -7686,7 +7836,7 @@
       </p:sp>
       <p:sp>
         <p:nvSpPr>
-          <p:cNvPr id="175" name="Text 172"/>
+          <p:cNvPr id="178" name="Text 175"/>
           <p:cNvSpPr txBox="1"/>
           <p:nvPr/>
         </p:nvSpPr>
@@ -7725,7 +7875,7 @@
       </p:sp>
       <p:sp>
         <p:nvSpPr>
-          <p:cNvPr id="176" name="Text 173"/>
+          <p:cNvPr id="179" name="Text 176"/>
           <p:cNvSpPr txBox="1"/>
           <p:nvPr/>
         </p:nvSpPr>
@@ -7764,7 +7914,7 @@
       </p:sp>
       <p:sp>
         <p:nvSpPr>
-          <p:cNvPr id="177" name="Text 174"/>
+          <p:cNvPr id="180" name="Text 177"/>
           <p:cNvSpPr txBox="1"/>
           <p:nvPr/>
         </p:nvSpPr>
@@ -7803,7 +7953,7 @@
       </p:sp>
       <p:sp>
         <p:nvSpPr>
-          <p:cNvPr id="178" name="Text 175"/>
+          <p:cNvPr id="181" name="Text 178"/>
           <p:cNvSpPr txBox="1"/>
           <p:nvPr/>
         </p:nvSpPr>
@@ -7842,7 +7992,7 @@
       </p:sp>
       <p:sp>
         <p:nvSpPr>
-          <p:cNvPr id="179" name="Text 176"/>
+          <p:cNvPr id="182" name="Text 179"/>
           <p:cNvSpPr txBox="1"/>
           <p:nvPr/>
         </p:nvSpPr>
@@ -7881,7 +8031,7 @@
       </p:sp>
       <p:sp>
         <p:nvSpPr>
-          <p:cNvPr id="180" name="Shape 177"/>
+          <p:cNvPr id="183" name="Shape 180"/>
           <p:cNvSpPr/>
           <p:nvPr/>
         </p:nvSpPr>
@@ -7901,7 +8051,7 @@
       </p:sp>
       <p:sp>
         <p:nvSpPr>
-          <p:cNvPr id="181" name="Text 178"/>
+          <p:cNvPr id="184" name="Text 181"/>
           <p:cNvSpPr txBox="1"/>
           <p:nvPr/>
         </p:nvSpPr>
@@ -7940,7 +8090,7 @@
       </p:sp>
       <p:sp>
         <p:nvSpPr>
-          <p:cNvPr id="182" name="Text 179"/>
+          <p:cNvPr id="185" name="Text 182"/>
           <p:cNvSpPr txBox="1"/>
           <p:nvPr/>
         </p:nvSpPr>
@@ -7979,7 +8129,7 @@
       </p:sp>
       <p:sp>
         <p:nvSpPr>
-          <p:cNvPr id="183" name="Text 180"/>
+          <p:cNvPr id="186" name="Text 183"/>
           <p:cNvSpPr txBox="1"/>
           <p:nvPr/>
         </p:nvSpPr>
@@ -8018,7 +8168,7 @@
       </p:sp>
       <p:sp>
         <p:nvSpPr>
-          <p:cNvPr id="184" name="Text 181"/>
+          <p:cNvPr id="187" name="Text 184"/>
           <p:cNvSpPr txBox="1"/>
           <p:nvPr/>
         </p:nvSpPr>
@@ -8057,7 +8207,7 @@
       </p:sp>
       <p:sp>
         <p:nvSpPr>
-          <p:cNvPr id="185" name="Text 182"/>
+          <p:cNvPr id="188" name="Text 185"/>
           <p:cNvSpPr txBox="1"/>
           <p:nvPr/>
         </p:nvSpPr>
@@ -8096,7 +8246,7 @@
       </p:sp>
       <p:sp>
         <p:nvSpPr>
-          <p:cNvPr id="186" name="Text 183"/>
+          <p:cNvPr id="189" name="Text 186"/>
           <p:cNvSpPr txBox="1"/>
           <p:nvPr/>
         </p:nvSpPr>
@@ -8135,7 +8285,7 @@
       </p:sp>
       <p:sp>
         <p:nvSpPr>
-          <p:cNvPr id="187" name="Text 184"/>
+          <p:cNvPr id="190" name="Text 187"/>
           <p:cNvSpPr txBox="1"/>
           <p:nvPr/>
         </p:nvSpPr>
@@ -8174,7 +8324,7 @@
       </p:sp>
       <p:sp>
         <p:nvSpPr>
-          <p:cNvPr id="188" name="Text 185"/>
+          <p:cNvPr id="191" name="Text 188"/>
           <p:cNvSpPr txBox="1"/>
           <p:nvPr/>
         </p:nvSpPr>
@@ -8213,7 +8363,7 @@
       </p:sp>
       <p:sp>
         <p:nvSpPr>
-          <p:cNvPr id="189" name="Text 186"/>
+          <p:cNvPr id="192" name="Text 189"/>
           <p:cNvSpPr txBox="1"/>
           <p:nvPr/>
         </p:nvSpPr>
@@ -8252,7 +8402,7 @@
       </p:sp>
       <p:sp>
         <p:nvSpPr>
-          <p:cNvPr id="190" name="Text 187"/>
+          <p:cNvPr id="193" name="Text 190"/>
           <p:cNvSpPr txBox="1"/>
           <p:nvPr/>
         </p:nvSpPr>
@@ -8291,46 +8441,7 @@
       </p:sp>
       <p:sp>
         <p:nvSpPr>
-          <p:cNvPr id="191" name="Text 188"/>
-          <p:cNvSpPr txBox="1"/>
-          <p:nvPr/>
-        </p:nvSpPr>
-        <p:spPr>
-          <a:xfrm>
-            <a:off x="8965692" y="4233672"/>
-            <a:ext cx="2647188" cy="347472"/>
-          </a:xfrm>
-          <a:prstGeom prst="rect">
-            <a:avLst/>
-          </a:prstGeom>
-          <a:noFill/>
-          <a:ln/>
-        </p:spPr>
-        <p:txBody>
-          <a:bodyPr wrap="square" lIns="0" tIns="0" rIns="0" bIns="0" rtlCol="0" anchor="t"/>
-          <a:lstStyle/>
-          <a:p>
-            <a:pPr indent="0" marL="0">
-              <a:buNone/>
-            </a:pPr>
-            <a:r>
-              <a:rPr lang="en-US" sz="540" dirty="0">
-                <a:solidFill>
-                  <a:srgbClr val="8FA1AC"/>
-                </a:solidFill>
-                <a:latin typeface="Poppins" pitchFamily="34" charset="0"/>
-                <a:ea typeface="Poppins" pitchFamily="34" charset="-122"/>
-                <a:cs typeface="Poppins" pitchFamily="34" charset="-120"/>
-              </a:rPr>
-              <a:t>Q4 hours by ticket company or name (estimate). AVC's 18h is the 9.2 upgrades ticket, flagged chargeable — confirm it was invoiced. Rodney: 8.25h of his 13.75h sit on these accounts.</a:t>
-            </a:r>
-            <a:endParaRPr lang="en-US" sz="540" dirty="0"/>
-          </a:p>
-        </p:txBody>
-      </p:sp>
-      <p:sp>
-        <p:nvSpPr>
-          <p:cNvPr id="192" name="Shape 189"/>
+          <p:cNvPr id="194" name="Shape 191"/>
           <p:cNvSpPr/>
           <p:nvPr/>
         </p:nvSpPr>
@@ -8359,7 +8470,7 @@
       </p:sp>
       <p:sp>
         <p:nvSpPr>
-          <p:cNvPr id="193" name="Text 190"/>
+          <p:cNvPr id="195" name="Text 192"/>
           <p:cNvSpPr txBox="1"/>
           <p:nvPr/>
         </p:nvSpPr>
@@ -8398,7 +8509,7 @@
       </p:sp>
       <p:sp>
         <p:nvSpPr>
-          <p:cNvPr id="194" name="Text 191"/>
+          <p:cNvPr id="196" name="Text 193"/>
           <p:cNvSpPr txBox="1"/>
           <p:nvPr/>
         </p:nvSpPr>
@@ -8564,7 +8675,7 @@
       </p:sp>
       <p:sp>
         <p:nvSpPr>
-          <p:cNvPr id="195" name="Shape 192"/>
+          <p:cNvPr id="197" name="Shape 194"/>
           <p:cNvSpPr/>
           <p:nvPr/>
         </p:nvSpPr>
@@ -8586,7 +8697,7 @@
       </p:sp>
       <p:sp>
         <p:nvSpPr>
-          <p:cNvPr id="196" name="Text 193"/>
+          <p:cNvPr id="198" name="Text 195"/>
           <p:cNvSpPr txBox="1"/>
           <p:nvPr/>
         </p:nvSpPr>

</xml_diff>

<commit_message>
PS Economics slide: unrecognised PS revenue at $150/h, "No flag" column
- The partner and key-account tables replace estimated cost with
  unrecognised PS revenue: hours not flagged chargeable x $150. H&L Pay's
  commission shows $0, not "separate".
- "Blank" becomes "No flag": billable hours with Is Chargeable empty.
- AVC stays as HubSpot has it: the 9.2 upgrades ticket (18h) reads Is
  Chargeable = Yes, so only AVC's 3.5h without a flag counts as
  unrecognised.

Co-Authored-By: Claude Opus 5.5 <noreply@anthropic.com>
Claude-Session: https://claude.ai/code/session_01Lq5maWicgiSj2RkHzTdcCm
</commit_message>
<xml_diff>
--- a/exec-deck/output/H&L PS Economics - The Hidden Work - WC 19 Oct 2026.pptx
+++ b/exec-deck/output/H&L PS Economics - The Hidden Work - WC 19 Oct 2026.pptx
@@ -3182,7 +3182,7 @@
                 <a:ea typeface="Poppins" pitchFamily="34" charset="-122"/>
                 <a:cs typeface="Poppins" pitchFamily="34" charset="-120"/>
               </a:rPr>
-              <a:t>BLANK</a:t>
+              <a:t>NO FLAG</a:t>
             </a:r>
             <a:endParaRPr lang="en-US" sz="580" dirty="0"/>
           </a:p>
@@ -4202,7 +4202,7 @@
         <p:spPr>
           <a:xfrm>
             <a:off x="5879592" y="2395728"/>
-            <a:ext cx="1097280" cy="146304"/>
+            <a:ext cx="1005840" cy="146304"/>
           </a:xfrm>
           <a:prstGeom prst="rect">
             <a:avLst/>
@@ -4240,8 +4240,8 @@
         </p:nvSpPr>
         <p:spPr>
           <a:xfrm>
-            <a:off x="6903720" y="2395728"/>
-            <a:ext cx="731520" cy="146304"/>
+            <a:off x="6858000" y="2395728"/>
+            <a:ext cx="713232" cy="146304"/>
           </a:xfrm>
           <a:prstGeom prst="rect">
             <a:avLst/>
@@ -4279,8 +4279,8 @@
         </p:nvSpPr>
         <p:spPr>
           <a:xfrm>
-            <a:off x="7680960" y="2395728"/>
-            <a:ext cx="411480" cy="146304"/>
+            <a:off x="7589520" y="2395728"/>
+            <a:ext cx="365760" cy="146304"/>
           </a:xfrm>
           <a:prstGeom prst="rect">
             <a:avLst/>
@@ -4318,8 +4318,8 @@
         </p:nvSpPr>
         <p:spPr>
           <a:xfrm>
-            <a:off x="8092440" y="2395728"/>
-            <a:ext cx="502920" cy="146304"/>
+            <a:off x="7955280" y="2395728"/>
+            <a:ext cx="566928" cy="146304"/>
           </a:xfrm>
           <a:prstGeom prst="rect">
             <a:avLst/>
@@ -4343,7 +4343,7 @@
                 <a:ea typeface="Poppins" pitchFamily="34" charset="-122"/>
                 <a:cs typeface="Poppins" pitchFamily="34" charset="-120"/>
               </a:rPr>
-              <a:t>EST. COST</a:t>
+              <a:t>UNREC. REV</a:t>
             </a:r>
             <a:endParaRPr lang="en-US" sz="560" dirty="0"/>
           </a:p>
@@ -4358,7 +4358,7 @@
         <p:spPr>
           <a:xfrm>
             <a:off x="5879592" y="2560320"/>
-            <a:ext cx="1097280" cy="150876"/>
+            <a:ext cx="1005840" cy="150876"/>
           </a:xfrm>
           <a:prstGeom prst="rect">
             <a:avLst/>
@@ -4396,8 +4396,8 @@
         </p:nvSpPr>
         <p:spPr>
           <a:xfrm>
-            <a:off x="6903720" y="2560320"/>
-            <a:ext cx="731520" cy="150876"/>
+            <a:off x="6858000" y="2560320"/>
+            <a:ext cx="713232" cy="150876"/>
           </a:xfrm>
           <a:prstGeom prst="rect">
             <a:avLst/>
@@ -4435,8 +4435,8 @@
         </p:nvSpPr>
         <p:spPr>
           <a:xfrm>
-            <a:off x="7680960" y="2560320"/>
-            <a:ext cx="411480" cy="150876"/>
+            <a:off x="7589520" y="2560320"/>
+            <a:ext cx="365760" cy="150876"/>
           </a:xfrm>
           <a:prstGeom prst="rect">
             <a:avLst/>
@@ -4474,8 +4474,8 @@
         </p:nvSpPr>
         <p:spPr>
           <a:xfrm>
-            <a:off x="8092440" y="2560320"/>
-            <a:ext cx="502920" cy="150876"/>
+            <a:off x="7955280" y="2560320"/>
+            <a:ext cx="566928" cy="150876"/>
           </a:xfrm>
           <a:prstGeom prst="rect">
             <a:avLst/>
@@ -4534,7 +4534,7 @@
         <p:spPr>
           <a:xfrm>
             <a:off x="5879592" y="2711196"/>
-            <a:ext cx="1097280" cy="150876"/>
+            <a:ext cx="1005840" cy="150876"/>
           </a:xfrm>
           <a:prstGeom prst="rect">
             <a:avLst/>
@@ -4572,8 +4572,8 @@
         </p:nvSpPr>
         <p:spPr>
           <a:xfrm>
-            <a:off x="6903720" y="2711196"/>
-            <a:ext cx="731520" cy="150876"/>
+            <a:off x="6858000" y="2711196"/>
+            <a:ext cx="713232" cy="150876"/>
           </a:xfrm>
           <a:prstGeom prst="rect">
             <a:avLst/>
@@ -4611,8 +4611,8 @@
         </p:nvSpPr>
         <p:spPr>
           <a:xfrm>
-            <a:off x="7680960" y="2711196"/>
-            <a:ext cx="411480" cy="150876"/>
+            <a:off x="7589520" y="2711196"/>
+            <a:ext cx="365760" cy="150876"/>
           </a:xfrm>
           <a:prstGeom prst="rect">
             <a:avLst/>
@@ -4650,8 +4650,8 @@
         </p:nvSpPr>
         <p:spPr>
           <a:xfrm>
-            <a:off x="8092440" y="2711196"/>
-            <a:ext cx="502920" cy="150876"/>
+            <a:off x="7955280" y="2711196"/>
+            <a:ext cx="566928" cy="150876"/>
           </a:xfrm>
           <a:prstGeom prst="rect">
             <a:avLst/>
@@ -4690,7 +4690,7 @@
         <p:spPr>
           <a:xfrm>
             <a:off x="5879592" y="2862072"/>
-            <a:ext cx="1097280" cy="150876"/>
+            <a:ext cx="1005840" cy="150876"/>
           </a:xfrm>
           <a:prstGeom prst="rect">
             <a:avLst/>
@@ -4728,8 +4728,8 @@
         </p:nvSpPr>
         <p:spPr>
           <a:xfrm>
-            <a:off x="6903720" y="2862072"/>
-            <a:ext cx="731520" cy="150876"/>
+            <a:off x="6858000" y="2862072"/>
+            <a:ext cx="713232" cy="150876"/>
           </a:xfrm>
           <a:prstGeom prst="rect">
             <a:avLst/>
@@ -4767,8 +4767,8 @@
         </p:nvSpPr>
         <p:spPr>
           <a:xfrm>
-            <a:off x="7680960" y="2862072"/>
-            <a:ext cx="411480" cy="150876"/>
+            <a:off x="7589520" y="2862072"/>
+            <a:ext cx="365760" cy="150876"/>
           </a:xfrm>
           <a:prstGeom prst="rect">
             <a:avLst/>
@@ -4806,8 +4806,8 @@
         </p:nvSpPr>
         <p:spPr>
           <a:xfrm>
-            <a:off x="8092440" y="2862072"/>
-            <a:ext cx="502920" cy="150876"/>
+            <a:off x="7955280" y="2862072"/>
+            <a:ext cx="566928" cy="150876"/>
           </a:xfrm>
           <a:prstGeom prst="rect">
             <a:avLst/>
@@ -4866,7 +4866,7 @@
         <p:spPr>
           <a:xfrm>
             <a:off x="5879592" y="3012948"/>
-            <a:ext cx="1097280" cy="150876"/>
+            <a:ext cx="1005840" cy="150876"/>
           </a:xfrm>
           <a:prstGeom prst="rect">
             <a:avLst/>
@@ -4904,8 +4904,8 @@
         </p:nvSpPr>
         <p:spPr>
           <a:xfrm>
-            <a:off x="6903720" y="3012948"/>
-            <a:ext cx="731520" cy="150876"/>
+            <a:off x="6858000" y="3012948"/>
+            <a:ext cx="713232" cy="150876"/>
           </a:xfrm>
           <a:prstGeom prst="rect">
             <a:avLst/>
@@ -4943,8 +4943,8 @@
         </p:nvSpPr>
         <p:spPr>
           <a:xfrm>
-            <a:off x="7680960" y="3012948"/>
-            <a:ext cx="411480" cy="150876"/>
+            <a:off x="7589520" y="3012948"/>
+            <a:ext cx="365760" cy="150876"/>
           </a:xfrm>
           <a:prstGeom prst="rect">
             <a:avLst/>
@@ -4982,8 +4982,125 @@
         </p:nvSpPr>
         <p:spPr>
           <a:xfrm>
-            <a:off x="8092440" y="3012948"/>
-            <a:ext cx="502920" cy="150876"/>
+            <a:off x="7955280" y="3012948"/>
+            <a:ext cx="566928" cy="150876"/>
+          </a:xfrm>
+          <a:prstGeom prst="rect">
+            <a:avLst/>
+          </a:prstGeom>
+          <a:noFill/>
+          <a:ln/>
+        </p:spPr>
+        <p:txBody>
+          <a:bodyPr wrap="square" lIns="0" tIns="0" rIns="0" bIns="0" rtlCol="0" anchor="ctr"/>
+          <a:lstStyle/>
+          <a:p>
+            <a:pPr algn="r" indent="0" marL="0">
+              <a:buNone/>
+            </a:pPr>
+            <a:r>
+              <a:rPr lang="en-US" sz="680" b="1" dirty="0">
+                <a:solidFill>
+                  <a:srgbClr val="B4552D"/>
+                </a:solidFill>
+                <a:latin typeface="Poppins" pitchFamily="34" charset="0"/>
+                <a:ea typeface="Poppins" pitchFamily="34" charset="-122"/>
+                <a:cs typeface="Poppins" pitchFamily="34" charset="-120"/>
+              </a:rPr>
+              <a:t>$150</a:t>
+            </a:r>
+            <a:endParaRPr lang="en-US" sz="680" dirty="0"/>
+          </a:p>
+        </p:txBody>
+      </p:sp>
+      <p:sp>
+        <p:nvSpPr>
+          <p:cNvPr id="102" name="Text 99"/>
+          <p:cNvSpPr txBox="1"/>
+          <p:nvPr/>
+        </p:nvSpPr>
+        <p:spPr>
+          <a:xfrm>
+            <a:off x="5879592" y="3163824"/>
+            <a:ext cx="1005840" cy="150876"/>
+          </a:xfrm>
+          <a:prstGeom prst="rect">
+            <a:avLst/>
+          </a:prstGeom>
+          <a:noFill/>
+          <a:ln/>
+        </p:spPr>
+        <p:txBody>
+          <a:bodyPr wrap="square" lIns="0" tIns="0" rIns="0" bIns="0" rtlCol="0" anchor="ctr"/>
+          <a:lstStyle/>
+          <a:p>
+            <a:pPr algn="l" indent="0" marL="0">
+              <a:buNone/>
+            </a:pPr>
+            <a:r>
+              <a:rPr lang="en-US" sz="680" b="1" dirty="0">
+                <a:solidFill>
+                  <a:srgbClr val="12293A"/>
+                </a:solidFill>
+                <a:latin typeface="Poppins" pitchFamily="34" charset="0"/>
+                <a:ea typeface="Poppins" pitchFamily="34" charset="-122"/>
+                <a:cs typeface="Poppins" pitchFamily="34" charset="-120"/>
+              </a:rPr>
+              <a:t>Zeller</a:t>
+            </a:r>
+            <a:endParaRPr lang="en-US" sz="680" dirty="0"/>
+          </a:p>
+        </p:txBody>
+      </p:sp>
+      <p:sp>
+        <p:nvSpPr>
+          <p:cNvPr id="103" name="Text 100"/>
+          <p:cNvSpPr txBox="1"/>
+          <p:nvPr/>
+        </p:nvSpPr>
+        <p:spPr>
+          <a:xfrm>
+            <a:off x="6858000" y="3163824"/>
+            <a:ext cx="713232" cy="150876"/>
+          </a:xfrm>
+          <a:prstGeom prst="rect">
+            <a:avLst/>
+          </a:prstGeom>
+          <a:noFill/>
+          <a:ln/>
+        </p:spPr>
+        <p:txBody>
+          <a:bodyPr wrap="square" lIns="0" tIns="0" rIns="0" bIns="0" rtlCol="0" anchor="ctr"/>
+          <a:lstStyle/>
+          <a:p>
+            <a:pPr algn="r" indent="0" marL="0">
+              <a:buNone/>
+            </a:pPr>
+            <a:r>
+              <a:rPr lang="en-US" sz="680" b="1" dirty="0">
+                <a:solidFill>
+                  <a:srgbClr val="12293A"/>
+                </a:solidFill>
+                <a:latin typeface="Poppins" pitchFamily="34" charset="0"/>
+                <a:ea typeface="Poppins" pitchFamily="34" charset="-122"/>
+                <a:cs typeface="Poppins" pitchFamily="34" charset="-120"/>
+              </a:rPr>
+              <a:t>$79k</a:t>
+            </a:r>
+            <a:endParaRPr lang="en-US" sz="680" dirty="0"/>
+          </a:p>
+        </p:txBody>
+      </p:sp>
+      <p:sp>
+        <p:nvSpPr>
+          <p:cNvPr id="104" name="Text 101"/>
+          <p:cNvSpPr txBox="1"/>
+          <p:nvPr/>
+        </p:nvSpPr>
+        <p:spPr>
+          <a:xfrm>
+            <a:off x="7589520" y="3163824"/>
+            <a:ext cx="365760" cy="150876"/>
           </a:xfrm>
           <a:prstGeom prst="rect">
             <a:avLst/>
@@ -5001,169 +5118,52 @@
             <a:r>
               <a:rPr lang="en-US" sz="680" dirty="0">
                 <a:solidFill>
-                  <a:srgbClr val="5E7280"/>
-                </a:solidFill>
-                <a:latin typeface="Poppins" pitchFamily="34" charset="0"/>
-                <a:ea typeface="Poppins" pitchFamily="34" charset="-122"/>
-                <a:cs typeface="Poppins" pitchFamily="34" charset="-120"/>
-              </a:rPr>
-              <a:t>$42</a:t>
-            </a:r>
-            <a:endParaRPr lang="en-US" sz="680" dirty="0"/>
-          </a:p>
-        </p:txBody>
-      </p:sp>
-      <p:sp>
-        <p:nvSpPr>
-          <p:cNvPr id="102" name="Text 99"/>
-          <p:cNvSpPr txBox="1"/>
-          <p:nvPr/>
-        </p:nvSpPr>
-        <p:spPr>
-          <a:xfrm>
-            <a:off x="5879592" y="3163824"/>
-            <a:ext cx="1097280" cy="150876"/>
-          </a:xfrm>
-          <a:prstGeom prst="rect">
-            <a:avLst/>
-          </a:prstGeom>
-          <a:noFill/>
-          <a:ln/>
-        </p:spPr>
-        <p:txBody>
-          <a:bodyPr wrap="square" lIns="0" tIns="0" rIns="0" bIns="0" rtlCol="0" anchor="ctr"/>
-          <a:lstStyle/>
-          <a:p>
-            <a:pPr algn="l" indent="0" marL="0">
+                  <a:srgbClr val="12293A"/>
+                </a:solidFill>
+                <a:latin typeface="Poppins" pitchFamily="34" charset="0"/>
+                <a:ea typeface="Poppins" pitchFamily="34" charset="-122"/>
+                <a:cs typeface="Poppins" pitchFamily="34" charset="-120"/>
+              </a:rPr>
+              <a:t>1.0h</a:t>
+            </a:r>
+            <a:endParaRPr lang="en-US" sz="680" dirty="0"/>
+          </a:p>
+        </p:txBody>
+      </p:sp>
+      <p:sp>
+        <p:nvSpPr>
+          <p:cNvPr id="105" name="Text 102"/>
+          <p:cNvSpPr txBox="1"/>
+          <p:nvPr/>
+        </p:nvSpPr>
+        <p:spPr>
+          <a:xfrm>
+            <a:off x="7955280" y="3163824"/>
+            <a:ext cx="566928" cy="150876"/>
+          </a:xfrm>
+          <a:prstGeom prst="rect">
+            <a:avLst/>
+          </a:prstGeom>
+          <a:noFill/>
+          <a:ln/>
+        </p:spPr>
+        <p:txBody>
+          <a:bodyPr wrap="square" lIns="0" tIns="0" rIns="0" bIns="0" rtlCol="0" anchor="ctr"/>
+          <a:lstStyle/>
+          <a:p>
+            <a:pPr algn="r" indent="0" marL="0">
               <a:buNone/>
             </a:pPr>
             <a:r>
               <a:rPr lang="en-US" sz="680" b="1" dirty="0">
                 <a:solidFill>
-                  <a:srgbClr val="12293A"/>
-                </a:solidFill>
-                <a:latin typeface="Poppins" pitchFamily="34" charset="0"/>
-                <a:ea typeface="Poppins" pitchFamily="34" charset="-122"/>
-                <a:cs typeface="Poppins" pitchFamily="34" charset="-120"/>
-              </a:rPr>
-              <a:t>Zeller</a:t>
-            </a:r>
-            <a:endParaRPr lang="en-US" sz="680" dirty="0"/>
-          </a:p>
-        </p:txBody>
-      </p:sp>
-      <p:sp>
-        <p:nvSpPr>
-          <p:cNvPr id="103" name="Text 100"/>
-          <p:cNvSpPr txBox="1"/>
-          <p:nvPr/>
-        </p:nvSpPr>
-        <p:spPr>
-          <a:xfrm>
-            <a:off x="6903720" y="3163824"/>
-            <a:ext cx="731520" cy="150876"/>
-          </a:xfrm>
-          <a:prstGeom prst="rect">
-            <a:avLst/>
-          </a:prstGeom>
-          <a:noFill/>
-          <a:ln/>
-        </p:spPr>
-        <p:txBody>
-          <a:bodyPr wrap="square" lIns="0" tIns="0" rIns="0" bIns="0" rtlCol="0" anchor="ctr"/>
-          <a:lstStyle/>
-          <a:p>
-            <a:pPr algn="r" indent="0" marL="0">
-              <a:buNone/>
-            </a:pPr>
-            <a:r>
-              <a:rPr lang="en-US" sz="680" b="1" dirty="0">
-                <a:solidFill>
-                  <a:srgbClr val="12293A"/>
-                </a:solidFill>
-                <a:latin typeface="Poppins" pitchFamily="34" charset="0"/>
-                <a:ea typeface="Poppins" pitchFamily="34" charset="-122"/>
-                <a:cs typeface="Poppins" pitchFamily="34" charset="-120"/>
-              </a:rPr>
-              <a:t>$79k</a:t>
-            </a:r>
-            <a:endParaRPr lang="en-US" sz="680" dirty="0"/>
-          </a:p>
-        </p:txBody>
-      </p:sp>
-      <p:sp>
-        <p:nvSpPr>
-          <p:cNvPr id="104" name="Text 101"/>
-          <p:cNvSpPr txBox="1"/>
-          <p:nvPr/>
-        </p:nvSpPr>
-        <p:spPr>
-          <a:xfrm>
-            <a:off x="7680960" y="3163824"/>
-            <a:ext cx="411480" cy="150876"/>
-          </a:xfrm>
-          <a:prstGeom prst="rect">
-            <a:avLst/>
-          </a:prstGeom>
-          <a:noFill/>
-          <a:ln/>
-        </p:spPr>
-        <p:txBody>
-          <a:bodyPr wrap="square" lIns="0" tIns="0" rIns="0" bIns="0" rtlCol="0" anchor="ctr"/>
-          <a:lstStyle/>
-          <a:p>
-            <a:pPr algn="r" indent="0" marL="0">
-              <a:buNone/>
-            </a:pPr>
-            <a:r>
-              <a:rPr lang="en-US" sz="680" dirty="0">
-                <a:solidFill>
-                  <a:srgbClr val="12293A"/>
-                </a:solidFill>
-                <a:latin typeface="Poppins" pitchFamily="34" charset="0"/>
-                <a:ea typeface="Poppins" pitchFamily="34" charset="-122"/>
-                <a:cs typeface="Poppins" pitchFamily="34" charset="-120"/>
-              </a:rPr>
-              <a:t>1.0h</a:t>
-            </a:r>
-            <a:endParaRPr lang="en-US" sz="680" dirty="0"/>
-          </a:p>
-        </p:txBody>
-      </p:sp>
-      <p:sp>
-        <p:nvSpPr>
-          <p:cNvPr id="105" name="Text 102"/>
-          <p:cNvSpPr txBox="1"/>
-          <p:nvPr/>
-        </p:nvSpPr>
-        <p:spPr>
-          <a:xfrm>
-            <a:off x="8092440" y="3163824"/>
-            <a:ext cx="502920" cy="150876"/>
-          </a:xfrm>
-          <a:prstGeom prst="rect">
-            <a:avLst/>
-          </a:prstGeom>
-          <a:noFill/>
-          <a:ln/>
-        </p:spPr>
-        <p:txBody>
-          <a:bodyPr wrap="square" lIns="0" tIns="0" rIns="0" bIns="0" rtlCol="0" anchor="ctr"/>
-          <a:lstStyle/>
-          <a:p>
-            <a:pPr algn="r" indent="0" marL="0">
-              <a:buNone/>
-            </a:pPr>
-            <a:r>
-              <a:rPr lang="en-US" sz="680" dirty="0">
-                <a:solidFill>
-                  <a:srgbClr val="5E7280"/>
-                </a:solidFill>
-                <a:latin typeface="Poppins" pitchFamily="34" charset="0"/>
-                <a:ea typeface="Poppins" pitchFamily="34" charset="-122"/>
-                <a:cs typeface="Poppins" pitchFamily="34" charset="-120"/>
-              </a:rPr>
-              <a:t>$42</a:t>
+                  <a:srgbClr val="B4552D"/>
+                </a:solidFill>
+                <a:latin typeface="Poppins" pitchFamily="34" charset="0"/>
+                <a:ea typeface="Poppins" pitchFamily="34" charset="-122"/>
+                <a:cs typeface="Poppins" pitchFamily="34" charset="-120"/>
+              </a:rPr>
+              <a:t>$150</a:t>
             </a:r>
             <a:endParaRPr lang="en-US" sz="680" dirty="0"/>
           </a:p>
@@ -5198,7 +5198,7 @@
         <p:spPr>
           <a:xfrm>
             <a:off x="5879592" y="3314700"/>
-            <a:ext cx="1097280" cy="150876"/>
+            <a:ext cx="1005840" cy="150876"/>
           </a:xfrm>
           <a:prstGeom prst="rect">
             <a:avLst/>
@@ -5236,8 +5236,8 @@
         </p:nvSpPr>
         <p:spPr>
           <a:xfrm>
-            <a:off x="6903720" y="3314700"/>
-            <a:ext cx="731520" cy="150876"/>
+            <a:off x="6858000" y="3314700"/>
+            <a:ext cx="713232" cy="150876"/>
           </a:xfrm>
           <a:prstGeom prst="rect">
             <a:avLst/>
@@ -5275,8 +5275,8 @@
         </p:nvSpPr>
         <p:spPr>
           <a:xfrm>
-            <a:off x="7680960" y="3314700"/>
-            <a:ext cx="411480" cy="150876"/>
+            <a:off x="7589520" y="3314700"/>
+            <a:ext cx="365760" cy="150876"/>
           </a:xfrm>
           <a:prstGeom prst="rect">
             <a:avLst/>
@@ -5314,8 +5314,8 @@
         </p:nvSpPr>
         <p:spPr>
           <a:xfrm>
-            <a:off x="8092440" y="3314700"/>
-            <a:ext cx="502920" cy="150876"/>
+            <a:off x="7955280" y="3314700"/>
+            <a:ext cx="566928" cy="150876"/>
           </a:xfrm>
           <a:prstGeom prst="rect">
             <a:avLst/>
@@ -5354,7 +5354,7 @@
         <p:spPr>
           <a:xfrm>
             <a:off x="5879592" y="3465576"/>
-            <a:ext cx="1097280" cy="150876"/>
+            <a:ext cx="1005840" cy="150876"/>
           </a:xfrm>
           <a:prstGeom prst="rect">
             <a:avLst/>
@@ -5392,8 +5392,8 @@
         </p:nvSpPr>
         <p:spPr>
           <a:xfrm>
-            <a:off x="6903720" y="3465576"/>
-            <a:ext cx="731520" cy="150876"/>
+            <a:off x="6858000" y="3465576"/>
+            <a:ext cx="713232" cy="150876"/>
           </a:xfrm>
           <a:prstGeom prst="rect">
             <a:avLst/>
@@ -5431,8 +5431,8 @@
         </p:nvSpPr>
         <p:spPr>
           <a:xfrm>
-            <a:off x="7680960" y="3465576"/>
-            <a:ext cx="411480" cy="150876"/>
+            <a:off x="7589520" y="3465576"/>
+            <a:ext cx="365760" cy="150876"/>
           </a:xfrm>
           <a:prstGeom prst="rect">
             <a:avLst/>
@@ -5470,8 +5470,8 @@
         </p:nvSpPr>
         <p:spPr>
           <a:xfrm>
-            <a:off x="8092440" y="3465576"/>
-            <a:ext cx="502920" cy="150876"/>
+            <a:off x="7955280" y="3465576"/>
+            <a:ext cx="566928" cy="150876"/>
           </a:xfrm>
           <a:prstGeom prst="rect">
             <a:avLst/>
@@ -5530,7 +5530,7 @@
         <p:spPr>
           <a:xfrm>
             <a:off x="5879592" y="3616452"/>
-            <a:ext cx="1097280" cy="150876"/>
+            <a:ext cx="1005840" cy="150876"/>
           </a:xfrm>
           <a:prstGeom prst="rect">
             <a:avLst/>
@@ -5568,8 +5568,8 @@
         </p:nvSpPr>
         <p:spPr>
           <a:xfrm>
-            <a:off x="6903720" y="3616452"/>
-            <a:ext cx="731520" cy="150876"/>
+            <a:off x="6858000" y="3616452"/>
+            <a:ext cx="713232" cy="150876"/>
           </a:xfrm>
           <a:prstGeom prst="rect">
             <a:avLst/>
@@ -5607,8 +5607,8 @@
         </p:nvSpPr>
         <p:spPr>
           <a:xfrm>
-            <a:off x="7680960" y="3616452"/>
-            <a:ext cx="411480" cy="150876"/>
+            <a:off x="7589520" y="3616452"/>
+            <a:ext cx="365760" cy="150876"/>
           </a:xfrm>
           <a:prstGeom prst="rect">
             <a:avLst/>
@@ -5646,8 +5646,125 @@
         </p:nvSpPr>
         <p:spPr>
           <a:xfrm>
-            <a:off x="8092440" y="3616452"/>
-            <a:ext cx="502920" cy="150876"/>
+            <a:off x="7955280" y="3616452"/>
+            <a:ext cx="566928" cy="150876"/>
+          </a:xfrm>
+          <a:prstGeom prst="rect">
+            <a:avLst/>
+          </a:prstGeom>
+          <a:noFill/>
+          <a:ln/>
+        </p:spPr>
+        <p:txBody>
+          <a:bodyPr wrap="square" lIns="0" tIns="0" rIns="0" bIns="0" rtlCol="0" anchor="ctr"/>
+          <a:lstStyle/>
+          <a:p>
+            <a:pPr algn="r" indent="0" marL="0">
+              <a:buNone/>
+            </a:pPr>
+            <a:r>
+              <a:rPr lang="en-US" sz="680" b="1" dirty="0">
+                <a:solidFill>
+                  <a:srgbClr val="B4552D"/>
+                </a:solidFill>
+                <a:latin typeface="Poppins" pitchFamily="34" charset="0"/>
+                <a:ea typeface="Poppins" pitchFamily="34" charset="-122"/>
+                <a:cs typeface="Poppins" pitchFamily="34" charset="-120"/>
+              </a:rPr>
+              <a:t>$225</a:t>
+            </a:r>
+            <a:endParaRPr lang="en-US" sz="680" dirty="0"/>
+          </a:p>
+        </p:txBody>
+      </p:sp>
+      <p:sp>
+        <p:nvSpPr>
+          <p:cNvPr id="120" name="Text 117"/>
+          <p:cNvSpPr txBox="1"/>
+          <p:nvPr/>
+        </p:nvSpPr>
+        <p:spPr>
+          <a:xfrm>
+            <a:off x="5879592" y="3767328"/>
+            <a:ext cx="1005840" cy="150876"/>
+          </a:xfrm>
+          <a:prstGeom prst="rect">
+            <a:avLst/>
+          </a:prstGeom>
+          <a:noFill/>
+          <a:ln/>
+        </p:spPr>
+        <p:txBody>
+          <a:bodyPr wrap="square" lIns="0" tIns="0" rIns="0" bIns="0" rtlCol="0" anchor="ctr"/>
+          <a:lstStyle/>
+          <a:p>
+            <a:pPr algn="l" indent="0" marL="0">
+              <a:buNone/>
+            </a:pPr>
+            <a:r>
+              <a:rPr lang="en-US" sz="680" b="1" dirty="0">
+                <a:solidFill>
+                  <a:srgbClr val="12293A"/>
+                </a:solidFill>
+                <a:latin typeface="Poppins" pitchFamily="34" charset="0"/>
+                <a:ea typeface="Poppins" pitchFamily="34" charset="-122"/>
+                <a:cs typeface="Poppins" pitchFamily="34" charset="-120"/>
+              </a:rPr>
+              <a:t>EatClub</a:t>
+            </a:r>
+            <a:endParaRPr lang="en-US" sz="680" dirty="0"/>
+          </a:p>
+        </p:txBody>
+      </p:sp>
+      <p:sp>
+        <p:nvSpPr>
+          <p:cNvPr id="121" name="Text 118"/>
+          <p:cNvSpPr txBox="1"/>
+          <p:nvPr/>
+        </p:nvSpPr>
+        <p:spPr>
+          <a:xfrm>
+            <a:off x="6858000" y="3767328"/>
+            <a:ext cx="713232" cy="150876"/>
+          </a:xfrm>
+          <a:prstGeom prst="rect">
+            <a:avLst/>
+          </a:prstGeom>
+          <a:noFill/>
+          <a:ln/>
+        </p:spPr>
+        <p:txBody>
+          <a:bodyPr wrap="square" lIns="0" tIns="0" rIns="0" bIns="0" rtlCol="0" anchor="ctr"/>
+          <a:lstStyle/>
+          <a:p>
+            <a:pPr algn="r" indent="0" marL="0">
+              <a:buNone/>
+            </a:pPr>
+            <a:r>
+              <a:rPr lang="en-US" sz="680" b="1" dirty="0">
+                <a:solidFill>
+                  <a:srgbClr val="12293A"/>
+                </a:solidFill>
+                <a:latin typeface="Poppins" pitchFamily="34" charset="0"/>
+                <a:ea typeface="Poppins" pitchFamily="34" charset="-122"/>
+                <a:cs typeface="Poppins" pitchFamily="34" charset="-120"/>
+              </a:rPr>
+              <a:t>$2k</a:t>
+            </a:r>
+            <a:endParaRPr lang="en-US" sz="680" dirty="0"/>
+          </a:p>
+        </p:txBody>
+      </p:sp>
+      <p:sp>
+        <p:nvSpPr>
+          <p:cNvPr id="122" name="Text 119"/>
+          <p:cNvSpPr txBox="1"/>
+          <p:nvPr/>
+        </p:nvSpPr>
+        <p:spPr>
+          <a:xfrm>
+            <a:off x="7589520" y="3767328"/>
+            <a:ext cx="365760" cy="150876"/>
           </a:xfrm>
           <a:prstGeom prst="rect">
             <a:avLst/>
@@ -5665,169 +5782,52 @@
             <a:r>
               <a:rPr lang="en-US" sz="680" dirty="0">
                 <a:solidFill>
-                  <a:srgbClr val="5E7280"/>
-                </a:solidFill>
-                <a:latin typeface="Poppins" pitchFamily="34" charset="0"/>
-                <a:ea typeface="Poppins" pitchFamily="34" charset="-122"/>
-                <a:cs typeface="Poppins" pitchFamily="34" charset="-120"/>
-              </a:rPr>
-              <a:t>$63</a:t>
-            </a:r>
-            <a:endParaRPr lang="en-US" sz="680" dirty="0"/>
-          </a:p>
-        </p:txBody>
-      </p:sp>
-      <p:sp>
-        <p:nvSpPr>
-          <p:cNvPr id="120" name="Text 117"/>
-          <p:cNvSpPr txBox="1"/>
-          <p:nvPr/>
-        </p:nvSpPr>
-        <p:spPr>
-          <a:xfrm>
-            <a:off x="5879592" y="3767328"/>
-            <a:ext cx="1097280" cy="150876"/>
-          </a:xfrm>
-          <a:prstGeom prst="rect">
-            <a:avLst/>
-          </a:prstGeom>
-          <a:noFill/>
-          <a:ln/>
-        </p:spPr>
-        <p:txBody>
-          <a:bodyPr wrap="square" lIns="0" tIns="0" rIns="0" bIns="0" rtlCol="0" anchor="ctr"/>
-          <a:lstStyle/>
-          <a:p>
-            <a:pPr algn="l" indent="0" marL="0">
+                  <a:srgbClr val="12293A"/>
+                </a:solidFill>
+                <a:latin typeface="Poppins" pitchFamily="34" charset="0"/>
+                <a:ea typeface="Poppins" pitchFamily="34" charset="-122"/>
+                <a:cs typeface="Poppins" pitchFamily="34" charset="-120"/>
+              </a:rPr>
+              <a:t>1.1h</a:t>
+            </a:r>
+            <a:endParaRPr lang="en-US" sz="680" dirty="0"/>
+          </a:p>
+        </p:txBody>
+      </p:sp>
+      <p:sp>
+        <p:nvSpPr>
+          <p:cNvPr id="123" name="Text 120"/>
+          <p:cNvSpPr txBox="1"/>
+          <p:nvPr/>
+        </p:nvSpPr>
+        <p:spPr>
+          <a:xfrm>
+            <a:off x="7955280" y="3767328"/>
+            <a:ext cx="566928" cy="150876"/>
+          </a:xfrm>
+          <a:prstGeom prst="rect">
+            <a:avLst/>
+          </a:prstGeom>
+          <a:noFill/>
+          <a:ln/>
+        </p:spPr>
+        <p:txBody>
+          <a:bodyPr wrap="square" lIns="0" tIns="0" rIns="0" bIns="0" rtlCol="0" anchor="ctr"/>
+          <a:lstStyle/>
+          <a:p>
+            <a:pPr algn="r" indent="0" marL="0">
               <a:buNone/>
             </a:pPr>
             <a:r>
               <a:rPr lang="en-US" sz="680" b="1" dirty="0">
                 <a:solidFill>
-                  <a:srgbClr val="12293A"/>
-                </a:solidFill>
-                <a:latin typeface="Poppins" pitchFamily="34" charset="0"/>
-                <a:ea typeface="Poppins" pitchFamily="34" charset="-122"/>
-                <a:cs typeface="Poppins" pitchFamily="34" charset="-120"/>
-              </a:rPr>
-              <a:t>EatClub</a:t>
-            </a:r>
-            <a:endParaRPr lang="en-US" sz="680" dirty="0"/>
-          </a:p>
-        </p:txBody>
-      </p:sp>
-      <p:sp>
-        <p:nvSpPr>
-          <p:cNvPr id="121" name="Text 118"/>
-          <p:cNvSpPr txBox="1"/>
-          <p:nvPr/>
-        </p:nvSpPr>
-        <p:spPr>
-          <a:xfrm>
-            <a:off x="6903720" y="3767328"/>
-            <a:ext cx="731520" cy="150876"/>
-          </a:xfrm>
-          <a:prstGeom prst="rect">
-            <a:avLst/>
-          </a:prstGeom>
-          <a:noFill/>
-          <a:ln/>
-        </p:spPr>
-        <p:txBody>
-          <a:bodyPr wrap="square" lIns="0" tIns="0" rIns="0" bIns="0" rtlCol="0" anchor="ctr"/>
-          <a:lstStyle/>
-          <a:p>
-            <a:pPr algn="r" indent="0" marL="0">
-              <a:buNone/>
-            </a:pPr>
-            <a:r>
-              <a:rPr lang="en-US" sz="680" b="1" dirty="0">
-                <a:solidFill>
-                  <a:srgbClr val="12293A"/>
-                </a:solidFill>
-                <a:latin typeface="Poppins" pitchFamily="34" charset="0"/>
-                <a:ea typeface="Poppins" pitchFamily="34" charset="-122"/>
-                <a:cs typeface="Poppins" pitchFamily="34" charset="-120"/>
-              </a:rPr>
-              <a:t>$2k</a:t>
-            </a:r>
-            <a:endParaRPr lang="en-US" sz="680" dirty="0"/>
-          </a:p>
-        </p:txBody>
-      </p:sp>
-      <p:sp>
-        <p:nvSpPr>
-          <p:cNvPr id="122" name="Text 119"/>
-          <p:cNvSpPr txBox="1"/>
-          <p:nvPr/>
-        </p:nvSpPr>
-        <p:spPr>
-          <a:xfrm>
-            <a:off x="7680960" y="3767328"/>
-            <a:ext cx="411480" cy="150876"/>
-          </a:xfrm>
-          <a:prstGeom prst="rect">
-            <a:avLst/>
-          </a:prstGeom>
-          <a:noFill/>
-          <a:ln/>
-        </p:spPr>
-        <p:txBody>
-          <a:bodyPr wrap="square" lIns="0" tIns="0" rIns="0" bIns="0" rtlCol="0" anchor="ctr"/>
-          <a:lstStyle/>
-          <a:p>
-            <a:pPr algn="r" indent="0" marL="0">
-              <a:buNone/>
-            </a:pPr>
-            <a:r>
-              <a:rPr lang="en-US" sz="680" dirty="0">
-                <a:solidFill>
-                  <a:srgbClr val="12293A"/>
-                </a:solidFill>
-                <a:latin typeface="Poppins" pitchFamily="34" charset="0"/>
-                <a:ea typeface="Poppins" pitchFamily="34" charset="-122"/>
-                <a:cs typeface="Poppins" pitchFamily="34" charset="-120"/>
-              </a:rPr>
-              <a:t>1.1h</a:t>
-            </a:r>
-            <a:endParaRPr lang="en-US" sz="680" dirty="0"/>
-          </a:p>
-        </p:txBody>
-      </p:sp>
-      <p:sp>
-        <p:nvSpPr>
-          <p:cNvPr id="123" name="Text 120"/>
-          <p:cNvSpPr txBox="1"/>
-          <p:nvPr/>
-        </p:nvSpPr>
-        <p:spPr>
-          <a:xfrm>
-            <a:off x="8092440" y="3767328"/>
-            <a:ext cx="502920" cy="150876"/>
-          </a:xfrm>
-          <a:prstGeom prst="rect">
-            <a:avLst/>
-          </a:prstGeom>
-          <a:noFill/>
-          <a:ln/>
-        </p:spPr>
-        <p:txBody>
-          <a:bodyPr wrap="square" lIns="0" tIns="0" rIns="0" bIns="0" rtlCol="0" anchor="ctr"/>
-          <a:lstStyle/>
-          <a:p>
-            <a:pPr algn="r" indent="0" marL="0">
-              <a:buNone/>
-            </a:pPr>
-            <a:r>
-              <a:rPr lang="en-US" sz="680" dirty="0">
-                <a:solidFill>
-                  <a:srgbClr val="5E7280"/>
-                </a:solidFill>
-                <a:latin typeface="Poppins" pitchFamily="34" charset="0"/>
-                <a:ea typeface="Poppins" pitchFamily="34" charset="-122"/>
-                <a:cs typeface="Poppins" pitchFamily="34" charset="-120"/>
-              </a:rPr>
-              <a:t>$47</a:t>
+                  <a:srgbClr val="B4552D"/>
+                </a:solidFill>
+                <a:latin typeface="Poppins" pitchFamily="34" charset="0"/>
+                <a:ea typeface="Poppins" pitchFamily="34" charset="-122"/>
+                <a:cs typeface="Poppins" pitchFamily="34" charset="-120"/>
+              </a:rPr>
+              <a:t>$167</a:t>
             </a:r>
             <a:endParaRPr lang="en-US" sz="680" dirty="0"/>
           </a:p>
@@ -5862,7 +5862,7 @@
         <p:spPr>
           <a:xfrm>
             <a:off x="5879592" y="3918204"/>
-            <a:ext cx="1097280" cy="150876"/>
+            <a:ext cx="1005840" cy="150876"/>
           </a:xfrm>
           <a:prstGeom prst="rect">
             <a:avLst/>
@@ -5880,28 +5880,106 @@
             <a:r>
               <a:rPr lang="en-US" sz="680" b="1" dirty="0">
                 <a:solidFill>
+                  <a:srgbClr val="B4552D"/>
+                </a:solidFill>
+                <a:latin typeface="Poppins" pitchFamily="34" charset="0"/>
+                <a:ea typeface="Poppins" pitchFamily="34" charset="-122"/>
+                <a:cs typeface="Poppins" pitchFamily="34" charset="-120"/>
+              </a:rPr>
+              <a:t>H&amp;L Pay</a:t>
+            </a:r>
+            <a:endParaRPr lang="en-US" sz="680" dirty="0"/>
+          </a:p>
+        </p:txBody>
+      </p:sp>
+      <p:sp>
+        <p:nvSpPr>
+          <p:cNvPr id="126" name="Text 123"/>
+          <p:cNvSpPr txBox="1"/>
+          <p:nvPr/>
+        </p:nvSpPr>
+        <p:spPr>
+          <a:xfrm>
+            <a:off x="6858000" y="3918204"/>
+            <a:ext cx="713232" cy="150876"/>
+          </a:xfrm>
+          <a:prstGeom prst="rect">
+            <a:avLst/>
+          </a:prstGeom>
+          <a:noFill/>
+          <a:ln/>
+        </p:spPr>
+        <p:txBody>
+          <a:bodyPr wrap="square" lIns="0" tIns="0" rIns="0" bIns="0" rtlCol="0" anchor="ctr"/>
+          <a:lstStyle/>
+          <a:p>
+            <a:pPr algn="r" indent="0" marL="0">
+              <a:buNone/>
+            </a:pPr>
+            <a:r>
+              <a:rPr lang="en-US" sz="680" b="1" dirty="0">
+                <a:solidFill>
+                  <a:srgbClr val="8FA1AC"/>
+                </a:solidFill>
+                <a:latin typeface="Poppins" pitchFamily="34" charset="0"/>
+                <a:ea typeface="Poppins" pitchFamily="34" charset="-122"/>
+                <a:cs typeface="Poppins" pitchFamily="34" charset="-120"/>
+              </a:rPr>
+              <a:t>$0</a:t>
+            </a:r>
+            <a:endParaRPr lang="en-US" sz="680" dirty="0"/>
+          </a:p>
+        </p:txBody>
+      </p:sp>
+      <p:sp>
+        <p:nvSpPr>
+          <p:cNvPr id="127" name="Text 124"/>
+          <p:cNvSpPr txBox="1"/>
+          <p:nvPr/>
+        </p:nvSpPr>
+        <p:spPr>
+          <a:xfrm>
+            <a:off x="7589520" y="3918204"/>
+            <a:ext cx="365760" cy="150876"/>
+          </a:xfrm>
+          <a:prstGeom prst="rect">
+            <a:avLst/>
+          </a:prstGeom>
+          <a:noFill/>
+          <a:ln/>
+        </p:spPr>
+        <p:txBody>
+          <a:bodyPr wrap="square" lIns="0" tIns="0" rIns="0" bIns="0" rtlCol="0" anchor="ctr"/>
+          <a:lstStyle/>
+          <a:p>
+            <a:pPr algn="r" indent="0" marL="0">
+              <a:buNone/>
+            </a:pPr>
+            <a:r>
+              <a:rPr lang="en-US" sz="680" dirty="0">
+                <a:solidFill>
                   <a:srgbClr val="12293A"/>
                 </a:solidFill>
                 <a:latin typeface="Poppins" pitchFamily="34" charset="0"/>
                 <a:ea typeface="Poppins" pitchFamily="34" charset="-122"/>
                 <a:cs typeface="Poppins" pitchFamily="34" charset="-120"/>
               </a:rPr>
-              <a:t>H&amp;L Pay</a:t>
-            </a:r>
-            <a:endParaRPr lang="en-US" sz="680" dirty="0"/>
-          </a:p>
-        </p:txBody>
-      </p:sp>
-      <p:sp>
-        <p:nvSpPr>
-          <p:cNvPr id="126" name="Text 123"/>
-          <p:cNvSpPr txBox="1"/>
-          <p:nvPr/>
-        </p:nvSpPr>
-        <p:spPr>
-          <a:xfrm>
-            <a:off x="6903720" y="3918204"/>
-            <a:ext cx="731520" cy="150876"/>
+              <a:t>2.0h</a:t>
+            </a:r>
+            <a:endParaRPr lang="en-US" sz="680" dirty="0"/>
+          </a:p>
+        </p:txBody>
+      </p:sp>
+      <p:sp>
+        <p:nvSpPr>
+          <p:cNvPr id="128" name="Text 125"/>
+          <p:cNvSpPr txBox="1"/>
+          <p:nvPr/>
+        </p:nvSpPr>
+        <p:spPr>
+          <a:xfrm>
+            <a:off x="7955280" y="3918204"/>
+            <a:ext cx="566928" cy="150876"/>
           </a:xfrm>
           <a:prstGeom prst="rect">
             <a:avLst/>
@@ -5919,28 +5997,106 @@
             <a:r>
               <a:rPr lang="en-US" sz="680" b="1" dirty="0">
                 <a:solidFill>
+                  <a:srgbClr val="B4552D"/>
+                </a:solidFill>
+                <a:latin typeface="Poppins" pitchFamily="34" charset="0"/>
+                <a:ea typeface="Poppins" pitchFamily="34" charset="-122"/>
+                <a:cs typeface="Poppins" pitchFamily="34" charset="-120"/>
+              </a:rPr>
+              <a:t>$300</a:t>
+            </a:r>
+            <a:endParaRPr lang="en-US" sz="680" dirty="0"/>
+          </a:p>
+        </p:txBody>
+      </p:sp>
+      <p:sp>
+        <p:nvSpPr>
+          <p:cNvPr id="129" name="Text 126"/>
+          <p:cNvSpPr txBox="1"/>
+          <p:nvPr/>
+        </p:nvSpPr>
+        <p:spPr>
+          <a:xfrm>
+            <a:off x="5879592" y="4069080"/>
+            <a:ext cx="1005840" cy="150876"/>
+          </a:xfrm>
+          <a:prstGeom prst="rect">
+            <a:avLst/>
+          </a:prstGeom>
+          <a:noFill/>
+          <a:ln/>
+        </p:spPr>
+        <p:txBody>
+          <a:bodyPr wrap="square" lIns="0" tIns="0" rIns="0" bIns="0" rtlCol="0" anchor="ctr"/>
+          <a:lstStyle/>
+          <a:p>
+            <a:pPr algn="l" indent="0" marL="0">
+              <a:buNone/>
+            </a:pPr>
+            <a:r>
+              <a:rPr lang="en-US" sz="680" b="1" dirty="0">
+                <a:solidFill>
+                  <a:srgbClr val="B4552D"/>
+                </a:solidFill>
+                <a:latin typeface="Poppins" pitchFamily="34" charset="0"/>
+                <a:ea typeface="Poppins" pitchFamily="34" charset="-122"/>
+                <a:cs typeface="Poppins" pitchFamily="34" charset="-120"/>
+              </a:rPr>
+              <a:t>NowBookIt</a:t>
+            </a:r>
+            <a:endParaRPr lang="en-US" sz="680" dirty="0"/>
+          </a:p>
+        </p:txBody>
+      </p:sp>
+      <p:sp>
+        <p:nvSpPr>
+          <p:cNvPr id="130" name="Text 127"/>
+          <p:cNvSpPr txBox="1"/>
+          <p:nvPr/>
+        </p:nvSpPr>
+        <p:spPr>
+          <a:xfrm>
+            <a:off x="6858000" y="4069080"/>
+            <a:ext cx="713232" cy="150876"/>
+          </a:xfrm>
+          <a:prstGeom prst="rect">
+            <a:avLst/>
+          </a:prstGeom>
+          <a:noFill/>
+          <a:ln/>
+        </p:spPr>
+        <p:txBody>
+          <a:bodyPr wrap="square" lIns="0" tIns="0" rIns="0" bIns="0" rtlCol="0" anchor="ctr"/>
+          <a:lstStyle/>
+          <a:p>
+            <a:pPr algn="r" indent="0" marL="0">
+              <a:buNone/>
+            </a:pPr>
+            <a:r>
+              <a:rPr lang="en-US" sz="680" b="1" dirty="0">
+                <a:solidFill>
                   <a:srgbClr val="8FA1AC"/>
                 </a:solidFill>
                 <a:latin typeface="Poppins" pitchFamily="34" charset="0"/>
                 <a:ea typeface="Poppins" pitchFamily="34" charset="-122"/>
                 <a:cs typeface="Poppins" pitchFamily="34" charset="-120"/>
               </a:rPr>
-              <a:t>separate</a:t>
-            </a:r>
-            <a:endParaRPr lang="en-US" sz="680" dirty="0"/>
-          </a:p>
-        </p:txBody>
-      </p:sp>
-      <p:sp>
-        <p:nvSpPr>
-          <p:cNvPr id="127" name="Text 124"/>
-          <p:cNvSpPr txBox="1"/>
-          <p:nvPr/>
-        </p:nvSpPr>
-        <p:spPr>
-          <a:xfrm>
-            <a:off x="7680960" y="3918204"/>
-            <a:ext cx="411480" cy="150876"/>
+              <a:t>$0</a:t>
+            </a:r>
+            <a:endParaRPr lang="en-US" sz="680" dirty="0"/>
+          </a:p>
+        </p:txBody>
+      </p:sp>
+      <p:sp>
+        <p:nvSpPr>
+          <p:cNvPr id="131" name="Text 128"/>
+          <p:cNvSpPr txBox="1"/>
+          <p:nvPr/>
+        </p:nvSpPr>
+        <p:spPr>
+          <a:xfrm>
+            <a:off x="7589520" y="4069080"/>
+            <a:ext cx="365760" cy="150876"/>
           </a:xfrm>
           <a:prstGeom prst="rect">
             <a:avLst/>
@@ -5972,65 +6128,26 @@
       </p:sp>
       <p:sp>
         <p:nvSpPr>
-          <p:cNvPr id="128" name="Text 125"/>
-          <p:cNvSpPr txBox="1"/>
-          <p:nvPr/>
-        </p:nvSpPr>
-        <p:spPr>
-          <a:xfrm>
-            <a:off x="8092440" y="3918204"/>
-            <a:ext cx="502920" cy="150876"/>
-          </a:xfrm>
-          <a:prstGeom prst="rect">
-            <a:avLst/>
-          </a:prstGeom>
-          <a:noFill/>
-          <a:ln/>
-        </p:spPr>
-        <p:txBody>
-          <a:bodyPr wrap="square" lIns="0" tIns="0" rIns="0" bIns="0" rtlCol="0" anchor="ctr"/>
-          <a:lstStyle/>
-          <a:p>
-            <a:pPr algn="r" indent="0" marL="0">
-              <a:buNone/>
-            </a:pPr>
-            <a:r>
-              <a:rPr lang="en-US" sz="680" dirty="0">
-                <a:solidFill>
-                  <a:srgbClr val="5E7280"/>
-                </a:solidFill>
-                <a:latin typeface="Poppins" pitchFamily="34" charset="0"/>
-                <a:ea typeface="Poppins" pitchFamily="34" charset="-122"/>
-                <a:cs typeface="Poppins" pitchFamily="34" charset="-120"/>
-              </a:rPr>
-              <a:t>$84</a:t>
-            </a:r>
-            <a:endParaRPr lang="en-US" sz="680" dirty="0"/>
-          </a:p>
-        </p:txBody>
-      </p:sp>
-      <p:sp>
-        <p:nvSpPr>
-          <p:cNvPr id="129" name="Text 126"/>
-          <p:cNvSpPr txBox="1"/>
-          <p:nvPr/>
-        </p:nvSpPr>
-        <p:spPr>
-          <a:xfrm>
-            <a:off x="5879592" y="4069080"/>
-            <a:ext cx="1097280" cy="150876"/>
-          </a:xfrm>
-          <a:prstGeom prst="rect">
-            <a:avLst/>
-          </a:prstGeom>
-          <a:noFill/>
-          <a:ln/>
-        </p:spPr>
-        <p:txBody>
-          <a:bodyPr wrap="square" lIns="0" tIns="0" rIns="0" bIns="0" rtlCol="0" anchor="ctr"/>
-          <a:lstStyle/>
-          <a:p>
-            <a:pPr algn="l" indent="0" marL="0">
+          <p:cNvPr id="132" name="Text 129"/>
+          <p:cNvSpPr txBox="1"/>
+          <p:nvPr/>
+        </p:nvSpPr>
+        <p:spPr>
+          <a:xfrm>
+            <a:off x="7955280" y="4069080"/>
+            <a:ext cx="566928" cy="150876"/>
+          </a:xfrm>
+          <a:prstGeom prst="rect">
+            <a:avLst/>
+          </a:prstGeom>
+          <a:noFill/>
+          <a:ln/>
+        </p:spPr>
+        <p:txBody>
+          <a:bodyPr wrap="square" lIns="0" tIns="0" rIns="0" bIns="0" rtlCol="0" anchor="ctr"/>
+          <a:lstStyle/>
+          <a:p>
+            <a:pPr algn="r" indent="0" marL="0">
               <a:buNone/>
             </a:pPr>
             <a:r>
@@ -6042,124 +6159,7 @@
                 <a:ea typeface="Poppins" pitchFamily="34" charset="-122"/>
                 <a:cs typeface="Poppins" pitchFamily="34" charset="-120"/>
               </a:rPr>
-              <a:t>NowBookIt</a:t>
-            </a:r>
-            <a:endParaRPr lang="en-US" sz="680" dirty="0"/>
-          </a:p>
-        </p:txBody>
-      </p:sp>
-      <p:sp>
-        <p:nvSpPr>
-          <p:cNvPr id="130" name="Text 127"/>
-          <p:cNvSpPr txBox="1"/>
-          <p:nvPr/>
-        </p:nvSpPr>
-        <p:spPr>
-          <a:xfrm>
-            <a:off x="6903720" y="4069080"/>
-            <a:ext cx="731520" cy="150876"/>
-          </a:xfrm>
-          <a:prstGeom prst="rect">
-            <a:avLst/>
-          </a:prstGeom>
-          <a:noFill/>
-          <a:ln/>
-        </p:spPr>
-        <p:txBody>
-          <a:bodyPr wrap="square" lIns="0" tIns="0" rIns="0" bIns="0" rtlCol="0" anchor="ctr"/>
-          <a:lstStyle/>
-          <a:p>
-            <a:pPr algn="r" indent="0" marL="0">
-              <a:buNone/>
-            </a:pPr>
-            <a:r>
-              <a:rPr lang="en-US" sz="680" b="1" dirty="0">
-                <a:solidFill>
-                  <a:srgbClr val="12293A"/>
-                </a:solidFill>
-                <a:latin typeface="Poppins" pitchFamily="34" charset="0"/>
-                <a:ea typeface="Poppins" pitchFamily="34" charset="-122"/>
-                <a:cs typeface="Poppins" pitchFamily="34" charset="-120"/>
-              </a:rPr>
-              <a:t>$0</a:t>
-            </a:r>
-            <a:endParaRPr lang="en-US" sz="680" dirty="0"/>
-          </a:p>
-        </p:txBody>
-      </p:sp>
-      <p:sp>
-        <p:nvSpPr>
-          <p:cNvPr id="131" name="Text 128"/>
-          <p:cNvSpPr txBox="1"/>
-          <p:nvPr/>
-        </p:nvSpPr>
-        <p:spPr>
-          <a:xfrm>
-            <a:off x="7680960" y="4069080"/>
-            <a:ext cx="411480" cy="150876"/>
-          </a:xfrm>
-          <a:prstGeom prst="rect">
-            <a:avLst/>
-          </a:prstGeom>
-          <a:noFill/>
-          <a:ln/>
-        </p:spPr>
-        <p:txBody>
-          <a:bodyPr wrap="square" lIns="0" tIns="0" rIns="0" bIns="0" rtlCol="0" anchor="ctr"/>
-          <a:lstStyle/>
-          <a:p>
-            <a:pPr algn="r" indent="0" marL="0">
-              <a:buNone/>
-            </a:pPr>
-            <a:r>
-              <a:rPr lang="en-US" sz="680" dirty="0">
-                <a:solidFill>
-                  <a:srgbClr val="12293A"/>
-                </a:solidFill>
-                <a:latin typeface="Poppins" pitchFamily="34" charset="0"/>
-                <a:ea typeface="Poppins" pitchFamily="34" charset="-122"/>
-                <a:cs typeface="Poppins" pitchFamily="34" charset="-120"/>
-              </a:rPr>
-              <a:t>2.0h</a:t>
-            </a:r>
-            <a:endParaRPr lang="en-US" sz="680" dirty="0"/>
-          </a:p>
-        </p:txBody>
-      </p:sp>
-      <p:sp>
-        <p:nvSpPr>
-          <p:cNvPr id="132" name="Text 129"/>
-          <p:cNvSpPr txBox="1"/>
-          <p:nvPr/>
-        </p:nvSpPr>
-        <p:spPr>
-          <a:xfrm>
-            <a:off x="8092440" y="4069080"/>
-            <a:ext cx="502920" cy="150876"/>
-          </a:xfrm>
-          <a:prstGeom prst="rect">
-            <a:avLst/>
-          </a:prstGeom>
-          <a:noFill/>
-          <a:ln/>
-        </p:spPr>
-        <p:txBody>
-          <a:bodyPr wrap="square" lIns="0" tIns="0" rIns="0" bIns="0" rtlCol="0" anchor="ctr"/>
-          <a:lstStyle/>
-          <a:p>
-            <a:pPr algn="r" indent="0" marL="0">
-              <a:buNone/>
-            </a:pPr>
-            <a:r>
-              <a:rPr lang="en-US" sz="680" dirty="0">
-                <a:solidFill>
-                  <a:srgbClr val="5E7280"/>
-                </a:solidFill>
-                <a:latin typeface="Poppins" pitchFamily="34" charset="0"/>
-                <a:ea typeface="Poppins" pitchFamily="34" charset="-122"/>
-                <a:cs typeface="Poppins" pitchFamily="34" charset="-120"/>
-              </a:rPr>
-              <a:t>$84</a:t>
+              <a:t>$300</a:t>
             </a:r>
             <a:endParaRPr lang="en-US" sz="680" dirty="0"/>
           </a:p>
@@ -6194,7 +6194,7 @@
         <p:spPr>
           <a:xfrm>
             <a:off x="5879592" y="4219956"/>
-            <a:ext cx="1097280" cy="150876"/>
+            <a:ext cx="1005840" cy="150876"/>
           </a:xfrm>
           <a:prstGeom prst="rect">
             <a:avLst/>
@@ -6232,8 +6232,8 @@
         </p:nvSpPr>
         <p:spPr>
           <a:xfrm>
-            <a:off x="6903720" y="4219956"/>
-            <a:ext cx="731520" cy="150876"/>
+            <a:off x="6858000" y="4219956"/>
+            <a:ext cx="713232" cy="150876"/>
           </a:xfrm>
           <a:prstGeom prst="rect">
             <a:avLst/>
@@ -6251,51 +6251,51 @@
             <a:r>
               <a:rPr lang="en-US" sz="680" b="1" dirty="0">
                 <a:solidFill>
+                  <a:srgbClr val="8FA1AC"/>
+                </a:solidFill>
+                <a:latin typeface="Poppins" pitchFamily="34" charset="0"/>
+                <a:ea typeface="Poppins" pitchFamily="34" charset="-122"/>
+                <a:cs typeface="Poppins" pitchFamily="34" charset="-120"/>
+              </a:rPr>
+              <a:t>$0</a:t>
+            </a:r>
+            <a:endParaRPr lang="en-US" sz="680" dirty="0"/>
+          </a:p>
+        </p:txBody>
+      </p:sp>
+      <p:sp>
+        <p:nvSpPr>
+          <p:cNvPr id="136" name="Text 133"/>
+          <p:cNvSpPr txBox="1"/>
+          <p:nvPr/>
+        </p:nvSpPr>
+        <p:spPr>
+          <a:xfrm>
+            <a:off x="7589520" y="4219956"/>
+            <a:ext cx="365760" cy="150876"/>
+          </a:xfrm>
+          <a:prstGeom prst="rect">
+            <a:avLst/>
+          </a:prstGeom>
+          <a:noFill/>
+          <a:ln/>
+        </p:spPr>
+        <p:txBody>
+          <a:bodyPr wrap="square" lIns="0" tIns="0" rIns="0" bIns="0" rtlCol="0" anchor="ctr"/>
+          <a:lstStyle/>
+          <a:p>
+            <a:pPr algn="r" indent="0" marL="0">
+              <a:buNone/>
+            </a:pPr>
+            <a:r>
+              <a:rPr lang="en-US" sz="680" dirty="0">
+                <a:solidFill>
                   <a:srgbClr val="12293A"/>
                 </a:solidFill>
                 <a:latin typeface="Poppins" pitchFamily="34" charset="0"/>
                 <a:ea typeface="Poppins" pitchFamily="34" charset="-122"/>
                 <a:cs typeface="Poppins" pitchFamily="34" charset="-120"/>
               </a:rPr>
-              <a:t>$0</a:t>
-            </a:r>
-            <a:endParaRPr lang="en-US" sz="680" dirty="0"/>
-          </a:p>
-        </p:txBody>
-      </p:sp>
-      <p:sp>
-        <p:nvSpPr>
-          <p:cNvPr id="136" name="Text 133"/>
-          <p:cNvSpPr txBox="1"/>
-          <p:nvPr/>
-        </p:nvSpPr>
-        <p:spPr>
-          <a:xfrm>
-            <a:off x="7680960" y="4219956"/>
-            <a:ext cx="411480" cy="150876"/>
-          </a:xfrm>
-          <a:prstGeom prst="rect">
-            <a:avLst/>
-          </a:prstGeom>
-          <a:noFill/>
-          <a:ln/>
-        </p:spPr>
-        <p:txBody>
-          <a:bodyPr wrap="square" lIns="0" tIns="0" rIns="0" bIns="0" rtlCol="0" anchor="ctr"/>
-          <a:lstStyle/>
-          <a:p>
-            <a:pPr algn="r" indent="0" marL="0">
-              <a:buNone/>
-            </a:pPr>
-            <a:r>
-              <a:rPr lang="en-US" sz="680" dirty="0">
-                <a:solidFill>
-                  <a:srgbClr val="12293A"/>
-                </a:solidFill>
-                <a:latin typeface="Poppins" pitchFamily="34" charset="0"/>
-                <a:ea typeface="Poppins" pitchFamily="34" charset="-122"/>
-                <a:cs typeface="Poppins" pitchFamily="34" charset="-120"/>
-              </a:rPr>
               <a:t>6.3h</a:t>
             </a:r>
             <a:endParaRPr lang="en-US" sz="680" dirty="0"/>
@@ -6310,32 +6310,32 @@
         </p:nvSpPr>
         <p:spPr>
           <a:xfrm>
-            <a:off x="8092440" y="4219956"/>
-            <a:ext cx="502920" cy="150876"/>
-          </a:xfrm>
-          <a:prstGeom prst="rect">
-            <a:avLst/>
-          </a:prstGeom>
-          <a:noFill/>
-          <a:ln/>
-        </p:spPr>
-        <p:txBody>
-          <a:bodyPr wrap="square" lIns="0" tIns="0" rIns="0" bIns="0" rtlCol="0" anchor="ctr"/>
-          <a:lstStyle/>
-          <a:p>
-            <a:pPr algn="r" indent="0" marL="0">
-              <a:buNone/>
-            </a:pPr>
-            <a:r>
-              <a:rPr lang="en-US" sz="680" dirty="0">
-                <a:solidFill>
-                  <a:srgbClr val="5E7280"/>
-                </a:solidFill>
-                <a:latin typeface="Poppins" pitchFamily="34" charset="0"/>
-                <a:ea typeface="Poppins" pitchFamily="34" charset="-122"/>
-                <a:cs typeface="Poppins" pitchFamily="34" charset="-120"/>
-              </a:rPr>
-              <a:t>$265</a:t>
+            <a:off x="7955280" y="4219956"/>
+            <a:ext cx="566928" cy="150876"/>
+          </a:xfrm>
+          <a:prstGeom prst="rect">
+            <a:avLst/>
+          </a:prstGeom>
+          <a:noFill/>
+          <a:ln/>
+        </p:spPr>
+        <p:txBody>
+          <a:bodyPr wrap="square" lIns="0" tIns="0" rIns="0" bIns="0" rtlCol="0" anchor="ctr"/>
+          <a:lstStyle/>
+          <a:p>
+            <a:pPr algn="r" indent="0" marL="0">
+              <a:buNone/>
+            </a:pPr>
+            <a:r>
+              <a:rPr lang="en-US" sz="680" b="1" dirty="0">
+                <a:solidFill>
+                  <a:srgbClr val="B4552D"/>
+                </a:solidFill>
+                <a:latin typeface="Poppins" pitchFamily="34" charset="0"/>
+                <a:ea typeface="Poppins" pitchFamily="34" charset="-122"/>
+                <a:cs typeface="Poppins" pitchFamily="34" charset="-120"/>
+              </a:rPr>
+              <a:t>$948</a:t>
             </a:r>
             <a:endParaRPr lang="en-US" sz="680" dirty="0"/>
           </a:p>
@@ -6418,7 +6418,7 @@
         <p:spPr>
           <a:xfrm>
             <a:off x="8965692" y="2395728"/>
-            <a:ext cx="1005840" cy="146304"/>
+            <a:ext cx="914400" cy="146304"/>
           </a:xfrm>
           <a:prstGeom prst="rect">
             <a:avLst/>
@@ -6456,7 +6456,7 @@
         </p:nvSpPr>
         <p:spPr>
           <a:xfrm>
-            <a:off x="9944100" y="2395728"/>
+            <a:off x="9852660" y="2395728"/>
             <a:ext cx="411480" cy="146304"/>
           </a:xfrm>
           <a:prstGeom prst="rect">
@@ -6495,8 +6495,8 @@
         </p:nvSpPr>
         <p:spPr>
           <a:xfrm>
-            <a:off x="10401300" y="2395728"/>
-            <a:ext cx="502920" cy="146304"/>
+            <a:off x="10264140" y="2395728"/>
+            <a:ext cx="457200" cy="146304"/>
           </a:xfrm>
           <a:prstGeom prst="rect">
             <a:avLst/>
@@ -6520,7 +6520,7 @@
                 <a:ea typeface="Poppins" pitchFamily="34" charset="-122"/>
                 <a:cs typeface="Poppins" pitchFamily="34" charset="-120"/>
               </a:rPr>
-              <a:t>CHARGEABLE</a:t>
+              <a:t>CHARGED</a:t>
             </a:r>
             <a:endParaRPr lang="en-US" sz="560" dirty="0"/>
           </a:p>
@@ -6534,8 +6534,8 @@
         </p:nvSpPr>
         <p:spPr>
           <a:xfrm>
-            <a:off x="10904220" y="2395728"/>
-            <a:ext cx="320040" cy="146304"/>
+            <a:off x="10721340" y="2395728"/>
+            <a:ext cx="384048" cy="146304"/>
           </a:xfrm>
           <a:prstGeom prst="rect">
             <a:avLst/>
@@ -6559,7 +6559,7 @@
                 <a:ea typeface="Poppins" pitchFamily="34" charset="-122"/>
                 <a:cs typeface="Poppins" pitchFamily="34" charset="-120"/>
               </a:rPr>
-              <a:t>BLANK</a:t>
+              <a:t>NO FLAG</a:t>
             </a:r>
             <a:endParaRPr lang="en-US" sz="560" dirty="0"/>
           </a:p>
@@ -6573,8 +6573,8 @@
         </p:nvSpPr>
         <p:spPr>
           <a:xfrm>
-            <a:off x="11224260" y="2395728"/>
-            <a:ext cx="457200" cy="146304"/>
+            <a:off x="11087100" y="2395728"/>
+            <a:ext cx="530352" cy="146304"/>
           </a:xfrm>
           <a:prstGeom prst="rect">
             <a:avLst/>
@@ -6598,7 +6598,7 @@
                 <a:ea typeface="Poppins" pitchFamily="34" charset="-122"/>
                 <a:cs typeface="Poppins" pitchFamily="34" charset="-120"/>
               </a:rPr>
-              <a:t>EST. COST</a:t>
+              <a:t>UNREC. REV</a:t>
             </a:r>
             <a:endParaRPr lang="en-US" sz="560" dirty="0"/>
           </a:p>
@@ -6613,7 +6613,7 @@
         <p:spPr>
           <a:xfrm>
             <a:off x="8965692" y="2560320"/>
-            <a:ext cx="1005840" cy="150876"/>
+            <a:ext cx="914400" cy="150876"/>
           </a:xfrm>
           <a:prstGeom prst="rect">
             <a:avLst/>
@@ -6651,7 +6651,7 @@
         </p:nvSpPr>
         <p:spPr>
           <a:xfrm>
-            <a:off x="9944100" y="2560320"/>
+            <a:off x="9852660" y="2560320"/>
             <a:ext cx="411480" cy="150876"/>
           </a:xfrm>
           <a:prstGeom prst="rect">
@@ -6690,8 +6690,8 @@
         </p:nvSpPr>
         <p:spPr>
           <a:xfrm>
-            <a:off x="10401300" y="2560320"/>
-            <a:ext cx="502920" cy="150876"/>
+            <a:off x="10264140" y="2560320"/>
+            <a:ext cx="457200" cy="150876"/>
           </a:xfrm>
           <a:prstGeom prst="rect">
             <a:avLst/>
@@ -6729,8 +6729,8 @@
         </p:nvSpPr>
         <p:spPr>
           <a:xfrm>
-            <a:off x="10904220" y="2560320"/>
-            <a:ext cx="320040" cy="150876"/>
+            <a:off x="10721340" y="2560320"/>
+            <a:ext cx="384048" cy="150876"/>
           </a:xfrm>
           <a:prstGeom prst="rect">
             <a:avLst/>
@@ -6768,32 +6768,32 @@
         </p:nvSpPr>
         <p:spPr>
           <a:xfrm>
-            <a:off x="11224260" y="2560320"/>
-            <a:ext cx="457200" cy="150876"/>
-          </a:xfrm>
-          <a:prstGeom prst="rect">
-            <a:avLst/>
-          </a:prstGeom>
-          <a:noFill/>
-          <a:ln/>
-        </p:spPr>
-        <p:txBody>
-          <a:bodyPr wrap="square" lIns="0" tIns="0" rIns="0" bIns="0" rtlCol="0" anchor="ctr"/>
-          <a:lstStyle/>
-          <a:p>
-            <a:pPr algn="r" indent="0" marL="0">
-              <a:buNone/>
-            </a:pPr>
-            <a:r>
-              <a:rPr lang="en-US" sz="680" dirty="0">
-                <a:solidFill>
-                  <a:srgbClr val="5E7280"/>
-                </a:solidFill>
-                <a:latin typeface="Poppins" pitchFamily="34" charset="0"/>
-                <a:ea typeface="Poppins" pitchFamily="34" charset="-122"/>
-                <a:cs typeface="Poppins" pitchFamily="34" charset="-120"/>
-              </a:rPr>
-              <a:t>$903</a:t>
+            <a:off x="11087100" y="2560320"/>
+            <a:ext cx="530352" cy="150876"/>
+          </a:xfrm>
+          <a:prstGeom prst="rect">
+            <a:avLst/>
+          </a:prstGeom>
+          <a:noFill/>
+          <a:ln/>
+        </p:spPr>
+        <p:txBody>
+          <a:bodyPr wrap="square" lIns="0" tIns="0" rIns="0" bIns="0" rtlCol="0" anchor="ctr"/>
+          <a:lstStyle/>
+          <a:p>
+            <a:pPr algn="r" indent="0" marL="0">
+              <a:buNone/>
+            </a:pPr>
+            <a:r>
+              <a:rPr lang="en-US" sz="680" b="1" dirty="0">
+                <a:solidFill>
+                  <a:srgbClr val="B4552D"/>
+                </a:solidFill>
+                <a:latin typeface="Poppins" pitchFamily="34" charset="0"/>
+                <a:ea typeface="Poppins" pitchFamily="34" charset="-122"/>
+                <a:cs typeface="Poppins" pitchFamily="34" charset="-120"/>
+              </a:rPr>
+              <a:t>$525</a:t>
             </a:r>
             <a:endParaRPr lang="en-US" sz="680" dirty="0"/>
           </a:p>
@@ -6828,7 +6828,7 @@
         <p:spPr>
           <a:xfrm>
             <a:off x="8965692" y="2711196"/>
-            <a:ext cx="1005840" cy="150876"/>
+            <a:ext cx="914400" cy="150876"/>
           </a:xfrm>
           <a:prstGeom prst="rect">
             <a:avLst/>
@@ -6866,7 +6866,7 @@
         </p:nvSpPr>
         <p:spPr>
           <a:xfrm>
-            <a:off x="9944100" y="2711196"/>
+            <a:off x="9852660" y="2711196"/>
             <a:ext cx="411480" cy="150876"/>
           </a:xfrm>
           <a:prstGeom prst="rect">
@@ -6905,8 +6905,8 @@
         </p:nvSpPr>
         <p:spPr>
           <a:xfrm>
-            <a:off x="10401300" y="2711196"/>
-            <a:ext cx="502920" cy="150876"/>
+            <a:off x="10264140" y="2711196"/>
+            <a:ext cx="457200" cy="150876"/>
           </a:xfrm>
           <a:prstGeom prst="rect">
             <a:avLst/>
@@ -6944,8 +6944,8 @@
         </p:nvSpPr>
         <p:spPr>
           <a:xfrm>
-            <a:off x="10904220" y="2711196"/>
-            <a:ext cx="320040" cy="150876"/>
+            <a:off x="10721340" y="2711196"/>
+            <a:ext cx="384048" cy="150876"/>
           </a:xfrm>
           <a:prstGeom prst="rect">
             <a:avLst/>
@@ -6983,7 +6983,124 @@
         </p:nvSpPr>
         <p:spPr>
           <a:xfrm>
-            <a:off x="11224260" y="2711196"/>
+            <a:off x="11087100" y="2711196"/>
+            <a:ext cx="530352" cy="150876"/>
+          </a:xfrm>
+          <a:prstGeom prst="rect">
+            <a:avLst/>
+          </a:prstGeom>
+          <a:noFill/>
+          <a:ln/>
+        </p:spPr>
+        <p:txBody>
+          <a:bodyPr wrap="square" lIns="0" tIns="0" rIns="0" bIns="0" rtlCol="0" anchor="ctr"/>
+          <a:lstStyle/>
+          <a:p>
+            <a:pPr algn="r" indent="0" marL="0">
+              <a:buNone/>
+            </a:pPr>
+            <a:r>
+              <a:rPr lang="en-US" sz="680" b="1" dirty="0">
+                <a:solidFill>
+                  <a:srgbClr val="B4552D"/>
+                </a:solidFill>
+                <a:latin typeface="Poppins" pitchFamily="34" charset="0"/>
+                <a:ea typeface="Poppins" pitchFamily="34" charset="-122"/>
+                <a:cs typeface="Poppins" pitchFamily="34" charset="-120"/>
+              </a:rPr>
+              <a:t>$675</a:t>
+            </a:r>
+            <a:endParaRPr lang="en-US" sz="680" dirty="0"/>
+          </a:p>
+        </p:txBody>
+      </p:sp>
+      <p:sp>
+        <p:nvSpPr>
+          <p:cNvPr id="156" name="Text 153"/>
+          <p:cNvSpPr txBox="1"/>
+          <p:nvPr/>
+        </p:nvSpPr>
+        <p:spPr>
+          <a:xfrm>
+            <a:off x="8965692" y="2862072"/>
+            <a:ext cx="914400" cy="150876"/>
+          </a:xfrm>
+          <a:prstGeom prst="rect">
+            <a:avLst/>
+          </a:prstGeom>
+          <a:noFill/>
+          <a:ln/>
+        </p:spPr>
+        <p:txBody>
+          <a:bodyPr wrap="square" lIns="0" tIns="0" rIns="0" bIns="0" rtlCol="0" anchor="ctr"/>
+          <a:lstStyle/>
+          <a:p>
+            <a:pPr algn="l" indent="0" marL="0">
+              <a:buNone/>
+            </a:pPr>
+            <a:r>
+              <a:rPr lang="en-US" sz="680" b="1" dirty="0">
+                <a:solidFill>
+                  <a:srgbClr val="12293A"/>
+                </a:solidFill>
+                <a:latin typeface="Poppins" pitchFamily="34" charset="0"/>
+                <a:ea typeface="Poppins" pitchFamily="34" charset="-122"/>
+                <a:cs typeface="Poppins" pitchFamily="34" charset="-120"/>
+              </a:rPr>
+              <a:t>Trader House</a:t>
+            </a:r>
+            <a:endParaRPr lang="en-US" sz="680" dirty="0"/>
+          </a:p>
+        </p:txBody>
+      </p:sp>
+      <p:sp>
+        <p:nvSpPr>
+          <p:cNvPr id="157" name="Text 154"/>
+          <p:cNvSpPr txBox="1"/>
+          <p:nvPr/>
+        </p:nvSpPr>
+        <p:spPr>
+          <a:xfrm>
+            <a:off x="9852660" y="2862072"/>
+            <a:ext cx="411480" cy="150876"/>
+          </a:xfrm>
+          <a:prstGeom prst="rect">
+            <a:avLst/>
+          </a:prstGeom>
+          <a:noFill/>
+          <a:ln/>
+        </p:spPr>
+        <p:txBody>
+          <a:bodyPr wrap="square" lIns="0" tIns="0" rIns="0" bIns="0" rtlCol="0" anchor="ctr"/>
+          <a:lstStyle/>
+          <a:p>
+            <a:pPr algn="r" indent="0" marL="0">
+              <a:buNone/>
+            </a:pPr>
+            <a:r>
+              <a:rPr lang="en-US" sz="680" b="1" dirty="0">
+                <a:solidFill>
+                  <a:srgbClr val="12293A"/>
+                </a:solidFill>
+                <a:latin typeface="Poppins" pitchFamily="34" charset="0"/>
+                <a:ea typeface="Poppins" pitchFamily="34" charset="-122"/>
+                <a:cs typeface="Poppins" pitchFamily="34" charset="-120"/>
+              </a:rPr>
+              <a:t>3.5h</a:t>
+            </a:r>
+            <a:endParaRPr lang="en-US" sz="680" dirty="0"/>
+          </a:p>
+        </p:txBody>
+      </p:sp>
+      <p:sp>
+        <p:nvSpPr>
+          <p:cNvPr id="158" name="Text 155"/>
+          <p:cNvSpPr txBox="1"/>
+          <p:nvPr/>
+        </p:nvSpPr>
+        <p:spPr>
+          <a:xfrm>
+            <a:off x="10264140" y="2862072"/>
             <a:ext cx="457200" cy="150876"/>
           </a:xfrm>
           <a:prstGeom prst="rect">
@@ -7002,208 +7119,91 @@
             <a:r>
               <a:rPr lang="en-US" sz="680" dirty="0">
                 <a:solidFill>
-                  <a:srgbClr val="5E7280"/>
-                </a:solidFill>
-                <a:latin typeface="Poppins" pitchFamily="34" charset="0"/>
-                <a:ea typeface="Poppins" pitchFamily="34" charset="-122"/>
-                <a:cs typeface="Poppins" pitchFamily="34" charset="-120"/>
-              </a:rPr>
-              <a:t>$294</a:t>
-            </a:r>
-            <a:endParaRPr lang="en-US" sz="680" dirty="0"/>
-          </a:p>
-        </p:txBody>
-      </p:sp>
-      <p:sp>
-        <p:nvSpPr>
-          <p:cNvPr id="156" name="Text 153"/>
-          <p:cNvSpPr txBox="1"/>
-          <p:nvPr/>
-        </p:nvSpPr>
-        <p:spPr>
-          <a:xfrm>
-            <a:off x="8965692" y="2862072"/>
-            <a:ext cx="1005840" cy="150876"/>
-          </a:xfrm>
-          <a:prstGeom prst="rect">
-            <a:avLst/>
-          </a:prstGeom>
-          <a:noFill/>
-          <a:ln/>
-        </p:spPr>
-        <p:txBody>
-          <a:bodyPr wrap="square" lIns="0" tIns="0" rIns="0" bIns="0" rtlCol="0" anchor="ctr"/>
-          <a:lstStyle/>
-          <a:p>
-            <a:pPr algn="l" indent="0" marL="0">
+                  <a:srgbClr val="8FA1AC"/>
+                </a:solidFill>
+                <a:latin typeface="Poppins" pitchFamily="34" charset="0"/>
+                <a:ea typeface="Poppins" pitchFamily="34" charset="-122"/>
+                <a:cs typeface="Poppins" pitchFamily="34" charset="-120"/>
+              </a:rPr>
+              <a:t>—</a:t>
+            </a:r>
+            <a:endParaRPr lang="en-US" sz="680" dirty="0"/>
+          </a:p>
+        </p:txBody>
+      </p:sp>
+      <p:sp>
+        <p:nvSpPr>
+          <p:cNvPr id="159" name="Text 156"/>
+          <p:cNvSpPr txBox="1"/>
+          <p:nvPr/>
+        </p:nvSpPr>
+        <p:spPr>
+          <a:xfrm>
+            <a:off x="10721340" y="2862072"/>
+            <a:ext cx="384048" cy="150876"/>
+          </a:xfrm>
+          <a:prstGeom prst="rect">
+            <a:avLst/>
+          </a:prstGeom>
+          <a:noFill/>
+          <a:ln/>
+        </p:spPr>
+        <p:txBody>
+          <a:bodyPr wrap="square" lIns="0" tIns="0" rIns="0" bIns="0" rtlCol="0" anchor="ctr"/>
+          <a:lstStyle/>
+          <a:p>
+            <a:pPr algn="r" indent="0" marL="0">
+              <a:buNone/>
+            </a:pPr>
+            <a:r>
+              <a:rPr lang="en-US" sz="680" dirty="0">
+                <a:solidFill>
+                  <a:srgbClr val="C88A2E"/>
+                </a:solidFill>
+                <a:latin typeface="Poppins" pitchFamily="34" charset="0"/>
+                <a:ea typeface="Poppins" pitchFamily="34" charset="-122"/>
+                <a:cs typeface="Poppins" pitchFamily="34" charset="-120"/>
+              </a:rPr>
+              <a:t>3.5h</a:t>
+            </a:r>
+            <a:endParaRPr lang="en-US" sz="680" dirty="0"/>
+          </a:p>
+        </p:txBody>
+      </p:sp>
+      <p:sp>
+        <p:nvSpPr>
+          <p:cNvPr id="160" name="Text 157"/>
+          <p:cNvSpPr txBox="1"/>
+          <p:nvPr/>
+        </p:nvSpPr>
+        <p:spPr>
+          <a:xfrm>
+            <a:off x="11087100" y="2862072"/>
+            <a:ext cx="530352" cy="150876"/>
+          </a:xfrm>
+          <a:prstGeom prst="rect">
+            <a:avLst/>
+          </a:prstGeom>
+          <a:noFill/>
+          <a:ln/>
+        </p:spPr>
+        <p:txBody>
+          <a:bodyPr wrap="square" lIns="0" tIns="0" rIns="0" bIns="0" rtlCol="0" anchor="ctr"/>
+          <a:lstStyle/>
+          <a:p>
+            <a:pPr algn="r" indent="0" marL="0">
               <a:buNone/>
             </a:pPr>
             <a:r>
               <a:rPr lang="en-US" sz="680" b="1" dirty="0">
                 <a:solidFill>
-                  <a:srgbClr val="12293A"/>
-                </a:solidFill>
-                <a:latin typeface="Poppins" pitchFamily="34" charset="0"/>
-                <a:ea typeface="Poppins" pitchFamily="34" charset="-122"/>
-                <a:cs typeface="Poppins" pitchFamily="34" charset="-120"/>
-              </a:rPr>
-              <a:t>Trader House</a:t>
-            </a:r>
-            <a:endParaRPr lang="en-US" sz="680" dirty="0"/>
-          </a:p>
-        </p:txBody>
-      </p:sp>
-      <p:sp>
-        <p:nvSpPr>
-          <p:cNvPr id="157" name="Text 154"/>
-          <p:cNvSpPr txBox="1"/>
-          <p:nvPr/>
-        </p:nvSpPr>
-        <p:spPr>
-          <a:xfrm>
-            <a:off x="9944100" y="2862072"/>
-            <a:ext cx="411480" cy="150876"/>
-          </a:xfrm>
-          <a:prstGeom prst="rect">
-            <a:avLst/>
-          </a:prstGeom>
-          <a:noFill/>
-          <a:ln/>
-        </p:spPr>
-        <p:txBody>
-          <a:bodyPr wrap="square" lIns="0" tIns="0" rIns="0" bIns="0" rtlCol="0" anchor="ctr"/>
-          <a:lstStyle/>
-          <a:p>
-            <a:pPr algn="r" indent="0" marL="0">
-              <a:buNone/>
-            </a:pPr>
-            <a:r>
-              <a:rPr lang="en-US" sz="680" b="1" dirty="0">
-                <a:solidFill>
-                  <a:srgbClr val="12293A"/>
-                </a:solidFill>
-                <a:latin typeface="Poppins" pitchFamily="34" charset="0"/>
-                <a:ea typeface="Poppins" pitchFamily="34" charset="-122"/>
-                <a:cs typeface="Poppins" pitchFamily="34" charset="-120"/>
-              </a:rPr>
-              <a:t>3.5h</a:t>
-            </a:r>
-            <a:endParaRPr lang="en-US" sz="680" dirty="0"/>
-          </a:p>
-        </p:txBody>
-      </p:sp>
-      <p:sp>
-        <p:nvSpPr>
-          <p:cNvPr id="158" name="Text 155"/>
-          <p:cNvSpPr txBox="1"/>
-          <p:nvPr/>
-        </p:nvSpPr>
-        <p:spPr>
-          <a:xfrm>
-            <a:off x="10401300" y="2862072"/>
-            <a:ext cx="502920" cy="150876"/>
-          </a:xfrm>
-          <a:prstGeom prst="rect">
-            <a:avLst/>
-          </a:prstGeom>
-          <a:noFill/>
-          <a:ln/>
-        </p:spPr>
-        <p:txBody>
-          <a:bodyPr wrap="square" lIns="0" tIns="0" rIns="0" bIns="0" rtlCol="0" anchor="ctr"/>
-          <a:lstStyle/>
-          <a:p>
-            <a:pPr algn="r" indent="0" marL="0">
-              <a:buNone/>
-            </a:pPr>
-            <a:r>
-              <a:rPr lang="en-US" sz="680" dirty="0">
-                <a:solidFill>
-                  <a:srgbClr val="8FA1AC"/>
-                </a:solidFill>
-                <a:latin typeface="Poppins" pitchFamily="34" charset="0"/>
-                <a:ea typeface="Poppins" pitchFamily="34" charset="-122"/>
-                <a:cs typeface="Poppins" pitchFamily="34" charset="-120"/>
-              </a:rPr>
-              <a:t>—</a:t>
-            </a:r>
-            <a:endParaRPr lang="en-US" sz="680" dirty="0"/>
-          </a:p>
-        </p:txBody>
-      </p:sp>
-      <p:sp>
-        <p:nvSpPr>
-          <p:cNvPr id="159" name="Text 156"/>
-          <p:cNvSpPr txBox="1"/>
-          <p:nvPr/>
-        </p:nvSpPr>
-        <p:spPr>
-          <a:xfrm>
-            <a:off x="10904220" y="2862072"/>
-            <a:ext cx="320040" cy="150876"/>
-          </a:xfrm>
-          <a:prstGeom prst="rect">
-            <a:avLst/>
-          </a:prstGeom>
-          <a:noFill/>
-          <a:ln/>
-        </p:spPr>
-        <p:txBody>
-          <a:bodyPr wrap="square" lIns="0" tIns="0" rIns="0" bIns="0" rtlCol="0" anchor="ctr"/>
-          <a:lstStyle/>
-          <a:p>
-            <a:pPr algn="r" indent="0" marL="0">
-              <a:buNone/>
-            </a:pPr>
-            <a:r>
-              <a:rPr lang="en-US" sz="680" dirty="0">
-                <a:solidFill>
-                  <a:srgbClr val="C88A2E"/>
-                </a:solidFill>
-                <a:latin typeface="Poppins" pitchFamily="34" charset="0"/>
-                <a:ea typeface="Poppins" pitchFamily="34" charset="-122"/>
-                <a:cs typeface="Poppins" pitchFamily="34" charset="-120"/>
-              </a:rPr>
-              <a:t>3.5h</a:t>
-            </a:r>
-            <a:endParaRPr lang="en-US" sz="680" dirty="0"/>
-          </a:p>
-        </p:txBody>
-      </p:sp>
-      <p:sp>
-        <p:nvSpPr>
-          <p:cNvPr id="160" name="Text 157"/>
-          <p:cNvSpPr txBox="1"/>
-          <p:nvPr/>
-        </p:nvSpPr>
-        <p:spPr>
-          <a:xfrm>
-            <a:off x="11224260" y="2862072"/>
-            <a:ext cx="457200" cy="150876"/>
-          </a:xfrm>
-          <a:prstGeom prst="rect">
-            <a:avLst/>
-          </a:prstGeom>
-          <a:noFill/>
-          <a:ln/>
-        </p:spPr>
-        <p:txBody>
-          <a:bodyPr wrap="square" lIns="0" tIns="0" rIns="0" bIns="0" rtlCol="0" anchor="ctr"/>
-          <a:lstStyle/>
-          <a:p>
-            <a:pPr algn="r" indent="0" marL="0">
-              <a:buNone/>
-            </a:pPr>
-            <a:r>
-              <a:rPr lang="en-US" sz="680" dirty="0">
-                <a:solidFill>
-                  <a:srgbClr val="5E7280"/>
-                </a:solidFill>
-                <a:latin typeface="Poppins" pitchFamily="34" charset="0"/>
-                <a:ea typeface="Poppins" pitchFamily="34" charset="-122"/>
-                <a:cs typeface="Poppins" pitchFamily="34" charset="-120"/>
-              </a:rPr>
-              <a:t>$147</a:t>
+                  <a:srgbClr val="B4552D"/>
+                </a:solidFill>
+                <a:latin typeface="Poppins" pitchFamily="34" charset="0"/>
+                <a:ea typeface="Poppins" pitchFamily="34" charset="-122"/>
+                <a:cs typeface="Poppins" pitchFamily="34" charset="-120"/>
+              </a:rPr>
+              <a:t>$525</a:t>
             </a:r>
             <a:endParaRPr lang="en-US" sz="680" dirty="0"/>
           </a:p>
@@ -7238,7 +7238,7 @@
         <p:spPr>
           <a:xfrm>
             <a:off x="8965692" y="3012948"/>
-            <a:ext cx="1005840" cy="150876"/>
+            <a:ext cx="914400" cy="150876"/>
           </a:xfrm>
           <a:prstGeom prst="rect">
             <a:avLst/>
@@ -7276,7 +7276,7 @@
         </p:nvSpPr>
         <p:spPr>
           <a:xfrm>
-            <a:off x="9944100" y="3012948"/>
+            <a:off x="9852660" y="3012948"/>
             <a:ext cx="411480" cy="150876"/>
           </a:xfrm>
           <a:prstGeom prst="rect">
@@ -7315,8 +7315,8 @@
         </p:nvSpPr>
         <p:spPr>
           <a:xfrm>
-            <a:off x="10401300" y="3012948"/>
-            <a:ext cx="502920" cy="150876"/>
+            <a:off x="10264140" y="3012948"/>
+            <a:ext cx="457200" cy="150876"/>
           </a:xfrm>
           <a:prstGeom prst="rect">
             <a:avLst/>
@@ -7354,8 +7354,8 @@
         </p:nvSpPr>
         <p:spPr>
           <a:xfrm>
-            <a:off x="10904220" y="3012948"/>
-            <a:ext cx="320040" cy="150876"/>
+            <a:off x="10721340" y="3012948"/>
+            <a:ext cx="384048" cy="150876"/>
           </a:xfrm>
           <a:prstGeom prst="rect">
             <a:avLst/>
@@ -7393,7 +7393,124 @@
         </p:nvSpPr>
         <p:spPr>
           <a:xfrm>
-            <a:off x="11224260" y="3012948"/>
+            <a:off x="11087100" y="3012948"/>
+            <a:ext cx="530352" cy="150876"/>
+          </a:xfrm>
+          <a:prstGeom prst="rect">
+            <a:avLst/>
+          </a:prstGeom>
+          <a:noFill/>
+          <a:ln/>
+        </p:spPr>
+        <p:txBody>
+          <a:bodyPr wrap="square" lIns="0" tIns="0" rIns="0" bIns="0" rtlCol="0" anchor="ctr"/>
+          <a:lstStyle/>
+          <a:p>
+            <a:pPr algn="r" indent="0" marL="0">
+              <a:buNone/>
+            </a:pPr>
+            <a:r>
+              <a:rPr lang="en-US" sz="680" b="1" dirty="0">
+                <a:solidFill>
+                  <a:srgbClr val="B4552D"/>
+                </a:solidFill>
+                <a:latin typeface="Poppins" pitchFamily="34" charset="0"/>
+                <a:ea typeface="Poppins" pitchFamily="34" charset="-122"/>
+                <a:cs typeface="Poppins" pitchFamily="34" charset="-120"/>
+              </a:rPr>
+              <a:t>$525</a:t>
+            </a:r>
+            <a:endParaRPr lang="en-US" sz="680" dirty="0"/>
+          </a:p>
+        </p:txBody>
+      </p:sp>
+      <p:sp>
+        <p:nvSpPr>
+          <p:cNvPr id="167" name="Text 164"/>
+          <p:cNvSpPr txBox="1"/>
+          <p:nvPr/>
+        </p:nvSpPr>
+        <p:spPr>
+          <a:xfrm>
+            <a:off x="8965692" y="3163824"/>
+            <a:ext cx="914400" cy="150876"/>
+          </a:xfrm>
+          <a:prstGeom prst="rect">
+            <a:avLst/>
+          </a:prstGeom>
+          <a:noFill/>
+          <a:ln/>
+        </p:spPr>
+        <p:txBody>
+          <a:bodyPr wrap="square" lIns="0" tIns="0" rIns="0" bIns="0" rtlCol="0" anchor="ctr"/>
+          <a:lstStyle/>
+          <a:p>
+            <a:pPr algn="l" indent="0" marL="0">
+              <a:buNone/>
+            </a:pPr>
+            <a:r>
+              <a:rPr lang="en-US" sz="680" b="1" dirty="0">
+                <a:solidFill>
+                  <a:srgbClr val="12293A"/>
+                </a:solidFill>
+                <a:latin typeface="Poppins" pitchFamily="34" charset="0"/>
+                <a:ea typeface="Poppins" pitchFamily="34" charset="-122"/>
+                <a:cs typeface="Poppins" pitchFamily="34" charset="-120"/>
+              </a:rPr>
+              <a:t>HHG</a:t>
+            </a:r>
+            <a:endParaRPr lang="en-US" sz="680" dirty="0"/>
+          </a:p>
+        </p:txBody>
+      </p:sp>
+      <p:sp>
+        <p:nvSpPr>
+          <p:cNvPr id="168" name="Text 165"/>
+          <p:cNvSpPr txBox="1"/>
+          <p:nvPr/>
+        </p:nvSpPr>
+        <p:spPr>
+          <a:xfrm>
+            <a:off x="9852660" y="3163824"/>
+            <a:ext cx="411480" cy="150876"/>
+          </a:xfrm>
+          <a:prstGeom prst="rect">
+            <a:avLst/>
+          </a:prstGeom>
+          <a:noFill/>
+          <a:ln/>
+        </p:spPr>
+        <p:txBody>
+          <a:bodyPr wrap="square" lIns="0" tIns="0" rIns="0" bIns="0" rtlCol="0" anchor="ctr"/>
+          <a:lstStyle/>
+          <a:p>
+            <a:pPr algn="r" indent="0" marL="0">
+              <a:buNone/>
+            </a:pPr>
+            <a:r>
+              <a:rPr lang="en-US" sz="680" b="1" dirty="0">
+                <a:solidFill>
+                  <a:srgbClr val="12293A"/>
+                </a:solidFill>
+                <a:latin typeface="Poppins" pitchFamily="34" charset="0"/>
+                <a:ea typeface="Poppins" pitchFamily="34" charset="-122"/>
+                <a:cs typeface="Poppins" pitchFamily="34" charset="-120"/>
+              </a:rPr>
+              <a:t>3.5h</a:t>
+            </a:r>
+            <a:endParaRPr lang="en-US" sz="680" dirty="0"/>
+          </a:p>
+        </p:txBody>
+      </p:sp>
+      <p:sp>
+        <p:nvSpPr>
+          <p:cNvPr id="169" name="Text 166"/>
+          <p:cNvSpPr txBox="1"/>
+          <p:nvPr/>
+        </p:nvSpPr>
+        <p:spPr>
+          <a:xfrm>
+            <a:off x="10264140" y="3163824"/>
             <a:ext cx="457200" cy="150876"/>
           </a:xfrm>
           <a:prstGeom prst="rect">
@@ -7412,208 +7529,91 @@
             <a:r>
               <a:rPr lang="en-US" sz="680" dirty="0">
                 <a:solidFill>
-                  <a:srgbClr val="5E7280"/>
-                </a:solidFill>
-                <a:latin typeface="Poppins" pitchFamily="34" charset="0"/>
-                <a:ea typeface="Poppins" pitchFamily="34" charset="-122"/>
-                <a:cs typeface="Poppins" pitchFamily="34" charset="-120"/>
-              </a:rPr>
-              <a:t>$147</a:t>
-            </a:r>
-            <a:endParaRPr lang="en-US" sz="680" dirty="0"/>
-          </a:p>
-        </p:txBody>
-      </p:sp>
-      <p:sp>
-        <p:nvSpPr>
-          <p:cNvPr id="167" name="Text 164"/>
-          <p:cNvSpPr txBox="1"/>
-          <p:nvPr/>
-        </p:nvSpPr>
-        <p:spPr>
-          <a:xfrm>
-            <a:off x="8965692" y="3163824"/>
-            <a:ext cx="1005840" cy="150876"/>
-          </a:xfrm>
-          <a:prstGeom prst="rect">
-            <a:avLst/>
-          </a:prstGeom>
-          <a:noFill/>
-          <a:ln/>
-        </p:spPr>
-        <p:txBody>
-          <a:bodyPr wrap="square" lIns="0" tIns="0" rIns="0" bIns="0" rtlCol="0" anchor="ctr"/>
-          <a:lstStyle/>
-          <a:p>
-            <a:pPr algn="l" indent="0" marL="0">
+                  <a:srgbClr val="3D8F5F"/>
+                </a:solidFill>
+                <a:latin typeface="Poppins" pitchFamily="34" charset="0"/>
+                <a:ea typeface="Poppins" pitchFamily="34" charset="-122"/>
+                <a:cs typeface="Poppins" pitchFamily="34" charset="-120"/>
+              </a:rPr>
+              <a:t>1.0h</a:t>
+            </a:r>
+            <a:endParaRPr lang="en-US" sz="680" dirty="0"/>
+          </a:p>
+        </p:txBody>
+      </p:sp>
+      <p:sp>
+        <p:nvSpPr>
+          <p:cNvPr id="170" name="Text 167"/>
+          <p:cNvSpPr txBox="1"/>
+          <p:nvPr/>
+        </p:nvSpPr>
+        <p:spPr>
+          <a:xfrm>
+            <a:off x="10721340" y="3163824"/>
+            <a:ext cx="384048" cy="150876"/>
+          </a:xfrm>
+          <a:prstGeom prst="rect">
+            <a:avLst/>
+          </a:prstGeom>
+          <a:noFill/>
+          <a:ln/>
+        </p:spPr>
+        <p:txBody>
+          <a:bodyPr wrap="square" lIns="0" tIns="0" rIns="0" bIns="0" rtlCol="0" anchor="ctr"/>
+          <a:lstStyle/>
+          <a:p>
+            <a:pPr algn="r" indent="0" marL="0">
+              <a:buNone/>
+            </a:pPr>
+            <a:r>
+              <a:rPr lang="en-US" sz="680" dirty="0">
+                <a:solidFill>
+                  <a:srgbClr val="C88A2E"/>
+                </a:solidFill>
+                <a:latin typeface="Poppins" pitchFamily="34" charset="0"/>
+                <a:ea typeface="Poppins" pitchFamily="34" charset="-122"/>
+                <a:cs typeface="Poppins" pitchFamily="34" charset="-120"/>
+              </a:rPr>
+              <a:t>2.5h</a:t>
+            </a:r>
+            <a:endParaRPr lang="en-US" sz="680" dirty="0"/>
+          </a:p>
+        </p:txBody>
+      </p:sp>
+      <p:sp>
+        <p:nvSpPr>
+          <p:cNvPr id="171" name="Text 168"/>
+          <p:cNvSpPr txBox="1"/>
+          <p:nvPr/>
+        </p:nvSpPr>
+        <p:spPr>
+          <a:xfrm>
+            <a:off x="11087100" y="3163824"/>
+            <a:ext cx="530352" cy="150876"/>
+          </a:xfrm>
+          <a:prstGeom prst="rect">
+            <a:avLst/>
+          </a:prstGeom>
+          <a:noFill/>
+          <a:ln/>
+        </p:spPr>
+        <p:txBody>
+          <a:bodyPr wrap="square" lIns="0" tIns="0" rIns="0" bIns="0" rtlCol="0" anchor="ctr"/>
+          <a:lstStyle/>
+          <a:p>
+            <a:pPr algn="r" indent="0" marL="0">
               <a:buNone/>
             </a:pPr>
             <a:r>
               <a:rPr lang="en-US" sz="680" b="1" dirty="0">
                 <a:solidFill>
-                  <a:srgbClr val="12293A"/>
-                </a:solidFill>
-                <a:latin typeface="Poppins" pitchFamily="34" charset="0"/>
-                <a:ea typeface="Poppins" pitchFamily="34" charset="-122"/>
-                <a:cs typeface="Poppins" pitchFamily="34" charset="-120"/>
-              </a:rPr>
-              <a:t>HHG</a:t>
-            </a:r>
-            <a:endParaRPr lang="en-US" sz="680" dirty="0"/>
-          </a:p>
-        </p:txBody>
-      </p:sp>
-      <p:sp>
-        <p:nvSpPr>
-          <p:cNvPr id="168" name="Text 165"/>
-          <p:cNvSpPr txBox="1"/>
-          <p:nvPr/>
-        </p:nvSpPr>
-        <p:spPr>
-          <a:xfrm>
-            <a:off x="9944100" y="3163824"/>
-            <a:ext cx="411480" cy="150876"/>
-          </a:xfrm>
-          <a:prstGeom prst="rect">
-            <a:avLst/>
-          </a:prstGeom>
-          <a:noFill/>
-          <a:ln/>
-        </p:spPr>
-        <p:txBody>
-          <a:bodyPr wrap="square" lIns="0" tIns="0" rIns="0" bIns="0" rtlCol="0" anchor="ctr"/>
-          <a:lstStyle/>
-          <a:p>
-            <a:pPr algn="r" indent="0" marL="0">
-              <a:buNone/>
-            </a:pPr>
-            <a:r>
-              <a:rPr lang="en-US" sz="680" b="1" dirty="0">
-                <a:solidFill>
-                  <a:srgbClr val="12293A"/>
-                </a:solidFill>
-                <a:latin typeface="Poppins" pitchFamily="34" charset="0"/>
-                <a:ea typeface="Poppins" pitchFamily="34" charset="-122"/>
-                <a:cs typeface="Poppins" pitchFamily="34" charset="-120"/>
-              </a:rPr>
-              <a:t>3.5h</a:t>
-            </a:r>
-            <a:endParaRPr lang="en-US" sz="680" dirty="0"/>
-          </a:p>
-        </p:txBody>
-      </p:sp>
-      <p:sp>
-        <p:nvSpPr>
-          <p:cNvPr id="169" name="Text 166"/>
-          <p:cNvSpPr txBox="1"/>
-          <p:nvPr/>
-        </p:nvSpPr>
-        <p:spPr>
-          <a:xfrm>
-            <a:off x="10401300" y="3163824"/>
-            <a:ext cx="502920" cy="150876"/>
-          </a:xfrm>
-          <a:prstGeom prst="rect">
-            <a:avLst/>
-          </a:prstGeom>
-          <a:noFill/>
-          <a:ln/>
-        </p:spPr>
-        <p:txBody>
-          <a:bodyPr wrap="square" lIns="0" tIns="0" rIns="0" bIns="0" rtlCol="0" anchor="ctr"/>
-          <a:lstStyle/>
-          <a:p>
-            <a:pPr algn="r" indent="0" marL="0">
-              <a:buNone/>
-            </a:pPr>
-            <a:r>
-              <a:rPr lang="en-US" sz="680" dirty="0">
-                <a:solidFill>
-                  <a:srgbClr val="3D8F5F"/>
-                </a:solidFill>
-                <a:latin typeface="Poppins" pitchFamily="34" charset="0"/>
-                <a:ea typeface="Poppins" pitchFamily="34" charset="-122"/>
-                <a:cs typeface="Poppins" pitchFamily="34" charset="-120"/>
-              </a:rPr>
-              <a:t>1.0h</a:t>
-            </a:r>
-            <a:endParaRPr lang="en-US" sz="680" dirty="0"/>
-          </a:p>
-        </p:txBody>
-      </p:sp>
-      <p:sp>
-        <p:nvSpPr>
-          <p:cNvPr id="170" name="Text 167"/>
-          <p:cNvSpPr txBox="1"/>
-          <p:nvPr/>
-        </p:nvSpPr>
-        <p:spPr>
-          <a:xfrm>
-            <a:off x="10904220" y="3163824"/>
-            <a:ext cx="320040" cy="150876"/>
-          </a:xfrm>
-          <a:prstGeom prst="rect">
-            <a:avLst/>
-          </a:prstGeom>
-          <a:noFill/>
-          <a:ln/>
-        </p:spPr>
-        <p:txBody>
-          <a:bodyPr wrap="square" lIns="0" tIns="0" rIns="0" bIns="0" rtlCol="0" anchor="ctr"/>
-          <a:lstStyle/>
-          <a:p>
-            <a:pPr algn="r" indent="0" marL="0">
-              <a:buNone/>
-            </a:pPr>
-            <a:r>
-              <a:rPr lang="en-US" sz="680" dirty="0">
-                <a:solidFill>
-                  <a:srgbClr val="C88A2E"/>
-                </a:solidFill>
-                <a:latin typeface="Poppins" pitchFamily="34" charset="0"/>
-                <a:ea typeface="Poppins" pitchFamily="34" charset="-122"/>
-                <a:cs typeface="Poppins" pitchFamily="34" charset="-120"/>
-              </a:rPr>
-              <a:t>2.5h</a:t>
-            </a:r>
-            <a:endParaRPr lang="en-US" sz="680" dirty="0"/>
-          </a:p>
-        </p:txBody>
-      </p:sp>
-      <p:sp>
-        <p:nvSpPr>
-          <p:cNvPr id="171" name="Text 168"/>
-          <p:cNvSpPr txBox="1"/>
-          <p:nvPr/>
-        </p:nvSpPr>
-        <p:spPr>
-          <a:xfrm>
-            <a:off x="11224260" y="3163824"/>
-            <a:ext cx="457200" cy="150876"/>
-          </a:xfrm>
-          <a:prstGeom prst="rect">
-            <a:avLst/>
-          </a:prstGeom>
-          <a:noFill/>
-          <a:ln/>
-        </p:spPr>
-        <p:txBody>
-          <a:bodyPr wrap="square" lIns="0" tIns="0" rIns="0" bIns="0" rtlCol="0" anchor="ctr"/>
-          <a:lstStyle/>
-          <a:p>
-            <a:pPr algn="r" indent="0" marL="0">
-              <a:buNone/>
-            </a:pPr>
-            <a:r>
-              <a:rPr lang="en-US" sz="680" dirty="0">
-                <a:solidFill>
-                  <a:srgbClr val="5E7280"/>
-                </a:solidFill>
-                <a:latin typeface="Poppins" pitchFamily="34" charset="0"/>
-                <a:ea typeface="Poppins" pitchFamily="34" charset="-122"/>
-                <a:cs typeface="Poppins" pitchFamily="34" charset="-120"/>
-              </a:rPr>
-              <a:t>$147</a:t>
+                  <a:srgbClr val="B4552D"/>
+                </a:solidFill>
+                <a:latin typeface="Poppins" pitchFamily="34" charset="0"/>
+                <a:ea typeface="Poppins" pitchFamily="34" charset="-122"/>
+                <a:cs typeface="Poppins" pitchFamily="34" charset="-120"/>
+              </a:rPr>
+              <a:t>$375</a:t>
             </a:r>
             <a:endParaRPr lang="en-US" sz="680" dirty="0"/>
           </a:p>
@@ -7648,7 +7648,7 @@
         <p:spPr>
           <a:xfrm>
             <a:off x="8965692" y="3314700"/>
-            <a:ext cx="1005840" cy="150876"/>
+            <a:ext cx="914400" cy="150876"/>
           </a:xfrm>
           <a:prstGeom prst="rect">
             <a:avLst/>
@@ -7686,7 +7686,7 @@
         </p:nvSpPr>
         <p:spPr>
           <a:xfrm>
-            <a:off x="9944100" y="3314700"/>
+            <a:off x="9852660" y="3314700"/>
             <a:ext cx="411480" cy="150876"/>
           </a:xfrm>
           <a:prstGeom prst="rect">
@@ -7725,8 +7725,8 @@
         </p:nvSpPr>
         <p:spPr>
           <a:xfrm>
-            <a:off x="10401300" y="3314700"/>
-            <a:ext cx="502920" cy="150876"/>
+            <a:off x="10264140" y="3314700"/>
+            <a:ext cx="457200" cy="150876"/>
           </a:xfrm>
           <a:prstGeom prst="rect">
             <a:avLst/>
@@ -7764,8 +7764,8 @@
         </p:nvSpPr>
         <p:spPr>
           <a:xfrm>
-            <a:off x="10904220" y="3314700"/>
-            <a:ext cx="320040" cy="150876"/>
+            <a:off x="10721340" y="3314700"/>
+            <a:ext cx="384048" cy="150876"/>
           </a:xfrm>
           <a:prstGeom prst="rect">
             <a:avLst/>
@@ -7803,7 +7803,124 @@
         </p:nvSpPr>
         <p:spPr>
           <a:xfrm>
-            <a:off x="11224260" y="3314700"/>
+            <a:off x="11087100" y="3314700"/>
+            <a:ext cx="530352" cy="150876"/>
+          </a:xfrm>
+          <a:prstGeom prst="rect">
+            <a:avLst/>
+          </a:prstGeom>
+          <a:noFill/>
+          <a:ln/>
+        </p:spPr>
+        <p:txBody>
+          <a:bodyPr wrap="square" lIns="0" tIns="0" rIns="0" bIns="0" rtlCol="0" anchor="ctr"/>
+          <a:lstStyle/>
+          <a:p>
+            <a:pPr algn="r" indent="0" marL="0">
+              <a:buNone/>
+            </a:pPr>
+            <a:r>
+              <a:rPr lang="en-US" sz="680" b="1" dirty="0">
+                <a:solidFill>
+                  <a:srgbClr val="B4552D"/>
+                </a:solidFill>
+                <a:latin typeface="Poppins" pitchFamily="34" charset="0"/>
+                <a:ea typeface="Poppins" pitchFamily="34" charset="-122"/>
+                <a:cs typeface="Poppins" pitchFamily="34" charset="-120"/>
+              </a:rPr>
+              <a:t>$450</a:t>
+            </a:r>
+            <a:endParaRPr lang="en-US" sz="680" dirty="0"/>
+          </a:p>
+        </p:txBody>
+      </p:sp>
+      <p:sp>
+        <p:nvSpPr>
+          <p:cNvPr id="178" name="Text 175"/>
+          <p:cNvSpPr txBox="1"/>
+          <p:nvPr/>
+        </p:nvSpPr>
+        <p:spPr>
+          <a:xfrm>
+            <a:off x="8965692" y="3465576"/>
+            <a:ext cx="914400" cy="150876"/>
+          </a:xfrm>
+          <a:prstGeom prst="rect">
+            <a:avLst/>
+          </a:prstGeom>
+          <a:noFill/>
+          <a:ln/>
+        </p:spPr>
+        <p:txBody>
+          <a:bodyPr wrap="square" lIns="0" tIns="0" rIns="0" bIns="0" rtlCol="0" anchor="ctr"/>
+          <a:lstStyle/>
+          <a:p>
+            <a:pPr algn="l" indent="0" marL="0">
+              <a:buNone/>
+            </a:pPr>
+            <a:r>
+              <a:rPr lang="en-US" sz="680" b="1" dirty="0">
+                <a:solidFill>
+                  <a:srgbClr val="12293A"/>
+                </a:solidFill>
+                <a:latin typeface="Poppins" pitchFamily="34" charset="0"/>
+                <a:ea typeface="Poppins" pitchFamily="34" charset="-122"/>
+                <a:cs typeface="Poppins" pitchFamily="34" charset="-120"/>
+              </a:rPr>
+              <a:t>Liquor Barons</a:t>
+            </a:r>
+            <a:endParaRPr lang="en-US" sz="680" dirty="0"/>
+          </a:p>
+        </p:txBody>
+      </p:sp>
+      <p:sp>
+        <p:nvSpPr>
+          <p:cNvPr id="179" name="Text 176"/>
+          <p:cNvSpPr txBox="1"/>
+          <p:nvPr/>
+        </p:nvSpPr>
+        <p:spPr>
+          <a:xfrm>
+            <a:off x="9852660" y="3465576"/>
+            <a:ext cx="411480" cy="150876"/>
+          </a:xfrm>
+          <a:prstGeom prst="rect">
+            <a:avLst/>
+          </a:prstGeom>
+          <a:noFill/>
+          <a:ln/>
+        </p:spPr>
+        <p:txBody>
+          <a:bodyPr wrap="square" lIns="0" tIns="0" rIns="0" bIns="0" rtlCol="0" anchor="ctr"/>
+          <a:lstStyle/>
+          <a:p>
+            <a:pPr algn="r" indent="0" marL="0">
+              <a:buNone/>
+            </a:pPr>
+            <a:r>
+              <a:rPr lang="en-US" sz="680" b="1" dirty="0">
+                <a:solidFill>
+                  <a:srgbClr val="12293A"/>
+                </a:solidFill>
+                <a:latin typeface="Poppins" pitchFamily="34" charset="0"/>
+                <a:ea typeface="Poppins" pitchFamily="34" charset="-122"/>
+                <a:cs typeface="Poppins" pitchFamily="34" charset="-120"/>
+              </a:rPr>
+              <a:t>2.5h</a:t>
+            </a:r>
+            <a:endParaRPr lang="en-US" sz="680" dirty="0"/>
+          </a:p>
+        </p:txBody>
+      </p:sp>
+      <p:sp>
+        <p:nvSpPr>
+          <p:cNvPr id="180" name="Text 177"/>
+          <p:cNvSpPr txBox="1"/>
+          <p:nvPr/>
+        </p:nvSpPr>
+        <p:spPr>
+          <a:xfrm>
+            <a:off x="10264140" y="3465576"/>
             <a:ext cx="457200" cy="150876"/>
           </a:xfrm>
           <a:prstGeom prst="rect">
@@ -7822,85 +7939,7 @@
             <a:r>
               <a:rPr lang="en-US" sz="680" dirty="0">
                 <a:solidFill>
-                  <a:srgbClr val="5E7280"/>
-                </a:solidFill>
-                <a:latin typeface="Poppins" pitchFamily="34" charset="0"/>
-                <a:ea typeface="Poppins" pitchFamily="34" charset="-122"/>
-                <a:cs typeface="Poppins" pitchFamily="34" charset="-120"/>
-              </a:rPr>
-              <a:t>$126</a:t>
-            </a:r>
-            <a:endParaRPr lang="en-US" sz="680" dirty="0"/>
-          </a:p>
-        </p:txBody>
-      </p:sp>
-      <p:sp>
-        <p:nvSpPr>
-          <p:cNvPr id="178" name="Text 175"/>
-          <p:cNvSpPr txBox="1"/>
-          <p:nvPr/>
-        </p:nvSpPr>
-        <p:spPr>
-          <a:xfrm>
-            <a:off x="8965692" y="3465576"/>
-            <a:ext cx="1005840" cy="150876"/>
-          </a:xfrm>
-          <a:prstGeom prst="rect">
-            <a:avLst/>
-          </a:prstGeom>
-          <a:noFill/>
-          <a:ln/>
-        </p:spPr>
-        <p:txBody>
-          <a:bodyPr wrap="square" lIns="0" tIns="0" rIns="0" bIns="0" rtlCol="0" anchor="ctr"/>
-          <a:lstStyle/>
-          <a:p>
-            <a:pPr algn="l" indent="0" marL="0">
-              <a:buNone/>
-            </a:pPr>
-            <a:r>
-              <a:rPr lang="en-US" sz="680" b="1" dirty="0">
-                <a:solidFill>
-                  <a:srgbClr val="12293A"/>
-                </a:solidFill>
-                <a:latin typeface="Poppins" pitchFamily="34" charset="0"/>
-                <a:ea typeface="Poppins" pitchFamily="34" charset="-122"/>
-                <a:cs typeface="Poppins" pitchFamily="34" charset="-120"/>
-              </a:rPr>
-              <a:t>Liquor Barons</a:t>
-            </a:r>
-            <a:endParaRPr lang="en-US" sz="680" dirty="0"/>
-          </a:p>
-        </p:txBody>
-      </p:sp>
-      <p:sp>
-        <p:nvSpPr>
-          <p:cNvPr id="179" name="Text 176"/>
-          <p:cNvSpPr txBox="1"/>
-          <p:nvPr/>
-        </p:nvSpPr>
-        <p:spPr>
-          <a:xfrm>
-            <a:off x="9944100" y="3465576"/>
-            <a:ext cx="411480" cy="150876"/>
-          </a:xfrm>
-          <a:prstGeom prst="rect">
-            <a:avLst/>
-          </a:prstGeom>
-          <a:noFill/>
-          <a:ln/>
-        </p:spPr>
-        <p:txBody>
-          <a:bodyPr wrap="square" lIns="0" tIns="0" rIns="0" bIns="0" rtlCol="0" anchor="ctr"/>
-          <a:lstStyle/>
-          <a:p>
-            <a:pPr algn="r" indent="0" marL="0">
-              <a:buNone/>
-            </a:pPr>
-            <a:r>
-              <a:rPr lang="en-US" sz="680" b="1" dirty="0">
-                <a:solidFill>
-                  <a:srgbClr val="12293A"/>
+                  <a:srgbClr val="3D8F5F"/>
                 </a:solidFill>
                 <a:latin typeface="Poppins" pitchFamily="34" charset="0"/>
                 <a:ea typeface="Poppins" pitchFamily="34" charset="-122"/>
@@ -7914,14 +7953,14 @@
       </p:sp>
       <p:sp>
         <p:nvSpPr>
-          <p:cNvPr id="180" name="Text 177"/>
-          <p:cNvSpPr txBox="1"/>
-          <p:nvPr/>
-        </p:nvSpPr>
-        <p:spPr>
-          <a:xfrm>
-            <a:off x="10401300" y="3465576"/>
-            <a:ext cx="502920" cy="150876"/>
+          <p:cNvPr id="181" name="Text 178"/>
+          <p:cNvSpPr txBox="1"/>
+          <p:nvPr/>
+        </p:nvSpPr>
+        <p:spPr>
+          <a:xfrm>
+            <a:off x="10721340" y="3465576"/>
+            <a:ext cx="384048" cy="150876"/>
           </a:xfrm>
           <a:prstGeom prst="rect">
             <a:avLst/>
@@ -7939,28 +7978,28 @@
             <a:r>
               <a:rPr lang="en-US" sz="680" dirty="0">
                 <a:solidFill>
-                  <a:srgbClr val="3D8F5F"/>
-                </a:solidFill>
-                <a:latin typeface="Poppins" pitchFamily="34" charset="0"/>
-                <a:ea typeface="Poppins" pitchFamily="34" charset="-122"/>
-                <a:cs typeface="Poppins" pitchFamily="34" charset="-120"/>
-              </a:rPr>
-              <a:t>2.5h</a:t>
-            </a:r>
-            <a:endParaRPr lang="en-US" sz="680" dirty="0"/>
-          </a:p>
-        </p:txBody>
-      </p:sp>
-      <p:sp>
-        <p:nvSpPr>
-          <p:cNvPr id="181" name="Text 178"/>
-          <p:cNvSpPr txBox="1"/>
-          <p:nvPr/>
-        </p:nvSpPr>
-        <p:spPr>
-          <a:xfrm>
-            <a:off x="10904220" y="3465576"/>
-            <a:ext cx="320040" cy="150876"/>
+                  <a:srgbClr val="8FA1AC"/>
+                </a:solidFill>
+                <a:latin typeface="Poppins" pitchFamily="34" charset="0"/>
+                <a:ea typeface="Poppins" pitchFamily="34" charset="-122"/>
+                <a:cs typeface="Poppins" pitchFamily="34" charset="-120"/>
+              </a:rPr>
+              <a:t>—</a:t>
+            </a:r>
+            <a:endParaRPr lang="en-US" sz="680" dirty="0"/>
+          </a:p>
+        </p:txBody>
+      </p:sp>
+      <p:sp>
+        <p:nvSpPr>
+          <p:cNvPr id="182" name="Text 179"/>
+          <p:cNvSpPr txBox="1"/>
+          <p:nvPr/>
+        </p:nvSpPr>
+        <p:spPr>
+          <a:xfrm>
+            <a:off x="11087100" y="3465576"/>
+            <a:ext cx="530352" cy="150876"/>
           </a:xfrm>
           <a:prstGeom prst="rect">
             <a:avLst/>
@@ -7985,45 +8024,6 @@
                 <a:cs typeface="Poppins" pitchFamily="34" charset="-120"/>
               </a:rPr>
               <a:t>—</a:t>
-            </a:r>
-            <a:endParaRPr lang="en-US" sz="680" dirty="0"/>
-          </a:p>
-        </p:txBody>
-      </p:sp>
-      <p:sp>
-        <p:nvSpPr>
-          <p:cNvPr id="182" name="Text 179"/>
-          <p:cNvSpPr txBox="1"/>
-          <p:nvPr/>
-        </p:nvSpPr>
-        <p:spPr>
-          <a:xfrm>
-            <a:off x="11224260" y="3465576"/>
-            <a:ext cx="457200" cy="150876"/>
-          </a:xfrm>
-          <a:prstGeom prst="rect">
-            <a:avLst/>
-          </a:prstGeom>
-          <a:noFill/>
-          <a:ln/>
-        </p:spPr>
-        <p:txBody>
-          <a:bodyPr wrap="square" lIns="0" tIns="0" rIns="0" bIns="0" rtlCol="0" anchor="ctr"/>
-          <a:lstStyle/>
-          <a:p>
-            <a:pPr algn="r" indent="0" marL="0">
-              <a:buNone/>
-            </a:pPr>
-            <a:r>
-              <a:rPr lang="en-US" sz="680" dirty="0">
-                <a:solidFill>
-                  <a:srgbClr val="5E7280"/>
-                </a:solidFill>
-                <a:latin typeface="Poppins" pitchFamily="34" charset="0"/>
-                <a:ea typeface="Poppins" pitchFamily="34" charset="-122"/>
-                <a:cs typeface="Poppins" pitchFamily="34" charset="-120"/>
-              </a:rPr>
-              <a:t>$105</a:t>
             </a:r>
             <a:endParaRPr lang="en-US" sz="680" dirty="0"/>
           </a:p>
@@ -8058,7 +8058,7 @@
         <p:spPr>
           <a:xfrm>
             <a:off x="8965692" y="3616452"/>
-            <a:ext cx="1005840" cy="150876"/>
+            <a:ext cx="914400" cy="150876"/>
           </a:xfrm>
           <a:prstGeom prst="rect">
             <a:avLst/>
@@ -8096,7 +8096,7 @@
         </p:nvSpPr>
         <p:spPr>
           <a:xfrm>
-            <a:off x="9944100" y="3616452"/>
+            <a:off x="9852660" y="3616452"/>
             <a:ext cx="411480" cy="150876"/>
           </a:xfrm>
           <a:prstGeom prst="rect">
@@ -8135,8 +8135,8 @@
         </p:nvSpPr>
         <p:spPr>
           <a:xfrm>
-            <a:off x="10401300" y="3616452"/>
-            <a:ext cx="502920" cy="150876"/>
+            <a:off x="10264140" y="3616452"/>
+            <a:ext cx="457200" cy="150876"/>
           </a:xfrm>
           <a:prstGeom prst="rect">
             <a:avLst/>
@@ -8174,8 +8174,8 @@
         </p:nvSpPr>
         <p:spPr>
           <a:xfrm>
-            <a:off x="10904220" y="3616452"/>
-            <a:ext cx="320040" cy="150876"/>
+            <a:off x="10721340" y="3616452"/>
+            <a:ext cx="384048" cy="150876"/>
           </a:xfrm>
           <a:prstGeom prst="rect">
             <a:avLst/>
@@ -8213,7 +8213,124 @@
         </p:nvSpPr>
         <p:spPr>
           <a:xfrm>
-            <a:off x="11224260" y="3616452"/>
+            <a:off x="11087100" y="3616452"/>
+            <a:ext cx="530352" cy="150876"/>
+          </a:xfrm>
+          <a:prstGeom prst="rect">
+            <a:avLst/>
+          </a:prstGeom>
+          <a:noFill/>
+          <a:ln/>
+        </p:spPr>
+        <p:txBody>
+          <a:bodyPr wrap="square" lIns="0" tIns="0" rIns="0" bIns="0" rtlCol="0" anchor="ctr"/>
+          <a:lstStyle/>
+          <a:p>
+            <a:pPr algn="r" indent="0" marL="0">
+              <a:buNone/>
+            </a:pPr>
+            <a:r>
+              <a:rPr lang="en-US" sz="680" b="1" dirty="0">
+                <a:solidFill>
+                  <a:srgbClr val="B4552D"/>
+                </a:solidFill>
+                <a:latin typeface="Poppins" pitchFamily="34" charset="0"/>
+                <a:ea typeface="Poppins" pitchFamily="34" charset="-122"/>
+                <a:cs typeface="Poppins" pitchFamily="34" charset="-120"/>
+              </a:rPr>
+              <a:t>$311</a:t>
+            </a:r>
+            <a:endParaRPr lang="en-US" sz="680" dirty="0"/>
+          </a:p>
+        </p:txBody>
+      </p:sp>
+      <p:sp>
+        <p:nvSpPr>
+          <p:cNvPr id="189" name="Text 186"/>
+          <p:cNvSpPr txBox="1"/>
+          <p:nvPr/>
+        </p:nvSpPr>
+        <p:spPr>
+          <a:xfrm>
+            <a:off x="8965692" y="3767328"/>
+            <a:ext cx="914400" cy="150876"/>
+          </a:xfrm>
+          <a:prstGeom prst="rect">
+            <a:avLst/>
+          </a:prstGeom>
+          <a:noFill/>
+          <a:ln/>
+        </p:spPr>
+        <p:txBody>
+          <a:bodyPr wrap="square" lIns="0" tIns="0" rIns="0" bIns="0" rtlCol="0" anchor="ctr"/>
+          <a:lstStyle/>
+          <a:p>
+            <a:pPr algn="l" indent="0" marL="0">
+              <a:buNone/>
+            </a:pPr>
+            <a:r>
+              <a:rPr lang="en-US" sz="680" b="1" dirty="0">
+                <a:solidFill>
+                  <a:srgbClr val="12293A"/>
+                </a:solidFill>
+                <a:latin typeface="Poppins" pitchFamily="34" charset="0"/>
+                <a:ea typeface="Poppins" pitchFamily="34" charset="-122"/>
+                <a:cs typeface="Poppins" pitchFamily="34" charset="-120"/>
+              </a:rPr>
+              <a:t>Perks Hospitality</a:t>
+            </a:r>
+            <a:endParaRPr lang="en-US" sz="680" dirty="0"/>
+          </a:p>
+        </p:txBody>
+      </p:sp>
+      <p:sp>
+        <p:nvSpPr>
+          <p:cNvPr id="190" name="Text 187"/>
+          <p:cNvSpPr txBox="1"/>
+          <p:nvPr/>
+        </p:nvSpPr>
+        <p:spPr>
+          <a:xfrm>
+            <a:off x="9852660" y="3767328"/>
+            <a:ext cx="411480" cy="150876"/>
+          </a:xfrm>
+          <a:prstGeom prst="rect">
+            <a:avLst/>
+          </a:prstGeom>
+          <a:noFill/>
+          <a:ln/>
+        </p:spPr>
+        <p:txBody>
+          <a:bodyPr wrap="square" lIns="0" tIns="0" rIns="0" bIns="0" rtlCol="0" anchor="ctr"/>
+          <a:lstStyle/>
+          <a:p>
+            <a:pPr algn="r" indent="0" marL="0">
+              <a:buNone/>
+            </a:pPr>
+            <a:r>
+              <a:rPr lang="en-US" sz="680" b="1" dirty="0">
+                <a:solidFill>
+                  <a:srgbClr val="12293A"/>
+                </a:solidFill>
+                <a:latin typeface="Poppins" pitchFamily="34" charset="0"/>
+                <a:ea typeface="Poppins" pitchFamily="34" charset="-122"/>
+                <a:cs typeface="Poppins" pitchFamily="34" charset="-120"/>
+              </a:rPr>
+              <a:t>2.0h</a:t>
+            </a:r>
+            <a:endParaRPr lang="en-US" sz="680" dirty="0"/>
+          </a:p>
+        </p:txBody>
+      </p:sp>
+      <p:sp>
+        <p:nvSpPr>
+          <p:cNvPr id="191" name="Text 188"/>
+          <p:cNvSpPr txBox="1"/>
+          <p:nvPr/>
+        </p:nvSpPr>
+        <p:spPr>
+          <a:xfrm>
+            <a:off x="10264140" y="3767328"/>
             <a:ext cx="457200" cy="150876"/>
           </a:xfrm>
           <a:prstGeom prst="rect">
@@ -8232,208 +8349,91 @@
             <a:r>
               <a:rPr lang="en-US" sz="680" dirty="0">
                 <a:solidFill>
-                  <a:srgbClr val="5E7280"/>
-                </a:solidFill>
-                <a:latin typeface="Poppins" pitchFamily="34" charset="0"/>
-                <a:ea typeface="Poppins" pitchFamily="34" charset="-122"/>
-                <a:cs typeface="Poppins" pitchFamily="34" charset="-120"/>
-              </a:rPr>
-              <a:t>$87</a:t>
-            </a:r>
-            <a:endParaRPr lang="en-US" sz="680" dirty="0"/>
-          </a:p>
-        </p:txBody>
-      </p:sp>
-      <p:sp>
-        <p:nvSpPr>
-          <p:cNvPr id="189" name="Text 186"/>
-          <p:cNvSpPr txBox="1"/>
-          <p:nvPr/>
-        </p:nvSpPr>
-        <p:spPr>
-          <a:xfrm>
-            <a:off x="8965692" y="3767328"/>
-            <a:ext cx="1005840" cy="150876"/>
-          </a:xfrm>
-          <a:prstGeom prst="rect">
-            <a:avLst/>
-          </a:prstGeom>
-          <a:noFill/>
-          <a:ln/>
-        </p:spPr>
-        <p:txBody>
-          <a:bodyPr wrap="square" lIns="0" tIns="0" rIns="0" bIns="0" rtlCol="0" anchor="ctr"/>
-          <a:lstStyle/>
-          <a:p>
-            <a:pPr algn="l" indent="0" marL="0">
+                  <a:srgbClr val="3D8F5F"/>
+                </a:solidFill>
+                <a:latin typeface="Poppins" pitchFamily="34" charset="0"/>
+                <a:ea typeface="Poppins" pitchFamily="34" charset="-122"/>
+                <a:cs typeface="Poppins" pitchFamily="34" charset="-120"/>
+              </a:rPr>
+              <a:t>1.0h</a:t>
+            </a:r>
+            <a:endParaRPr lang="en-US" sz="680" dirty="0"/>
+          </a:p>
+        </p:txBody>
+      </p:sp>
+      <p:sp>
+        <p:nvSpPr>
+          <p:cNvPr id="192" name="Text 189"/>
+          <p:cNvSpPr txBox="1"/>
+          <p:nvPr/>
+        </p:nvSpPr>
+        <p:spPr>
+          <a:xfrm>
+            <a:off x="10721340" y="3767328"/>
+            <a:ext cx="384048" cy="150876"/>
+          </a:xfrm>
+          <a:prstGeom prst="rect">
+            <a:avLst/>
+          </a:prstGeom>
+          <a:noFill/>
+          <a:ln/>
+        </p:spPr>
+        <p:txBody>
+          <a:bodyPr wrap="square" lIns="0" tIns="0" rIns="0" bIns="0" rtlCol="0" anchor="ctr"/>
+          <a:lstStyle/>
+          <a:p>
+            <a:pPr algn="r" indent="0" marL="0">
+              <a:buNone/>
+            </a:pPr>
+            <a:r>
+              <a:rPr lang="en-US" sz="680" dirty="0">
+                <a:solidFill>
+                  <a:srgbClr val="C88A2E"/>
+                </a:solidFill>
+                <a:latin typeface="Poppins" pitchFamily="34" charset="0"/>
+                <a:ea typeface="Poppins" pitchFamily="34" charset="-122"/>
+                <a:cs typeface="Poppins" pitchFamily="34" charset="-120"/>
+              </a:rPr>
+              <a:t>1.0h</a:t>
+            </a:r>
+            <a:endParaRPr lang="en-US" sz="680" dirty="0"/>
+          </a:p>
+        </p:txBody>
+      </p:sp>
+      <p:sp>
+        <p:nvSpPr>
+          <p:cNvPr id="193" name="Text 190"/>
+          <p:cNvSpPr txBox="1"/>
+          <p:nvPr/>
+        </p:nvSpPr>
+        <p:spPr>
+          <a:xfrm>
+            <a:off x="11087100" y="3767328"/>
+            <a:ext cx="530352" cy="150876"/>
+          </a:xfrm>
+          <a:prstGeom prst="rect">
+            <a:avLst/>
+          </a:prstGeom>
+          <a:noFill/>
+          <a:ln/>
+        </p:spPr>
+        <p:txBody>
+          <a:bodyPr wrap="square" lIns="0" tIns="0" rIns="0" bIns="0" rtlCol="0" anchor="ctr"/>
+          <a:lstStyle/>
+          <a:p>
+            <a:pPr algn="r" indent="0" marL="0">
               <a:buNone/>
             </a:pPr>
             <a:r>
               <a:rPr lang="en-US" sz="680" b="1" dirty="0">
                 <a:solidFill>
-                  <a:srgbClr val="12293A"/>
-                </a:solidFill>
-                <a:latin typeface="Poppins" pitchFamily="34" charset="0"/>
-                <a:ea typeface="Poppins" pitchFamily="34" charset="-122"/>
-                <a:cs typeface="Poppins" pitchFamily="34" charset="-120"/>
-              </a:rPr>
-              <a:t>Perks Hospitality</a:t>
-            </a:r>
-            <a:endParaRPr lang="en-US" sz="680" dirty="0"/>
-          </a:p>
-        </p:txBody>
-      </p:sp>
-      <p:sp>
-        <p:nvSpPr>
-          <p:cNvPr id="190" name="Text 187"/>
-          <p:cNvSpPr txBox="1"/>
-          <p:nvPr/>
-        </p:nvSpPr>
-        <p:spPr>
-          <a:xfrm>
-            <a:off x="9944100" y="3767328"/>
-            <a:ext cx="411480" cy="150876"/>
-          </a:xfrm>
-          <a:prstGeom prst="rect">
-            <a:avLst/>
-          </a:prstGeom>
-          <a:noFill/>
-          <a:ln/>
-        </p:spPr>
-        <p:txBody>
-          <a:bodyPr wrap="square" lIns="0" tIns="0" rIns="0" bIns="0" rtlCol="0" anchor="ctr"/>
-          <a:lstStyle/>
-          <a:p>
-            <a:pPr algn="r" indent="0" marL="0">
-              <a:buNone/>
-            </a:pPr>
-            <a:r>
-              <a:rPr lang="en-US" sz="680" b="1" dirty="0">
-                <a:solidFill>
-                  <a:srgbClr val="12293A"/>
-                </a:solidFill>
-                <a:latin typeface="Poppins" pitchFamily="34" charset="0"/>
-                <a:ea typeface="Poppins" pitchFamily="34" charset="-122"/>
-                <a:cs typeface="Poppins" pitchFamily="34" charset="-120"/>
-              </a:rPr>
-              <a:t>2.0h</a:t>
-            </a:r>
-            <a:endParaRPr lang="en-US" sz="680" dirty="0"/>
-          </a:p>
-        </p:txBody>
-      </p:sp>
-      <p:sp>
-        <p:nvSpPr>
-          <p:cNvPr id="191" name="Text 188"/>
-          <p:cNvSpPr txBox="1"/>
-          <p:nvPr/>
-        </p:nvSpPr>
-        <p:spPr>
-          <a:xfrm>
-            <a:off x="10401300" y="3767328"/>
-            <a:ext cx="502920" cy="150876"/>
-          </a:xfrm>
-          <a:prstGeom prst="rect">
-            <a:avLst/>
-          </a:prstGeom>
-          <a:noFill/>
-          <a:ln/>
-        </p:spPr>
-        <p:txBody>
-          <a:bodyPr wrap="square" lIns="0" tIns="0" rIns="0" bIns="0" rtlCol="0" anchor="ctr"/>
-          <a:lstStyle/>
-          <a:p>
-            <a:pPr algn="r" indent="0" marL="0">
-              <a:buNone/>
-            </a:pPr>
-            <a:r>
-              <a:rPr lang="en-US" sz="680" dirty="0">
-                <a:solidFill>
-                  <a:srgbClr val="3D8F5F"/>
-                </a:solidFill>
-                <a:latin typeface="Poppins" pitchFamily="34" charset="0"/>
-                <a:ea typeface="Poppins" pitchFamily="34" charset="-122"/>
-                <a:cs typeface="Poppins" pitchFamily="34" charset="-120"/>
-              </a:rPr>
-              <a:t>1.0h</a:t>
-            </a:r>
-            <a:endParaRPr lang="en-US" sz="680" dirty="0"/>
-          </a:p>
-        </p:txBody>
-      </p:sp>
-      <p:sp>
-        <p:nvSpPr>
-          <p:cNvPr id="192" name="Text 189"/>
-          <p:cNvSpPr txBox="1"/>
-          <p:nvPr/>
-        </p:nvSpPr>
-        <p:spPr>
-          <a:xfrm>
-            <a:off x="10904220" y="3767328"/>
-            <a:ext cx="320040" cy="150876"/>
-          </a:xfrm>
-          <a:prstGeom prst="rect">
-            <a:avLst/>
-          </a:prstGeom>
-          <a:noFill/>
-          <a:ln/>
-        </p:spPr>
-        <p:txBody>
-          <a:bodyPr wrap="square" lIns="0" tIns="0" rIns="0" bIns="0" rtlCol="0" anchor="ctr"/>
-          <a:lstStyle/>
-          <a:p>
-            <a:pPr algn="r" indent="0" marL="0">
-              <a:buNone/>
-            </a:pPr>
-            <a:r>
-              <a:rPr lang="en-US" sz="680" dirty="0">
-                <a:solidFill>
-                  <a:srgbClr val="C88A2E"/>
-                </a:solidFill>
-                <a:latin typeface="Poppins" pitchFamily="34" charset="0"/>
-                <a:ea typeface="Poppins" pitchFamily="34" charset="-122"/>
-                <a:cs typeface="Poppins" pitchFamily="34" charset="-120"/>
-              </a:rPr>
-              <a:t>1.0h</a:t>
-            </a:r>
-            <a:endParaRPr lang="en-US" sz="680" dirty="0"/>
-          </a:p>
-        </p:txBody>
-      </p:sp>
-      <p:sp>
-        <p:nvSpPr>
-          <p:cNvPr id="193" name="Text 190"/>
-          <p:cNvSpPr txBox="1"/>
-          <p:nvPr/>
-        </p:nvSpPr>
-        <p:spPr>
-          <a:xfrm>
-            <a:off x="11224260" y="3767328"/>
-            <a:ext cx="457200" cy="150876"/>
-          </a:xfrm>
-          <a:prstGeom prst="rect">
-            <a:avLst/>
-          </a:prstGeom>
-          <a:noFill/>
-          <a:ln/>
-        </p:spPr>
-        <p:txBody>
-          <a:bodyPr wrap="square" lIns="0" tIns="0" rIns="0" bIns="0" rtlCol="0" anchor="ctr"/>
-          <a:lstStyle/>
-          <a:p>
-            <a:pPr algn="r" indent="0" marL="0">
-              <a:buNone/>
-            </a:pPr>
-            <a:r>
-              <a:rPr lang="en-US" sz="680" dirty="0">
-                <a:solidFill>
-                  <a:srgbClr val="5E7280"/>
-                </a:solidFill>
-                <a:latin typeface="Poppins" pitchFamily="34" charset="0"/>
-                <a:ea typeface="Poppins" pitchFamily="34" charset="-122"/>
-                <a:cs typeface="Poppins" pitchFamily="34" charset="-120"/>
-              </a:rPr>
-              <a:t>$84</a:t>
+                  <a:srgbClr val="B4552D"/>
+                </a:solidFill>
+                <a:latin typeface="Poppins" pitchFamily="34" charset="0"/>
+                <a:ea typeface="Poppins" pitchFamily="34" charset="-122"/>
+                <a:cs typeface="Poppins" pitchFamily="34" charset="-120"/>
+              </a:rPr>
+              <a:t>$150</a:t>
             </a:r>
             <a:endParaRPr lang="en-US" sz="680" dirty="0"/>
           </a:p>
@@ -8619,7 +8619,7 @@
                 <a:ea typeface="Poppins" pitchFamily="34" charset="-122"/>
                 <a:cs typeface="Poppins" pitchFamily="34" charset="-120"/>
               </a:rPr>
-              <a:t>Is Chargeable went live this week: 7.0 of the 11.5h logged (61%) are still blank, so the hidden work is under-counted.</a:t>
+              <a:t>Is Chargeable went live this week: 7.0 of the 11.5h logged (61%) have no flag yet, so the hidden work is under-counted.</a:t>
             </a:r>
             <a:endParaRPr lang="en-US" sz="900" dirty="0"/>
           </a:p>

</xml_diff>

<commit_message>
PS Economics slide: group the billable boxes under billable utilisation
A pale teal panel sits behind billable utilisation and the chargeable /
non-chargeable boxes, and the two child boxes carry a lighter accent.
Their percentages now read "of billable", so it is clear they split the
umbrella figure.

Co-Authored-By: Claude Opus 5.5 <noreply@anthropic.com>
Claude-Session: https://claude.ai/code/session_01Lq5maWicgiSj2RkHzTdcCm
</commit_message>
<xml_diff>
--- a/exec-deck/output/H&L PS Economics - The Hidden Work - WC 19 Oct 2026.pptx
+++ b/exec-deck/output/H&L PS Economics - The Hidden Work - WC 19 Oct 2026.pptx
@@ -1783,6 +1783,33 @@
         </p:nvSpPr>
         <p:spPr>
           <a:xfrm>
+            <a:off x="2282952" y="941832"/>
+            <a:ext cx="5705856" cy="1005840"/>
+          </a:xfrm>
+          <a:prstGeom prst="roundRect">
+            <a:avLst>
+              <a:gd name="adj" fmla="val 8182"/>
+            </a:avLst>
+          </a:prstGeom>
+          <a:solidFill>
+            <a:srgbClr val="E4F1F4"/>
+          </a:solidFill>
+          <a:ln w="9525">
+            <a:solidFill>
+              <a:srgbClr val="6FAEBB"/>
+            </a:solidFill>
+            <a:prstDash val="solid"/>
+          </a:ln>
+        </p:spPr>
+      </p:sp>
+      <p:sp>
+        <p:nvSpPr>
+          <p:cNvPr id="14" name="Shape 12"/>
+          <p:cNvSpPr/>
+          <p:nvPr/>
+        </p:nvSpPr>
+        <p:spPr>
+          <a:xfrm>
             <a:off x="411480" y="987552"/>
             <a:ext cx="1780032" cy="914400"/>
           </a:xfrm>
@@ -1806,7 +1833,7 @@
       </p:sp>
       <p:sp>
         <p:nvSpPr>
-          <p:cNvPr id="14" name="Shape 12"/>
+          <p:cNvPr id="15" name="Shape 13"/>
           <p:cNvSpPr/>
           <p:nvPr/>
         </p:nvSpPr>
@@ -1826,7 +1853,7 @@
       </p:sp>
       <p:sp>
         <p:nvSpPr>
-          <p:cNvPr id="15" name="Text 13"/>
+          <p:cNvPr id="16" name="Text 14"/>
           <p:cNvSpPr txBox="1"/>
           <p:nvPr/>
         </p:nvSpPr>
@@ -1865,7 +1892,7 @@
       </p:sp>
       <p:sp>
         <p:nvSpPr>
-          <p:cNvPr id="16" name="Text 14"/>
+          <p:cNvPr id="17" name="Text 15"/>
           <p:cNvSpPr txBox="1"/>
           <p:nvPr/>
         </p:nvSpPr>
@@ -1918,7 +1945,7 @@
       </p:sp>
       <p:sp>
         <p:nvSpPr>
-          <p:cNvPr id="17" name="Text 15"/>
+          <p:cNvPr id="18" name="Text 16"/>
           <p:cNvSpPr txBox="1"/>
           <p:nvPr/>
         </p:nvSpPr>
@@ -1957,7 +1984,7 @@
       </p:sp>
       <p:sp>
         <p:nvSpPr>
-          <p:cNvPr id="18" name="Shape 16"/>
+          <p:cNvPr id="19" name="Shape 17"/>
           <p:cNvSpPr/>
           <p:nvPr/>
         </p:nvSpPr>
@@ -1986,7 +2013,7 @@
       </p:sp>
       <p:sp>
         <p:nvSpPr>
-          <p:cNvPr id="19" name="Shape 17"/>
+          <p:cNvPr id="20" name="Shape 18"/>
           <p:cNvSpPr/>
           <p:nvPr/>
         </p:nvSpPr>
@@ -2006,7 +2033,7 @@
       </p:sp>
       <p:sp>
         <p:nvSpPr>
-          <p:cNvPr id="20" name="Text 18"/>
+          <p:cNvPr id="21" name="Text 19"/>
           <p:cNvSpPr txBox="1"/>
           <p:nvPr/>
         </p:nvSpPr>
@@ -2045,7 +2072,7 @@
       </p:sp>
       <p:sp>
         <p:nvSpPr>
-          <p:cNvPr id="21" name="Text 19"/>
+          <p:cNvPr id="22" name="Text 20"/>
           <p:cNvSpPr txBox="1"/>
           <p:nvPr/>
         </p:nvSpPr>
@@ -2098,7 +2125,7 @@
       </p:sp>
       <p:sp>
         <p:nvSpPr>
-          <p:cNvPr id="22" name="Text 20"/>
+          <p:cNvPr id="23" name="Text 21"/>
           <p:cNvSpPr txBox="1"/>
           <p:nvPr/>
         </p:nvSpPr>
@@ -2137,7 +2164,7 @@
       </p:sp>
       <p:sp>
         <p:nvSpPr>
-          <p:cNvPr id="23" name="Shape 21"/>
+          <p:cNvPr id="24" name="Shape 22"/>
           <p:cNvSpPr/>
           <p:nvPr/>
         </p:nvSpPr>
@@ -2166,7 +2193,7 @@
       </p:sp>
       <p:sp>
         <p:nvSpPr>
-          <p:cNvPr id="24" name="Shape 22"/>
+          <p:cNvPr id="25" name="Shape 23"/>
           <p:cNvSpPr/>
           <p:nvPr/>
         </p:nvSpPr>
@@ -2179,14 +2206,14 @@
             <a:avLst/>
           </a:prstGeom>
           <a:solidFill>
-            <a:srgbClr val="1B8DA6"/>
+            <a:srgbClr val="6FAEBB"/>
           </a:solidFill>
           <a:ln/>
         </p:spPr>
       </p:sp>
       <p:sp>
         <p:nvSpPr>
-          <p:cNvPr id="25" name="Text 23"/>
+          <p:cNvPr id="26" name="Text 24"/>
           <p:cNvSpPr txBox="1"/>
           <p:nvPr/>
         </p:nvSpPr>
@@ -2225,7 +2252,7 @@
       </p:sp>
       <p:sp>
         <p:nvSpPr>
-          <p:cNvPr id="26" name="Text 24"/>
+          <p:cNvPr id="27" name="Text 25"/>
           <p:cNvSpPr txBox="1"/>
           <p:nvPr/>
         </p:nvSpPr>
@@ -2262,7 +2289,7 @@
               <a:buNone/>
             </a:pPr>
             <a:r>
-              <a:rPr lang="en-US" sz="900" b="1" dirty="0">
+              <a:rPr lang="en-US" sz="700" b="1" dirty="0">
                 <a:solidFill>
                   <a:srgbClr val="5E7280"/>
                 </a:solidFill>
@@ -2270,7 +2297,7 @@
                 <a:ea typeface="Poppins" pitchFamily="34" charset="-122"/>
                 <a:cs typeface="Poppins" pitchFamily="34" charset="-120"/>
               </a:rPr>
-              <a:t>  30%</a:t>
+              <a:t>  30% of billable</a:t>
             </a:r>
             <a:endParaRPr lang="en-US" sz="2000" dirty="0"/>
           </a:p>
@@ -2278,7 +2305,7 @@
       </p:sp>
       <p:sp>
         <p:nvSpPr>
-          <p:cNvPr id="27" name="Text 25"/>
+          <p:cNvPr id="28" name="Text 26"/>
           <p:cNvSpPr txBox="1"/>
           <p:nvPr/>
         </p:nvSpPr>
@@ -2317,7 +2344,7 @@
       </p:sp>
       <p:sp>
         <p:nvSpPr>
-          <p:cNvPr id="28" name="Shape 26"/>
+          <p:cNvPr id="29" name="Shape 27"/>
           <p:cNvSpPr/>
           <p:nvPr/>
         </p:nvSpPr>
@@ -2346,7 +2373,7 @@
       </p:sp>
       <p:sp>
         <p:nvSpPr>
-          <p:cNvPr id="29" name="Shape 27"/>
+          <p:cNvPr id="30" name="Shape 28"/>
           <p:cNvSpPr/>
           <p:nvPr/>
         </p:nvSpPr>
@@ -2359,14 +2386,14 @@
             <a:avLst/>
           </a:prstGeom>
           <a:solidFill>
-            <a:srgbClr val="1B8DA6"/>
+            <a:srgbClr val="6FAEBB"/>
           </a:solidFill>
           <a:ln/>
         </p:spPr>
       </p:sp>
       <p:sp>
         <p:nvSpPr>
-          <p:cNvPr id="30" name="Text 28"/>
+          <p:cNvPr id="31" name="Text 29"/>
           <p:cNvSpPr txBox="1"/>
           <p:nvPr/>
         </p:nvSpPr>
@@ -2405,7 +2432,7 @@
       </p:sp>
       <p:sp>
         <p:nvSpPr>
-          <p:cNvPr id="31" name="Text 29"/>
+          <p:cNvPr id="32" name="Text 30"/>
           <p:cNvSpPr txBox="1"/>
           <p:nvPr/>
         </p:nvSpPr>
@@ -2442,7 +2469,7 @@
               <a:buNone/>
             </a:pPr>
             <a:r>
-              <a:rPr lang="en-US" sz="900" b="1" dirty="0">
+              <a:rPr lang="en-US" sz="700" b="1" dirty="0">
                 <a:solidFill>
                   <a:srgbClr val="5E7280"/>
                 </a:solidFill>
@@ -2450,7 +2477,7 @@
                 <a:ea typeface="Poppins" pitchFamily="34" charset="-122"/>
                 <a:cs typeface="Poppins" pitchFamily="34" charset="-120"/>
               </a:rPr>
-              <a:t>  9%</a:t>
+              <a:t>  9% of billable</a:t>
             </a:r>
             <a:endParaRPr lang="en-US" sz="2000" dirty="0"/>
           </a:p>
@@ -2458,7 +2485,7 @@
       </p:sp>
       <p:sp>
         <p:nvSpPr>
-          <p:cNvPr id="32" name="Text 30"/>
+          <p:cNvPr id="33" name="Text 31"/>
           <p:cNvSpPr txBox="1"/>
           <p:nvPr/>
         </p:nvSpPr>
@@ -2497,7 +2524,7 @@
       </p:sp>
       <p:sp>
         <p:nvSpPr>
-          <p:cNvPr id="33" name="Shape 31"/>
+          <p:cNvPr id="34" name="Shape 32"/>
           <p:cNvSpPr/>
           <p:nvPr/>
         </p:nvSpPr>
@@ -2526,7 +2553,7 @@
       </p:sp>
       <p:sp>
         <p:nvSpPr>
-          <p:cNvPr id="34" name="Shape 32"/>
+          <p:cNvPr id="35" name="Shape 33"/>
           <p:cNvSpPr/>
           <p:nvPr/>
         </p:nvSpPr>
@@ -2546,7 +2573,7 @@
       </p:sp>
       <p:sp>
         <p:nvSpPr>
-          <p:cNvPr id="35" name="Text 33"/>
+          <p:cNvPr id="36" name="Text 34"/>
           <p:cNvSpPr txBox="1"/>
           <p:nvPr/>
         </p:nvSpPr>
@@ -2585,7 +2612,7 @@
       </p:sp>
       <p:sp>
         <p:nvSpPr>
-          <p:cNvPr id="36" name="Text 34"/>
+          <p:cNvPr id="37" name="Text 35"/>
           <p:cNvSpPr txBox="1"/>
           <p:nvPr/>
         </p:nvSpPr>
@@ -2624,7 +2651,7 @@
       </p:sp>
       <p:sp>
         <p:nvSpPr>
-          <p:cNvPr id="37" name="Text 35"/>
+          <p:cNvPr id="38" name="Text 36"/>
           <p:cNvSpPr txBox="1"/>
           <p:nvPr/>
         </p:nvSpPr>
@@ -2663,7 +2690,7 @@
       </p:sp>
       <p:sp>
         <p:nvSpPr>
-          <p:cNvPr id="38" name="Shape 36"/>
+          <p:cNvPr id="39" name="Shape 37"/>
           <p:cNvSpPr/>
           <p:nvPr/>
         </p:nvSpPr>
@@ -2692,7 +2719,7 @@
       </p:sp>
       <p:sp>
         <p:nvSpPr>
-          <p:cNvPr id="39" name="Shape 37"/>
+          <p:cNvPr id="40" name="Shape 38"/>
           <p:cNvSpPr/>
           <p:nvPr/>
         </p:nvSpPr>
@@ -2712,7 +2739,7 @@
       </p:sp>
       <p:sp>
         <p:nvSpPr>
-          <p:cNvPr id="40" name="Text 38"/>
+          <p:cNvPr id="41" name="Text 39"/>
           <p:cNvSpPr txBox="1"/>
           <p:nvPr/>
         </p:nvSpPr>
@@ -2751,7 +2778,7 @@
       </p:sp>
       <p:sp>
         <p:nvSpPr>
-          <p:cNvPr id="41" name="Text 39"/>
+          <p:cNvPr id="42" name="Text 40"/>
           <p:cNvSpPr txBox="1"/>
           <p:nvPr/>
         </p:nvSpPr>
@@ -2790,7 +2817,7 @@
       </p:sp>
       <p:sp>
         <p:nvSpPr>
-          <p:cNvPr id="42" name="Text 40"/>
+          <p:cNvPr id="43" name="Text 41"/>
           <p:cNvSpPr txBox="1"/>
           <p:nvPr/>
         </p:nvSpPr>
@@ -2829,7 +2856,7 @@
       </p:sp>
       <p:sp>
         <p:nvSpPr>
-          <p:cNvPr id="43" name="Shape 41"/>
+          <p:cNvPr id="44" name="Shape 42"/>
           <p:cNvSpPr/>
           <p:nvPr/>
         </p:nvSpPr>
@@ -2858,7 +2885,7 @@
       </p:sp>
       <p:sp>
         <p:nvSpPr>
-          <p:cNvPr id="44" name="Text 42"/>
+          <p:cNvPr id="45" name="Text 43"/>
           <p:cNvSpPr txBox="1"/>
           <p:nvPr/>
         </p:nvSpPr>
@@ -2897,7 +2924,7 @@
       </p:sp>
       <p:graphicFrame>
         <p:nvGraphicFramePr>
-          <p:cNvPr id="45" name="Chart 0" descr=""/>
+          <p:cNvPr id="46" name="Chart 0" descr=""/>
           <p:cNvGraphicFramePr/>
           <p:nvPr/>
         </p:nvGraphicFramePr>
@@ -2913,7 +2940,7 @@
       </p:graphicFrame>
       <p:sp>
         <p:nvSpPr>
-          <p:cNvPr id="46" name="Shape 43"/>
+          <p:cNvPr id="47" name="Shape 44"/>
           <p:cNvSpPr/>
           <p:nvPr/>
         </p:nvSpPr>
@@ -2942,7 +2969,7 @@
       </p:sp>
       <p:sp>
         <p:nvSpPr>
-          <p:cNvPr id="47" name="Text 44"/>
+          <p:cNvPr id="48" name="Text 45"/>
           <p:cNvSpPr txBox="1"/>
           <p:nvPr/>
         </p:nvSpPr>
@@ -2995,7 +3022,7 @@
       </p:sp>
       <p:sp>
         <p:nvSpPr>
-          <p:cNvPr id="48" name="Text 45"/>
+          <p:cNvPr id="49" name="Text 46"/>
           <p:cNvSpPr txBox="1"/>
           <p:nvPr/>
         </p:nvSpPr>
@@ -3034,7 +3061,7 @@
       </p:sp>
       <p:sp>
         <p:nvSpPr>
-          <p:cNvPr id="49" name="Text 46"/>
+          <p:cNvPr id="50" name="Text 47"/>
           <p:cNvSpPr txBox="1"/>
           <p:nvPr/>
         </p:nvSpPr>
@@ -3073,7 +3100,7 @@
       </p:sp>
       <p:sp>
         <p:nvSpPr>
-          <p:cNvPr id="50" name="Text 47"/>
+          <p:cNvPr id="51" name="Text 48"/>
           <p:cNvSpPr txBox="1"/>
           <p:nvPr/>
         </p:nvSpPr>
@@ -3112,7 +3139,7 @@
       </p:sp>
       <p:sp>
         <p:nvSpPr>
-          <p:cNvPr id="51" name="Text 48"/>
+          <p:cNvPr id="52" name="Text 49"/>
           <p:cNvSpPr txBox="1"/>
           <p:nvPr/>
         </p:nvSpPr>
@@ -3151,7 +3178,7 @@
       </p:sp>
       <p:sp>
         <p:nvSpPr>
-          <p:cNvPr id="52" name="Text 49"/>
+          <p:cNvPr id="53" name="Text 50"/>
           <p:cNvSpPr txBox="1"/>
           <p:nvPr/>
         </p:nvSpPr>
@@ -3190,7 +3217,7 @@
       </p:sp>
       <p:sp>
         <p:nvSpPr>
-          <p:cNvPr id="53" name="Text 50"/>
+          <p:cNvPr id="54" name="Text 51"/>
           <p:cNvSpPr txBox="1"/>
           <p:nvPr/>
         </p:nvSpPr>
@@ -3229,7 +3256,7 @@
       </p:sp>
       <p:sp>
         <p:nvSpPr>
-          <p:cNvPr id="54" name="Text 51"/>
+          <p:cNvPr id="55" name="Text 52"/>
           <p:cNvSpPr txBox="1"/>
           <p:nvPr/>
         </p:nvSpPr>
@@ -3268,7 +3295,7 @@
       </p:sp>
       <p:sp>
         <p:nvSpPr>
-          <p:cNvPr id="55" name="Text 52"/>
+          <p:cNvPr id="56" name="Text 53"/>
           <p:cNvSpPr txBox="1"/>
           <p:nvPr/>
         </p:nvSpPr>
@@ -3307,7 +3334,7 @@
       </p:sp>
       <p:sp>
         <p:nvSpPr>
-          <p:cNvPr id="56" name="Text 53"/>
+          <p:cNvPr id="57" name="Text 54"/>
           <p:cNvSpPr txBox="1"/>
           <p:nvPr/>
         </p:nvSpPr>
@@ -3346,7 +3373,7 @@
       </p:sp>
       <p:sp>
         <p:nvSpPr>
-          <p:cNvPr id="57" name="Text 54"/>
+          <p:cNvPr id="58" name="Text 55"/>
           <p:cNvSpPr txBox="1"/>
           <p:nvPr/>
         </p:nvSpPr>
@@ -3385,7 +3412,7 @@
       </p:sp>
       <p:sp>
         <p:nvSpPr>
-          <p:cNvPr id="58" name="Text 55"/>
+          <p:cNvPr id="59" name="Text 56"/>
           <p:cNvSpPr txBox="1"/>
           <p:nvPr/>
         </p:nvSpPr>
@@ -3424,7 +3451,7 @@
       </p:sp>
       <p:sp>
         <p:nvSpPr>
-          <p:cNvPr id="59" name="Text 56"/>
+          <p:cNvPr id="60" name="Text 57"/>
           <p:cNvSpPr txBox="1"/>
           <p:nvPr/>
         </p:nvSpPr>
@@ -3463,7 +3490,7 @@
       </p:sp>
       <p:sp>
         <p:nvSpPr>
-          <p:cNvPr id="60" name="Text 57"/>
+          <p:cNvPr id="61" name="Text 58"/>
           <p:cNvSpPr txBox="1"/>
           <p:nvPr/>
         </p:nvSpPr>
@@ -3502,7 +3529,7 @@
       </p:sp>
       <p:sp>
         <p:nvSpPr>
-          <p:cNvPr id="61" name="Text 58"/>
+          <p:cNvPr id="62" name="Text 59"/>
           <p:cNvSpPr txBox="1"/>
           <p:nvPr/>
         </p:nvSpPr>
@@ -3541,7 +3568,7 @@
       </p:sp>
       <p:sp>
         <p:nvSpPr>
-          <p:cNvPr id="62" name="Shape 59"/>
+          <p:cNvPr id="63" name="Shape 60"/>
           <p:cNvSpPr/>
           <p:nvPr/>
         </p:nvSpPr>
@@ -3561,7 +3588,7 @@
       </p:sp>
       <p:sp>
         <p:nvSpPr>
-          <p:cNvPr id="63" name="Text 60"/>
+          <p:cNvPr id="64" name="Text 61"/>
           <p:cNvSpPr txBox="1"/>
           <p:nvPr/>
         </p:nvSpPr>
@@ -3600,7 +3627,7 @@
       </p:sp>
       <p:sp>
         <p:nvSpPr>
-          <p:cNvPr id="64" name="Text 61"/>
+          <p:cNvPr id="65" name="Text 62"/>
           <p:cNvSpPr txBox="1"/>
           <p:nvPr/>
         </p:nvSpPr>
@@ -3639,7 +3666,7 @@
       </p:sp>
       <p:sp>
         <p:nvSpPr>
-          <p:cNvPr id="65" name="Text 62"/>
+          <p:cNvPr id="66" name="Text 63"/>
           <p:cNvSpPr txBox="1"/>
           <p:nvPr/>
         </p:nvSpPr>
@@ -3678,7 +3705,7 @@
       </p:sp>
       <p:sp>
         <p:nvSpPr>
-          <p:cNvPr id="66" name="Text 63"/>
+          <p:cNvPr id="67" name="Text 64"/>
           <p:cNvSpPr txBox="1"/>
           <p:nvPr/>
         </p:nvSpPr>
@@ -3717,7 +3744,7 @@
       </p:sp>
       <p:sp>
         <p:nvSpPr>
-          <p:cNvPr id="67" name="Text 64"/>
+          <p:cNvPr id="68" name="Text 65"/>
           <p:cNvSpPr txBox="1"/>
           <p:nvPr/>
         </p:nvSpPr>
@@ -3756,7 +3783,7 @@
       </p:sp>
       <p:sp>
         <p:nvSpPr>
-          <p:cNvPr id="68" name="Text 65"/>
+          <p:cNvPr id="69" name="Text 66"/>
           <p:cNvSpPr txBox="1"/>
           <p:nvPr/>
         </p:nvSpPr>
@@ -3795,7 +3822,7 @@
       </p:sp>
       <p:sp>
         <p:nvSpPr>
-          <p:cNvPr id="69" name="Text 66"/>
+          <p:cNvPr id="70" name="Text 67"/>
           <p:cNvSpPr txBox="1"/>
           <p:nvPr/>
         </p:nvSpPr>
@@ -3834,7 +3861,7 @@
       </p:sp>
       <p:sp>
         <p:nvSpPr>
-          <p:cNvPr id="70" name="Shape 67"/>
+          <p:cNvPr id="71" name="Shape 68"/>
           <p:cNvSpPr/>
           <p:nvPr/>
         </p:nvSpPr>
@@ -3854,7 +3881,7 @@
       </p:sp>
       <p:sp>
         <p:nvSpPr>
-          <p:cNvPr id="71" name="Text 68"/>
+          <p:cNvPr id="72" name="Text 69"/>
           <p:cNvSpPr txBox="1"/>
           <p:nvPr/>
         </p:nvSpPr>
@@ -3893,7 +3920,7 @@
       </p:sp>
       <p:sp>
         <p:nvSpPr>
-          <p:cNvPr id="72" name="Text 69"/>
+          <p:cNvPr id="73" name="Text 70"/>
           <p:cNvSpPr txBox="1"/>
           <p:nvPr/>
         </p:nvSpPr>
@@ -3932,7 +3959,7 @@
       </p:sp>
       <p:sp>
         <p:nvSpPr>
-          <p:cNvPr id="73" name="Text 70"/>
+          <p:cNvPr id="74" name="Text 71"/>
           <p:cNvSpPr txBox="1"/>
           <p:nvPr/>
         </p:nvSpPr>
@@ -3971,7 +3998,7 @@
       </p:sp>
       <p:sp>
         <p:nvSpPr>
-          <p:cNvPr id="74" name="Text 71"/>
+          <p:cNvPr id="75" name="Text 72"/>
           <p:cNvSpPr txBox="1"/>
           <p:nvPr/>
         </p:nvSpPr>
@@ -4010,7 +4037,7 @@
       </p:sp>
       <p:sp>
         <p:nvSpPr>
-          <p:cNvPr id="75" name="Text 72"/>
+          <p:cNvPr id="76" name="Text 73"/>
           <p:cNvSpPr txBox="1"/>
           <p:nvPr/>
         </p:nvSpPr>
@@ -4049,7 +4076,7 @@
       </p:sp>
       <p:sp>
         <p:nvSpPr>
-          <p:cNvPr id="76" name="Text 73"/>
+          <p:cNvPr id="77" name="Text 74"/>
           <p:cNvSpPr txBox="1"/>
           <p:nvPr/>
         </p:nvSpPr>
@@ -4088,7 +4115,7 @@
       </p:sp>
       <p:sp>
         <p:nvSpPr>
-          <p:cNvPr id="77" name="Text 74"/>
+          <p:cNvPr id="78" name="Text 75"/>
           <p:cNvSpPr txBox="1"/>
           <p:nvPr/>
         </p:nvSpPr>
@@ -4127,7 +4154,7 @@
       </p:sp>
       <p:sp>
         <p:nvSpPr>
-          <p:cNvPr id="78" name="Shape 75"/>
+          <p:cNvPr id="79" name="Shape 76"/>
           <p:cNvSpPr/>
           <p:nvPr/>
         </p:nvSpPr>
@@ -4156,7 +4183,7 @@
       </p:sp>
       <p:sp>
         <p:nvSpPr>
-          <p:cNvPr id="79" name="Text 76"/>
+          <p:cNvPr id="80" name="Text 77"/>
           <p:cNvSpPr txBox="1"/>
           <p:nvPr/>
         </p:nvSpPr>
@@ -4195,7 +4222,7 @@
       </p:sp>
       <p:sp>
         <p:nvSpPr>
-          <p:cNvPr id="80" name="Text 77"/>
+          <p:cNvPr id="81" name="Text 78"/>
           <p:cNvSpPr txBox="1"/>
           <p:nvPr/>
         </p:nvSpPr>
@@ -4234,7 +4261,7 @@
       </p:sp>
       <p:sp>
         <p:nvSpPr>
-          <p:cNvPr id="81" name="Text 78"/>
+          <p:cNvPr id="82" name="Text 79"/>
           <p:cNvSpPr txBox="1"/>
           <p:nvPr/>
         </p:nvSpPr>
@@ -4273,7 +4300,7 @@
       </p:sp>
       <p:sp>
         <p:nvSpPr>
-          <p:cNvPr id="82" name="Text 79"/>
+          <p:cNvPr id="83" name="Text 80"/>
           <p:cNvSpPr txBox="1"/>
           <p:nvPr/>
         </p:nvSpPr>
@@ -4312,7 +4339,7 @@
       </p:sp>
       <p:sp>
         <p:nvSpPr>
-          <p:cNvPr id="83" name="Text 80"/>
+          <p:cNvPr id="84" name="Text 81"/>
           <p:cNvSpPr txBox="1"/>
           <p:nvPr/>
         </p:nvSpPr>
@@ -4351,7 +4378,7 @@
       </p:sp>
       <p:sp>
         <p:nvSpPr>
-          <p:cNvPr id="84" name="Text 81"/>
+          <p:cNvPr id="85" name="Text 82"/>
           <p:cNvSpPr txBox="1"/>
           <p:nvPr/>
         </p:nvSpPr>
@@ -4390,7 +4417,7 @@
       </p:sp>
       <p:sp>
         <p:nvSpPr>
-          <p:cNvPr id="85" name="Text 82"/>
+          <p:cNvPr id="86" name="Text 83"/>
           <p:cNvSpPr txBox="1"/>
           <p:nvPr/>
         </p:nvSpPr>
@@ -4429,7 +4456,7 @@
       </p:sp>
       <p:sp>
         <p:nvSpPr>
-          <p:cNvPr id="86" name="Text 83"/>
+          <p:cNvPr id="87" name="Text 84"/>
           <p:cNvSpPr txBox="1"/>
           <p:nvPr/>
         </p:nvSpPr>
@@ -4468,7 +4495,7 @@
       </p:sp>
       <p:sp>
         <p:nvSpPr>
-          <p:cNvPr id="87" name="Text 84"/>
+          <p:cNvPr id="88" name="Text 85"/>
           <p:cNvSpPr txBox="1"/>
           <p:nvPr/>
         </p:nvSpPr>
@@ -4507,7 +4534,7 @@
       </p:sp>
       <p:sp>
         <p:nvSpPr>
-          <p:cNvPr id="88" name="Shape 85"/>
+          <p:cNvPr id="89" name="Shape 86"/>
           <p:cNvSpPr/>
           <p:nvPr/>
         </p:nvSpPr>
@@ -4527,7 +4554,7 @@
       </p:sp>
       <p:sp>
         <p:nvSpPr>
-          <p:cNvPr id="89" name="Text 86"/>
+          <p:cNvPr id="90" name="Text 87"/>
           <p:cNvSpPr txBox="1"/>
           <p:nvPr/>
         </p:nvSpPr>
@@ -4566,7 +4593,7 @@
       </p:sp>
       <p:sp>
         <p:nvSpPr>
-          <p:cNvPr id="90" name="Text 87"/>
+          <p:cNvPr id="91" name="Text 88"/>
           <p:cNvSpPr txBox="1"/>
           <p:nvPr/>
         </p:nvSpPr>
@@ -4605,7 +4632,7 @@
       </p:sp>
       <p:sp>
         <p:nvSpPr>
-          <p:cNvPr id="91" name="Text 88"/>
+          <p:cNvPr id="92" name="Text 89"/>
           <p:cNvSpPr txBox="1"/>
           <p:nvPr/>
         </p:nvSpPr>
@@ -4644,7 +4671,7 @@
       </p:sp>
       <p:sp>
         <p:nvSpPr>
-          <p:cNvPr id="92" name="Text 89"/>
+          <p:cNvPr id="93" name="Text 90"/>
           <p:cNvSpPr txBox="1"/>
           <p:nvPr/>
         </p:nvSpPr>
@@ -4683,7 +4710,7 @@
       </p:sp>
       <p:sp>
         <p:nvSpPr>
-          <p:cNvPr id="93" name="Text 90"/>
+          <p:cNvPr id="94" name="Text 91"/>
           <p:cNvSpPr txBox="1"/>
           <p:nvPr/>
         </p:nvSpPr>
@@ -4722,7 +4749,7 @@
       </p:sp>
       <p:sp>
         <p:nvSpPr>
-          <p:cNvPr id="94" name="Text 91"/>
+          <p:cNvPr id="95" name="Text 92"/>
           <p:cNvSpPr txBox="1"/>
           <p:nvPr/>
         </p:nvSpPr>
@@ -4761,7 +4788,7 @@
       </p:sp>
       <p:sp>
         <p:nvSpPr>
-          <p:cNvPr id="95" name="Text 92"/>
+          <p:cNvPr id="96" name="Text 93"/>
           <p:cNvSpPr txBox="1"/>
           <p:nvPr/>
         </p:nvSpPr>
@@ -4800,7 +4827,7 @@
       </p:sp>
       <p:sp>
         <p:nvSpPr>
-          <p:cNvPr id="96" name="Text 93"/>
+          <p:cNvPr id="97" name="Text 94"/>
           <p:cNvSpPr txBox="1"/>
           <p:nvPr/>
         </p:nvSpPr>
@@ -4839,7 +4866,7 @@
       </p:sp>
       <p:sp>
         <p:nvSpPr>
-          <p:cNvPr id="97" name="Shape 94"/>
+          <p:cNvPr id="98" name="Shape 95"/>
           <p:cNvSpPr/>
           <p:nvPr/>
         </p:nvSpPr>
@@ -4859,7 +4886,7 @@
       </p:sp>
       <p:sp>
         <p:nvSpPr>
-          <p:cNvPr id="98" name="Text 95"/>
+          <p:cNvPr id="99" name="Text 96"/>
           <p:cNvSpPr txBox="1"/>
           <p:nvPr/>
         </p:nvSpPr>
@@ -4898,7 +4925,7 @@
       </p:sp>
       <p:sp>
         <p:nvSpPr>
-          <p:cNvPr id="99" name="Text 96"/>
+          <p:cNvPr id="100" name="Text 97"/>
           <p:cNvSpPr txBox="1"/>
           <p:nvPr/>
         </p:nvSpPr>
@@ -4937,7 +4964,7 @@
       </p:sp>
       <p:sp>
         <p:nvSpPr>
-          <p:cNvPr id="100" name="Text 97"/>
+          <p:cNvPr id="101" name="Text 98"/>
           <p:cNvSpPr txBox="1"/>
           <p:nvPr/>
         </p:nvSpPr>
@@ -4976,7 +5003,7 @@
       </p:sp>
       <p:sp>
         <p:nvSpPr>
-          <p:cNvPr id="101" name="Text 98"/>
+          <p:cNvPr id="102" name="Text 99"/>
           <p:cNvSpPr txBox="1"/>
           <p:nvPr/>
         </p:nvSpPr>
@@ -5015,7 +5042,7 @@
       </p:sp>
       <p:sp>
         <p:nvSpPr>
-          <p:cNvPr id="102" name="Text 99"/>
+          <p:cNvPr id="103" name="Text 100"/>
           <p:cNvSpPr txBox="1"/>
           <p:nvPr/>
         </p:nvSpPr>
@@ -5054,7 +5081,7 @@
       </p:sp>
       <p:sp>
         <p:nvSpPr>
-          <p:cNvPr id="103" name="Text 100"/>
+          <p:cNvPr id="104" name="Text 101"/>
           <p:cNvSpPr txBox="1"/>
           <p:nvPr/>
         </p:nvSpPr>
@@ -5093,7 +5120,7 @@
       </p:sp>
       <p:sp>
         <p:nvSpPr>
-          <p:cNvPr id="104" name="Text 101"/>
+          <p:cNvPr id="105" name="Text 102"/>
           <p:cNvSpPr txBox="1"/>
           <p:nvPr/>
         </p:nvSpPr>
@@ -5132,7 +5159,7 @@
       </p:sp>
       <p:sp>
         <p:nvSpPr>
-          <p:cNvPr id="105" name="Text 102"/>
+          <p:cNvPr id="106" name="Text 103"/>
           <p:cNvSpPr txBox="1"/>
           <p:nvPr/>
         </p:nvSpPr>
@@ -5171,7 +5198,7 @@
       </p:sp>
       <p:sp>
         <p:nvSpPr>
-          <p:cNvPr id="106" name="Shape 103"/>
+          <p:cNvPr id="107" name="Shape 104"/>
           <p:cNvSpPr/>
           <p:nvPr/>
         </p:nvSpPr>
@@ -5191,7 +5218,7 @@
       </p:sp>
       <p:sp>
         <p:nvSpPr>
-          <p:cNvPr id="107" name="Text 104"/>
+          <p:cNvPr id="108" name="Text 105"/>
           <p:cNvSpPr txBox="1"/>
           <p:nvPr/>
         </p:nvSpPr>
@@ -5230,7 +5257,7 @@
       </p:sp>
       <p:sp>
         <p:nvSpPr>
-          <p:cNvPr id="108" name="Text 105"/>
+          <p:cNvPr id="109" name="Text 106"/>
           <p:cNvSpPr txBox="1"/>
           <p:nvPr/>
         </p:nvSpPr>
@@ -5269,7 +5296,7 @@
       </p:sp>
       <p:sp>
         <p:nvSpPr>
-          <p:cNvPr id="109" name="Text 106"/>
+          <p:cNvPr id="110" name="Text 107"/>
           <p:cNvSpPr txBox="1"/>
           <p:nvPr/>
         </p:nvSpPr>
@@ -5308,7 +5335,7 @@
       </p:sp>
       <p:sp>
         <p:nvSpPr>
-          <p:cNvPr id="110" name="Text 107"/>
+          <p:cNvPr id="111" name="Text 108"/>
           <p:cNvSpPr txBox="1"/>
           <p:nvPr/>
         </p:nvSpPr>
@@ -5347,7 +5374,7 @@
       </p:sp>
       <p:sp>
         <p:nvSpPr>
-          <p:cNvPr id="111" name="Text 108"/>
+          <p:cNvPr id="112" name="Text 109"/>
           <p:cNvSpPr txBox="1"/>
           <p:nvPr/>
         </p:nvSpPr>
@@ -5386,7 +5413,7 @@
       </p:sp>
       <p:sp>
         <p:nvSpPr>
-          <p:cNvPr id="112" name="Text 109"/>
+          <p:cNvPr id="113" name="Text 110"/>
           <p:cNvSpPr txBox="1"/>
           <p:nvPr/>
         </p:nvSpPr>
@@ -5425,7 +5452,7 @@
       </p:sp>
       <p:sp>
         <p:nvSpPr>
-          <p:cNvPr id="113" name="Text 110"/>
+          <p:cNvPr id="114" name="Text 111"/>
           <p:cNvSpPr txBox="1"/>
           <p:nvPr/>
         </p:nvSpPr>
@@ -5464,7 +5491,7 @@
       </p:sp>
       <p:sp>
         <p:nvSpPr>
-          <p:cNvPr id="114" name="Text 111"/>
+          <p:cNvPr id="115" name="Text 112"/>
           <p:cNvSpPr txBox="1"/>
           <p:nvPr/>
         </p:nvSpPr>
@@ -5503,7 +5530,7 @@
       </p:sp>
       <p:sp>
         <p:nvSpPr>
-          <p:cNvPr id="115" name="Shape 112"/>
+          <p:cNvPr id="116" name="Shape 113"/>
           <p:cNvSpPr/>
           <p:nvPr/>
         </p:nvSpPr>
@@ -5523,7 +5550,7 @@
       </p:sp>
       <p:sp>
         <p:nvSpPr>
-          <p:cNvPr id="116" name="Text 113"/>
+          <p:cNvPr id="117" name="Text 114"/>
           <p:cNvSpPr txBox="1"/>
           <p:nvPr/>
         </p:nvSpPr>
@@ -5562,7 +5589,7 @@
       </p:sp>
       <p:sp>
         <p:nvSpPr>
-          <p:cNvPr id="117" name="Text 114"/>
+          <p:cNvPr id="118" name="Text 115"/>
           <p:cNvSpPr txBox="1"/>
           <p:nvPr/>
         </p:nvSpPr>
@@ -5601,7 +5628,7 @@
       </p:sp>
       <p:sp>
         <p:nvSpPr>
-          <p:cNvPr id="118" name="Text 115"/>
+          <p:cNvPr id="119" name="Text 116"/>
           <p:cNvSpPr txBox="1"/>
           <p:nvPr/>
         </p:nvSpPr>
@@ -5640,7 +5667,7 @@
       </p:sp>
       <p:sp>
         <p:nvSpPr>
-          <p:cNvPr id="119" name="Text 116"/>
+          <p:cNvPr id="120" name="Text 117"/>
           <p:cNvSpPr txBox="1"/>
           <p:nvPr/>
         </p:nvSpPr>
@@ -5679,7 +5706,7 @@
       </p:sp>
       <p:sp>
         <p:nvSpPr>
-          <p:cNvPr id="120" name="Text 117"/>
+          <p:cNvPr id="121" name="Text 118"/>
           <p:cNvSpPr txBox="1"/>
           <p:nvPr/>
         </p:nvSpPr>
@@ -5718,7 +5745,7 @@
       </p:sp>
       <p:sp>
         <p:nvSpPr>
-          <p:cNvPr id="121" name="Text 118"/>
+          <p:cNvPr id="122" name="Text 119"/>
           <p:cNvSpPr txBox="1"/>
           <p:nvPr/>
         </p:nvSpPr>
@@ -5757,7 +5784,7 @@
       </p:sp>
       <p:sp>
         <p:nvSpPr>
-          <p:cNvPr id="122" name="Text 119"/>
+          <p:cNvPr id="123" name="Text 120"/>
           <p:cNvSpPr txBox="1"/>
           <p:nvPr/>
         </p:nvSpPr>
@@ -5796,7 +5823,7 @@
       </p:sp>
       <p:sp>
         <p:nvSpPr>
-          <p:cNvPr id="123" name="Text 120"/>
+          <p:cNvPr id="124" name="Text 121"/>
           <p:cNvSpPr txBox="1"/>
           <p:nvPr/>
         </p:nvSpPr>
@@ -5835,7 +5862,7 @@
       </p:sp>
       <p:sp>
         <p:nvSpPr>
-          <p:cNvPr id="124" name="Shape 121"/>
+          <p:cNvPr id="125" name="Shape 122"/>
           <p:cNvSpPr/>
           <p:nvPr/>
         </p:nvSpPr>
@@ -5855,7 +5882,7 @@
       </p:sp>
       <p:sp>
         <p:nvSpPr>
-          <p:cNvPr id="125" name="Text 122"/>
+          <p:cNvPr id="126" name="Text 123"/>
           <p:cNvSpPr txBox="1"/>
           <p:nvPr/>
         </p:nvSpPr>
@@ -5894,7 +5921,7 @@
       </p:sp>
       <p:sp>
         <p:nvSpPr>
-          <p:cNvPr id="126" name="Text 123"/>
+          <p:cNvPr id="127" name="Text 124"/>
           <p:cNvSpPr txBox="1"/>
           <p:nvPr/>
         </p:nvSpPr>
@@ -5933,7 +5960,7 @@
       </p:sp>
       <p:sp>
         <p:nvSpPr>
-          <p:cNvPr id="127" name="Text 124"/>
+          <p:cNvPr id="128" name="Text 125"/>
           <p:cNvSpPr txBox="1"/>
           <p:nvPr/>
         </p:nvSpPr>
@@ -5972,7 +5999,7 @@
       </p:sp>
       <p:sp>
         <p:nvSpPr>
-          <p:cNvPr id="128" name="Text 125"/>
+          <p:cNvPr id="129" name="Text 126"/>
           <p:cNvSpPr txBox="1"/>
           <p:nvPr/>
         </p:nvSpPr>
@@ -6011,7 +6038,7 @@
       </p:sp>
       <p:sp>
         <p:nvSpPr>
-          <p:cNvPr id="129" name="Text 126"/>
+          <p:cNvPr id="130" name="Text 127"/>
           <p:cNvSpPr txBox="1"/>
           <p:nvPr/>
         </p:nvSpPr>
@@ -6050,7 +6077,7 @@
       </p:sp>
       <p:sp>
         <p:nvSpPr>
-          <p:cNvPr id="130" name="Text 127"/>
+          <p:cNvPr id="131" name="Text 128"/>
           <p:cNvSpPr txBox="1"/>
           <p:nvPr/>
         </p:nvSpPr>
@@ -6089,7 +6116,7 @@
       </p:sp>
       <p:sp>
         <p:nvSpPr>
-          <p:cNvPr id="131" name="Text 128"/>
+          <p:cNvPr id="132" name="Text 129"/>
           <p:cNvSpPr txBox="1"/>
           <p:nvPr/>
         </p:nvSpPr>
@@ -6128,7 +6155,7 @@
       </p:sp>
       <p:sp>
         <p:nvSpPr>
-          <p:cNvPr id="132" name="Text 129"/>
+          <p:cNvPr id="133" name="Text 130"/>
           <p:cNvSpPr txBox="1"/>
           <p:nvPr/>
         </p:nvSpPr>
@@ -6167,7 +6194,7 @@
       </p:sp>
       <p:sp>
         <p:nvSpPr>
-          <p:cNvPr id="133" name="Shape 130"/>
+          <p:cNvPr id="134" name="Shape 131"/>
           <p:cNvSpPr/>
           <p:nvPr/>
         </p:nvSpPr>
@@ -6187,7 +6214,7 @@
       </p:sp>
       <p:sp>
         <p:nvSpPr>
-          <p:cNvPr id="134" name="Text 131"/>
+          <p:cNvPr id="135" name="Text 132"/>
           <p:cNvSpPr txBox="1"/>
           <p:nvPr/>
         </p:nvSpPr>
@@ -6226,7 +6253,7 @@
       </p:sp>
       <p:sp>
         <p:nvSpPr>
-          <p:cNvPr id="135" name="Text 132"/>
+          <p:cNvPr id="136" name="Text 133"/>
           <p:cNvSpPr txBox="1"/>
           <p:nvPr/>
         </p:nvSpPr>
@@ -6265,7 +6292,7 @@
       </p:sp>
       <p:sp>
         <p:nvSpPr>
-          <p:cNvPr id="136" name="Text 133"/>
+          <p:cNvPr id="137" name="Text 134"/>
           <p:cNvSpPr txBox="1"/>
           <p:nvPr/>
         </p:nvSpPr>
@@ -6304,7 +6331,7 @@
       </p:sp>
       <p:sp>
         <p:nvSpPr>
-          <p:cNvPr id="137" name="Text 134"/>
+          <p:cNvPr id="138" name="Text 135"/>
           <p:cNvSpPr txBox="1"/>
           <p:nvPr/>
         </p:nvSpPr>
@@ -6343,7 +6370,7 @@
       </p:sp>
       <p:sp>
         <p:nvSpPr>
-          <p:cNvPr id="138" name="Shape 135"/>
+          <p:cNvPr id="139" name="Shape 136"/>
           <p:cNvSpPr/>
           <p:nvPr/>
         </p:nvSpPr>
@@ -6372,7 +6399,7 @@
       </p:sp>
       <p:sp>
         <p:nvSpPr>
-          <p:cNvPr id="139" name="Text 136"/>
+          <p:cNvPr id="140" name="Text 137"/>
           <p:cNvSpPr txBox="1"/>
           <p:nvPr/>
         </p:nvSpPr>
@@ -6411,7 +6438,7 @@
       </p:sp>
       <p:sp>
         <p:nvSpPr>
-          <p:cNvPr id="140" name="Text 137"/>
+          <p:cNvPr id="141" name="Text 138"/>
           <p:cNvSpPr txBox="1"/>
           <p:nvPr/>
         </p:nvSpPr>
@@ -6450,7 +6477,7 @@
       </p:sp>
       <p:sp>
         <p:nvSpPr>
-          <p:cNvPr id="141" name="Text 138"/>
+          <p:cNvPr id="142" name="Text 139"/>
           <p:cNvSpPr txBox="1"/>
           <p:nvPr/>
         </p:nvSpPr>
@@ -6489,7 +6516,7 @@
       </p:sp>
       <p:sp>
         <p:nvSpPr>
-          <p:cNvPr id="142" name="Text 139"/>
+          <p:cNvPr id="143" name="Text 140"/>
           <p:cNvSpPr txBox="1"/>
           <p:nvPr/>
         </p:nvSpPr>
@@ -6528,7 +6555,7 @@
       </p:sp>
       <p:sp>
         <p:nvSpPr>
-          <p:cNvPr id="143" name="Text 140"/>
+          <p:cNvPr id="144" name="Text 141"/>
           <p:cNvSpPr txBox="1"/>
           <p:nvPr/>
         </p:nvSpPr>
@@ -6567,7 +6594,7 @@
       </p:sp>
       <p:sp>
         <p:nvSpPr>
-          <p:cNvPr id="144" name="Text 141"/>
+          <p:cNvPr id="145" name="Text 142"/>
           <p:cNvSpPr txBox="1"/>
           <p:nvPr/>
         </p:nvSpPr>
@@ -6606,7 +6633,7 @@
       </p:sp>
       <p:sp>
         <p:nvSpPr>
-          <p:cNvPr id="145" name="Text 142"/>
+          <p:cNvPr id="146" name="Text 143"/>
           <p:cNvSpPr txBox="1"/>
           <p:nvPr/>
         </p:nvSpPr>
@@ -6645,7 +6672,7 @@
       </p:sp>
       <p:sp>
         <p:nvSpPr>
-          <p:cNvPr id="146" name="Text 143"/>
+          <p:cNvPr id="147" name="Text 144"/>
           <p:cNvSpPr txBox="1"/>
           <p:nvPr/>
         </p:nvSpPr>
@@ -6684,7 +6711,7 @@
       </p:sp>
       <p:sp>
         <p:nvSpPr>
-          <p:cNvPr id="147" name="Text 144"/>
+          <p:cNvPr id="148" name="Text 145"/>
           <p:cNvSpPr txBox="1"/>
           <p:nvPr/>
         </p:nvSpPr>
@@ -6723,7 +6750,7 @@
       </p:sp>
       <p:sp>
         <p:nvSpPr>
-          <p:cNvPr id="148" name="Text 145"/>
+          <p:cNvPr id="149" name="Text 146"/>
           <p:cNvSpPr txBox="1"/>
           <p:nvPr/>
         </p:nvSpPr>
@@ -6762,7 +6789,7 @@
       </p:sp>
       <p:sp>
         <p:nvSpPr>
-          <p:cNvPr id="149" name="Text 146"/>
+          <p:cNvPr id="150" name="Text 147"/>
           <p:cNvSpPr txBox="1"/>
           <p:nvPr/>
         </p:nvSpPr>
@@ -6801,7 +6828,7 @@
       </p:sp>
       <p:sp>
         <p:nvSpPr>
-          <p:cNvPr id="150" name="Shape 147"/>
+          <p:cNvPr id="151" name="Shape 148"/>
           <p:cNvSpPr/>
           <p:nvPr/>
         </p:nvSpPr>
@@ -6821,7 +6848,7 @@
       </p:sp>
       <p:sp>
         <p:nvSpPr>
-          <p:cNvPr id="151" name="Text 148"/>
+          <p:cNvPr id="152" name="Text 149"/>
           <p:cNvSpPr txBox="1"/>
           <p:nvPr/>
         </p:nvSpPr>
@@ -6860,7 +6887,7 @@
       </p:sp>
       <p:sp>
         <p:nvSpPr>
-          <p:cNvPr id="152" name="Text 149"/>
+          <p:cNvPr id="153" name="Text 150"/>
           <p:cNvSpPr txBox="1"/>
           <p:nvPr/>
         </p:nvSpPr>
@@ -6899,7 +6926,7 @@
       </p:sp>
       <p:sp>
         <p:nvSpPr>
-          <p:cNvPr id="153" name="Text 150"/>
+          <p:cNvPr id="154" name="Text 151"/>
           <p:cNvSpPr txBox="1"/>
           <p:nvPr/>
         </p:nvSpPr>
@@ -6938,7 +6965,7 @@
       </p:sp>
       <p:sp>
         <p:nvSpPr>
-          <p:cNvPr id="154" name="Text 151"/>
+          <p:cNvPr id="155" name="Text 152"/>
           <p:cNvSpPr txBox="1"/>
           <p:nvPr/>
         </p:nvSpPr>
@@ -6977,7 +7004,7 @@
       </p:sp>
       <p:sp>
         <p:nvSpPr>
-          <p:cNvPr id="155" name="Text 152"/>
+          <p:cNvPr id="156" name="Text 153"/>
           <p:cNvSpPr txBox="1"/>
           <p:nvPr/>
         </p:nvSpPr>
@@ -7016,7 +7043,7 @@
       </p:sp>
       <p:sp>
         <p:nvSpPr>
-          <p:cNvPr id="156" name="Text 153"/>
+          <p:cNvPr id="157" name="Text 154"/>
           <p:cNvSpPr txBox="1"/>
           <p:nvPr/>
         </p:nvSpPr>
@@ -7055,7 +7082,7 @@
       </p:sp>
       <p:sp>
         <p:nvSpPr>
-          <p:cNvPr id="157" name="Text 154"/>
+          <p:cNvPr id="158" name="Text 155"/>
           <p:cNvSpPr txBox="1"/>
           <p:nvPr/>
         </p:nvSpPr>
@@ -7094,7 +7121,7 @@
       </p:sp>
       <p:sp>
         <p:nvSpPr>
-          <p:cNvPr id="158" name="Text 155"/>
+          <p:cNvPr id="159" name="Text 156"/>
           <p:cNvSpPr txBox="1"/>
           <p:nvPr/>
         </p:nvSpPr>
@@ -7133,7 +7160,7 @@
       </p:sp>
       <p:sp>
         <p:nvSpPr>
-          <p:cNvPr id="159" name="Text 156"/>
+          <p:cNvPr id="160" name="Text 157"/>
           <p:cNvSpPr txBox="1"/>
           <p:nvPr/>
         </p:nvSpPr>
@@ -7172,7 +7199,7 @@
       </p:sp>
       <p:sp>
         <p:nvSpPr>
-          <p:cNvPr id="160" name="Text 157"/>
+          <p:cNvPr id="161" name="Text 158"/>
           <p:cNvSpPr txBox="1"/>
           <p:nvPr/>
         </p:nvSpPr>
@@ -7211,7 +7238,7 @@
       </p:sp>
       <p:sp>
         <p:nvSpPr>
-          <p:cNvPr id="161" name="Shape 158"/>
+          <p:cNvPr id="162" name="Shape 159"/>
           <p:cNvSpPr/>
           <p:nvPr/>
         </p:nvSpPr>
@@ -7231,7 +7258,7 @@
       </p:sp>
       <p:sp>
         <p:nvSpPr>
-          <p:cNvPr id="162" name="Text 159"/>
+          <p:cNvPr id="163" name="Text 160"/>
           <p:cNvSpPr txBox="1"/>
           <p:nvPr/>
         </p:nvSpPr>
@@ -7270,7 +7297,7 @@
       </p:sp>
       <p:sp>
         <p:nvSpPr>
-          <p:cNvPr id="163" name="Text 160"/>
+          <p:cNvPr id="164" name="Text 161"/>
           <p:cNvSpPr txBox="1"/>
           <p:nvPr/>
         </p:nvSpPr>
@@ -7309,7 +7336,7 @@
       </p:sp>
       <p:sp>
         <p:nvSpPr>
-          <p:cNvPr id="164" name="Text 161"/>
+          <p:cNvPr id="165" name="Text 162"/>
           <p:cNvSpPr txBox="1"/>
           <p:nvPr/>
         </p:nvSpPr>
@@ -7348,7 +7375,7 @@
       </p:sp>
       <p:sp>
         <p:nvSpPr>
-          <p:cNvPr id="165" name="Text 162"/>
+          <p:cNvPr id="166" name="Text 163"/>
           <p:cNvSpPr txBox="1"/>
           <p:nvPr/>
         </p:nvSpPr>
@@ -7387,7 +7414,7 @@
       </p:sp>
       <p:sp>
         <p:nvSpPr>
-          <p:cNvPr id="166" name="Text 163"/>
+          <p:cNvPr id="167" name="Text 164"/>
           <p:cNvSpPr txBox="1"/>
           <p:nvPr/>
         </p:nvSpPr>
@@ -7426,7 +7453,7 @@
       </p:sp>
       <p:sp>
         <p:nvSpPr>
-          <p:cNvPr id="167" name="Text 164"/>
+          <p:cNvPr id="168" name="Text 165"/>
           <p:cNvSpPr txBox="1"/>
           <p:nvPr/>
         </p:nvSpPr>
@@ -7465,7 +7492,7 @@
       </p:sp>
       <p:sp>
         <p:nvSpPr>
-          <p:cNvPr id="168" name="Text 165"/>
+          <p:cNvPr id="169" name="Text 166"/>
           <p:cNvSpPr txBox="1"/>
           <p:nvPr/>
         </p:nvSpPr>
@@ -7504,7 +7531,7 @@
       </p:sp>
       <p:sp>
         <p:nvSpPr>
-          <p:cNvPr id="169" name="Text 166"/>
+          <p:cNvPr id="170" name="Text 167"/>
           <p:cNvSpPr txBox="1"/>
           <p:nvPr/>
         </p:nvSpPr>
@@ -7543,7 +7570,7 @@
       </p:sp>
       <p:sp>
         <p:nvSpPr>
-          <p:cNvPr id="170" name="Text 167"/>
+          <p:cNvPr id="171" name="Text 168"/>
           <p:cNvSpPr txBox="1"/>
           <p:nvPr/>
         </p:nvSpPr>
@@ -7582,7 +7609,7 @@
       </p:sp>
       <p:sp>
         <p:nvSpPr>
-          <p:cNvPr id="171" name="Text 168"/>
+          <p:cNvPr id="172" name="Text 169"/>
           <p:cNvSpPr txBox="1"/>
           <p:nvPr/>
         </p:nvSpPr>
@@ -7621,7 +7648,7 @@
       </p:sp>
       <p:sp>
         <p:nvSpPr>
-          <p:cNvPr id="172" name="Shape 169"/>
+          <p:cNvPr id="173" name="Shape 170"/>
           <p:cNvSpPr/>
           <p:nvPr/>
         </p:nvSpPr>
@@ -7641,7 +7668,7 @@
       </p:sp>
       <p:sp>
         <p:nvSpPr>
-          <p:cNvPr id="173" name="Text 170"/>
+          <p:cNvPr id="174" name="Text 171"/>
           <p:cNvSpPr txBox="1"/>
           <p:nvPr/>
         </p:nvSpPr>
@@ -7680,7 +7707,7 @@
       </p:sp>
       <p:sp>
         <p:nvSpPr>
-          <p:cNvPr id="174" name="Text 171"/>
+          <p:cNvPr id="175" name="Text 172"/>
           <p:cNvSpPr txBox="1"/>
           <p:nvPr/>
         </p:nvSpPr>
@@ -7719,7 +7746,7 @@
       </p:sp>
       <p:sp>
         <p:nvSpPr>
-          <p:cNvPr id="175" name="Text 172"/>
+          <p:cNvPr id="176" name="Text 173"/>
           <p:cNvSpPr txBox="1"/>
           <p:nvPr/>
         </p:nvSpPr>
@@ -7758,7 +7785,7 @@
       </p:sp>
       <p:sp>
         <p:nvSpPr>
-          <p:cNvPr id="176" name="Text 173"/>
+          <p:cNvPr id="177" name="Text 174"/>
           <p:cNvSpPr txBox="1"/>
           <p:nvPr/>
         </p:nvSpPr>
@@ -7797,7 +7824,7 @@
       </p:sp>
       <p:sp>
         <p:nvSpPr>
-          <p:cNvPr id="177" name="Text 174"/>
+          <p:cNvPr id="178" name="Text 175"/>
           <p:cNvSpPr txBox="1"/>
           <p:nvPr/>
         </p:nvSpPr>
@@ -7836,7 +7863,7 @@
       </p:sp>
       <p:sp>
         <p:nvSpPr>
-          <p:cNvPr id="178" name="Text 175"/>
+          <p:cNvPr id="179" name="Text 176"/>
           <p:cNvSpPr txBox="1"/>
           <p:nvPr/>
         </p:nvSpPr>
@@ -7875,7 +7902,7 @@
       </p:sp>
       <p:sp>
         <p:nvSpPr>
-          <p:cNvPr id="179" name="Text 176"/>
+          <p:cNvPr id="180" name="Text 177"/>
           <p:cNvSpPr txBox="1"/>
           <p:nvPr/>
         </p:nvSpPr>
@@ -7914,7 +7941,7 @@
       </p:sp>
       <p:sp>
         <p:nvSpPr>
-          <p:cNvPr id="180" name="Text 177"/>
+          <p:cNvPr id="181" name="Text 178"/>
           <p:cNvSpPr txBox="1"/>
           <p:nvPr/>
         </p:nvSpPr>
@@ -7953,7 +7980,7 @@
       </p:sp>
       <p:sp>
         <p:nvSpPr>
-          <p:cNvPr id="181" name="Text 178"/>
+          <p:cNvPr id="182" name="Text 179"/>
           <p:cNvSpPr txBox="1"/>
           <p:nvPr/>
         </p:nvSpPr>
@@ -7992,7 +8019,7 @@
       </p:sp>
       <p:sp>
         <p:nvSpPr>
-          <p:cNvPr id="182" name="Text 179"/>
+          <p:cNvPr id="183" name="Text 180"/>
           <p:cNvSpPr txBox="1"/>
           <p:nvPr/>
         </p:nvSpPr>
@@ -8031,7 +8058,7 @@
       </p:sp>
       <p:sp>
         <p:nvSpPr>
-          <p:cNvPr id="183" name="Shape 180"/>
+          <p:cNvPr id="184" name="Shape 181"/>
           <p:cNvSpPr/>
           <p:nvPr/>
         </p:nvSpPr>
@@ -8051,7 +8078,7 @@
       </p:sp>
       <p:sp>
         <p:nvSpPr>
-          <p:cNvPr id="184" name="Text 181"/>
+          <p:cNvPr id="185" name="Text 182"/>
           <p:cNvSpPr txBox="1"/>
           <p:nvPr/>
         </p:nvSpPr>
@@ -8090,7 +8117,7 @@
       </p:sp>
       <p:sp>
         <p:nvSpPr>
-          <p:cNvPr id="185" name="Text 182"/>
+          <p:cNvPr id="186" name="Text 183"/>
           <p:cNvSpPr txBox="1"/>
           <p:nvPr/>
         </p:nvSpPr>
@@ -8129,7 +8156,7 @@
       </p:sp>
       <p:sp>
         <p:nvSpPr>
-          <p:cNvPr id="186" name="Text 183"/>
+          <p:cNvPr id="187" name="Text 184"/>
           <p:cNvSpPr txBox="1"/>
           <p:nvPr/>
         </p:nvSpPr>
@@ -8168,7 +8195,7 @@
       </p:sp>
       <p:sp>
         <p:nvSpPr>
-          <p:cNvPr id="187" name="Text 184"/>
+          <p:cNvPr id="188" name="Text 185"/>
           <p:cNvSpPr txBox="1"/>
           <p:nvPr/>
         </p:nvSpPr>
@@ -8207,7 +8234,7 @@
       </p:sp>
       <p:sp>
         <p:nvSpPr>
-          <p:cNvPr id="188" name="Text 185"/>
+          <p:cNvPr id="189" name="Text 186"/>
           <p:cNvSpPr txBox="1"/>
           <p:nvPr/>
         </p:nvSpPr>
@@ -8246,7 +8273,7 @@
       </p:sp>
       <p:sp>
         <p:nvSpPr>
-          <p:cNvPr id="189" name="Text 186"/>
+          <p:cNvPr id="190" name="Text 187"/>
           <p:cNvSpPr txBox="1"/>
           <p:nvPr/>
         </p:nvSpPr>
@@ -8285,7 +8312,7 @@
       </p:sp>
       <p:sp>
         <p:nvSpPr>
-          <p:cNvPr id="190" name="Text 187"/>
+          <p:cNvPr id="191" name="Text 188"/>
           <p:cNvSpPr txBox="1"/>
           <p:nvPr/>
         </p:nvSpPr>
@@ -8324,7 +8351,7 @@
       </p:sp>
       <p:sp>
         <p:nvSpPr>
-          <p:cNvPr id="191" name="Text 188"/>
+          <p:cNvPr id="192" name="Text 189"/>
           <p:cNvSpPr txBox="1"/>
           <p:nvPr/>
         </p:nvSpPr>
@@ -8363,7 +8390,7 @@
       </p:sp>
       <p:sp>
         <p:nvSpPr>
-          <p:cNvPr id="192" name="Text 189"/>
+          <p:cNvPr id="193" name="Text 190"/>
           <p:cNvSpPr txBox="1"/>
           <p:nvPr/>
         </p:nvSpPr>
@@ -8402,7 +8429,7 @@
       </p:sp>
       <p:sp>
         <p:nvSpPr>
-          <p:cNvPr id="193" name="Text 190"/>
+          <p:cNvPr id="194" name="Text 191"/>
           <p:cNvSpPr txBox="1"/>
           <p:nvPr/>
         </p:nvSpPr>
@@ -8441,7 +8468,7 @@
       </p:sp>
       <p:sp>
         <p:nvSpPr>
-          <p:cNvPr id="194" name="Shape 191"/>
+          <p:cNvPr id="195" name="Shape 192"/>
           <p:cNvSpPr/>
           <p:nvPr/>
         </p:nvSpPr>
@@ -8470,7 +8497,7 @@
       </p:sp>
       <p:sp>
         <p:nvSpPr>
-          <p:cNvPr id="195" name="Text 192"/>
+          <p:cNvPr id="196" name="Text 193"/>
           <p:cNvSpPr txBox="1"/>
           <p:nvPr/>
         </p:nvSpPr>
@@ -8509,7 +8536,7 @@
       </p:sp>
       <p:sp>
         <p:nvSpPr>
-          <p:cNvPr id="196" name="Text 193"/>
+          <p:cNvPr id="197" name="Text 194"/>
           <p:cNvSpPr txBox="1"/>
           <p:nvPr/>
         </p:nvSpPr>
@@ -8675,7 +8702,7 @@
       </p:sp>
       <p:sp>
         <p:nvSpPr>
-          <p:cNvPr id="197" name="Shape 194"/>
+          <p:cNvPr id="198" name="Shape 195"/>
           <p:cNvSpPr/>
           <p:nvPr/>
         </p:nvSpPr>
@@ -8697,7 +8724,7 @@
       </p:sp>
       <p:sp>
         <p:nvSpPr>
-          <p:cNvPr id="198" name="Text 195"/>
+          <p:cNvPr id="199" name="Text 196"/>
           <p:cNvSpPr txBox="1"/>
           <p:nvPr/>
         </p:nvSpPr>

</xml_diff>

<commit_message>
PS Economics slide: no flag counts as chargeable; AVC upgrades non-chargeable
- Is Chargeable = No is non-chargeable. Yes, or no flag, is chargeable,
  so it is recognised revenue. Unrecognised PS revenue is now
  non-chargeable hours x $150 only.
- The "No flag" column is gone from the account table and the
  week-on-week table.
- AVC 9.2 Upgrades (ticket 283985380831, 18h, 9 Oct) is treated as
  non-chargeable on the PS lead's say-so; HubSpot still reads Yes. The
  override is recorded in the data file. Q4 hidden work is now 20h /
  $3,000: AVC $2,700, H&L Pay $300.

Co-Authored-By: Claude Opus 5.5 <noreply@anthropic.com>
Claude-Session: https://claude.ai/code/session_01Lq5maWicgiSj2RkHzTdcCm
</commit_message>
<xml_diff>
--- a/exec-deck/output/H&L PS Economics - The Hidden Work - WC 19 Oct 2026.pptx
+++ b/exec-deck/output/H&L PS Economics - The Hidden Work - WC 19 Oct 2026.pptx
@@ -2283,7 +2283,7 @@
                 <a:ea typeface="Poppins" pitchFamily="34" charset="-122"/>
                 <a:cs typeface="Poppins" pitchFamily="34" charset="-120"/>
               </a:rPr>
-              <a:t>3.5h</a:t>
+              <a:t>10.5h</a:t>
             </a:r>
             <a:pPr indent="0" marL="0">
               <a:buNone/>
@@ -2297,7 +2297,7 @@
                 <a:ea typeface="Poppins" pitchFamily="34" charset="-122"/>
                 <a:cs typeface="Poppins" pitchFamily="34" charset="-120"/>
               </a:rPr>
-              <a:t>  30% of billable</a:t>
+              <a:t>  91% of billable</a:t>
             </a:r>
             <a:endParaRPr lang="en-US" sz="2000" dirty="0"/>
           </a:p>
@@ -2336,7 +2336,7 @@
                 <a:ea typeface="Poppins" pitchFamily="34" charset="-122"/>
                 <a:cs typeface="Poppins" pitchFamily="34" charset="-120"/>
               </a:rPr>
-              <a:t>▼ from 12.5h (25%) last week</a:t>
+              <a:t>▼ from 50.0h (98%) last week</a:t>
             </a:r>
             <a:endParaRPr lang="en-US" sz="650" dirty="0"/>
           </a:p>
@@ -3029,7 +3029,7 @@
         <p:spPr>
           <a:xfrm>
             <a:off x="594360" y="5294376"/>
-            <a:ext cx="777240" cy="146304"/>
+            <a:ext cx="822960" cy="146304"/>
           </a:xfrm>
           <a:prstGeom prst="rect">
             <a:avLst/>
@@ -3067,8 +3067,8 @@
         </p:nvSpPr>
         <p:spPr>
           <a:xfrm>
-            <a:off x="1371600" y="5294376"/>
-            <a:ext cx="594360" cy="146304"/>
+            <a:off x="1463040" y="5294376"/>
+            <a:ext cx="640080" cy="146304"/>
           </a:xfrm>
           <a:prstGeom prst="rect">
             <a:avLst/>
@@ -3106,8 +3106,8 @@
         </p:nvSpPr>
         <p:spPr>
           <a:xfrm>
-            <a:off x="2011680" y="5294376"/>
-            <a:ext cx="685800" cy="146304"/>
+            <a:off x="2194560" y="5294376"/>
+            <a:ext cx="731520" cy="146304"/>
           </a:xfrm>
           <a:prstGeom prst="rect">
             <a:avLst/>
@@ -3145,8 +3145,8 @@
         </p:nvSpPr>
         <p:spPr>
           <a:xfrm>
-            <a:off x="2743200" y="5294376"/>
-            <a:ext cx="640080" cy="146304"/>
+            <a:off x="3017520" y="5294376"/>
+            <a:ext cx="868680" cy="146304"/>
           </a:xfrm>
           <a:prstGeom prst="rect">
             <a:avLst/>
@@ -3170,7 +3170,7 @@
                 <a:ea typeface="Poppins" pitchFamily="34" charset="-122"/>
                 <a:cs typeface="Poppins" pitchFamily="34" charset="-120"/>
               </a:rPr>
-              <a:t>NON-CHARG.</a:t>
+              <a:t>NON-CHARGEABLE</a:t>
             </a:r>
             <a:endParaRPr lang="en-US" sz="580" dirty="0"/>
           </a:p>
@@ -3179,45 +3179,6 @@
       <p:sp>
         <p:nvSpPr>
           <p:cNvPr id="53" name="Text 50"/>
-          <p:cNvSpPr txBox="1"/>
-          <p:nvPr/>
-        </p:nvSpPr>
-        <p:spPr>
-          <a:xfrm>
-            <a:off x="3429000" y="5294376"/>
-            <a:ext cx="457200" cy="146304"/>
-          </a:xfrm>
-          <a:prstGeom prst="rect">
-            <a:avLst/>
-          </a:prstGeom>
-          <a:noFill/>
-          <a:ln/>
-        </p:spPr>
-        <p:txBody>
-          <a:bodyPr wrap="square" lIns="0" tIns="0" rIns="0" bIns="0" rtlCol="0" anchor="ctr"/>
-          <a:lstStyle/>
-          <a:p>
-            <a:pPr algn="r" indent="0" marL="0">
-              <a:buNone/>
-            </a:pPr>
-            <a:r>
-              <a:rPr lang="en-US" sz="580" b="1" dirty="0">
-                <a:solidFill>
-                  <a:srgbClr val="8FA1AC"/>
-                </a:solidFill>
-                <a:latin typeface="Poppins" pitchFamily="34" charset="0"/>
-                <a:ea typeface="Poppins" pitchFamily="34" charset="-122"/>
-                <a:cs typeface="Poppins" pitchFamily="34" charset="-120"/>
-              </a:rPr>
-              <a:t>NO FLAG</a:t>
-            </a:r>
-            <a:endParaRPr lang="en-US" sz="580" dirty="0"/>
-          </a:p>
-        </p:txBody>
-      </p:sp>
-      <p:sp>
-        <p:nvSpPr>
-          <p:cNvPr id="54" name="Text 51"/>
           <p:cNvSpPr txBox="1"/>
           <p:nvPr/>
         </p:nvSpPr>
@@ -3256,7 +3217,7 @@
       </p:sp>
       <p:sp>
         <p:nvSpPr>
-          <p:cNvPr id="55" name="Text 52"/>
+          <p:cNvPr id="54" name="Text 51"/>
           <p:cNvSpPr txBox="1"/>
           <p:nvPr/>
         </p:nvSpPr>
@@ -3295,38 +3256,116 @@
       </p:sp>
       <p:sp>
         <p:nvSpPr>
+          <p:cNvPr id="55" name="Text 52"/>
+          <p:cNvSpPr txBox="1"/>
+          <p:nvPr/>
+        </p:nvSpPr>
+        <p:spPr>
+          <a:xfrm>
+            <a:off x="594360" y="5458968"/>
+            <a:ext cx="822960" cy="237744"/>
+          </a:xfrm>
+          <a:prstGeom prst="rect">
+            <a:avLst/>
+          </a:prstGeom>
+          <a:noFill/>
+          <a:ln/>
+        </p:spPr>
+        <p:txBody>
+          <a:bodyPr wrap="square" lIns="0" tIns="0" rIns="0" bIns="0" rtlCol="0" anchor="ctr"/>
+          <a:lstStyle/>
+          <a:p>
+            <a:pPr algn="l" indent="0" marL="0">
+              <a:buNone/>
+            </a:pPr>
+            <a:r>
+              <a:rPr lang="en-US" sz="780" b="1" dirty="0">
+                <a:solidFill>
+                  <a:srgbClr val="12293A"/>
+                </a:solidFill>
+                <a:latin typeface="Poppins" pitchFamily="34" charset="0"/>
+                <a:ea typeface="Poppins" pitchFamily="34" charset="-122"/>
+                <a:cs typeface="Poppins" pitchFamily="34" charset="-120"/>
+              </a:rPr>
+              <a:t>5–11 Oct</a:t>
+            </a:r>
+            <a:endParaRPr lang="en-US" sz="780" dirty="0"/>
+          </a:p>
+        </p:txBody>
+      </p:sp>
+      <p:sp>
+        <p:nvSpPr>
           <p:cNvPr id="56" name="Text 53"/>
           <p:cNvSpPr txBox="1"/>
           <p:nvPr/>
         </p:nvSpPr>
         <p:spPr>
           <a:xfrm>
-            <a:off x="594360" y="5458968"/>
-            <a:ext cx="777240" cy="237744"/>
-          </a:xfrm>
-          <a:prstGeom prst="rect">
-            <a:avLst/>
-          </a:prstGeom>
-          <a:noFill/>
-          <a:ln/>
-        </p:spPr>
-        <p:txBody>
-          <a:bodyPr wrap="square" lIns="0" tIns="0" rIns="0" bIns="0" rtlCol="0" anchor="ctr"/>
-          <a:lstStyle/>
-          <a:p>
-            <a:pPr algn="l" indent="0" marL="0">
+            <a:off x="1463040" y="5458968"/>
+            <a:ext cx="640080" cy="237744"/>
+          </a:xfrm>
+          <a:prstGeom prst="rect">
+            <a:avLst/>
+          </a:prstGeom>
+          <a:noFill/>
+          <a:ln/>
+        </p:spPr>
+        <p:txBody>
+          <a:bodyPr wrap="square" lIns="0" tIns="0" rIns="0" bIns="0" rtlCol="0" anchor="ctr"/>
+          <a:lstStyle/>
+          <a:p>
+            <a:pPr algn="r" indent="0" marL="0">
               <a:buNone/>
             </a:pPr>
             <a:r>
               <a:rPr lang="en-US" sz="780" b="1" dirty="0">
                 <a:solidFill>
+                  <a:srgbClr val="2C8394"/>
+                </a:solidFill>
+                <a:latin typeface="Poppins" pitchFamily="34" charset="0"/>
+                <a:ea typeface="Poppins" pitchFamily="34" charset="-122"/>
+                <a:cs typeface="Poppins" pitchFamily="34" charset="-120"/>
+              </a:rPr>
+              <a:t>35.3h</a:t>
+            </a:r>
+            <a:endParaRPr lang="en-US" sz="780" dirty="0"/>
+          </a:p>
+        </p:txBody>
+      </p:sp>
+      <p:sp>
+        <p:nvSpPr>
+          <p:cNvPr id="57" name="Text 54"/>
+          <p:cNvSpPr txBox="1"/>
+          <p:nvPr/>
+        </p:nvSpPr>
+        <p:spPr>
+          <a:xfrm>
+            <a:off x="2194560" y="5458968"/>
+            <a:ext cx="731520" cy="237744"/>
+          </a:xfrm>
+          <a:prstGeom prst="rect">
+            <a:avLst/>
+          </a:prstGeom>
+          <a:noFill/>
+          <a:ln/>
+        </p:spPr>
+        <p:txBody>
+          <a:bodyPr wrap="square" lIns="0" tIns="0" rIns="0" bIns="0" rtlCol="0" anchor="ctr"/>
+          <a:lstStyle/>
+          <a:p>
+            <a:pPr algn="r" indent="0" marL="0">
+              <a:buNone/>
+            </a:pPr>
+            <a:r>
+              <a:rPr lang="en-US" sz="780" dirty="0">
+                <a:solidFill>
                   <a:srgbClr val="12293A"/>
                 </a:solidFill>
                 <a:latin typeface="Poppins" pitchFamily="34" charset="0"/>
                 <a:ea typeface="Poppins" pitchFamily="34" charset="-122"/>
                 <a:cs typeface="Poppins" pitchFamily="34" charset="-120"/>
               </a:rPr>
-              <a:t>5–11 Oct</a:t>
+              <a:t>17.3h</a:t>
             </a:r>
             <a:endParaRPr lang="en-US" sz="780" dirty="0"/>
           </a:p>
@@ -3334,14 +3373,14 @@
       </p:sp>
       <p:sp>
         <p:nvSpPr>
-          <p:cNvPr id="57" name="Text 54"/>
-          <p:cNvSpPr txBox="1"/>
-          <p:nvPr/>
-        </p:nvSpPr>
-        <p:spPr>
-          <a:xfrm>
-            <a:off x="1371600" y="5458968"/>
-            <a:ext cx="594360" cy="237744"/>
+          <p:cNvPr id="58" name="Text 55"/>
+          <p:cNvSpPr txBox="1"/>
+          <p:nvPr/>
+        </p:nvSpPr>
+        <p:spPr>
+          <a:xfrm>
+            <a:off x="3017520" y="5458968"/>
+            <a:ext cx="868680" cy="237744"/>
           </a:xfrm>
           <a:prstGeom prst="rect">
             <a:avLst/>
@@ -3359,13 +3398,13 @@
             <a:r>
               <a:rPr lang="en-US" sz="780" b="1" dirty="0">
                 <a:solidFill>
-                  <a:srgbClr val="2C8394"/>
-                </a:solidFill>
-                <a:latin typeface="Poppins" pitchFamily="34" charset="0"/>
-                <a:ea typeface="Poppins" pitchFamily="34" charset="-122"/>
-                <a:cs typeface="Poppins" pitchFamily="34" charset="-120"/>
-              </a:rPr>
-              <a:t>35.3h</a:t>
+                  <a:srgbClr val="B4552D"/>
+                </a:solidFill>
+                <a:latin typeface="Poppins" pitchFamily="34" charset="0"/>
+                <a:ea typeface="Poppins" pitchFamily="34" charset="-122"/>
+                <a:cs typeface="Poppins" pitchFamily="34" charset="-120"/>
+              </a:rPr>
+              <a:t>18.0h</a:t>
             </a:r>
             <a:endParaRPr lang="en-US" sz="780" dirty="0"/>
           </a:p>
@@ -3373,124 +3412,7 @@
       </p:sp>
       <p:sp>
         <p:nvSpPr>
-          <p:cNvPr id="58" name="Text 55"/>
-          <p:cNvSpPr txBox="1"/>
-          <p:nvPr/>
-        </p:nvSpPr>
-        <p:spPr>
-          <a:xfrm>
-            <a:off x="2011680" y="5458968"/>
-            <a:ext cx="685800" cy="237744"/>
-          </a:xfrm>
-          <a:prstGeom prst="rect">
-            <a:avLst/>
-          </a:prstGeom>
-          <a:noFill/>
-          <a:ln/>
-        </p:spPr>
-        <p:txBody>
-          <a:bodyPr wrap="square" lIns="0" tIns="0" rIns="0" bIns="0" rtlCol="0" anchor="ctr"/>
-          <a:lstStyle/>
-          <a:p>
-            <a:pPr algn="r" indent="0" marL="0">
-              <a:buNone/>
-            </a:pPr>
-            <a:r>
-              <a:rPr lang="en-US" sz="780" dirty="0">
-                <a:solidFill>
-                  <a:srgbClr val="12293A"/>
-                </a:solidFill>
-                <a:latin typeface="Poppins" pitchFamily="34" charset="0"/>
-                <a:ea typeface="Poppins" pitchFamily="34" charset="-122"/>
-                <a:cs typeface="Poppins" pitchFamily="34" charset="-120"/>
-              </a:rPr>
-              <a:t>19.0h</a:t>
-            </a:r>
-            <a:endParaRPr lang="en-US" sz="780" dirty="0"/>
-          </a:p>
-        </p:txBody>
-      </p:sp>
-      <p:sp>
-        <p:nvSpPr>
           <p:cNvPr id="59" name="Text 56"/>
-          <p:cNvSpPr txBox="1"/>
-          <p:nvPr/>
-        </p:nvSpPr>
-        <p:spPr>
-          <a:xfrm>
-            <a:off x="2743200" y="5458968"/>
-            <a:ext cx="640080" cy="237744"/>
-          </a:xfrm>
-          <a:prstGeom prst="rect">
-            <a:avLst/>
-          </a:prstGeom>
-          <a:noFill/>
-          <a:ln/>
-        </p:spPr>
-        <p:txBody>
-          <a:bodyPr wrap="square" lIns="0" tIns="0" rIns="0" bIns="0" rtlCol="0" anchor="ctr"/>
-          <a:lstStyle/>
-          <a:p>
-            <a:pPr algn="r" indent="0" marL="0">
-              <a:buNone/>
-            </a:pPr>
-            <a:r>
-              <a:rPr lang="en-US" sz="780" dirty="0">
-                <a:solidFill>
-                  <a:srgbClr val="8FA1AC"/>
-                </a:solidFill>
-                <a:latin typeface="Poppins" pitchFamily="34" charset="0"/>
-                <a:ea typeface="Poppins" pitchFamily="34" charset="-122"/>
-                <a:cs typeface="Poppins" pitchFamily="34" charset="-120"/>
-              </a:rPr>
-              <a:t>—</a:t>
-            </a:r>
-            <a:endParaRPr lang="en-US" sz="780" dirty="0"/>
-          </a:p>
-        </p:txBody>
-      </p:sp>
-      <p:sp>
-        <p:nvSpPr>
-          <p:cNvPr id="60" name="Text 57"/>
-          <p:cNvSpPr txBox="1"/>
-          <p:nvPr/>
-        </p:nvSpPr>
-        <p:spPr>
-          <a:xfrm>
-            <a:off x="3429000" y="5458968"/>
-            <a:ext cx="457200" cy="237744"/>
-          </a:xfrm>
-          <a:prstGeom prst="rect">
-            <a:avLst/>
-          </a:prstGeom>
-          <a:noFill/>
-          <a:ln/>
-        </p:spPr>
-        <p:txBody>
-          <a:bodyPr wrap="square" lIns="0" tIns="0" rIns="0" bIns="0" rtlCol="0" anchor="ctr"/>
-          <a:lstStyle/>
-          <a:p>
-            <a:pPr algn="r" indent="0" marL="0">
-              <a:buNone/>
-            </a:pPr>
-            <a:r>
-              <a:rPr lang="en-US" sz="780" dirty="0">
-                <a:solidFill>
-                  <a:srgbClr val="C88A2E"/>
-                </a:solidFill>
-                <a:latin typeface="Poppins" pitchFamily="34" charset="0"/>
-                <a:ea typeface="Poppins" pitchFamily="34" charset="-122"/>
-                <a:cs typeface="Poppins" pitchFamily="34" charset="-120"/>
-              </a:rPr>
-              <a:t>16.3h</a:t>
-            </a:r>
-            <a:endParaRPr lang="en-US" sz="780" dirty="0"/>
-          </a:p>
-        </p:txBody>
-      </p:sp>
-      <p:sp>
-        <p:nvSpPr>
-          <p:cNvPr id="61" name="Text 58"/>
           <p:cNvSpPr txBox="1"/>
           <p:nvPr/>
         </p:nvSpPr>
@@ -3529,7 +3451,7 @@
       </p:sp>
       <p:sp>
         <p:nvSpPr>
-          <p:cNvPr id="62" name="Text 59"/>
+          <p:cNvPr id="60" name="Text 57"/>
           <p:cNvSpPr txBox="1"/>
           <p:nvPr/>
         </p:nvSpPr>
@@ -3568,7 +3490,7 @@
       </p:sp>
       <p:sp>
         <p:nvSpPr>
-          <p:cNvPr id="63" name="Shape 60"/>
+          <p:cNvPr id="61" name="Shape 58"/>
           <p:cNvSpPr/>
           <p:nvPr/>
         </p:nvSpPr>
@@ -3588,38 +3510,155 @@
       </p:sp>
       <p:sp>
         <p:nvSpPr>
+          <p:cNvPr id="62" name="Text 59"/>
+          <p:cNvSpPr txBox="1"/>
+          <p:nvPr/>
+        </p:nvSpPr>
+        <p:spPr>
+          <a:xfrm>
+            <a:off x="594360" y="5696712"/>
+            <a:ext cx="822960" cy="237744"/>
+          </a:xfrm>
+          <a:prstGeom prst="rect">
+            <a:avLst/>
+          </a:prstGeom>
+          <a:noFill/>
+          <a:ln/>
+        </p:spPr>
+        <p:txBody>
+          <a:bodyPr wrap="square" lIns="0" tIns="0" rIns="0" bIns="0" rtlCol="0" anchor="ctr"/>
+          <a:lstStyle/>
+          <a:p>
+            <a:pPr algn="l" indent="0" marL="0">
+              <a:buNone/>
+            </a:pPr>
+            <a:r>
+              <a:rPr lang="en-US" sz="780" b="1" dirty="0">
+                <a:solidFill>
+                  <a:srgbClr val="12293A"/>
+                </a:solidFill>
+                <a:latin typeface="Poppins" pitchFamily="34" charset="0"/>
+                <a:ea typeface="Poppins" pitchFamily="34" charset="-122"/>
+                <a:cs typeface="Poppins" pitchFamily="34" charset="-120"/>
+              </a:rPr>
+              <a:t>12–18 Oct</a:t>
+            </a:r>
+            <a:endParaRPr lang="en-US" sz="780" dirty="0"/>
+          </a:p>
+        </p:txBody>
+      </p:sp>
+      <p:sp>
+        <p:nvSpPr>
+          <p:cNvPr id="63" name="Text 60"/>
+          <p:cNvSpPr txBox="1"/>
+          <p:nvPr/>
+        </p:nvSpPr>
+        <p:spPr>
+          <a:xfrm>
+            <a:off x="1463040" y="5696712"/>
+            <a:ext cx="640080" cy="237744"/>
+          </a:xfrm>
+          <a:prstGeom prst="rect">
+            <a:avLst/>
+          </a:prstGeom>
+          <a:noFill/>
+          <a:ln/>
+        </p:spPr>
+        <p:txBody>
+          <a:bodyPr wrap="square" lIns="0" tIns="0" rIns="0" bIns="0" rtlCol="0" anchor="ctr"/>
+          <a:lstStyle/>
+          <a:p>
+            <a:pPr algn="r" indent="0" marL="0">
+              <a:buNone/>
+            </a:pPr>
+            <a:r>
+              <a:rPr lang="en-US" sz="780" b="1" dirty="0">
+                <a:solidFill>
+                  <a:srgbClr val="2C8394"/>
+                </a:solidFill>
+                <a:latin typeface="Poppins" pitchFamily="34" charset="0"/>
+                <a:ea typeface="Poppins" pitchFamily="34" charset="-122"/>
+                <a:cs typeface="Poppins" pitchFamily="34" charset="-120"/>
+              </a:rPr>
+              <a:t>51.0h</a:t>
+            </a:r>
+            <a:endParaRPr lang="en-US" sz="780" dirty="0"/>
+          </a:p>
+        </p:txBody>
+      </p:sp>
+      <p:sp>
+        <p:nvSpPr>
           <p:cNvPr id="64" name="Text 61"/>
           <p:cNvSpPr txBox="1"/>
           <p:nvPr/>
         </p:nvSpPr>
         <p:spPr>
           <a:xfrm>
-            <a:off x="594360" y="5696712"/>
-            <a:ext cx="777240" cy="237744"/>
-          </a:xfrm>
-          <a:prstGeom prst="rect">
-            <a:avLst/>
-          </a:prstGeom>
-          <a:noFill/>
-          <a:ln/>
-        </p:spPr>
-        <p:txBody>
-          <a:bodyPr wrap="square" lIns="0" tIns="0" rIns="0" bIns="0" rtlCol="0" anchor="ctr"/>
-          <a:lstStyle/>
-          <a:p>
-            <a:pPr algn="l" indent="0" marL="0">
+            <a:off x="2194560" y="5696712"/>
+            <a:ext cx="731520" cy="237744"/>
+          </a:xfrm>
+          <a:prstGeom prst="rect">
+            <a:avLst/>
+          </a:prstGeom>
+          <a:noFill/>
+          <a:ln/>
+        </p:spPr>
+        <p:txBody>
+          <a:bodyPr wrap="square" lIns="0" tIns="0" rIns="0" bIns="0" rtlCol="0" anchor="ctr"/>
+          <a:lstStyle/>
+          <a:p>
+            <a:pPr algn="r" indent="0" marL="0">
+              <a:buNone/>
+            </a:pPr>
+            <a:r>
+              <a:rPr lang="en-US" sz="780" dirty="0">
+                <a:solidFill>
+                  <a:srgbClr val="12293A"/>
+                </a:solidFill>
+                <a:latin typeface="Poppins" pitchFamily="34" charset="0"/>
+                <a:ea typeface="Poppins" pitchFamily="34" charset="-122"/>
+                <a:cs typeface="Poppins" pitchFamily="34" charset="-120"/>
+              </a:rPr>
+              <a:t>50.0h</a:t>
+            </a:r>
+            <a:endParaRPr lang="en-US" sz="780" dirty="0"/>
+          </a:p>
+        </p:txBody>
+      </p:sp>
+      <p:sp>
+        <p:nvSpPr>
+          <p:cNvPr id="65" name="Text 62"/>
+          <p:cNvSpPr txBox="1"/>
+          <p:nvPr/>
+        </p:nvSpPr>
+        <p:spPr>
+          <a:xfrm>
+            <a:off x="3017520" y="5696712"/>
+            <a:ext cx="868680" cy="237744"/>
+          </a:xfrm>
+          <a:prstGeom prst="rect">
+            <a:avLst/>
+          </a:prstGeom>
+          <a:noFill/>
+          <a:ln/>
+        </p:spPr>
+        <p:txBody>
+          <a:bodyPr wrap="square" lIns="0" tIns="0" rIns="0" bIns="0" rtlCol="0" anchor="ctr"/>
+          <a:lstStyle/>
+          <a:p>
+            <a:pPr algn="r" indent="0" marL="0">
               <a:buNone/>
             </a:pPr>
             <a:r>
               <a:rPr lang="en-US" sz="780" b="1" dirty="0">
                 <a:solidFill>
-                  <a:srgbClr val="12293A"/>
-                </a:solidFill>
-                <a:latin typeface="Poppins" pitchFamily="34" charset="0"/>
-                <a:ea typeface="Poppins" pitchFamily="34" charset="-122"/>
-                <a:cs typeface="Poppins" pitchFamily="34" charset="-120"/>
-              </a:rPr>
-              <a:t>12–18 Oct</a:t>
+                  <a:srgbClr val="B4552D"/>
+                </a:solidFill>
+                <a:latin typeface="Poppins" pitchFamily="34" charset="0"/>
+                <a:ea typeface="Poppins" pitchFamily="34" charset="-122"/>
+                <a:cs typeface="Poppins" pitchFamily="34" charset="-120"/>
+              </a:rPr>
+              <a:t>1.0h</a:t>
             </a:r>
             <a:endParaRPr lang="en-US" sz="780" dirty="0"/>
           </a:p>
@@ -3627,163 +3666,7 @@
       </p:sp>
       <p:sp>
         <p:nvSpPr>
-          <p:cNvPr id="65" name="Text 62"/>
-          <p:cNvSpPr txBox="1"/>
-          <p:nvPr/>
-        </p:nvSpPr>
-        <p:spPr>
-          <a:xfrm>
-            <a:off x="1371600" y="5696712"/>
-            <a:ext cx="594360" cy="237744"/>
-          </a:xfrm>
-          <a:prstGeom prst="rect">
-            <a:avLst/>
-          </a:prstGeom>
-          <a:noFill/>
-          <a:ln/>
-        </p:spPr>
-        <p:txBody>
-          <a:bodyPr wrap="square" lIns="0" tIns="0" rIns="0" bIns="0" rtlCol="0" anchor="ctr"/>
-          <a:lstStyle/>
-          <a:p>
-            <a:pPr algn="r" indent="0" marL="0">
-              <a:buNone/>
-            </a:pPr>
-            <a:r>
-              <a:rPr lang="en-US" sz="780" b="1" dirty="0">
-                <a:solidFill>
-                  <a:srgbClr val="2C8394"/>
-                </a:solidFill>
-                <a:latin typeface="Poppins" pitchFamily="34" charset="0"/>
-                <a:ea typeface="Poppins" pitchFamily="34" charset="-122"/>
-                <a:cs typeface="Poppins" pitchFamily="34" charset="-120"/>
-              </a:rPr>
-              <a:t>51.0h</a:t>
-            </a:r>
-            <a:endParaRPr lang="en-US" sz="780" dirty="0"/>
-          </a:p>
-        </p:txBody>
-      </p:sp>
-      <p:sp>
-        <p:nvSpPr>
           <p:cNvPr id="66" name="Text 63"/>
-          <p:cNvSpPr txBox="1"/>
-          <p:nvPr/>
-        </p:nvSpPr>
-        <p:spPr>
-          <a:xfrm>
-            <a:off x="2011680" y="5696712"/>
-            <a:ext cx="685800" cy="237744"/>
-          </a:xfrm>
-          <a:prstGeom prst="rect">
-            <a:avLst/>
-          </a:prstGeom>
-          <a:noFill/>
-          <a:ln/>
-        </p:spPr>
-        <p:txBody>
-          <a:bodyPr wrap="square" lIns="0" tIns="0" rIns="0" bIns="0" rtlCol="0" anchor="ctr"/>
-          <a:lstStyle/>
-          <a:p>
-            <a:pPr algn="r" indent="0" marL="0">
-              <a:buNone/>
-            </a:pPr>
-            <a:r>
-              <a:rPr lang="en-US" sz="780" dirty="0">
-                <a:solidFill>
-                  <a:srgbClr val="12293A"/>
-                </a:solidFill>
-                <a:latin typeface="Poppins" pitchFamily="34" charset="0"/>
-                <a:ea typeface="Poppins" pitchFamily="34" charset="-122"/>
-                <a:cs typeface="Poppins" pitchFamily="34" charset="-120"/>
-              </a:rPr>
-              <a:t>12.5h</a:t>
-            </a:r>
-            <a:endParaRPr lang="en-US" sz="780" dirty="0"/>
-          </a:p>
-        </p:txBody>
-      </p:sp>
-      <p:sp>
-        <p:nvSpPr>
-          <p:cNvPr id="67" name="Text 64"/>
-          <p:cNvSpPr txBox="1"/>
-          <p:nvPr/>
-        </p:nvSpPr>
-        <p:spPr>
-          <a:xfrm>
-            <a:off x="2743200" y="5696712"/>
-            <a:ext cx="640080" cy="237744"/>
-          </a:xfrm>
-          <a:prstGeom prst="rect">
-            <a:avLst/>
-          </a:prstGeom>
-          <a:noFill/>
-          <a:ln/>
-        </p:spPr>
-        <p:txBody>
-          <a:bodyPr wrap="square" lIns="0" tIns="0" rIns="0" bIns="0" rtlCol="0" anchor="ctr"/>
-          <a:lstStyle/>
-          <a:p>
-            <a:pPr algn="r" indent="0" marL="0">
-              <a:buNone/>
-            </a:pPr>
-            <a:r>
-              <a:rPr lang="en-US" sz="780" dirty="0">
-                <a:solidFill>
-                  <a:srgbClr val="12293A"/>
-                </a:solidFill>
-                <a:latin typeface="Poppins" pitchFamily="34" charset="0"/>
-                <a:ea typeface="Poppins" pitchFamily="34" charset="-122"/>
-                <a:cs typeface="Poppins" pitchFamily="34" charset="-120"/>
-              </a:rPr>
-              <a:t>1.0h</a:t>
-            </a:r>
-            <a:endParaRPr lang="en-US" sz="780" dirty="0"/>
-          </a:p>
-        </p:txBody>
-      </p:sp>
-      <p:sp>
-        <p:nvSpPr>
-          <p:cNvPr id="68" name="Text 65"/>
-          <p:cNvSpPr txBox="1"/>
-          <p:nvPr/>
-        </p:nvSpPr>
-        <p:spPr>
-          <a:xfrm>
-            <a:off x="3429000" y="5696712"/>
-            <a:ext cx="457200" cy="237744"/>
-          </a:xfrm>
-          <a:prstGeom prst="rect">
-            <a:avLst/>
-          </a:prstGeom>
-          <a:noFill/>
-          <a:ln/>
-        </p:spPr>
-        <p:txBody>
-          <a:bodyPr wrap="square" lIns="0" tIns="0" rIns="0" bIns="0" rtlCol="0" anchor="ctr"/>
-          <a:lstStyle/>
-          <a:p>
-            <a:pPr algn="r" indent="0" marL="0">
-              <a:buNone/>
-            </a:pPr>
-            <a:r>
-              <a:rPr lang="en-US" sz="780" dirty="0">
-                <a:solidFill>
-                  <a:srgbClr val="C88A2E"/>
-                </a:solidFill>
-                <a:latin typeface="Poppins" pitchFamily="34" charset="0"/>
-                <a:ea typeface="Poppins" pitchFamily="34" charset="-122"/>
-                <a:cs typeface="Poppins" pitchFamily="34" charset="-120"/>
-              </a:rPr>
-              <a:t>37.5h</a:t>
-            </a:r>
-            <a:endParaRPr lang="en-US" sz="780" dirty="0"/>
-          </a:p>
-        </p:txBody>
-      </p:sp>
-      <p:sp>
-        <p:nvSpPr>
-          <p:cNvPr id="69" name="Text 66"/>
           <p:cNvSpPr txBox="1"/>
           <p:nvPr/>
         </p:nvSpPr>
@@ -3822,7 +3705,7 @@
       </p:sp>
       <p:sp>
         <p:nvSpPr>
-          <p:cNvPr id="70" name="Text 67"/>
+          <p:cNvPr id="67" name="Text 64"/>
           <p:cNvSpPr txBox="1"/>
           <p:nvPr/>
         </p:nvSpPr>
@@ -3861,7 +3744,7 @@
       </p:sp>
       <p:sp>
         <p:nvSpPr>
-          <p:cNvPr id="71" name="Shape 68"/>
+          <p:cNvPr id="68" name="Shape 65"/>
           <p:cNvSpPr/>
           <p:nvPr/>
         </p:nvSpPr>
@@ -3881,38 +3764,155 @@
       </p:sp>
       <p:sp>
         <p:nvSpPr>
+          <p:cNvPr id="69" name="Text 66"/>
+          <p:cNvSpPr txBox="1"/>
+          <p:nvPr/>
+        </p:nvSpPr>
+        <p:spPr>
+          <a:xfrm>
+            <a:off x="594360" y="5934456"/>
+            <a:ext cx="822960" cy="237744"/>
+          </a:xfrm>
+          <a:prstGeom prst="rect">
+            <a:avLst/>
+          </a:prstGeom>
+          <a:noFill/>
+          <a:ln/>
+        </p:spPr>
+        <p:txBody>
+          <a:bodyPr wrap="square" lIns="0" tIns="0" rIns="0" bIns="0" rtlCol="0" anchor="ctr"/>
+          <a:lstStyle/>
+          <a:p>
+            <a:pPr algn="l" indent="0" marL="0">
+              <a:buNone/>
+            </a:pPr>
+            <a:r>
+              <a:rPr lang="en-US" sz="780" b="1" dirty="0">
+                <a:solidFill>
+                  <a:srgbClr val="2C8394"/>
+                </a:solidFill>
+                <a:latin typeface="Poppins" pitchFamily="34" charset="0"/>
+                <a:ea typeface="Poppins" pitchFamily="34" charset="-122"/>
+                <a:cs typeface="Poppins" pitchFamily="34" charset="-120"/>
+              </a:rPr>
+              <a:t>19–25 Oct ●</a:t>
+            </a:r>
+            <a:endParaRPr lang="en-US" sz="780" dirty="0"/>
+          </a:p>
+        </p:txBody>
+      </p:sp>
+      <p:sp>
+        <p:nvSpPr>
+          <p:cNvPr id="70" name="Text 67"/>
+          <p:cNvSpPr txBox="1"/>
+          <p:nvPr/>
+        </p:nvSpPr>
+        <p:spPr>
+          <a:xfrm>
+            <a:off x="1463040" y="5934456"/>
+            <a:ext cx="640080" cy="237744"/>
+          </a:xfrm>
+          <a:prstGeom prst="rect">
+            <a:avLst/>
+          </a:prstGeom>
+          <a:noFill/>
+          <a:ln/>
+        </p:spPr>
+        <p:txBody>
+          <a:bodyPr wrap="square" lIns="0" tIns="0" rIns="0" bIns="0" rtlCol="0" anchor="ctr"/>
+          <a:lstStyle/>
+          <a:p>
+            <a:pPr algn="r" indent="0" marL="0">
+              <a:buNone/>
+            </a:pPr>
+            <a:r>
+              <a:rPr lang="en-US" sz="780" b="1" dirty="0">
+                <a:solidFill>
+                  <a:srgbClr val="2C8394"/>
+                </a:solidFill>
+                <a:latin typeface="Poppins" pitchFamily="34" charset="0"/>
+                <a:ea typeface="Poppins" pitchFamily="34" charset="-122"/>
+                <a:cs typeface="Poppins" pitchFamily="34" charset="-120"/>
+              </a:rPr>
+              <a:t>11.5h</a:t>
+            </a:r>
+            <a:endParaRPr lang="en-US" sz="780" dirty="0"/>
+          </a:p>
+        </p:txBody>
+      </p:sp>
+      <p:sp>
+        <p:nvSpPr>
+          <p:cNvPr id="71" name="Text 68"/>
+          <p:cNvSpPr txBox="1"/>
+          <p:nvPr/>
+        </p:nvSpPr>
+        <p:spPr>
+          <a:xfrm>
+            <a:off x="2194560" y="5934456"/>
+            <a:ext cx="731520" cy="237744"/>
+          </a:xfrm>
+          <a:prstGeom prst="rect">
+            <a:avLst/>
+          </a:prstGeom>
+          <a:noFill/>
+          <a:ln/>
+        </p:spPr>
+        <p:txBody>
+          <a:bodyPr wrap="square" lIns="0" tIns="0" rIns="0" bIns="0" rtlCol="0" anchor="ctr"/>
+          <a:lstStyle/>
+          <a:p>
+            <a:pPr algn="r" indent="0" marL="0">
+              <a:buNone/>
+            </a:pPr>
+            <a:r>
+              <a:rPr lang="en-US" sz="780" dirty="0">
+                <a:solidFill>
+                  <a:srgbClr val="12293A"/>
+                </a:solidFill>
+                <a:latin typeface="Poppins" pitchFamily="34" charset="0"/>
+                <a:ea typeface="Poppins" pitchFamily="34" charset="-122"/>
+                <a:cs typeface="Poppins" pitchFamily="34" charset="-120"/>
+              </a:rPr>
+              <a:t>10.5h</a:t>
+            </a:r>
+            <a:endParaRPr lang="en-US" sz="780" dirty="0"/>
+          </a:p>
+        </p:txBody>
+      </p:sp>
+      <p:sp>
+        <p:nvSpPr>
           <p:cNvPr id="72" name="Text 69"/>
           <p:cNvSpPr txBox="1"/>
           <p:nvPr/>
         </p:nvSpPr>
         <p:spPr>
           <a:xfrm>
-            <a:off x="594360" y="5934456"/>
-            <a:ext cx="777240" cy="237744"/>
-          </a:xfrm>
-          <a:prstGeom prst="rect">
-            <a:avLst/>
-          </a:prstGeom>
-          <a:noFill/>
-          <a:ln/>
-        </p:spPr>
-        <p:txBody>
-          <a:bodyPr wrap="square" lIns="0" tIns="0" rIns="0" bIns="0" rtlCol="0" anchor="ctr"/>
-          <a:lstStyle/>
-          <a:p>
-            <a:pPr algn="l" indent="0" marL="0">
+            <a:off x="3017520" y="5934456"/>
+            <a:ext cx="868680" cy="237744"/>
+          </a:xfrm>
+          <a:prstGeom prst="rect">
+            <a:avLst/>
+          </a:prstGeom>
+          <a:noFill/>
+          <a:ln/>
+        </p:spPr>
+        <p:txBody>
+          <a:bodyPr wrap="square" lIns="0" tIns="0" rIns="0" bIns="0" rtlCol="0" anchor="ctr"/>
+          <a:lstStyle/>
+          <a:p>
+            <a:pPr algn="r" indent="0" marL="0">
               <a:buNone/>
             </a:pPr>
             <a:r>
               <a:rPr lang="en-US" sz="780" b="1" dirty="0">
                 <a:solidFill>
-                  <a:srgbClr val="2C8394"/>
-                </a:solidFill>
-                <a:latin typeface="Poppins" pitchFamily="34" charset="0"/>
-                <a:ea typeface="Poppins" pitchFamily="34" charset="-122"/>
-                <a:cs typeface="Poppins" pitchFamily="34" charset="-120"/>
-              </a:rPr>
-              <a:t>19–25 Oct ●</a:t>
+                  <a:srgbClr val="B4552D"/>
+                </a:solidFill>
+                <a:latin typeface="Poppins" pitchFamily="34" charset="0"/>
+                <a:ea typeface="Poppins" pitchFamily="34" charset="-122"/>
+                <a:cs typeface="Poppins" pitchFamily="34" charset="-120"/>
+              </a:rPr>
+              <a:t>1.0h</a:t>
             </a:r>
             <a:endParaRPr lang="en-US" sz="780" dirty="0"/>
           </a:p>
@@ -3921,162 +3921,6 @@
       <p:sp>
         <p:nvSpPr>
           <p:cNvPr id="73" name="Text 70"/>
-          <p:cNvSpPr txBox="1"/>
-          <p:nvPr/>
-        </p:nvSpPr>
-        <p:spPr>
-          <a:xfrm>
-            <a:off x="1371600" y="5934456"/>
-            <a:ext cx="594360" cy="237744"/>
-          </a:xfrm>
-          <a:prstGeom prst="rect">
-            <a:avLst/>
-          </a:prstGeom>
-          <a:noFill/>
-          <a:ln/>
-        </p:spPr>
-        <p:txBody>
-          <a:bodyPr wrap="square" lIns="0" tIns="0" rIns="0" bIns="0" rtlCol="0" anchor="ctr"/>
-          <a:lstStyle/>
-          <a:p>
-            <a:pPr algn="r" indent="0" marL="0">
-              <a:buNone/>
-            </a:pPr>
-            <a:r>
-              <a:rPr lang="en-US" sz="780" b="1" dirty="0">
-                <a:solidFill>
-                  <a:srgbClr val="2C8394"/>
-                </a:solidFill>
-                <a:latin typeface="Poppins" pitchFamily="34" charset="0"/>
-                <a:ea typeface="Poppins" pitchFamily="34" charset="-122"/>
-                <a:cs typeface="Poppins" pitchFamily="34" charset="-120"/>
-              </a:rPr>
-              <a:t>11.5h</a:t>
-            </a:r>
-            <a:endParaRPr lang="en-US" sz="780" dirty="0"/>
-          </a:p>
-        </p:txBody>
-      </p:sp>
-      <p:sp>
-        <p:nvSpPr>
-          <p:cNvPr id="74" name="Text 71"/>
-          <p:cNvSpPr txBox="1"/>
-          <p:nvPr/>
-        </p:nvSpPr>
-        <p:spPr>
-          <a:xfrm>
-            <a:off x="2011680" y="5934456"/>
-            <a:ext cx="685800" cy="237744"/>
-          </a:xfrm>
-          <a:prstGeom prst="rect">
-            <a:avLst/>
-          </a:prstGeom>
-          <a:noFill/>
-          <a:ln/>
-        </p:spPr>
-        <p:txBody>
-          <a:bodyPr wrap="square" lIns="0" tIns="0" rIns="0" bIns="0" rtlCol="0" anchor="ctr"/>
-          <a:lstStyle/>
-          <a:p>
-            <a:pPr algn="r" indent="0" marL="0">
-              <a:buNone/>
-            </a:pPr>
-            <a:r>
-              <a:rPr lang="en-US" sz="780" dirty="0">
-                <a:solidFill>
-                  <a:srgbClr val="12293A"/>
-                </a:solidFill>
-                <a:latin typeface="Poppins" pitchFamily="34" charset="0"/>
-                <a:ea typeface="Poppins" pitchFamily="34" charset="-122"/>
-                <a:cs typeface="Poppins" pitchFamily="34" charset="-120"/>
-              </a:rPr>
-              <a:t>3.5h</a:t>
-            </a:r>
-            <a:endParaRPr lang="en-US" sz="780" dirty="0"/>
-          </a:p>
-        </p:txBody>
-      </p:sp>
-      <p:sp>
-        <p:nvSpPr>
-          <p:cNvPr id="75" name="Text 72"/>
-          <p:cNvSpPr txBox="1"/>
-          <p:nvPr/>
-        </p:nvSpPr>
-        <p:spPr>
-          <a:xfrm>
-            <a:off x="2743200" y="5934456"/>
-            <a:ext cx="640080" cy="237744"/>
-          </a:xfrm>
-          <a:prstGeom prst="rect">
-            <a:avLst/>
-          </a:prstGeom>
-          <a:noFill/>
-          <a:ln/>
-        </p:spPr>
-        <p:txBody>
-          <a:bodyPr wrap="square" lIns="0" tIns="0" rIns="0" bIns="0" rtlCol="0" anchor="ctr"/>
-          <a:lstStyle/>
-          <a:p>
-            <a:pPr algn="r" indent="0" marL="0">
-              <a:buNone/>
-            </a:pPr>
-            <a:r>
-              <a:rPr lang="en-US" sz="780" dirty="0">
-                <a:solidFill>
-                  <a:srgbClr val="12293A"/>
-                </a:solidFill>
-                <a:latin typeface="Poppins" pitchFamily="34" charset="0"/>
-                <a:ea typeface="Poppins" pitchFamily="34" charset="-122"/>
-                <a:cs typeface="Poppins" pitchFamily="34" charset="-120"/>
-              </a:rPr>
-              <a:t>1.0h</a:t>
-            </a:r>
-            <a:endParaRPr lang="en-US" sz="780" dirty="0"/>
-          </a:p>
-        </p:txBody>
-      </p:sp>
-      <p:sp>
-        <p:nvSpPr>
-          <p:cNvPr id="76" name="Text 73"/>
-          <p:cNvSpPr txBox="1"/>
-          <p:nvPr/>
-        </p:nvSpPr>
-        <p:spPr>
-          <a:xfrm>
-            <a:off x="3429000" y="5934456"/>
-            <a:ext cx="457200" cy="237744"/>
-          </a:xfrm>
-          <a:prstGeom prst="rect">
-            <a:avLst/>
-          </a:prstGeom>
-          <a:noFill/>
-          <a:ln/>
-        </p:spPr>
-        <p:txBody>
-          <a:bodyPr wrap="square" lIns="0" tIns="0" rIns="0" bIns="0" rtlCol="0" anchor="ctr"/>
-          <a:lstStyle/>
-          <a:p>
-            <a:pPr algn="r" indent="0" marL="0">
-              <a:buNone/>
-            </a:pPr>
-            <a:r>
-              <a:rPr lang="en-US" sz="780" dirty="0">
-                <a:solidFill>
-                  <a:srgbClr val="C88A2E"/>
-                </a:solidFill>
-                <a:latin typeface="Poppins" pitchFamily="34" charset="0"/>
-                <a:ea typeface="Poppins" pitchFamily="34" charset="-122"/>
-                <a:cs typeface="Poppins" pitchFamily="34" charset="-120"/>
-              </a:rPr>
-              <a:t>7.0h</a:t>
-            </a:r>
-            <a:endParaRPr lang="en-US" sz="780" dirty="0"/>
-          </a:p>
-        </p:txBody>
-      </p:sp>
-      <p:sp>
-        <p:nvSpPr>
-          <p:cNvPr id="77" name="Text 74"/>
           <p:cNvSpPr txBox="1"/>
           <p:nvPr/>
         </p:nvSpPr>
@@ -4115,7 +3959,7 @@
       </p:sp>
       <p:sp>
         <p:nvSpPr>
-          <p:cNvPr id="78" name="Text 75"/>
+          <p:cNvPr id="74" name="Text 71"/>
           <p:cNvSpPr txBox="1"/>
           <p:nvPr/>
         </p:nvSpPr>
@@ -4154,7 +3998,7 @@
       </p:sp>
       <p:sp>
         <p:nvSpPr>
-          <p:cNvPr id="79" name="Shape 76"/>
+          <p:cNvPr id="75" name="Shape 72"/>
           <p:cNvSpPr/>
           <p:nvPr/>
         </p:nvSpPr>
@@ -4183,7 +4027,7 @@
       </p:sp>
       <p:sp>
         <p:nvSpPr>
-          <p:cNvPr id="80" name="Text 77"/>
+          <p:cNvPr id="76" name="Text 73"/>
           <p:cNvSpPr txBox="1"/>
           <p:nvPr/>
         </p:nvSpPr>
@@ -4222,7 +4066,7 @@
       </p:sp>
       <p:sp>
         <p:nvSpPr>
-          <p:cNvPr id="81" name="Text 78"/>
+          <p:cNvPr id="77" name="Text 74"/>
           <p:cNvSpPr txBox="1"/>
           <p:nvPr/>
         </p:nvSpPr>
@@ -4261,7 +4105,7 @@
       </p:sp>
       <p:sp>
         <p:nvSpPr>
-          <p:cNvPr id="82" name="Text 79"/>
+          <p:cNvPr id="78" name="Text 75"/>
           <p:cNvSpPr txBox="1"/>
           <p:nvPr/>
         </p:nvSpPr>
@@ -4300,7 +4144,7 @@
       </p:sp>
       <p:sp>
         <p:nvSpPr>
-          <p:cNvPr id="83" name="Text 80"/>
+          <p:cNvPr id="79" name="Text 76"/>
           <p:cNvSpPr txBox="1"/>
           <p:nvPr/>
         </p:nvSpPr>
@@ -4339,7 +4183,7 @@
       </p:sp>
       <p:sp>
         <p:nvSpPr>
-          <p:cNvPr id="84" name="Text 81"/>
+          <p:cNvPr id="80" name="Text 77"/>
           <p:cNvSpPr txBox="1"/>
           <p:nvPr/>
         </p:nvSpPr>
@@ -4378,7 +4222,7 @@
       </p:sp>
       <p:sp>
         <p:nvSpPr>
-          <p:cNvPr id="85" name="Text 82"/>
+          <p:cNvPr id="81" name="Text 78"/>
           <p:cNvSpPr txBox="1"/>
           <p:nvPr/>
         </p:nvSpPr>
@@ -4417,7 +4261,7 @@
       </p:sp>
       <p:sp>
         <p:nvSpPr>
-          <p:cNvPr id="86" name="Text 83"/>
+          <p:cNvPr id="82" name="Text 79"/>
           <p:cNvSpPr txBox="1"/>
           <p:nvPr/>
         </p:nvSpPr>
@@ -4456,7 +4300,7 @@
       </p:sp>
       <p:sp>
         <p:nvSpPr>
-          <p:cNvPr id="87" name="Text 84"/>
+          <p:cNvPr id="83" name="Text 80"/>
           <p:cNvSpPr txBox="1"/>
           <p:nvPr/>
         </p:nvSpPr>
@@ -4495,7 +4339,7 @@
       </p:sp>
       <p:sp>
         <p:nvSpPr>
-          <p:cNvPr id="88" name="Text 85"/>
+          <p:cNvPr id="84" name="Text 81"/>
           <p:cNvSpPr txBox="1"/>
           <p:nvPr/>
         </p:nvSpPr>
@@ -4534,7 +4378,7 @@
       </p:sp>
       <p:sp>
         <p:nvSpPr>
-          <p:cNvPr id="89" name="Shape 86"/>
+          <p:cNvPr id="85" name="Shape 82"/>
           <p:cNvSpPr/>
           <p:nvPr/>
         </p:nvSpPr>
@@ -4554,7 +4398,7 @@
       </p:sp>
       <p:sp>
         <p:nvSpPr>
-          <p:cNvPr id="90" name="Text 87"/>
+          <p:cNvPr id="86" name="Text 83"/>
           <p:cNvSpPr txBox="1"/>
           <p:nvPr/>
         </p:nvSpPr>
@@ -4593,7 +4437,7 @@
       </p:sp>
       <p:sp>
         <p:nvSpPr>
-          <p:cNvPr id="91" name="Text 88"/>
+          <p:cNvPr id="87" name="Text 84"/>
           <p:cNvSpPr txBox="1"/>
           <p:nvPr/>
         </p:nvSpPr>
@@ -4632,7 +4476,7 @@
       </p:sp>
       <p:sp>
         <p:nvSpPr>
-          <p:cNvPr id="92" name="Text 89"/>
+          <p:cNvPr id="88" name="Text 85"/>
           <p:cNvSpPr txBox="1"/>
           <p:nvPr/>
         </p:nvSpPr>
@@ -4671,7 +4515,7 @@
       </p:sp>
       <p:sp>
         <p:nvSpPr>
-          <p:cNvPr id="93" name="Text 90"/>
+          <p:cNvPr id="89" name="Text 86"/>
           <p:cNvSpPr txBox="1"/>
           <p:nvPr/>
         </p:nvSpPr>
@@ -4710,7 +4554,7 @@
       </p:sp>
       <p:sp>
         <p:nvSpPr>
-          <p:cNvPr id="94" name="Text 91"/>
+          <p:cNvPr id="90" name="Text 87"/>
           <p:cNvSpPr txBox="1"/>
           <p:nvPr/>
         </p:nvSpPr>
@@ -4749,7 +4593,7 @@
       </p:sp>
       <p:sp>
         <p:nvSpPr>
-          <p:cNvPr id="95" name="Text 92"/>
+          <p:cNvPr id="91" name="Text 88"/>
           <p:cNvSpPr txBox="1"/>
           <p:nvPr/>
         </p:nvSpPr>
@@ -4788,7 +4632,7 @@
       </p:sp>
       <p:sp>
         <p:nvSpPr>
-          <p:cNvPr id="96" name="Text 93"/>
+          <p:cNvPr id="92" name="Text 89"/>
           <p:cNvSpPr txBox="1"/>
           <p:nvPr/>
         </p:nvSpPr>
@@ -4827,7 +4671,7 @@
       </p:sp>
       <p:sp>
         <p:nvSpPr>
-          <p:cNvPr id="97" name="Text 94"/>
+          <p:cNvPr id="93" name="Text 90"/>
           <p:cNvSpPr txBox="1"/>
           <p:nvPr/>
         </p:nvSpPr>
@@ -4866,7 +4710,7 @@
       </p:sp>
       <p:sp>
         <p:nvSpPr>
-          <p:cNvPr id="98" name="Shape 95"/>
+          <p:cNvPr id="94" name="Shape 91"/>
           <p:cNvSpPr/>
           <p:nvPr/>
         </p:nvSpPr>
@@ -4886,7 +4730,7 @@
       </p:sp>
       <p:sp>
         <p:nvSpPr>
-          <p:cNvPr id="99" name="Text 96"/>
+          <p:cNvPr id="95" name="Text 92"/>
           <p:cNvSpPr txBox="1"/>
           <p:nvPr/>
         </p:nvSpPr>
@@ -4925,7 +4769,7 @@
       </p:sp>
       <p:sp>
         <p:nvSpPr>
-          <p:cNvPr id="100" name="Text 97"/>
+          <p:cNvPr id="96" name="Text 93"/>
           <p:cNvSpPr txBox="1"/>
           <p:nvPr/>
         </p:nvSpPr>
@@ -4964,7 +4808,7 @@
       </p:sp>
       <p:sp>
         <p:nvSpPr>
-          <p:cNvPr id="101" name="Text 98"/>
+          <p:cNvPr id="97" name="Text 94"/>
           <p:cNvSpPr txBox="1"/>
           <p:nvPr/>
         </p:nvSpPr>
@@ -5003,7 +4847,7 @@
       </p:sp>
       <p:sp>
         <p:nvSpPr>
-          <p:cNvPr id="102" name="Text 99"/>
+          <p:cNvPr id="98" name="Text 95"/>
           <p:cNvSpPr txBox="1"/>
           <p:nvPr/>
         </p:nvSpPr>
@@ -5026,23 +4870,23 @@
               <a:buNone/>
             </a:pPr>
             <a:r>
-              <a:rPr lang="en-US" sz="680" b="1" dirty="0">
-                <a:solidFill>
-                  <a:srgbClr val="B4552D"/>
-                </a:solidFill>
-                <a:latin typeface="Poppins" pitchFamily="34" charset="0"/>
-                <a:ea typeface="Poppins" pitchFamily="34" charset="-122"/>
-                <a:cs typeface="Poppins" pitchFamily="34" charset="-120"/>
-              </a:rPr>
-              <a:t>$150</a:t>
-            </a:r>
-            <a:endParaRPr lang="en-US" sz="680" dirty="0"/>
-          </a:p>
-        </p:txBody>
-      </p:sp>
-      <p:sp>
-        <p:nvSpPr>
-          <p:cNvPr id="103" name="Text 100"/>
+              <a:rPr lang="en-US" sz="680" dirty="0">
+                <a:solidFill>
+                  <a:srgbClr val="8FA1AC"/>
+                </a:solidFill>
+                <a:latin typeface="Poppins" pitchFamily="34" charset="0"/>
+                <a:ea typeface="Poppins" pitchFamily="34" charset="-122"/>
+                <a:cs typeface="Poppins" pitchFamily="34" charset="-120"/>
+              </a:rPr>
+              <a:t>—</a:t>
+            </a:r>
+            <a:endParaRPr lang="en-US" sz="680" dirty="0"/>
+          </a:p>
+        </p:txBody>
+      </p:sp>
+      <p:sp>
+        <p:nvSpPr>
+          <p:cNvPr id="99" name="Text 96"/>
           <p:cNvSpPr txBox="1"/>
           <p:nvPr/>
         </p:nvSpPr>
@@ -5081,7 +4925,7 @@
       </p:sp>
       <p:sp>
         <p:nvSpPr>
-          <p:cNvPr id="104" name="Text 101"/>
+          <p:cNvPr id="100" name="Text 97"/>
           <p:cNvSpPr txBox="1"/>
           <p:nvPr/>
         </p:nvSpPr>
@@ -5120,7 +4964,7 @@
       </p:sp>
       <p:sp>
         <p:nvSpPr>
-          <p:cNvPr id="105" name="Text 102"/>
+          <p:cNvPr id="101" name="Text 98"/>
           <p:cNvSpPr txBox="1"/>
           <p:nvPr/>
         </p:nvSpPr>
@@ -5159,7 +5003,7 @@
       </p:sp>
       <p:sp>
         <p:nvSpPr>
-          <p:cNvPr id="106" name="Text 103"/>
+          <p:cNvPr id="102" name="Text 99"/>
           <p:cNvSpPr txBox="1"/>
           <p:nvPr/>
         </p:nvSpPr>
@@ -5182,23 +5026,23 @@
               <a:buNone/>
             </a:pPr>
             <a:r>
-              <a:rPr lang="en-US" sz="680" b="1" dirty="0">
-                <a:solidFill>
-                  <a:srgbClr val="B4552D"/>
-                </a:solidFill>
-                <a:latin typeface="Poppins" pitchFamily="34" charset="0"/>
-                <a:ea typeface="Poppins" pitchFamily="34" charset="-122"/>
-                <a:cs typeface="Poppins" pitchFamily="34" charset="-120"/>
-              </a:rPr>
-              <a:t>$150</a:t>
-            </a:r>
-            <a:endParaRPr lang="en-US" sz="680" dirty="0"/>
-          </a:p>
-        </p:txBody>
-      </p:sp>
-      <p:sp>
-        <p:nvSpPr>
-          <p:cNvPr id="107" name="Shape 104"/>
+              <a:rPr lang="en-US" sz="680" dirty="0">
+                <a:solidFill>
+                  <a:srgbClr val="8FA1AC"/>
+                </a:solidFill>
+                <a:latin typeface="Poppins" pitchFamily="34" charset="0"/>
+                <a:ea typeface="Poppins" pitchFamily="34" charset="-122"/>
+                <a:cs typeface="Poppins" pitchFamily="34" charset="-120"/>
+              </a:rPr>
+              <a:t>—</a:t>
+            </a:r>
+            <a:endParaRPr lang="en-US" sz="680" dirty="0"/>
+          </a:p>
+        </p:txBody>
+      </p:sp>
+      <p:sp>
+        <p:nvSpPr>
+          <p:cNvPr id="103" name="Shape 100"/>
           <p:cNvSpPr/>
           <p:nvPr/>
         </p:nvSpPr>
@@ -5218,7 +5062,7 @@
       </p:sp>
       <p:sp>
         <p:nvSpPr>
-          <p:cNvPr id="108" name="Text 105"/>
+          <p:cNvPr id="104" name="Text 101"/>
           <p:cNvSpPr txBox="1"/>
           <p:nvPr/>
         </p:nvSpPr>
@@ -5257,7 +5101,7 @@
       </p:sp>
       <p:sp>
         <p:nvSpPr>
-          <p:cNvPr id="109" name="Text 106"/>
+          <p:cNvPr id="105" name="Text 102"/>
           <p:cNvSpPr txBox="1"/>
           <p:nvPr/>
         </p:nvSpPr>
@@ -5296,7 +5140,7 @@
       </p:sp>
       <p:sp>
         <p:nvSpPr>
-          <p:cNvPr id="110" name="Text 107"/>
+          <p:cNvPr id="106" name="Text 103"/>
           <p:cNvSpPr txBox="1"/>
           <p:nvPr/>
         </p:nvSpPr>
@@ -5335,7 +5179,7 @@
       </p:sp>
       <p:sp>
         <p:nvSpPr>
-          <p:cNvPr id="111" name="Text 108"/>
+          <p:cNvPr id="107" name="Text 104"/>
           <p:cNvSpPr txBox="1"/>
           <p:nvPr/>
         </p:nvSpPr>
@@ -5374,7 +5218,7 @@
       </p:sp>
       <p:sp>
         <p:nvSpPr>
-          <p:cNvPr id="112" name="Text 109"/>
+          <p:cNvPr id="108" name="Text 105"/>
           <p:cNvSpPr txBox="1"/>
           <p:nvPr/>
         </p:nvSpPr>
@@ -5413,7 +5257,7 @@
       </p:sp>
       <p:sp>
         <p:nvSpPr>
-          <p:cNvPr id="113" name="Text 110"/>
+          <p:cNvPr id="109" name="Text 106"/>
           <p:cNvSpPr txBox="1"/>
           <p:nvPr/>
         </p:nvSpPr>
@@ -5452,7 +5296,7 @@
       </p:sp>
       <p:sp>
         <p:nvSpPr>
-          <p:cNvPr id="114" name="Text 111"/>
+          <p:cNvPr id="110" name="Text 107"/>
           <p:cNvSpPr txBox="1"/>
           <p:nvPr/>
         </p:nvSpPr>
@@ -5491,7 +5335,7 @@
       </p:sp>
       <p:sp>
         <p:nvSpPr>
-          <p:cNvPr id="115" name="Text 112"/>
+          <p:cNvPr id="111" name="Text 108"/>
           <p:cNvSpPr txBox="1"/>
           <p:nvPr/>
         </p:nvSpPr>
@@ -5530,7 +5374,7 @@
       </p:sp>
       <p:sp>
         <p:nvSpPr>
-          <p:cNvPr id="116" name="Shape 113"/>
+          <p:cNvPr id="112" name="Shape 109"/>
           <p:cNvSpPr/>
           <p:nvPr/>
         </p:nvSpPr>
@@ -5550,7 +5394,7 @@
       </p:sp>
       <p:sp>
         <p:nvSpPr>
-          <p:cNvPr id="117" name="Text 114"/>
+          <p:cNvPr id="113" name="Text 110"/>
           <p:cNvSpPr txBox="1"/>
           <p:nvPr/>
         </p:nvSpPr>
@@ -5589,7 +5433,7 @@
       </p:sp>
       <p:sp>
         <p:nvSpPr>
-          <p:cNvPr id="118" name="Text 115"/>
+          <p:cNvPr id="114" name="Text 111"/>
           <p:cNvSpPr txBox="1"/>
           <p:nvPr/>
         </p:nvSpPr>
@@ -5628,7 +5472,7 @@
       </p:sp>
       <p:sp>
         <p:nvSpPr>
-          <p:cNvPr id="119" name="Text 116"/>
+          <p:cNvPr id="115" name="Text 112"/>
           <p:cNvSpPr txBox="1"/>
           <p:nvPr/>
         </p:nvSpPr>
@@ -5667,7 +5511,7 @@
       </p:sp>
       <p:sp>
         <p:nvSpPr>
-          <p:cNvPr id="120" name="Text 117"/>
+          <p:cNvPr id="116" name="Text 113"/>
           <p:cNvSpPr txBox="1"/>
           <p:nvPr/>
         </p:nvSpPr>
@@ -5690,23 +5534,23 @@
               <a:buNone/>
             </a:pPr>
             <a:r>
-              <a:rPr lang="en-US" sz="680" b="1" dirty="0">
-                <a:solidFill>
-                  <a:srgbClr val="B4552D"/>
-                </a:solidFill>
-                <a:latin typeface="Poppins" pitchFamily="34" charset="0"/>
-                <a:ea typeface="Poppins" pitchFamily="34" charset="-122"/>
-                <a:cs typeface="Poppins" pitchFamily="34" charset="-120"/>
-              </a:rPr>
-              <a:t>$225</a:t>
-            </a:r>
-            <a:endParaRPr lang="en-US" sz="680" dirty="0"/>
-          </a:p>
-        </p:txBody>
-      </p:sp>
-      <p:sp>
-        <p:nvSpPr>
-          <p:cNvPr id="121" name="Text 118"/>
+              <a:rPr lang="en-US" sz="680" dirty="0">
+                <a:solidFill>
+                  <a:srgbClr val="8FA1AC"/>
+                </a:solidFill>
+                <a:latin typeface="Poppins" pitchFamily="34" charset="0"/>
+                <a:ea typeface="Poppins" pitchFamily="34" charset="-122"/>
+                <a:cs typeface="Poppins" pitchFamily="34" charset="-120"/>
+              </a:rPr>
+              <a:t>—</a:t>
+            </a:r>
+            <a:endParaRPr lang="en-US" sz="680" dirty="0"/>
+          </a:p>
+        </p:txBody>
+      </p:sp>
+      <p:sp>
+        <p:nvSpPr>
+          <p:cNvPr id="117" name="Text 114"/>
           <p:cNvSpPr txBox="1"/>
           <p:nvPr/>
         </p:nvSpPr>
@@ -5745,7 +5589,7 @@
       </p:sp>
       <p:sp>
         <p:nvSpPr>
-          <p:cNvPr id="122" name="Text 119"/>
+          <p:cNvPr id="118" name="Text 115"/>
           <p:cNvSpPr txBox="1"/>
           <p:nvPr/>
         </p:nvSpPr>
@@ -5784,7 +5628,7 @@
       </p:sp>
       <p:sp>
         <p:nvSpPr>
-          <p:cNvPr id="123" name="Text 120"/>
+          <p:cNvPr id="119" name="Text 116"/>
           <p:cNvSpPr txBox="1"/>
           <p:nvPr/>
         </p:nvSpPr>
@@ -5823,7 +5667,7 @@
       </p:sp>
       <p:sp>
         <p:nvSpPr>
-          <p:cNvPr id="124" name="Text 121"/>
+          <p:cNvPr id="120" name="Text 117"/>
           <p:cNvSpPr txBox="1"/>
           <p:nvPr/>
         </p:nvSpPr>
@@ -5846,23 +5690,23 @@
               <a:buNone/>
             </a:pPr>
             <a:r>
-              <a:rPr lang="en-US" sz="680" b="1" dirty="0">
-                <a:solidFill>
-                  <a:srgbClr val="B4552D"/>
-                </a:solidFill>
-                <a:latin typeface="Poppins" pitchFamily="34" charset="0"/>
-                <a:ea typeface="Poppins" pitchFamily="34" charset="-122"/>
-                <a:cs typeface="Poppins" pitchFamily="34" charset="-120"/>
-              </a:rPr>
-              <a:t>$167</a:t>
-            </a:r>
-            <a:endParaRPr lang="en-US" sz="680" dirty="0"/>
-          </a:p>
-        </p:txBody>
-      </p:sp>
-      <p:sp>
-        <p:nvSpPr>
-          <p:cNvPr id="125" name="Shape 122"/>
+              <a:rPr lang="en-US" sz="680" dirty="0">
+                <a:solidFill>
+                  <a:srgbClr val="8FA1AC"/>
+                </a:solidFill>
+                <a:latin typeface="Poppins" pitchFamily="34" charset="0"/>
+                <a:ea typeface="Poppins" pitchFamily="34" charset="-122"/>
+                <a:cs typeface="Poppins" pitchFamily="34" charset="-120"/>
+              </a:rPr>
+              <a:t>—</a:t>
+            </a:r>
+            <a:endParaRPr lang="en-US" sz="680" dirty="0"/>
+          </a:p>
+        </p:txBody>
+      </p:sp>
+      <p:sp>
+        <p:nvSpPr>
+          <p:cNvPr id="121" name="Shape 118"/>
           <p:cNvSpPr/>
           <p:nvPr/>
         </p:nvSpPr>
@@ -5882,7 +5726,7 @@
       </p:sp>
       <p:sp>
         <p:nvSpPr>
-          <p:cNvPr id="126" name="Text 123"/>
+          <p:cNvPr id="122" name="Text 119"/>
           <p:cNvSpPr txBox="1"/>
           <p:nvPr/>
         </p:nvSpPr>
@@ -5921,7 +5765,7 @@
       </p:sp>
       <p:sp>
         <p:nvSpPr>
-          <p:cNvPr id="127" name="Text 124"/>
+          <p:cNvPr id="123" name="Text 120"/>
           <p:cNvSpPr txBox="1"/>
           <p:nvPr/>
         </p:nvSpPr>
@@ -5960,7 +5804,7 @@
       </p:sp>
       <p:sp>
         <p:nvSpPr>
-          <p:cNvPr id="128" name="Text 125"/>
+          <p:cNvPr id="124" name="Text 121"/>
           <p:cNvSpPr txBox="1"/>
           <p:nvPr/>
         </p:nvSpPr>
@@ -5999,7 +5843,7 @@
       </p:sp>
       <p:sp>
         <p:nvSpPr>
-          <p:cNvPr id="129" name="Text 126"/>
+          <p:cNvPr id="125" name="Text 122"/>
           <p:cNvSpPr txBox="1"/>
           <p:nvPr/>
         </p:nvSpPr>
@@ -6038,7 +5882,7 @@
       </p:sp>
       <p:sp>
         <p:nvSpPr>
-          <p:cNvPr id="130" name="Text 127"/>
+          <p:cNvPr id="126" name="Text 123"/>
           <p:cNvSpPr txBox="1"/>
           <p:nvPr/>
         </p:nvSpPr>
@@ -6077,7 +5921,7 @@
       </p:sp>
       <p:sp>
         <p:nvSpPr>
-          <p:cNvPr id="131" name="Text 128"/>
+          <p:cNvPr id="127" name="Text 124"/>
           <p:cNvSpPr txBox="1"/>
           <p:nvPr/>
         </p:nvSpPr>
@@ -6116,7 +5960,7 @@
       </p:sp>
       <p:sp>
         <p:nvSpPr>
-          <p:cNvPr id="132" name="Text 129"/>
+          <p:cNvPr id="128" name="Text 125"/>
           <p:cNvSpPr txBox="1"/>
           <p:nvPr/>
         </p:nvSpPr>
@@ -6155,7 +5999,7 @@
       </p:sp>
       <p:sp>
         <p:nvSpPr>
-          <p:cNvPr id="133" name="Text 130"/>
+          <p:cNvPr id="129" name="Text 126"/>
           <p:cNvSpPr txBox="1"/>
           <p:nvPr/>
         </p:nvSpPr>
@@ -6178,23 +6022,23 @@
               <a:buNone/>
             </a:pPr>
             <a:r>
-              <a:rPr lang="en-US" sz="680" b="1" dirty="0">
-                <a:solidFill>
-                  <a:srgbClr val="B4552D"/>
-                </a:solidFill>
-                <a:latin typeface="Poppins" pitchFamily="34" charset="0"/>
-                <a:ea typeface="Poppins" pitchFamily="34" charset="-122"/>
-                <a:cs typeface="Poppins" pitchFamily="34" charset="-120"/>
-              </a:rPr>
-              <a:t>$300</a:t>
-            </a:r>
-            <a:endParaRPr lang="en-US" sz="680" dirty="0"/>
-          </a:p>
-        </p:txBody>
-      </p:sp>
-      <p:sp>
-        <p:nvSpPr>
-          <p:cNvPr id="134" name="Shape 131"/>
+              <a:rPr lang="en-US" sz="680" dirty="0">
+                <a:solidFill>
+                  <a:srgbClr val="8FA1AC"/>
+                </a:solidFill>
+                <a:latin typeface="Poppins" pitchFamily="34" charset="0"/>
+                <a:ea typeface="Poppins" pitchFamily="34" charset="-122"/>
+                <a:cs typeface="Poppins" pitchFamily="34" charset="-120"/>
+              </a:rPr>
+              <a:t>—</a:t>
+            </a:r>
+            <a:endParaRPr lang="en-US" sz="680" dirty="0"/>
+          </a:p>
+        </p:txBody>
+      </p:sp>
+      <p:sp>
+        <p:nvSpPr>
+          <p:cNvPr id="130" name="Shape 127"/>
           <p:cNvSpPr/>
           <p:nvPr/>
         </p:nvSpPr>
@@ -6214,7 +6058,7 @@
       </p:sp>
       <p:sp>
         <p:nvSpPr>
-          <p:cNvPr id="135" name="Text 132"/>
+          <p:cNvPr id="131" name="Text 128"/>
           <p:cNvSpPr txBox="1"/>
           <p:nvPr/>
         </p:nvSpPr>
@@ -6253,7 +6097,7 @@
       </p:sp>
       <p:sp>
         <p:nvSpPr>
-          <p:cNvPr id="136" name="Text 133"/>
+          <p:cNvPr id="132" name="Text 129"/>
           <p:cNvSpPr txBox="1"/>
           <p:nvPr/>
         </p:nvSpPr>
@@ -6292,7 +6136,7 @@
       </p:sp>
       <p:sp>
         <p:nvSpPr>
-          <p:cNvPr id="137" name="Text 134"/>
+          <p:cNvPr id="133" name="Text 130"/>
           <p:cNvSpPr txBox="1"/>
           <p:nvPr/>
         </p:nvSpPr>
@@ -6331,7 +6175,7 @@
       </p:sp>
       <p:sp>
         <p:nvSpPr>
-          <p:cNvPr id="138" name="Text 135"/>
+          <p:cNvPr id="134" name="Text 131"/>
           <p:cNvSpPr txBox="1"/>
           <p:nvPr/>
         </p:nvSpPr>
@@ -6354,23 +6198,23 @@
               <a:buNone/>
             </a:pPr>
             <a:r>
-              <a:rPr lang="en-US" sz="680" b="1" dirty="0">
-                <a:solidFill>
-                  <a:srgbClr val="B4552D"/>
-                </a:solidFill>
-                <a:latin typeface="Poppins" pitchFamily="34" charset="0"/>
-                <a:ea typeface="Poppins" pitchFamily="34" charset="-122"/>
-                <a:cs typeface="Poppins" pitchFamily="34" charset="-120"/>
-              </a:rPr>
-              <a:t>$948</a:t>
-            </a:r>
-            <a:endParaRPr lang="en-US" sz="680" dirty="0"/>
-          </a:p>
-        </p:txBody>
-      </p:sp>
-      <p:sp>
-        <p:nvSpPr>
-          <p:cNvPr id="139" name="Shape 136"/>
+              <a:rPr lang="en-US" sz="680" dirty="0">
+                <a:solidFill>
+                  <a:srgbClr val="8FA1AC"/>
+                </a:solidFill>
+                <a:latin typeface="Poppins" pitchFamily="34" charset="0"/>
+                <a:ea typeface="Poppins" pitchFamily="34" charset="-122"/>
+                <a:cs typeface="Poppins" pitchFamily="34" charset="-120"/>
+              </a:rPr>
+              <a:t>—</a:t>
+            </a:r>
+            <a:endParaRPr lang="en-US" sz="680" dirty="0"/>
+          </a:p>
+        </p:txBody>
+      </p:sp>
+      <p:sp>
+        <p:nvSpPr>
+          <p:cNvPr id="135" name="Shape 132"/>
           <p:cNvSpPr/>
           <p:nvPr/>
         </p:nvSpPr>
@@ -6399,7 +6243,7 @@
       </p:sp>
       <p:sp>
         <p:nvSpPr>
-          <p:cNvPr id="140" name="Text 137"/>
+          <p:cNvPr id="136" name="Text 133"/>
           <p:cNvSpPr txBox="1"/>
           <p:nvPr/>
         </p:nvSpPr>
@@ -6438,7 +6282,7 @@
       </p:sp>
       <p:sp>
         <p:nvSpPr>
-          <p:cNvPr id="141" name="Text 138"/>
+          <p:cNvPr id="137" name="Text 134"/>
           <p:cNvSpPr txBox="1"/>
           <p:nvPr/>
         </p:nvSpPr>
@@ -6477,7 +6321,7 @@
       </p:sp>
       <p:sp>
         <p:nvSpPr>
-          <p:cNvPr id="142" name="Text 139"/>
+          <p:cNvPr id="138" name="Text 135"/>
           <p:cNvSpPr txBox="1"/>
           <p:nvPr/>
         </p:nvSpPr>
@@ -6516,7 +6360,7 @@
       </p:sp>
       <p:sp>
         <p:nvSpPr>
-          <p:cNvPr id="143" name="Text 140"/>
+          <p:cNvPr id="139" name="Text 136"/>
           <p:cNvSpPr txBox="1"/>
           <p:nvPr/>
         </p:nvSpPr>
@@ -6547,7 +6391,7 @@
                 <a:ea typeface="Poppins" pitchFamily="34" charset="-122"/>
                 <a:cs typeface="Poppins" pitchFamily="34" charset="-120"/>
               </a:rPr>
-              <a:t>CHARGED</a:t>
+              <a:t>CHG.</a:t>
             </a:r>
             <a:endParaRPr lang="en-US" sz="560" dirty="0"/>
           </a:p>
@@ -6555,7 +6399,7 @@
       </p:sp>
       <p:sp>
         <p:nvSpPr>
-          <p:cNvPr id="144" name="Text 141"/>
+          <p:cNvPr id="140" name="Text 137"/>
           <p:cNvSpPr txBox="1"/>
           <p:nvPr/>
         </p:nvSpPr>
@@ -6586,7 +6430,7 @@
                 <a:ea typeface="Poppins" pitchFamily="34" charset="-122"/>
                 <a:cs typeface="Poppins" pitchFamily="34" charset="-120"/>
               </a:rPr>
-              <a:t>NO FLAG</a:t>
+              <a:t>NON-CHG.</a:t>
             </a:r>
             <a:endParaRPr lang="en-US" sz="560" dirty="0"/>
           </a:p>
@@ -6594,7 +6438,7 @@
       </p:sp>
       <p:sp>
         <p:nvSpPr>
-          <p:cNvPr id="145" name="Text 142"/>
+          <p:cNvPr id="141" name="Text 138"/>
           <p:cNvSpPr txBox="1"/>
           <p:nvPr/>
         </p:nvSpPr>
@@ -6633,7 +6477,7 @@
       </p:sp>
       <p:sp>
         <p:nvSpPr>
-          <p:cNvPr id="146" name="Text 143"/>
+          <p:cNvPr id="142" name="Text 139"/>
           <p:cNvSpPr txBox="1"/>
           <p:nvPr/>
         </p:nvSpPr>
@@ -6672,7 +6516,7 @@
       </p:sp>
       <p:sp>
         <p:nvSpPr>
-          <p:cNvPr id="147" name="Text 144"/>
+          <p:cNvPr id="143" name="Text 140"/>
           <p:cNvSpPr txBox="1"/>
           <p:nvPr/>
         </p:nvSpPr>
@@ -6711,7 +6555,7 @@
       </p:sp>
       <p:sp>
         <p:nvSpPr>
-          <p:cNvPr id="148" name="Text 145"/>
+          <p:cNvPr id="144" name="Text 141"/>
           <p:cNvSpPr txBox="1"/>
           <p:nvPr/>
         </p:nvSpPr>
@@ -6736,21 +6580,21 @@
             <a:r>
               <a:rPr lang="en-US" sz="680" dirty="0">
                 <a:solidFill>
-                  <a:srgbClr val="3D8F5F"/>
-                </a:solidFill>
-                <a:latin typeface="Poppins" pitchFamily="34" charset="0"/>
-                <a:ea typeface="Poppins" pitchFamily="34" charset="-122"/>
-                <a:cs typeface="Poppins" pitchFamily="34" charset="-120"/>
-              </a:rPr>
-              <a:t>18.0h</a:t>
-            </a:r>
-            <a:endParaRPr lang="en-US" sz="680" dirty="0"/>
-          </a:p>
-        </p:txBody>
-      </p:sp>
-      <p:sp>
-        <p:nvSpPr>
-          <p:cNvPr id="149" name="Text 146"/>
+                  <a:srgbClr val="12293A"/>
+                </a:solidFill>
+                <a:latin typeface="Poppins" pitchFamily="34" charset="0"/>
+                <a:ea typeface="Poppins" pitchFamily="34" charset="-122"/>
+                <a:cs typeface="Poppins" pitchFamily="34" charset="-120"/>
+              </a:rPr>
+              <a:t>3.5h</a:t>
+            </a:r>
+            <a:endParaRPr lang="en-US" sz="680" dirty="0"/>
+          </a:p>
+        </p:txBody>
+      </p:sp>
+      <p:sp>
+        <p:nvSpPr>
+          <p:cNvPr id="145" name="Text 142"/>
           <p:cNvSpPr txBox="1"/>
           <p:nvPr/>
         </p:nvSpPr>
@@ -6773,23 +6617,23 @@
               <a:buNone/>
             </a:pPr>
             <a:r>
-              <a:rPr lang="en-US" sz="680" dirty="0">
-                <a:solidFill>
-                  <a:srgbClr val="C88A2E"/>
-                </a:solidFill>
-                <a:latin typeface="Poppins" pitchFamily="34" charset="0"/>
-                <a:ea typeface="Poppins" pitchFamily="34" charset="-122"/>
-                <a:cs typeface="Poppins" pitchFamily="34" charset="-120"/>
-              </a:rPr>
-              <a:t>3.5h</a:t>
-            </a:r>
-            <a:endParaRPr lang="en-US" sz="680" dirty="0"/>
-          </a:p>
-        </p:txBody>
-      </p:sp>
-      <p:sp>
-        <p:nvSpPr>
-          <p:cNvPr id="150" name="Text 147"/>
+              <a:rPr lang="en-US" sz="680" b="1" dirty="0">
+                <a:solidFill>
+                  <a:srgbClr val="B4552D"/>
+                </a:solidFill>
+                <a:latin typeface="Poppins" pitchFamily="34" charset="0"/>
+                <a:ea typeface="Poppins" pitchFamily="34" charset="-122"/>
+                <a:cs typeface="Poppins" pitchFamily="34" charset="-120"/>
+              </a:rPr>
+              <a:t>18.0h</a:t>
+            </a:r>
+            <a:endParaRPr lang="en-US" sz="680" dirty="0"/>
+          </a:p>
+        </p:txBody>
+      </p:sp>
+      <p:sp>
+        <p:nvSpPr>
+          <p:cNvPr id="146" name="Text 143"/>
           <p:cNvSpPr txBox="1"/>
           <p:nvPr/>
         </p:nvSpPr>
@@ -6820,15 +6664,15 @@
                 <a:ea typeface="Poppins" pitchFamily="34" charset="-122"/>
                 <a:cs typeface="Poppins" pitchFamily="34" charset="-120"/>
               </a:rPr>
-              <a:t>$525</a:t>
-            </a:r>
-            <a:endParaRPr lang="en-US" sz="680" dirty="0"/>
-          </a:p>
-        </p:txBody>
-      </p:sp>
-      <p:sp>
-        <p:nvSpPr>
-          <p:cNvPr id="151" name="Shape 148"/>
+              <a:t>$2,700</a:t>
+            </a:r>
+            <a:endParaRPr lang="en-US" sz="680" dirty="0"/>
+          </a:p>
+        </p:txBody>
+      </p:sp>
+      <p:sp>
+        <p:nvSpPr>
+          <p:cNvPr id="147" name="Shape 144"/>
           <p:cNvSpPr/>
           <p:nvPr/>
         </p:nvSpPr>
@@ -6848,7 +6692,7 @@
       </p:sp>
       <p:sp>
         <p:nvSpPr>
-          <p:cNvPr id="152" name="Text 149"/>
+          <p:cNvPr id="148" name="Text 145"/>
           <p:cNvSpPr txBox="1"/>
           <p:nvPr/>
         </p:nvSpPr>
@@ -6887,7 +6731,7 @@
       </p:sp>
       <p:sp>
         <p:nvSpPr>
-          <p:cNvPr id="153" name="Text 150"/>
+          <p:cNvPr id="149" name="Text 146"/>
           <p:cNvSpPr txBox="1"/>
           <p:nvPr/>
         </p:nvSpPr>
@@ -6926,7 +6770,7 @@
       </p:sp>
       <p:sp>
         <p:nvSpPr>
-          <p:cNvPr id="154" name="Text 151"/>
+          <p:cNvPr id="150" name="Text 147"/>
           <p:cNvSpPr txBox="1"/>
           <p:nvPr/>
         </p:nvSpPr>
@@ -6951,21 +6795,21 @@
             <a:r>
               <a:rPr lang="en-US" sz="680" dirty="0">
                 <a:solidFill>
-                  <a:srgbClr val="3D8F5F"/>
-                </a:solidFill>
-                <a:latin typeface="Poppins" pitchFamily="34" charset="0"/>
-                <a:ea typeface="Poppins" pitchFamily="34" charset="-122"/>
-                <a:cs typeface="Poppins" pitchFamily="34" charset="-120"/>
-              </a:rPr>
-              <a:t>2.5h</a:t>
-            </a:r>
-            <a:endParaRPr lang="en-US" sz="680" dirty="0"/>
-          </a:p>
-        </p:txBody>
-      </p:sp>
-      <p:sp>
-        <p:nvSpPr>
-          <p:cNvPr id="155" name="Text 152"/>
+                  <a:srgbClr val="12293A"/>
+                </a:solidFill>
+                <a:latin typeface="Poppins" pitchFamily="34" charset="0"/>
+                <a:ea typeface="Poppins" pitchFamily="34" charset="-122"/>
+                <a:cs typeface="Poppins" pitchFamily="34" charset="-120"/>
+              </a:rPr>
+              <a:t>7.0h</a:t>
+            </a:r>
+            <a:endParaRPr lang="en-US" sz="680" dirty="0"/>
+          </a:p>
+        </p:txBody>
+      </p:sp>
+      <p:sp>
+        <p:nvSpPr>
+          <p:cNvPr id="151" name="Text 148"/>
           <p:cNvSpPr txBox="1"/>
           <p:nvPr/>
         </p:nvSpPr>
@@ -6990,21 +6834,21 @@
             <a:r>
               <a:rPr lang="en-US" sz="680" dirty="0">
                 <a:solidFill>
-                  <a:srgbClr val="C88A2E"/>
-                </a:solidFill>
-                <a:latin typeface="Poppins" pitchFamily="34" charset="0"/>
-                <a:ea typeface="Poppins" pitchFamily="34" charset="-122"/>
-                <a:cs typeface="Poppins" pitchFamily="34" charset="-120"/>
-              </a:rPr>
-              <a:t>4.5h</a:t>
-            </a:r>
-            <a:endParaRPr lang="en-US" sz="680" dirty="0"/>
-          </a:p>
-        </p:txBody>
-      </p:sp>
-      <p:sp>
-        <p:nvSpPr>
-          <p:cNvPr id="156" name="Text 153"/>
+                  <a:srgbClr val="8FA1AC"/>
+                </a:solidFill>
+                <a:latin typeface="Poppins" pitchFamily="34" charset="0"/>
+                <a:ea typeface="Poppins" pitchFamily="34" charset="-122"/>
+                <a:cs typeface="Poppins" pitchFamily="34" charset="-120"/>
+              </a:rPr>
+              <a:t>—</a:t>
+            </a:r>
+            <a:endParaRPr lang="en-US" sz="680" dirty="0"/>
+          </a:p>
+        </p:txBody>
+      </p:sp>
+      <p:sp>
+        <p:nvSpPr>
+          <p:cNvPr id="152" name="Text 149"/>
           <p:cNvSpPr txBox="1"/>
           <p:nvPr/>
         </p:nvSpPr>
@@ -7027,23 +6871,23 @@
               <a:buNone/>
             </a:pPr>
             <a:r>
-              <a:rPr lang="en-US" sz="680" b="1" dirty="0">
-                <a:solidFill>
-                  <a:srgbClr val="B4552D"/>
-                </a:solidFill>
-                <a:latin typeface="Poppins" pitchFamily="34" charset="0"/>
-                <a:ea typeface="Poppins" pitchFamily="34" charset="-122"/>
-                <a:cs typeface="Poppins" pitchFamily="34" charset="-120"/>
-              </a:rPr>
-              <a:t>$675</a:t>
-            </a:r>
-            <a:endParaRPr lang="en-US" sz="680" dirty="0"/>
-          </a:p>
-        </p:txBody>
-      </p:sp>
-      <p:sp>
-        <p:nvSpPr>
-          <p:cNvPr id="157" name="Text 154"/>
+              <a:rPr lang="en-US" sz="680" dirty="0">
+                <a:solidFill>
+                  <a:srgbClr val="8FA1AC"/>
+                </a:solidFill>
+                <a:latin typeface="Poppins" pitchFamily="34" charset="0"/>
+                <a:ea typeface="Poppins" pitchFamily="34" charset="-122"/>
+                <a:cs typeface="Poppins" pitchFamily="34" charset="-120"/>
+              </a:rPr>
+              <a:t>—</a:t>
+            </a:r>
+            <a:endParaRPr lang="en-US" sz="680" dirty="0"/>
+          </a:p>
+        </p:txBody>
+      </p:sp>
+      <p:sp>
+        <p:nvSpPr>
+          <p:cNvPr id="153" name="Text 150"/>
           <p:cNvSpPr txBox="1"/>
           <p:nvPr/>
         </p:nvSpPr>
@@ -7082,7 +6926,7 @@
       </p:sp>
       <p:sp>
         <p:nvSpPr>
-          <p:cNvPr id="158" name="Text 155"/>
+          <p:cNvPr id="154" name="Text 151"/>
           <p:cNvSpPr txBox="1"/>
           <p:nvPr/>
         </p:nvSpPr>
@@ -7121,7 +6965,7 @@
       </p:sp>
       <p:sp>
         <p:nvSpPr>
-          <p:cNvPr id="159" name="Text 156"/>
+          <p:cNvPr id="155" name="Text 152"/>
           <p:cNvSpPr txBox="1"/>
           <p:nvPr/>
         </p:nvSpPr>
@@ -7146,21 +6990,21 @@
             <a:r>
               <a:rPr lang="en-US" sz="680" dirty="0">
                 <a:solidFill>
-                  <a:srgbClr val="8FA1AC"/>
-                </a:solidFill>
-                <a:latin typeface="Poppins" pitchFamily="34" charset="0"/>
-                <a:ea typeface="Poppins" pitchFamily="34" charset="-122"/>
-                <a:cs typeface="Poppins" pitchFamily="34" charset="-120"/>
-              </a:rPr>
-              <a:t>—</a:t>
-            </a:r>
-            <a:endParaRPr lang="en-US" sz="680" dirty="0"/>
-          </a:p>
-        </p:txBody>
-      </p:sp>
-      <p:sp>
-        <p:nvSpPr>
-          <p:cNvPr id="160" name="Text 157"/>
+                  <a:srgbClr val="12293A"/>
+                </a:solidFill>
+                <a:latin typeface="Poppins" pitchFamily="34" charset="0"/>
+                <a:ea typeface="Poppins" pitchFamily="34" charset="-122"/>
+                <a:cs typeface="Poppins" pitchFamily="34" charset="-120"/>
+              </a:rPr>
+              <a:t>3.5h</a:t>
+            </a:r>
+            <a:endParaRPr lang="en-US" sz="680" dirty="0"/>
+          </a:p>
+        </p:txBody>
+      </p:sp>
+      <p:sp>
+        <p:nvSpPr>
+          <p:cNvPr id="156" name="Text 153"/>
           <p:cNvSpPr txBox="1"/>
           <p:nvPr/>
         </p:nvSpPr>
@@ -7185,21 +7029,21 @@
             <a:r>
               <a:rPr lang="en-US" sz="680" dirty="0">
                 <a:solidFill>
-                  <a:srgbClr val="C88A2E"/>
-                </a:solidFill>
-                <a:latin typeface="Poppins" pitchFamily="34" charset="0"/>
-                <a:ea typeface="Poppins" pitchFamily="34" charset="-122"/>
-                <a:cs typeface="Poppins" pitchFamily="34" charset="-120"/>
-              </a:rPr>
-              <a:t>3.5h</a:t>
-            </a:r>
-            <a:endParaRPr lang="en-US" sz="680" dirty="0"/>
-          </a:p>
-        </p:txBody>
-      </p:sp>
-      <p:sp>
-        <p:nvSpPr>
-          <p:cNvPr id="161" name="Text 158"/>
+                  <a:srgbClr val="8FA1AC"/>
+                </a:solidFill>
+                <a:latin typeface="Poppins" pitchFamily="34" charset="0"/>
+                <a:ea typeface="Poppins" pitchFamily="34" charset="-122"/>
+                <a:cs typeface="Poppins" pitchFamily="34" charset="-120"/>
+              </a:rPr>
+              <a:t>—</a:t>
+            </a:r>
+            <a:endParaRPr lang="en-US" sz="680" dirty="0"/>
+          </a:p>
+        </p:txBody>
+      </p:sp>
+      <p:sp>
+        <p:nvSpPr>
+          <p:cNvPr id="157" name="Text 154"/>
           <p:cNvSpPr txBox="1"/>
           <p:nvPr/>
         </p:nvSpPr>
@@ -7222,23 +7066,23 @@
               <a:buNone/>
             </a:pPr>
             <a:r>
-              <a:rPr lang="en-US" sz="680" b="1" dirty="0">
-                <a:solidFill>
-                  <a:srgbClr val="B4552D"/>
-                </a:solidFill>
-                <a:latin typeface="Poppins" pitchFamily="34" charset="0"/>
-                <a:ea typeface="Poppins" pitchFamily="34" charset="-122"/>
-                <a:cs typeface="Poppins" pitchFamily="34" charset="-120"/>
-              </a:rPr>
-              <a:t>$525</a:t>
-            </a:r>
-            <a:endParaRPr lang="en-US" sz="680" dirty="0"/>
-          </a:p>
-        </p:txBody>
-      </p:sp>
-      <p:sp>
-        <p:nvSpPr>
-          <p:cNvPr id="162" name="Shape 159"/>
+              <a:rPr lang="en-US" sz="680" dirty="0">
+                <a:solidFill>
+                  <a:srgbClr val="8FA1AC"/>
+                </a:solidFill>
+                <a:latin typeface="Poppins" pitchFamily="34" charset="0"/>
+                <a:ea typeface="Poppins" pitchFamily="34" charset="-122"/>
+                <a:cs typeface="Poppins" pitchFamily="34" charset="-120"/>
+              </a:rPr>
+              <a:t>—</a:t>
+            </a:r>
+            <a:endParaRPr lang="en-US" sz="680" dirty="0"/>
+          </a:p>
+        </p:txBody>
+      </p:sp>
+      <p:sp>
+        <p:nvSpPr>
+          <p:cNvPr id="158" name="Shape 155"/>
           <p:cNvSpPr/>
           <p:nvPr/>
         </p:nvSpPr>
@@ -7258,7 +7102,7 @@
       </p:sp>
       <p:sp>
         <p:nvSpPr>
-          <p:cNvPr id="163" name="Text 160"/>
+          <p:cNvPr id="159" name="Text 156"/>
           <p:cNvSpPr txBox="1"/>
           <p:nvPr/>
         </p:nvSpPr>
@@ -7297,7 +7141,7 @@
       </p:sp>
       <p:sp>
         <p:nvSpPr>
-          <p:cNvPr id="164" name="Text 161"/>
+          <p:cNvPr id="160" name="Text 157"/>
           <p:cNvSpPr txBox="1"/>
           <p:nvPr/>
         </p:nvSpPr>
@@ -7336,7 +7180,7 @@
       </p:sp>
       <p:sp>
         <p:nvSpPr>
-          <p:cNvPr id="165" name="Text 162"/>
+          <p:cNvPr id="161" name="Text 158"/>
           <p:cNvSpPr txBox="1"/>
           <p:nvPr/>
         </p:nvSpPr>
@@ -7361,21 +7205,21 @@
             <a:r>
               <a:rPr lang="en-US" sz="680" dirty="0">
                 <a:solidFill>
-                  <a:srgbClr val="8FA1AC"/>
-                </a:solidFill>
-                <a:latin typeface="Poppins" pitchFamily="34" charset="0"/>
-                <a:ea typeface="Poppins" pitchFamily="34" charset="-122"/>
-                <a:cs typeface="Poppins" pitchFamily="34" charset="-120"/>
-              </a:rPr>
-              <a:t>—</a:t>
-            </a:r>
-            <a:endParaRPr lang="en-US" sz="680" dirty="0"/>
-          </a:p>
-        </p:txBody>
-      </p:sp>
-      <p:sp>
-        <p:nvSpPr>
-          <p:cNvPr id="166" name="Text 163"/>
+                  <a:srgbClr val="12293A"/>
+                </a:solidFill>
+                <a:latin typeface="Poppins" pitchFamily="34" charset="0"/>
+                <a:ea typeface="Poppins" pitchFamily="34" charset="-122"/>
+                <a:cs typeface="Poppins" pitchFamily="34" charset="-120"/>
+              </a:rPr>
+              <a:t>3.5h</a:t>
+            </a:r>
+            <a:endParaRPr lang="en-US" sz="680" dirty="0"/>
+          </a:p>
+        </p:txBody>
+      </p:sp>
+      <p:sp>
+        <p:nvSpPr>
+          <p:cNvPr id="162" name="Text 159"/>
           <p:cNvSpPr txBox="1"/>
           <p:nvPr/>
         </p:nvSpPr>
@@ -7400,21 +7244,21 @@
             <a:r>
               <a:rPr lang="en-US" sz="680" dirty="0">
                 <a:solidFill>
-                  <a:srgbClr val="C88A2E"/>
-                </a:solidFill>
-                <a:latin typeface="Poppins" pitchFamily="34" charset="0"/>
-                <a:ea typeface="Poppins" pitchFamily="34" charset="-122"/>
-                <a:cs typeface="Poppins" pitchFamily="34" charset="-120"/>
-              </a:rPr>
-              <a:t>3.5h</a:t>
-            </a:r>
-            <a:endParaRPr lang="en-US" sz="680" dirty="0"/>
-          </a:p>
-        </p:txBody>
-      </p:sp>
-      <p:sp>
-        <p:nvSpPr>
-          <p:cNvPr id="167" name="Text 164"/>
+                  <a:srgbClr val="8FA1AC"/>
+                </a:solidFill>
+                <a:latin typeface="Poppins" pitchFamily="34" charset="0"/>
+                <a:ea typeface="Poppins" pitchFamily="34" charset="-122"/>
+                <a:cs typeface="Poppins" pitchFamily="34" charset="-120"/>
+              </a:rPr>
+              <a:t>—</a:t>
+            </a:r>
+            <a:endParaRPr lang="en-US" sz="680" dirty="0"/>
+          </a:p>
+        </p:txBody>
+      </p:sp>
+      <p:sp>
+        <p:nvSpPr>
+          <p:cNvPr id="163" name="Text 160"/>
           <p:cNvSpPr txBox="1"/>
           <p:nvPr/>
         </p:nvSpPr>
@@ -7437,23 +7281,23 @@
               <a:buNone/>
             </a:pPr>
             <a:r>
-              <a:rPr lang="en-US" sz="680" b="1" dirty="0">
-                <a:solidFill>
-                  <a:srgbClr val="B4552D"/>
-                </a:solidFill>
-                <a:latin typeface="Poppins" pitchFamily="34" charset="0"/>
-                <a:ea typeface="Poppins" pitchFamily="34" charset="-122"/>
-                <a:cs typeface="Poppins" pitchFamily="34" charset="-120"/>
-              </a:rPr>
-              <a:t>$525</a:t>
-            </a:r>
-            <a:endParaRPr lang="en-US" sz="680" dirty="0"/>
-          </a:p>
-        </p:txBody>
-      </p:sp>
-      <p:sp>
-        <p:nvSpPr>
-          <p:cNvPr id="168" name="Text 165"/>
+              <a:rPr lang="en-US" sz="680" dirty="0">
+                <a:solidFill>
+                  <a:srgbClr val="8FA1AC"/>
+                </a:solidFill>
+                <a:latin typeface="Poppins" pitchFamily="34" charset="0"/>
+                <a:ea typeface="Poppins" pitchFamily="34" charset="-122"/>
+                <a:cs typeface="Poppins" pitchFamily="34" charset="-120"/>
+              </a:rPr>
+              <a:t>—</a:t>
+            </a:r>
+            <a:endParaRPr lang="en-US" sz="680" dirty="0"/>
+          </a:p>
+        </p:txBody>
+      </p:sp>
+      <p:sp>
+        <p:nvSpPr>
+          <p:cNvPr id="164" name="Text 161"/>
           <p:cNvSpPr txBox="1"/>
           <p:nvPr/>
         </p:nvSpPr>
@@ -7492,7 +7336,7 @@
       </p:sp>
       <p:sp>
         <p:nvSpPr>
-          <p:cNvPr id="169" name="Text 166"/>
+          <p:cNvPr id="165" name="Text 162"/>
           <p:cNvSpPr txBox="1"/>
           <p:nvPr/>
         </p:nvSpPr>
@@ -7531,7 +7375,7 @@
       </p:sp>
       <p:sp>
         <p:nvSpPr>
-          <p:cNvPr id="170" name="Text 167"/>
+          <p:cNvPr id="166" name="Text 163"/>
           <p:cNvSpPr txBox="1"/>
           <p:nvPr/>
         </p:nvSpPr>
@@ -7556,21 +7400,21 @@
             <a:r>
               <a:rPr lang="en-US" sz="680" dirty="0">
                 <a:solidFill>
-                  <a:srgbClr val="3D8F5F"/>
-                </a:solidFill>
-                <a:latin typeface="Poppins" pitchFamily="34" charset="0"/>
-                <a:ea typeface="Poppins" pitchFamily="34" charset="-122"/>
-                <a:cs typeface="Poppins" pitchFamily="34" charset="-120"/>
-              </a:rPr>
-              <a:t>1.0h</a:t>
-            </a:r>
-            <a:endParaRPr lang="en-US" sz="680" dirty="0"/>
-          </a:p>
-        </p:txBody>
-      </p:sp>
-      <p:sp>
-        <p:nvSpPr>
-          <p:cNvPr id="171" name="Text 168"/>
+                  <a:srgbClr val="12293A"/>
+                </a:solidFill>
+                <a:latin typeface="Poppins" pitchFamily="34" charset="0"/>
+                <a:ea typeface="Poppins" pitchFamily="34" charset="-122"/>
+                <a:cs typeface="Poppins" pitchFamily="34" charset="-120"/>
+              </a:rPr>
+              <a:t>3.5h</a:t>
+            </a:r>
+            <a:endParaRPr lang="en-US" sz="680" dirty="0"/>
+          </a:p>
+        </p:txBody>
+      </p:sp>
+      <p:sp>
+        <p:nvSpPr>
+          <p:cNvPr id="167" name="Text 164"/>
           <p:cNvSpPr txBox="1"/>
           <p:nvPr/>
         </p:nvSpPr>
@@ -7595,21 +7439,21 @@
             <a:r>
               <a:rPr lang="en-US" sz="680" dirty="0">
                 <a:solidFill>
-                  <a:srgbClr val="C88A2E"/>
-                </a:solidFill>
-                <a:latin typeface="Poppins" pitchFamily="34" charset="0"/>
-                <a:ea typeface="Poppins" pitchFamily="34" charset="-122"/>
-                <a:cs typeface="Poppins" pitchFamily="34" charset="-120"/>
-              </a:rPr>
-              <a:t>2.5h</a:t>
-            </a:r>
-            <a:endParaRPr lang="en-US" sz="680" dirty="0"/>
-          </a:p>
-        </p:txBody>
-      </p:sp>
-      <p:sp>
-        <p:nvSpPr>
-          <p:cNvPr id="172" name="Text 169"/>
+                  <a:srgbClr val="8FA1AC"/>
+                </a:solidFill>
+                <a:latin typeface="Poppins" pitchFamily="34" charset="0"/>
+                <a:ea typeface="Poppins" pitchFamily="34" charset="-122"/>
+                <a:cs typeface="Poppins" pitchFamily="34" charset="-120"/>
+              </a:rPr>
+              <a:t>—</a:t>
+            </a:r>
+            <a:endParaRPr lang="en-US" sz="680" dirty="0"/>
+          </a:p>
+        </p:txBody>
+      </p:sp>
+      <p:sp>
+        <p:nvSpPr>
+          <p:cNvPr id="168" name="Text 165"/>
           <p:cNvSpPr txBox="1"/>
           <p:nvPr/>
         </p:nvSpPr>
@@ -7632,23 +7476,23 @@
               <a:buNone/>
             </a:pPr>
             <a:r>
-              <a:rPr lang="en-US" sz="680" b="1" dirty="0">
-                <a:solidFill>
-                  <a:srgbClr val="B4552D"/>
-                </a:solidFill>
-                <a:latin typeface="Poppins" pitchFamily="34" charset="0"/>
-                <a:ea typeface="Poppins" pitchFamily="34" charset="-122"/>
-                <a:cs typeface="Poppins" pitchFamily="34" charset="-120"/>
-              </a:rPr>
-              <a:t>$375</a:t>
-            </a:r>
-            <a:endParaRPr lang="en-US" sz="680" dirty="0"/>
-          </a:p>
-        </p:txBody>
-      </p:sp>
-      <p:sp>
-        <p:nvSpPr>
-          <p:cNvPr id="173" name="Shape 170"/>
+              <a:rPr lang="en-US" sz="680" dirty="0">
+                <a:solidFill>
+                  <a:srgbClr val="8FA1AC"/>
+                </a:solidFill>
+                <a:latin typeface="Poppins" pitchFamily="34" charset="0"/>
+                <a:ea typeface="Poppins" pitchFamily="34" charset="-122"/>
+                <a:cs typeface="Poppins" pitchFamily="34" charset="-120"/>
+              </a:rPr>
+              <a:t>—</a:t>
+            </a:r>
+            <a:endParaRPr lang="en-US" sz="680" dirty="0"/>
+          </a:p>
+        </p:txBody>
+      </p:sp>
+      <p:sp>
+        <p:nvSpPr>
+          <p:cNvPr id="169" name="Shape 166"/>
           <p:cNvSpPr/>
           <p:nvPr/>
         </p:nvSpPr>
@@ -7668,7 +7512,7 @@
       </p:sp>
       <p:sp>
         <p:nvSpPr>
-          <p:cNvPr id="174" name="Text 171"/>
+          <p:cNvPr id="170" name="Text 167"/>
           <p:cNvSpPr txBox="1"/>
           <p:nvPr/>
         </p:nvSpPr>
@@ -7707,7 +7551,7 @@
       </p:sp>
       <p:sp>
         <p:nvSpPr>
-          <p:cNvPr id="175" name="Text 172"/>
+          <p:cNvPr id="171" name="Text 168"/>
           <p:cNvSpPr txBox="1"/>
           <p:nvPr/>
         </p:nvSpPr>
@@ -7746,7 +7590,7 @@
       </p:sp>
       <p:sp>
         <p:nvSpPr>
-          <p:cNvPr id="176" name="Text 173"/>
+          <p:cNvPr id="172" name="Text 169"/>
           <p:cNvSpPr txBox="1"/>
           <p:nvPr/>
         </p:nvSpPr>
@@ -7771,21 +7615,21 @@
             <a:r>
               <a:rPr lang="en-US" sz="680" dirty="0">
                 <a:solidFill>
-                  <a:srgbClr val="8FA1AC"/>
-                </a:solidFill>
-                <a:latin typeface="Poppins" pitchFamily="34" charset="0"/>
-                <a:ea typeface="Poppins" pitchFamily="34" charset="-122"/>
-                <a:cs typeface="Poppins" pitchFamily="34" charset="-120"/>
-              </a:rPr>
-              <a:t>—</a:t>
-            </a:r>
-            <a:endParaRPr lang="en-US" sz="680" dirty="0"/>
-          </a:p>
-        </p:txBody>
-      </p:sp>
-      <p:sp>
-        <p:nvSpPr>
-          <p:cNvPr id="177" name="Text 174"/>
+                  <a:srgbClr val="12293A"/>
+                </a:solidFill>
+                <a:latin typeface="Poppins" pitchFamily="34" charset="0"/>
+                <a:ea typeface="Poppins" pitchFamily="34" charset="-122"/>
+                <a:cs typeface="Poppins" pitchFamily="34" charset="-120"/>
+              </a:rPr>
+              <a:t>3.0h</a:t>
+            </a:r>
+            <a:endParaRPr lang="en-US" sz="680" dirty="0"/>
+          </a:p>
+        </p:txBody>
+      </p:sp>
+      <p:sp>
+        <p:nvSpPr>
+          <p:cNvPr id="173" name="Text 170"/>
           <p:cNvSpPr txBox="1"/>
           <p:nvPr/>
         </p:nvSpPr>
@@ -7810,21 +7654,21 @@
             <a:r>
               <a:rPr lang="en-US" sz="680" dirty="0">
                 <a:solidFill>
-                  <a:srgbClr val="C88A2E"/>
-                </a:solidFill>
-                <a:latin typeface="Poppins" pitchFamily="34" charset="0"/>
-                <a:ea typeface="Poppins" pitchFamily="34" charset="-122"/>
-                <a:cs typeface="Poppins" pitchFamily="34" charset="-120"/>
-              </a:rPr>
-              <a:t>3.0h</a:t>
-            </a:r>
-            <a:endParaRPr lang="en-US" sz="680" dirty="0"/>
-          </a:p>
-        </p:txBody>
-      </p:sp>
-      <p:sp>
-        <p:nvSpPr>
-          <p:cNvPr id="178" name="Text 175"/>
+                  <a:srgbClr val="8FA1AC"/>
+                </a:solidFill>
+                <a:latin typeface="Poppins" pitchFamily="34" charset="0"/>
+                <a:ea typeface="Poppins" pitchFamily="34" charset="-122"/>
+                <a:cs typeface="Poppins" pitchFamily="34" charset="-120"/>
+              </a:rPr>
+              <a:t>—</a:t>
+            </a:r>
+            <a:endParaRPr lang="en-US" sz="680" dirty="0"/>
+          </a:p>
+        </p:txBody>
+      </p:sp>
+      <p:sp>
+        <p:nvSpPr>
+          <p:cNvPr id="174" name="Text 171"/>
           <p:cNvSpPr txBox="1"/>
           <p:nvPr/>
         </p:nvSpPr>
@@ -7847,23 +7691,23 @@
               <a:buNone/>
             </a:pPr>
             <a:r>
-              <a:rPr lang="en-US" sz="680" b="1" dirty="0">
-                <a:solidFill>
-                  <a:srgbClr val="B4552D"/>
-                </a:solidFill>
-                <a:latin typeface="Poppins" pitchFamily="34" charset="0"/>
-                <a:ea typeface="Poppins" pitchFamily="34" charset="-122"/>
-                <a:cs typeface="Poppins" pitchFamily="34" charset="-120"/>
-              </a:rPr>
-              <a:t>$450</a:t>
-            </a:r>
-            <a:endParaRPr lang="en-US" sz="680" dirty="0"/>
-          </a:p>
-        </p:txBody>
-      </p:sp>
-      <p:sp>
-        <p:nvSpPr>
-          <p:cNvPr id="179" name="Text 176"/>
+              <a:rPr lang="en-US" sz="680" dirty="0">
+                <a:solidFill>
+                  <a:srgbClr val="8FA1AC"/>
+                </a:solidFill>
+                <a:latin typeface="Poppins" pitchFamily="34" charset="0"/>
+                <a:ea typeface="Poppins" pitchFamily="34" charset="-122"/>
+                <a:cs typeface="Poppins" pitchFamily="34" charset="-120"/>
+              </a:rPr>
+              <a:t>—</a:t>
+            </a:r>
+            <a:endParaRPr lang="en-US" sz="680" dirty="0"/>
+          </a:p>
+        </p:txBody>
+      </p:sp>
+      <p:sp>
+        <p:nvSpPr>
+          <p:cNvPr id="175" name="Text 172"/>
           <p:cNvSpPr txBox="1"/>
           <p:nvPr/>
         </p:nvSpPr>
@@ -7902,7 +7746,7 @@
       </p:sp>
       <p:sp>
         <p:nvSpPr>
-          <p:cNvPr id="180" name="Text 177"/>
+          <p:cNvPr id="176" name="Text 173"/>
           <p:cNvSpPr txBox="1"/>
           <p:nvPr/>
         </p:nvSpPr>
@@ -7941,7 +7785,7 @@
       </p:sp>
       <p:sp>
         <p:nvSpPr>
-          <p:cNvPr id="181" name="Text 178"/>
+          <p:cNvPr id="177" name="Text 174"/>
           <p:cNvSpPr txBox="1"/>
           <p:nvPr/>
         </p:nvSpPr>
@@ -7966,7 +7810,7 @@
             <a:r>
               <a:rPr lang="en-US" sz="680" dirty="0">
                 <a:solidFill>
-                  <a:srgbClr val="3D8F5F"/>
+                  <a:srgbClr val="12293A"/>
                 </a:solidFill>
                 <a:latin typeface="Poppins" pitchFamily="34" charset="0"/>
                 <a:ea typeface="Poppins" pitchFamily="34" charset="-122"/>
@@ -7980,7 +7824,7 @@
       </p:sp>
       <p:sp>
         <p:nvSpPr>
-          <p:cNvPr id="182" name="Text 179"/>
+          <p:cNvPr id="178" name="Text 175"/>
           <p:cNvSpPr txBox="1"/>
           <p:nvPr/>
         </p:nvSpPr>
@@ -8019,7 +7863,7 @@
       </p:sp>
       <p:sp>
         <p:nvSpPr>
-          <p:cNvPr id="183" name="Text 180"/>
+          <p:cNvPr id="179" name="Text 176"/>
           <p:cNvSpPr txBox="1"/>
           <p:nvPr/>
         </p:nvSpPr>
@@ -8058,7 +7902,7 @@
       </p:sp>
       <p:sp>
         <p:nvSpPr>
-          <p:cNvPr id="184" name="Shape 181"/>
+          <p:cNvPr id="180" name="Shape 177"/>
           <p:cNvSpPr/>
           <p:nvPr/>
         </p:nvSpPr>
@@ -8078,7 +7922,7 @@
       </p:sp>
       <p:sp>
         <p:nvSpPr>
-          <p:cNvPr id="185" name="Text 182"/>
+          <p:cNvPr id="181" name="Text 178"/>
           <p:cNvSpPr txBox="1"/>
           <p:nvPr/>
         </p:nvSpPr>
@@ -8117,7 +7961,7 @@
       </p:sp>
       <p:sp>
         <p:nvSpPr>
-          <p:cNvPr id="186" name="Text 183"/>
+          <p:cNvPr id="182" name="Text 179"/>
           <p:cNvSpPr txBox="1"/>
           <p:nvPr/>
         </p:nvSpPr>
@@ -8156,7 +8000,7 @@
       </p:sp>
       <p:sp>
         <p:nvSpPr>
-          <p:cNvPr id="187" name="Text 184"/>
+          <p:cNvPr id="183" name="Text 180"/>
           <p:cNvSpPr txBox="1"/>
           <p:nvPr/>
         </p:nvSpPr>
@@ -8181,21 +8025,21 @@
             <a:r>
               <a:rPr lang="en-US" sz="680" dirty="0">
                 <a:solidFill>
-                  <a:srgbClr val="8FA1AC"/>
-                </a:solidFill>
-                <a:latin typeface="Poppins" pitchFamily="34" charset="0"/>
-                <a:ea typeface="Poppins" pitchFamily="34" charset="-122"/>
-                <a:cs typeface="Poppins" pitchFamily="34" charset="-120"/>
-              </a:rPr>
-              <a:t>—</a:t>
-            </a:r>
-            <a:endParaRPr lang="en-US" sz="680" dirty="0"/>
-          </a:p>
-        </p:txBody>
-      </p:sp>
-      <p:sp>
-        <p:nvSpPr>
-          <p:cNvPr id="188" name="Text 185"/>
+                  <a:srgbClr val="12293A"/>
+                </a:solidFill>
+                <a:latin typeface="Poppins" pitchFamily="34" charset="0"/>
+                <a:ea typeface="Poppins" pitchFamily="34" charset="-122"/>
+                <a:cs typeface="Poppins" pitchFamily="34" charset="-120"/>
+              </a:rPr>
+              <a:t>2.1h</a:t>
+            </a:r>
+            <a:endParaRPr lang="en-US" sz="680" dirty="0"/>
+          </a:p>
+        </p:txBody>
+      </p:sp>
+      <p:sp>
+        <p:nvSpPr>
+          <p:cNvPr id="184" name="Text 181"/>
           <p:cNvSpPr txBox="1"/>
           <p:nvPr/>
         </p:nvSpPr>
@@ -8220,21 +8064,21 @@
             <a:r>
               <a:rPr lang="en-US" sz="680" dirty="0">
                 <a:solidFill>
-                  <a:srgbClr val="C88A2E"/>
-                </a:solidFill>
-                <a:latin typeface="Poppins" pitchFamily="34" charset="0"/>
-                <a:ea typeface="Poppins" pitchFamily="34" charset="-122"/>
-                <a:cs typeface="Poppins" pitchFamily="34" charset="-120"/>
-              </a:rPr>
-              <a:t>2.1h</a:t>
-            </a:r>
-            <a:endParaRPr lang="en-US" sz="680" dirty="0"/>
-          </a:p>
-        </p:txBody>
-      </p:sp>
-      <p:sp>
-        <p:nvSpPr>
-          <p:cNvPr id="189" name="Text 186"/>
+                  <a:srgbClr val="8FA1AC"/>
+                </a:solidFill>
+                <a:latin typeface="Poppins" pitchFamily="34" charset="0"/>
+                <a:ea typeface="Poppins" pitchFamily="34" charset="-122"/>
+                <a:cs typeface="Poppins" pitchFamily="34" charset="-120"/>
+              </a:rPr>
+              <a:t>—</a:t>
+            </a:r>
+            <a:endParaRPr lang="en-US" sz="680" dirty="0"/>
+          </a:p>
+        </p:txBody>
+      </p:sp>
+      <p:sp>
+        <p:nvSpPr>
+          <p:cNvPr id="185" name="Text 182"/>
           <p:cNvSpPr txBox="1"/>
           <p:nvPr/>
         </p:nvSpPr>
@@ -8257,23 +8101,23 @@
               <a:buNone/>
             </a:pPr>
             <a:r>
-              <a:rPr lang="en-US" sz="680" b="1" dirty="0">
-                <a:solidFill>
-                  <a:srgbClr val="B4552D"/>
-                </a:solidFill>
-                <a:latin typeface="Poppins" pitchFamily="34" charset="0"/>
-                <a:ea typeface="Poppins" pitchFamily="34" charset="-122"/>
-                <a:cs typeface="Poppins" pitchFamily="34" charset="-120"/>
-              </a:rPr>
-              <a:t>$311</a:t>
-            </a:r>
-            <a:endParaRPr lang="en-US" sz="680" dirty="0"/>
-          </a:p>
-        </p:txBody>
-      </p:sp>
-      <p:sp>
-        <p:nvSpPr>
-          <p:cNvPr id="190" name="Text 187"/>
+              <a:rPr lang="en-US" sz="680" dirty="0">
+                <a:solidFill>
+                  <a:srgbClr val="8FA1AC"/>
+                </a:solidFill>
+                <a:latin typeface="Poppins" pitchFamily="34" charset="0"/>
+                <a:ea typeface="Poppins" pitchFamily="34" charset="-122"/>
+                <a:cs typeface="Poppins" pitchFamily="34" charset="-120"/>
+              </a:rPr>
+              <a:t>—</a:t>
+            </a:r>
+            <a:endParaRPr lang="en-US" sz="680" dirty="0"/>
+          </a:p>
+        </p:txBody>
+      </p:sp>
+      <p:sp>
+        <p:nvSpPr>
+          <p:cNvPr id="186" name="Text 183"/>
           <p:cNvSpPr txBox="1"/>
           <p:nvPr/>
         </p:nvSpPr>
@@ -8312,7 +8156,7 @@
       </p:sp>
       <p:sp>
         <p:nvSpPr>
-          <p:cNvPr id="191" name="Text 188"/>
+          <p:cNvPr id="187" name="Text 184"/>
           <p:cNvSpPr txBox="1"/>
           <p:nvPr/>
         </p:nvSpPr>
@@ -8351,7 +8195,7 @@
       </p:sp>
       <p:sp>
         <p:nvSpPr>
-          <p:cNvPr id="192" name="Text 189"/>
+          <p:cNvPr id="188" name="Text 185"/>
           <p:cNvSpPr txBox="1"/>
           <p:nvPr/>
         </p:nvSpPr>
@@ -8376,21 +8220,21 @@
             <a:r>
               <a:rPr lang="en-US" sz="680" dirty="0">
                 <a:solidFill>
-                  <a:srgbClr val="3D8F5F"/>
-                </a:solidFill>
-                <a:latin typeface="Poppins" pitchFamily="34" charset="0"/>
-                <a:ea typeface="Poppins" pitchFamily="34" charset="-122"/>
-                <a:cs typeface="Poppins" pitchFamily="34" charset="-120"/>
-              </a:rPr>
-              <a:t>1.0h</a:t>
-            </a:r>
-            <a:endParaRPr lang="en-US" sz="680" dirty="0"/>
-          </a:p>
-        </p:txBody>
-      </p:sp>
-      <p:sp>
-        <p:nvSpPr>
-          <p:cNvPr id="193" name="Text 190"/>
+                  <a:srgbClr val="12293A"/>
+                </a:solidFill>
+                <a:latin typeface="Poppins" pitchFamily="34" charset="0"/>
+                <a:ea typeface="Poppins" pitchFamily="34" charset="-122"/>
+                <a:cs typeface="Poppins" pitchFamily="34" charset="-120"/>
+              </a:rPr>
+              <a:t>2.0h</a:t>
+            </a:r>
+            <a:endParaRPr lang="en-US" sz="680" dirty="0"/>
+          </a:p>
+        </p:txBody>
+      </p:sp>
+      <p:sp>
+        <p:nvSpPr>
+          <p:cNvPr id="189" name="Text 186"/>
           <p:cNvSpPr txBox="1"/>
           <p:nvPr/>
         </p:nvSpPr>
@@ -8415,21 +8259,21 @@
             <a:r>
               <a:rPr lang="en-US" sz="680" dirty="0">
                 <a:solidFill>
-                  <a:srgbClr val="C88A2E"/>
-                </a:solidFill>
-                <a:latin typeface="Poppins" pitchFamily="34" charset="0"/>
-                <a:ea typeface="Poppins" pitchFamily="34" charset="-122"/>
-                <a:cs typeface="Poppins" pitchFamily="34" charset="-120"/>
-              </a:rPr>
-              <a:t>1.0h</a:t>
-            </a:r>
-            <a:endParaRPr lang="en-US" sz="680" dirty="0"/>
-          </a:p>
-        </p:txBody>
-      </p:sp>
-      <p:sp>
-        <p:nvSpPr>
-          <p:cNvPr id="194" name="Text 191"/>
+                  <a:srgbClr val="8FA1AC"/>
+                </a:solidFill>
+                <a:latin typeface="Poppins" pitchFamily="34" charset="0"/>
+                <a:ea typeface="Poppins" pitchFamily="34" charset="-122"/>
+                <a:cs typeface="Poppins" pitchFamily="34" charset="-120"/>
+              </a:rPr>
+              <a:t>—</a:t>
+            </a:r>
+            <a:endParaRPr lang="en-US" sz="680" dirty="0"/>
+          </a:p>
+        </p:txBody>
+      </p:sp>
+      <p:sp>
+        <p:nvSpPr>
+          <p:cNvPr id="190" name="Text 187"/>
           <p:cNvSpPr txBox="1"/>
           <p:nvPr/>
         </p:nvSpPr>
@@ -8452,23 +8296,23 @@
               <a:buNone/>
             </a:pPr>
             <a:r>
-              <a:rPr lang="en-US" sz="680" b="1" dirty="0">
-                <a:solidFill>
-                  <a:srgbClr val="B4552D"/>
-                </a:solidFill>
-                <a:latin typeface="Poppins" pitchFamily="34" charset="0"/>
-                <a:ea typeface="Poppins" pitchFamily="34" charset="-122"/>
-                <a:cs typeface="Poppins" pitchFamily="34" charset="-120"/>
-              </a:rPr>
-              <a:t>$150</a:t>
-            </a:r>
-            <a:endParaRPr lang="en-US" sz="680" dirty="0"/>
-          </a:p>
-        </p:txBody>
-      </p:sp>
-      <p:sp>
-        <p:nvSpPr>
-          <p:cNvPr id="195" name="Shape 192"/>
+              <a:rPr lang="en-US" sz="680" dirty="0">
+                <a:solidFill>
+                  <a:srgbClr val="8FA1AC"/>
+                </a:solidFill>
+                <a:latin typeface="Poppins" pitchFamily="34" charset="0"/>
+                <a:ea typeface="Poppins" pitchFamily="34" charset="-122"/>
+                <a:cs typeface="Poppins" pitchFamily="34" charset="-120"/>
+              </a:rPr>
+              <a:t>—</a:t>
+            </a:r>
+            <a:endParaRPr lang="en-US" sz="680" dirty="0"/>
+          </a:p>
+        </p:txBody>
+      </p:sp>
+      <p:sp>
+        <p:nvSpPr>
+          <p:cNvPr id="191" name="Shape 188"/>
           <p:cNvSpPr/>
           <p:nvPr/>
         </p:nvSpPr>
@@ -8497,7 +8341,7 @@
       </p:sp>
       <p:sp>
         <p:nvSpPr>
-          <p:cNvPr id="196" name="Text 193"/>
+          <p:cNvPr id="192" name="Text 189"/>
           <p:cNvSpPr txBox="1"/>
           <p:nvPr/>
         </p:nvSpPr>
@@ -8536,7 +8380,7 @@
       </p:sp>
       <p:sp>
         <p:nvSpPr>
-          <p:cNvPr id="197" name="Text 194"/>
+          <p:cNvPr id="193" name="Text 190"/>
           <p:cNvSpPr txBox="1"/>
           <p:nvPr/>
         </p:nvSpPr>
@@ -8598,7 +8442,7 @@
                 <a:ea typeface="Poppins" pitchFamily="34" charset="-122"/>
                 <a:cs typeface="Poppins" pitchFamily="34" charset="-120"/>
               </a:rPr>
-              <a:t>Part of the shortfall is partner integration and key-account work we don't charge for — the billable, non-chargeable hours.</a:t>
+              <a:t>Part of the shortfall is partner and key-account work we don't charge for — the billable, non-chargeable hours.</a:t>
             </a:r>
             <a:endParaRPr lang="en-US" sz="900" dirty="0"/>
           </a:p>
@@ -8629,7 +8473,7 @@
                 <a:ea typeface="Poppins" pitchFamily="34" charset="-122"/>
                 <a:cs typeface="Poppins" pitchFamily="34" charset="-120"/>
               </a:rPr>
-              <a:t>This week only 1.0h is flagged non-chargeable. </a:t>
+              <a:t>Q4's hidden work so far: 20h, $3,000 of unrecognised PS revenue. </a:t>
             </a:r>
             <a:pPr indent="0" marL="0">
               <a:spcAft>
@@ -8646,7 +8490,7 @@
                 <a:ea typeface="Poppins" pitchFamily="34" charset="-122"/>
                 <a:cs typeface="Poppins" pitchFamily="34" charset="-120"/>
               </a:rPr>
-              <a:t>Is Chargeable went live this week: 7.0 of the 11.5h logged (61%) have no flag yet, so the hidden work is under-counted.</a:t>
+              <a:t>AVC's 9.2 upgrades (18h, $2,700) and H&amp;L Pay activations (2h, $300). Hours with no Is Chargeable flag are counted as chargeable.</a:t>
             </a:r>
             <a:endParaRPr lang="en-US" sz="900" dirty="0"/>
           </a:p>
@@ -8677,7 +8521,7 @@
                 <a:ea typeface="Poppins" pitchFamily="34" charset="-122"/>
                 <a:cs typeface="Poppins" pitchFamily="34" charset="-120"/>
               </a:rPr>
-              <a:t>To renegotiate, each non-chargeable hour needs a reason and an owner: </a:t>
+              <a:t>To renegotiate, every non-chargeable hour needs its partner or account, </a:t>
             </a:r>
             <a:pPr indent="0" marL="0">
               <a:spcAft>
@@ -8694,7 +8538,7 @@
                 <a:ea typeface="Poppins" pitchFamily="34" charset="-122"/>
                 <a:cs typeface="Poppins" pitchFamily="34" charset="-120"/>
               </a:rPr>
-              <a:t>premium partner (which one) or key account (which one). Then the partner and account tables price themselves.</a:t>
+              <a:t>so these tables total the revenue PS gives away against what each relationship pays.</a:t>
             </a:r>
             <a:endParaRPr lang="en-US" sz="900" dirty="0"/>
           </a:p>
@@ -8702,7 +8546,7 @@
       </p:sp>
       <p:sp>
         <p:nvSpPr>
-          <p:cNvPr id="198" name="Shape 195"/>
+          <p:cNvPr id="194" name="Shape 191"/>
           <p:cNvSpPr/>
           <p:nvPr/>
         </p:nvSpPr>
@@ -8724,7 +8568,7 @@
       </p:sp>
       <p:sp>
         <p:nvSpPr>
-          <p:cNvPr id="199" name="Text 196"/>
+          <p:cNvPr id="195" name="Text 192"/>
           <p:cNvSpPr txBox="1"/>
           <p:nvPr/>
         </p:nvSpPr>

</xml_diff>